<commit_message>
sync(workvault): 2026-10-21 10:17 差分 5 件
</commit_message>
<xml_diff>
--- a/workvault-sync/10_業務全般/業務報告/10月業務報告(篠原).pptx
+++ b/workvault-sync/10_業務全般/業務報告/10月業務報告(篠原).pptx
@@ -5197,7 +5197,7 @@
 </file>
 
 <file path=ppt/slides/slide1.xml><?xml version="1.0" encoding="utf-8"?>
-<p:sld xmlns:a="http://schemas.openxmlformats.org/drawingml/2006/main" xmlns:a16="http://schemas.microsoft.com/office/drawing/2014/main" xmlns:ns3="http://schemas.microsoft.com/office/drawing/2010/main" xmlns:p="http://schemas.openxmlformats.org/presentationml/2006/main">
+<p:sld xmlns:a="http://schemas.openxmlformats.org/drawingml/2006/main" xmlns:r="http://schemas.openxmlformats.org/officeDocument/2006/relationships" xmlns:p="http://schemas.openxmlformats.org/presentationml/2006/main">
   <p:cSld>
     <p:spTree>
       <p:nvGrpSpPr>
@@ -5218,7 +5218,7 @@
           <p:cNvPr id="3" name="サブタイトル 2">
             <a:extLst>
               <a:ext uri="{FF2B5EF4-FFF2-40B4-BE49-F238E27FC236}">
-                <a16:creationId id="{D8611FDF-9B1D-9612-327D-9456F6143916}"/>
+                <a16:creationId xmlns:a16="http://schemas.microsoft.com/office/drawing/2014/main" id="{D8611FDF-9B1D-9612-327D-9456F6143916}"/>
               </a:ext>
             </a:extLst>
           </p:cNvPr>
@@ -5241,21 +5241,21 @@
           </a:ln>
           <a:extLst>
             <a:ext uri="{909E8E84-426E-40DD-AFC4-6F175D3DCCD1}">
-              <ns3:hiddenFill>
+              <a14:hiddenFill xmlns:a14="http://schemas.microsoft.com/office/drawing/2010/main">
                 <a:solidFill>
                   <a:srgbClr val="FFFFFF"/>
                 </a:solidFill>
-              </ns3:hiddenFill>
+              </a14:hiddenFill>
             </a:ext>
             <a:ext uri="{91240B29-F687-4F45-9708-019B960494DF}">
-              <ns3:hiddenLine w="9525">
+              <a14:hiddenLine xmlns:a14="http://schemas.microsoft.com/office/drawing/2010/main" w="9525">
                 <a:solidFill>
                   <a:srgbClr val="000000"/>
                 </a:solidFill>
                 <a:miter lim="800000"/>
                 <a:headEnd/>
                 <a:tailEnd/>
-              </ns3:hiddenLine>
+              </a14:hiddenLine>
             </a:ext>
           </a:extLst>
         </p:spPr>
@@ -5478,7 +5478,7 @@
           <p:cNvPr id="8" name="タイトル 1">
             <a:extLst>
               <a:ext uri="{FF2B5EF4-FFF2-40B4-BE49-F238E27FC236}">
-                <a16:creationId id="{D2FA8936-D68E-6874-8EB3-C9A079275CE7}"/>
+                <a16:creationId xmlns:a16="http://schemas.microsoft.com/office/drawing/2014/main" id="{D2FA8936-D68E-6874-8EB3-C9A079275CE7}"/>
               </a:ext>
             </a:extLst>
           </p:cNvPr>
@@ -5501,21 +5501,21 @@
           </a:ln>
           <a:extLst>
             <a:ext uri="{909E8E84-426E-40DD-AFC4-6F175D3DCCD1}">
-              <ns3:hiddenFill>
+              <a14:hiddenFill xmlns:a14="http://schemas.microsoft.com/office/drawing/2010/main">
                 <a:solidFill>
                   <a:srgbClr val="FFFFFF"/>
                 </a:solidFill>
-              </ns3:hiddenFill>
+              </a14:hiddenFill>
             </a:ext>
             <a:ext uri="{91240B29-F687-4F45-9708-019B960494DF}">
-              <ns3:hiddenLine w="9525">
+              <a14:hiddenLine xmlns:a14="http://schemas.microsoft.com/office/drawing/2010/main" w="9525">
                 <a:solidFill>
                   <a:srgbClr val="000000"/>
                 </a:solidFill>
                 <a:miter lim="800000"/>
                 <a:headEnd/>
                 <a:tailEnd/>
-              </ns3:hiddenLine>
+              </a14:hiddenLine>
             </a:ext>
           </a:extLst>
         </p:spPr>
@@ -5673,7 +5673,40 @@
                   </a:schemeClr>
                 </a:solidFill>
               </a:rPr>
-              <a:t>76期　10月業務報告</a:t>
+              <a:t>76</a:t>
+            </a:r>
+            <a:r>
+              <a:rPr lang="ja-JP" altLang="en-US" sz="5400" kern="0" dirty="0">
+                <a:solidFill>
+                  <a:schemeClr val="tx1">
+                    <a:lumMod val="95000"/>
+                    <a:lumOff val="5000"/>
+                  </a:schemeClr>
+                </a:solidFill>
+              </a:rPr>
+              <a:t>期　</a:t>
+            </a:r>
+            <a:r>
+              <a:rPr lang="en-US" altLang="ja-JP" sz="5400" kern="0" dirty="0">
+                <a:solidFill>
+                  <a:schemeClr val="tx1">
+                    <a:lumMod val="95000"/>
+                    <a:lumOff val="5000"/>
+                  </a:schemeClr>
+                </a:solidFill>
+              </a:rPr>
+              <a:t>10</a:t>
+            </a:r>
+            <a:r>
+              <a:rPr lang="ja-JP" altLang="en-US" sz="5400" kern="0" dirty="0">
+                <a:solidFill>
+                  <a:schemeClr val="tx1">
+                    <a:lumMod val="95000"/>
+                    <a:lumOff val="5000"/>
+                  </a:schemeClr>
+                </a:solidFill>
+              </a:rPr>
+              <a:t>月業務報告</a:t>
             </a:r>
           </a:p>
         </p:txBody>
@@ -5687,7 +5720,7 @@
 </file>
 
 <file path=ppt/slides/slide2.xml><?xml version="1.0" encoding="utf-8"?>
-<p:sld xmlns:a="http://schemas.openxmlformats.org/drawingml/2006/main" xmlns:a16="http://schemas.microsoft.com/office/drawing/2014/main" xmlns:p="http://schemas.openxmlformats.org/presentationml/2006/main">
+<p:sld xmlns:a="http://schemas.openxmlformats.org/drawingml/2006/main" xmlns:r="http://schemas.openxmlformats.org/officeDocument/2006/relationships" xmlns:p="http://schemas.openxmlformats.org/presentationml/2006/main">
   <p:cSld>
     <p:spTree>
       <p:nvGrpSpPr>
@@ -5708,7 +5741,7 @@
           <p:cNvPr id="21506" name="Rectangle 2">
             <a:extLst>
               <a:ext uri="{FF2B5EF4-FFF2-40B4-BE49-F238E27FC236}">
-                <a16:creationId id="{F73DBF07-353A-1DAE-881E-450898FCC584}"/>
+                <a16:creationId xmlns:a16="http://schemas.microsoft.com/office/drawing/2014/main" id="{F73DBF07-353A-1DAE-881E-450898FCC584}"/>
               </a:ext>
             </a:extLst>
           </p:cNvPr>
@@ -5766,7 +5799,7 @@
           <p:cNvPr id="9" name="TB22">
             <a:extLst>
               <a:ext uri="{FF2B5EF4-FFF2-40B4-BE49-F238E27FC236}">
-                <a16:creationId id="{286AF094-EB23-DE59-C364-CE66702F5820}"/>
+                <a16:creationId xmlns:a16="http://schemas.microsoft.com/office/drawing/2014/main" id="{286AF094-EB23-DE59-C364-CE66702F5820}"/>
               </a:ext>
             </a:extLst>
           </p:cNvPr>
@@ -5815,7 +5848,7 @@
           <p:cNvPr id="11" name="TB23">
             <a:extLst>
               <a:ext uri="{FF2B5EF4-FFF2-40B4-BE49-F238E27FC236}">
-                <a16:creationId id="{9062C9EA-A562-CB3D-30B1-0D2FE45C706F}"/>
+                <a16:creationId xmlns:a16="http://schemas.microsoft.com/office/drawing/2014/main" id="{9062C9EA-A562-CB3D-30B1-0D2FE45C706F}"/>
               </a:ext>
             </a:extLst>
           </p:cNvPr>
@@ -5825,7 +5858,7 @@
         <p:spPr>
           <a:xfrm>
             <a:off x="540000" y="1572621"/>
-            <a:ext cx="10656000" cy="648000"/>
+            <a:ext cx="10656000" cy="2200000"/>
           </a:xfrm>
           <a:prstGeom prst="rect">
             <a:avLst/>
@@ -5854,7 +5887,7 @@
                 <a:latin typeface="Meiryo"/>
                 <a:ea typeface="Meiryo"/>
               </a:rPr>
-              <a:t>固定テーブル棚卸しの準備(0確認マクロの整備)と、LNB・Pana-CIM管理文書の作成</a:t>
+              <a:t>前任者が開発・運用・保守を担当していた在庫・棚卸し業務の引継ぎ(継続)</a:t>
             </a:r>
             <a:endParaRPr lang="en-US" altLang="ja-JP" b="0" dirty="0">
               <a:solidFill>
@@ -5864,6 +5897,141 @@
               <a:ea typeface="Meiryo"/>
             </a:endParaRPr>
           </a:p>
+          <a:p>
+            <a:pPr algn="l">
+              <a:lnSpc>
+                <a:spcPct val="112000"/>
+              </a:lnSpc>
+              <a:spcAft>
+                <a:spcPts val="400"/>
+              </a:spcAft>
+            </a:pPr>
+            <a:r>
+              <a:rPr lang="ja-JP" altLang="en-US" b="0" dirty="0">
+                <a:solidFill>
+                  <a:srgbClr val="000000"/>
+                </a:solidFill>
+                <a:latin typeface="Meiryo"/>
+                <a:ea typeface="Meiryo"/>
+              </a:rPr>
+              <a:t>　 - 在庫差異修正：B列のL2限定差異修正を9/24に完了</a:t>
+            </a:r>
+            <a:endParaRPr lang="en-US" altLang="ja-JP" b="0" dirty="0">
+              <a:solidFill>
+                <a:srgbClr val="000000"/>
+              </a:solidFill>
+              <a:latin typeface="Meiryo"/>
+              <a:ea typeface="Meiryo"/>
+            </a:endParaRPr>
+          </a:p>
+          <a:p>
+            <a:pPr algn="l">
+              <a:lnSpc>
+                <a:spcPct val="112000"/>
+              </a:lnSpc>
+              <a:spcAft>
+                <a:spcPts val="400"/>
+              </a:spcAft>
+            </a:pPr>
+            <a:r>
+              <a:rPr lang="ja-JP" altLang="en-US" b="0" dirty="0">
+                <a:solidFill>
+                  <a:srgbClr val="000000"/>
+                </a:solidFill>
+                <a:latin typeface="Meiryo"/>
+                <a:ea typeface="Meiryo"/>
+              </a:rPr>
+              <a:t>　 - 0確認マクロver.2：無変更のまま実機で動作を確認、運用を確定</a:t>
+            </a:r>
+            <a:endParaRPr lang="en-US" altLang="ja-JP" b="0" dirty="0">
+              <a:solidFill>
+                <a:srgbClr val="000000"/>
+              </a:solidFill>
+              <a:latin typeface="Meiryo"/>
+              <a:ea typeface="Meiryo"/>
+            </a:endParaRPr>
+          </a:p>
+          <a:p>
+            <a:pPr algn="l">
+              <a:lnSpc>
+                <a:spcPct val="112000"/>
+              </a:lnSpc>
+              <a:spcAft>
+                <a:spcPts val="400"/>
+              </a:spcAft>
+            </a:pPr>
+            <a:r>
+              <a:rPr lang="ja-JP" altLang="en-US" b="0" dirty="0">
+                <a:solidFill>
+                  <a:srgbClr val="000000"/>
+                </a:solidFill>
+                <a:latin typeface="Meiryo"/>
+                <a:ea typeface="Meiryo"/>
+              </a:rPr>
+              <a:t>　 - PanaCIM・LNB管理手順書：会議で統合方針を決定、案2冊を作成</a:t>
+            </a:r>
+            <a:endParaRPr lang="en-US" altLang="ja-JP" b="0" dirty="0">
+              <a:solidFill>
+                <a:srgbClr val="000000"/>
+              </a:solidFill>
+              <a:latin typeface="Meiryo"/>
+              <a:ea typeface="Meiryo"/>
+            </a:endParaRPr>
+          </a:p>
+          <a:p>
+            <a:pPr algn="l">
+              <a:lnSpc>
+                <a:spcPct val="112000"/>
+              </a:lnSpc>
+              <a:spcAft>
+                <a:spcPts val="400"/>
+              </a:spcAft>
+            </a:pPr>
+            <a:r>
+              <a:rPr lang="ja-JP" altLang="en-US" b="0" dirty="0">
+                <a:solidFill>
+                  <a:srgbClr val="000000"/>
+                </a:solidFill>
+                <a:latin typeface="Meiryo"/>
+                <a:ea typeface="Meiryo"/>
+              </a:rPr>
+              <a:t>　 - 固定テーブル棚卸しマクロ：改修をver.2へ統合、テストケース47件</a:t>
+            </a:r>
+            <a:endParaRPr lang="en-US" altLang="ja-JP" b="0" dirty="0">
+              <a:solidFill>
+                <a:srgbClr val="000000"/>
+              </a:solidFill>
+              <a:latin typeface="Meiryo"/>
+              <a:ea typeface="Meiryo"/>
+            </a:endParaRPr>
+          </a:p>
+          <a:p>
+            <a:pPr algn="l">
+              <a:lnSpc>
+                <a:spcPct val="112000"/>
+              </a:lnSpc>
+              <a:spcAft>
+                <a:spcPts val="400"/>
+              </a:spcAft>
+            </a:pPr>
+            <a:r>
+              <a:rPr lang="ja-JP" altLang="en-US" b="0" dirty="0">
+                <a:solidFill>
+                  <a:srgbClr val="000000"/>
+                </a:solidFill>
+                <a:latin typeface="Meiryo"/>
+                <a:ea typeface="Meiryo"/>
+              </a:rPr>
+              <a:t>　 - 保管庫の整理・BOSS計画の解析・鹿島引き込みマクロの分析・PowerBI改修準備</a:t>
+            </a:r>
+            <a:endParaRPr lang="en-US" altLang="ja-JP" b="0" dirty="0">
+              <a:solidFill>
+                <a:srgbClr val="000000"/>
+              </a:solidFill>
+              <a:latin typeface="Meiryo"/>
+              <a:ea typeface="Meiryo"/>
+            </a:endParaRPr>
+          </a:p>
         </p:txBody>
       </p:sp>
       <p:sp>
@@ -5871,7 +6039,7 @@
           <p:cNvPr id="29" name="R20">
             <a:extLst>
               <a:ext uri="{FF2B5EF4-FFF2-40B4-BE49-F238E27FC236}">
-                <a16:creationId id="{99BBA5A8-AC1B-3C0B-F774-2765F922C93F}"/>
+                <a16:creationId xmlns:a16="http://schemas.microsoft.com/office/drawing/2014/main" id="{99BBA5A8-AC1B-3C0B-F774-2765F922C93F}"/>
               </a:ext>
             </a:extLst>
           </p:cNvPr>
@@ -5904,116 +6072,6 @@
           </a:p>
         </p:txBody>
       </p:sp>
-      <p:sp>
-        <p:nvSpPr>
-          <p:cNvPr id="900" name="テーマ一覧">
-            <a:extLst>
-              <a:ext uri="{FF2B5EF4-FFF2-40B4-BE49-F238E27FC236}">
-                <a16:creationId id="{9062C9EA-A562-CB3D-30B1-0D2FE45C706F}"/>
-              </a:ext>
-            </a:extLst>
-          </p:cNvPr>
-          <p:cNvSpPr txBox="1"/>
-          <p:nvPr/>
-        </p:nvSpPr>
-        <p:spPr>
-          <a:xfrm>
-            <a:off x="315033" y="3200257"/>
-            <a:ext cx="11561933" cy="2874245"/>
-          </a:xfrm>
-          <a:prstGeom prst="rect">
-            <a:avLst/>
-          </a:prstGeom>
-          <a:noFill/>
-        </p:spPr>
-        <p:txBody>
-          <a:bodyPr wrap="square" lIns="0" tIns="0" rIns="0" bIns="0" anchor="t">
-            <a:noAutofit/>
-          </a:bodyPr>
-          <a:lstStyle/>
-          <a:p>
-            <a:pPr algn="l">
-              <a:lnSpc>
-                <a:spcPct val="112000"/>
-              </a:lnSpc>
-              <a:spcAft>
-                <a:spcPts val="400"/>
-              </a:spcAft>
-            </a:pPr>
-            <a:r>
-              <a:rPr lang="ja-JP" altLang="en-US" b="0" dirty="0">
-                <a:solidFill>
-                  <a:srgbClr val="000000"/>
-                </a:solidFill>
-                <a:latin typeface="Meiryo"/>
-                <a:ea typeface="Meiryo"/>
-              </a:rPr>
-              <a:t>・テーマ1  0確認マクロの整備 — 9月〜10月 / 解決(実機で採用済み・残る確認7件)</a:t>
-            </a:r>
-            <a:endParaRPr lang="en-US" altLang="ja-JP" b="0" dirty="0">
-              <a:solidFill>
-                <a:srgbClr val="000000"/>
-              </a:solidFill>
-              <a:latin typeface="Meiryo"/>
-              <a:ea typeface="Meiryo"/>
-            </a:endParaRPr>
-          </a:p>
-          <a:p>
-            <a:pPr algn="l">
-              <a:lnSpc>
-                <a:spcPct val="112000"/>
-              </a:lnSpc>
-              <a:spcAft>
-                <a:spcPts val="400"/>
-              </a:spcAft>
-            </a:pPr>
-            <a:r>
-              <a:rPr lang="ja-JP" altLang="en-US" b="0" dirty="0">
-                <a:solidFill>
-                  <a:srgbClr val="000000"/>
-                </a:solidFill>
-                <a:latin typeface="Meiryo"/>
-                <a:ea typeface="Meiryo"/>
-              </a:rPr>
-              <a:t>・テーマ2  LNB・Pana-CIM管理文書の作成 — 9月16日以降 / 進行中(手順書案2冊・未承認)</a:t>
-            </a:r>
-            <a:endParaRPr lang="en-US" altLang="ja-JP" b="0" dirty="0">
-              <a:solidFill>
-                <a:srgbClr val="000000"/>
-              </a:solidFill>
-              <a:latin typeface="Meiryo"/>
-              <a:ea typeface="Meiryo"/>
-            </a:endParaRPr>
-          </a:p>
-          <a:p>
-            <a:pPr algn="l">
-              <a:lnSpc>
-                <a:spcPct val="112000"/>
-              </a:lnSpc>
-              <a:spcAft>
-                <a:spcPts val="400"/>
-              </a:spcAft>
-            </a:pPr>
-            <a:r>
-              <a:rPr lang="ja-JP" altLang="en-US" b="0" dirty="0">
-                <a:solidFill>
-                  <a:srgbClr val="000000"/>
-                </a:solidFill>
-                <a:latin typeface="Meiryo"/>
-                <a:ea typeface="Meiryo"/>
-              </a:rPr>
-              <a:t>・継続  固定テーブル棚卸しの本番 — 10/23〜26予定</a:t>
-            </a:r>
-            <a:endParaRPr lang="en-US" altLang="ja-JP" b="0" dirty="0">
-              <a:solidFill>
-                <a:srgbClr val="000000"/>
-              </a:solidFill>
-              <a:latin typeface="Meiryo"/>
-              <a:ea typeface="Meiryo"/>
-            </a:endParaRPr>
-          </a:p>
-        </p:txBody>
-      </p:sp>
     </p:spTree>
   </p:cSld>
   <p:clrMapOvr>
@@ -6023,14 +6081,14 @@
 </file>
 
 <file path=ppt/slides/slide3.xml><?xml version="1.0" encoding="utf-8"?>
-<p:sld xmlns:a="http://schemas.openxmlformats.org/drawingml/2006/main" xmlns:a16="http://schemas.microsoft.com/office/drawing/2014/main" xmlns:ns3="http://schemas.microsoft.com/office/powerpoint/2010/main" xmlns:p="http://schemas.openxmlformats.org/presentationml/2006/main">
+<p:sld xmlns:a="http://schemas.openxmlformats.org/drawingml/2006/main" xmlns:r="http://schemas.openxmlformats.org/officeDocument/2006/relationships" xmlns:p="http://schemas.openxmlformats.org/presentationml/2006/main">
   <p:cSld>
     <p:spTree>
       <p:nvGrpSpPr>
         <p:cNvPr id="1" name="">
           <a:extLst>
             <a:ext uri="{FF2B5EF4-FFF2-40B4-BE49-F238E27FC236}">
-              <a16:creationId id="{14C09242-80D5-04D1-AA59-FD8FAB0FBAC6}"/>
+              <a16:creationId xmlns:a16="http://schemas.microsoft.com/office/drawing/2014/main" id="{14C09242-80D5-04D1-AA59-FD8FAB0FBAC6}"/>
             </a:ext>
           </a:extLst>
         </p:cNvPr>
@@ -6050,7 +6108,7 @@
           <p:cNvPr id="21506" name="Rectangle 2">
             <a:extLst>
               <a:ext uri="{FF2B5EF4-FFF2-40B4-BE49-F238E27FC236}">
-                <a16:creationId id="{BBF3B7B6-7F4A-254F-EB33-2638E125F1E0}"/>
+                <a16:creationId xmlns:a16="http://schemas.microsoft.com/office/drawing/2014/main" id="{BBF3B7B6-7F4A-254F-EB33-2638E125F1E0}"/>
               </a:ext>
             </a:extLst>
           </p:cNvPr>
@@ -6079,27 +6137,7 @@
                 <a:latin typeface="Meiryo"/>
                 <a:ea typeface="Meiryo"/>
               </a:rPr>
-              <a:t>Topics</a:t>
-            </a:r>
-            <a:r>
-              <a:rPr lang="en-US" altLang="ja-JP" sz="3600" b="1" dirty="0">
-                <a:solidFill>
-                  <a:schemeClr val="bg1"/>
-                </a:solidFill>
-                <a:latin typeface="Meiryo"/>
-                <a:ea typeface="Meiryo"/>
-              </a:rPr>
-              <a:t>1</a:t>
-            </a:r>
-            <a:r>
-              <a:rPr lang="ja-JP" altLang="en-US" sz="3600" b="1" dirty="0">
-                <a:solidFill>
-                  <a:schemeClr val="bg1"/>
-                </a:solidFill>
-                <a:latin typeface="Meiryo"/>
-                <a:ea typeface="Meiryo"/>
-              </a:rPr>
-              <a:t>　0確認マクロの整備</a:t>
+              <a:t>Topics 1　0確認マクロver.2の運用確定</a:t>
             </a:r>
             <a:endParaRPr lang="ja-JP" altLang="en-US" sz="3600" dirty="0">
               <a:solidFill>
@@ -6114,7 +6152,7 @@
           <p:cNvPr id="5" name="R20">
             <a:extLst>
               <a:ext uri="{FF2B5EF4-FFF2-40B4-BE49-F238E27FC236}">
-                <a16:creationId id="{03ADD616-96E1-C816-722E-D432D1B1434B}"/>
+                <a16:creationId xmlns:a16="http://schemas.microsoft.com/office/drawing/2014/main" id="{03ADD616-96E1-C816-722E-D432D1B1434B}"/>
               </a:ext>
             </a:extLst>
           </p:cNvPr>
@@ -6152,7 +6190,7 @@
           <p:cNvPr id="7" name="TB21">
             <a:extLst>
               <a:ext uri="{FF2B5EF4-FFF2-40B4-BE49-F238E27FC236}">
-                <a16:creationId id="{9D8E4493-09ED-D66D-BB69-F4E17FDDAAE5}"/>
+                <a16:creationId xmlns:a16="http://schemas.microsoft.com/office/drawing/2014/main" id="{9D8E4493-09ED-D66D-BB69-F4E17FDDAAE5}"/>
               </a:ext>
             </a:extLst>
           </p:cNvPr>
@@ -6162,7 +6200,7 @@
         <p:spPr>
           <a:xfrm>
             <a:off x="36000" y="928195"/>
-            <a:ext cx="1208600" cy="288000"/>
+            <a:ext cx="2461667" cy="288000"/>
           </a:xfrm>
           <a:prstGeom prst="rect">
             <a:avLst/>
@@ -6191,7 +6229,7 @@
                 <a:latin typeface="Meiryo"/>
                 <a:ea typeface="Meiryo"/>
               </a:rPr>
-              <a:t>実施時期：9月〜10月</a:t>
+              <a:t>実施時期：9〜10月</a:t>
             </a:r>
           </a:p>
         </p:txBody>
@@ -6201,7 +6239,7 @@
           <p:cNvPr id="9" name="TB22">
             <a:extLst>
               <a:ext uri="{FF2B5EF4-FFF2-40B4-BE49-F238E27FC236}">
-                <a16:creationId id="{A76CBF8E-780A-F613-552A-79DF92A79B34}"/>
+                <a16:creationId xmlns:a16="http://schemas.microsoft.com/office/drawing/2014/main" id="{A76CBF8E-780A-F613-552A-79DF92A79B34}"/>
               </a:ext>
             </a:extLst>
           </p:cNvPr>
@@ -6250,7 +6288,7 @@
           <p:cNvPr id="11" name="TB23">
             <a:extLst>
               <a:ext uri="{FF2B5EF4-FFF2-40B4-BE49-F238E27FC236}">
-                <a16:creationId id="{334C37F2-BE3E-BFC0-CAB9-D3917FDC0606}"/>
+                <a16:creationId xmlns:a16="http://schemas.microsoft.com/office/drawing/2014/main" id="{334C37F2-BE3E-BFC0-CAB9-D3917FDC0606}"/>
               </a:ext>
             </a:extLst>
           </p:cNvPr>
@@ -6289,7 +6327,7 @@
                 <a:latin typeface="Meiryo"/>
                 <a:ea typeface="Meiryo"/>
               </a:rPr>
-              <a:t>・0確認(棚卸し前に消費済みリールの在庫をゼロにする確認)をしていた担当者が不在で、手順が残っていない。</a:t>
+              <a:t>・0確認は棚卸し前の必須作業だが、手順書が残らず担当者も不在で、動かない原因を切り分けられなかった。</a:t>
             </a:r>
             <a:endParaRPr lang="en-US" altLang="ja-JP" b="0" dirty="0">
               <a:solidFill>
@@ -6316,7 +6354,7 @@
                 <a:latin typeface="Meiryo"/>
                 <a:ea typeface="Meiryo"/>
               </a:rPr>
-              <a:t>・消し込みの判断を誰が出すのかも分からないまま、棚卸し本番(10月末)を迎える状態だった。</a:t>
+              <a:t>・原因が入力CSVかマクロかを判別する方法が無く、推測に頼った報告になっていた。</a:t>
             </a:r>
             <a:endParaRPr lang="en-US" altLang="ja-JP" b="0" dirty="0">
               <a:solidFill>
@@ -6333,7 +6371,7 @@
           <p:cNvPr id="13" name="TB24">
             <a:extLst>
               <a:ext uri="{FF2B5EF4-FFF2-40B4-BE49-F238E27FC236}">
-                <a16:creationId id="{CFA581EB-E5DD-E949-61AD-F14177A9CC17}"/>
+                <a16:creationId xmlns:a16="http://schemas.microsoft.com/office/drawing/2014/main" id="{CFA581EB-E5DD-E949-61AD-F14177A9CC17}"/>
               </a:ext>
             </a:extLst>
           </p:cNvPr>
@@ -6382,7 +6420,7 @@
           <p:cNvPr id="15" name="TB25">
             <a:extLst>
               <a:ext uri="{FF2B5EF4-FFF2-40B4-BE49-F238E27FC236}">
-                <a16:creationId id="{CBB4D034-4453-9918-E427-6F3BF26F1E67}"/>
+                <a16:creationId xmlns:a16="http://schemas.microsoft.com/office/drawing/2014/main" id="{CBB4D034-4453-9918-E427-6F3BF26F1E67}"/>
               </a:ext>
             </a:extLst>
           </p:cNvPr>
@@ -6421,7 +6459,7 @@
                 <a:latin typeface="Meiryo"/>
                 <a:ea typeface="Meiryo"/>
               </a:rPr>
-              <a:t>・マクロのExcelとVBAを解析し、セル単位の意味まで仕様書化(手順 Step1〜11)。</a:t>
+              <a:t>・マクロと入力CSVを照合するスクリプトを作成し、原因の切り分けを機械化した。</a:t>
             </a:r>
             <a:endParaRPr lang="en-US" altLang="ja-JP" b="0" dirty="0">
               <a:solidFill>
@@ -6448,7 +6486,7 @@
                 <a:latin typeface="Meiryo"/>
                 <a:ea typeface="Meiryo"/>
               </a:rPr>
-              <a:t>・入力CSVを全件照合し、0確認の対象件数を数えた。</a:t>
+              <a:t>・9/28にコンパイルエラー2つが原因と報告したが誤診断。10/2に無変更で実機成功し訂正。</a:t>
             </a:r>
             <a:endParaRPr lang="en-US" altLang="ja-JP" b="0" dirty="0">
               <a:solidFill>
@@ -6465,7 +6503,7 @@
           <p:cNvPr id="17" name="TB26">
             <a:extLst>
               <a:ext uri="{FF2B5EF4-FFF2-40B4-BE49-F238E27FC236}">
-                <a16:creationId id="{9EA7CA49-8438-F8C9-4C30-426972466047}"/>
+                <a16:creationId xmlns:a16="http://schemas.microsoft.com/office/drawing/2014/main" id="{9EA7CA49-8438-F8C9-4C30-426972466047}"/>
               </a:ext>
             </a:extLst>
           </p:cNvPr>
@@ -6514,7 +6552,7 @@
           <p:cNvPr id="19" name="TB27">
             <a:extLst>
               <a:ext uri="{FF2B5EF4-FFF2-40B4-BE49-F238E27FC236}">
-                <a16:creationId id="{0E391B8E-AB01-AC75-D1D9-4BA5617A534F}"/>
+                <a16:creationId xmlns:a16="http://schemas.microsoft.com/office/drawing/2014/main" id="{0E391B8E-AB01-AC75-D1D9-4BA5617A534F}"/>
               </a:ext>
             </a:extLst>
           </p:cNvPr>
@@ -6553,7 +6591,7 @@
                 <a:latin typeface="Meiryo"/>
                 <a:ea typeface="Meiryo"/>
               </a:rPr>
-              <a:t>・更新日時・マクロのコード・セルの値を突き合わせ、聞けない作業を実態から復元。</a:t>
+              <a:t>・9/28時点の対象件数は5,848件(入力CSVは29,246行)。</a:t>
             </a:r>
           </a:p>
           <a:p>
@@ -6573,7 +6611,47 @@
                 <a:latin typeface="Meiryo"/>
                 <a:ea typeface="Meiryo"/>
               </a:rPr>
-              <a:t>・対象は在庫CSV 29,246行中6,884行(0確認)。棚卸し対象は5,848件(L1 2,090/L2 1,496/L3 3,298、9/25版)。CSVの日時で件数は変わる(10/13版は6,084件)。</a:t>
+              <a:t>・再計算スクリプトで10/2版CSV(29,345行)も記録値と一致することを確認。</a:t>
+            </a:r>
+          </a:p>
+          <a:p>
+            <a:pPr algn="l">
+              <a:lnSpc>
+                <a:spcPct val="112000"/>
+              </a:lnSpc>
+              <a:spcAft>
+                <a:spcPts val="400"/>
+              </a:spcAft>
+            </a:pPr>
+            <a:r>
+              <a:rPr lang="ja-JP" altLang="en-US" b="0" dirty="0">
+                <a:solidFill>
+                  <a:srgbClr val="000000"/>
+                </a:solidFill>
+                <a:latin typeface="Meiryo"/>
+                <a:ea typeface="Meiryo"/>
+              </a:rPr>
+              <a:t>・運用確定質問票(35問)に回答を記入し、正本を共有サーバーの「0確認マクロ_ver2.xlsm」に確定。</a:t>
+            </a:r>
+          </a:p>
+          <a:p>
+            <a:pPr algn="l">
+              <a:lnSpc>
+                <a:spcPct val="112000"/>
+              </a:lnSpc>
+              <a:spcAft>
+                <a:spcPts val="400"/>
+              </a:spcAft>
+            </a:pPr>
+            <a:r>
+              <a:rPr lang="ja-JP" altLang="en-US" b="0" dirty="0">
+                <a:solidFill>
+                  <a:srgbClr val="000000"/>
+                </a:solidFill>
+                <a:latin typeface="Meiryo"/>
+                <a:ea typeface="Meiryo"/>
+              </a:rPr>
+              <a:t>・残る確認は7件。10月末の棚卸し本番で仕上げる。</a:t>
             </a:r>
           </a:p>
         </p:txBody>
@@ -6581,7 +6659,7 @@
     </p:spTree>
     <p:extLst>
       <p:ext uri="{BB962C8B-B14F-4D97-AF65-F5344CB8AC3E}">
-        <ns3:creationId val="2416652295"/>
+        <p14:creationId xmlns:p14="http://schemas.microsoft.com/office/powerpoint/2010/main" val="2416652295"/>
       </p:ext>
     </p:extLst>
   </p:cSld>
@@ -6592,14 +6670,14 @@
 </file>
 
 <file path=ppt/slides/slide4.xml><?xml version="1.0" encoding="utf-8"?>
-<p:sld xmlns:a="http://schemas.openxmlformats.org/drawingml/2006/main" xmlns:a16="http://schemas.microsoft.com/office/drawing/2014/main" xmlns:ns3="http://schemas.microsoft.com/office/powerpoint/2010/main" xmlns:p="http://schemas.openxmlformats.org/presentationml/2006/main">
+<p:sld xmlns:a="http://schemas.openxmlformats.org/drawingml/2006/main" xmlns:r="http://schemas.openxmlformats.org/officeDocument/2006/relationships" xmlns:p="http://schemas.openxmlformats.org/presentationml/2006/main">
   <p:cSld>
     <p:spTree>
       <p:nvGrpSpPr>
         <p:cNvPr id="1" name="">
           <a:extLst>
             <a:ext uri="{FF2B5EF4-FFF2-40B4-BE49-F238E27FC236}">
-              <a16:creationId id="{D397C30C-11A3-FE08-718A-0273393F0186}"/>
+              <a16:creationId xmlns:a16="http://schemas.microsoft.com/office/drawing/2014/main" id="{D397C30C-11A3-FE08-718A-0273393F0186}"/>
             </a:ext>
           </a:extLst>
         </p:cNvPr>
@@ -6619,7 +6697,7 @@
           <p:cNvPr id="21506" name="Rectangle 2">
             <a:extLst>
               <a:ext uri="{FF2B5EF4-FFF2-40B4-BE49-F238E27FC236}">
-                <a16:creationId id="{8B5E1CCB-E003-0B0A-94DD-5D464AE71E1F}"/>
+                <a16:creationId xmlns:a16="http://schemas.microsoft.com/office/drawing/2014/main" id="{8B5E1CCB-E003-0B0A-94DD-5D464AE71E1F}"/>
               </a:ext>
             </a:extLst>
           </p:cNvPr>
@@ -6648,27 +6726,7 @@
                 <a:latin typeface="Meiryo"/>
                 <a:ea typeface="Meiryo"/>
               </a:rPr>
-              <a:t>Topics</a:t>
-            </a:r>
-            <a:r>
-              <a:rPr lang="en-US" altLang="ja-JP" sz="3600" b="1" dirty="0">
-                <a:solidFill>
-                  <a:schemeClr val="bg1"/>
-                </a:solidFill>
-                <a:latin typeface="Meiryo"/>
-                <a:ea typeface="Meiryo"/>
-              </a:rPr>
-              <a:t>1-2</a:t>
-            </a:r>
-            <a:r>
-              <a:rPr lang="ja-JP" altLang="en-US" sz="3600" b="1" dirty="0">
-                <a:solidFill>
-                  <a:schemeClr val="bg1"/>
-                </a:solidFill>
-                <a:latin typeface="Meiryo"/>
-                <a:ea typeface="Meiryo"/>
-              </a:rPr>
-              <a:t>　診断の誤りと実機での採用</a:t>
+              <a:t>Topics 2　PanaCIM・LNB管理手順書の整備</a:t>
             </a:r>
             <a:endParaRPr lang="ja-JP" altLang="en-US" sz="3600" dirty="0">
               <a:solidFill>
@@ -6683,7 +6741,7 @@
           <p:cNvPr id="10" name="TB32">
             <a:extLst>
               <a:ext uri="{FF2B5EF4-FFF2-40B4-BE49-F238E27FC236}">
-                <a16:creationId id="{3ED9BB57-B053-F70B-D524-9A419F78B21D}"/>
+                <a16:creationId xmlns:a16="http://schemas.microsoft.com/office/drawing/2014/main" id="{3ED9BB57-B053-F70B-D524-9A419F78B21D}"/>
               </a:ext>
             </a:extLst>
           </p:cNvPr>
@@ -6732,7 +6790,7 @@
           <p:cNvPr id="14" name="S33">
             <a:extLst>
               <a:ext uri="{FF2B5EF4-FFF2-40B4-BE49-F238E27FC236}">
-                <a16:creationId id="{5B0E15B8-93C6-B5DC-8BC8-AE4DFDADDF16}"/>
+                <a16:creationId xmlns:a16="http://schemas.microsoft.com/office/drawing/2014/main" id="{5B0E15B8-93C6-B5DC-8BC8-AE4DFDADDF16}"/>
               </a:ext>
             </a:extLst>
           </p:cNvPr>
@@ -6775,7 +6833,7 @@
                 <a:latin typeface="Meiryo"/>
                 <a:ea typeface="Meiryo"/>
               </a:rPr>
-              <a:t>「動かない」との引継ぎ</a:t>
+              <a:t>草案に引用元が無い</a:t>
             </a:r>
           </a:p>
         </p:txBody>
@@ -6785,7 +6843,7 @@
           <p:cNvPr id="18" name="S34">
             <a:extLst>
               <a:ext uri="{FF2B5EF4-FFF2-40B4-BE49-F238E27FC236}">
-                <a16:creationId id="{497756DF-3408-5C63-2891-8CB7EF569B47}"/>
+                <a16:creationId xmlns:a16="http://schemas.microsoft.com/office/drawing/2014/main" id="{497756DF-3408-5C63-2891-8CB7EF569B47}"/>
               </a:ext>
             </a:extLst>
           </p:cNvPr>
@@ -6827,7 +6885,7 @@
           <p:cNvPr id="22" name="S35">
             <a:extLst>
               <a:ext uri="{FF2B5EF4-FFF2-40B4-BE49-F238E27FC236}">
-                <a16:creationId id="{1ED71925-19F6-F7EB-DF01-3604792C541E}"/>
+                <a16:creationId xmlns:a16="http://schemas.microsoft.com/office/drawing/2014/main" id="{1ED71925-19F6-F7EB-DF01-3604792C541E}"/>
               </a:ext>
             </a:extLst>
           </p:cNvPr>
@@ -6870,7 +6928,7 @@
                 <a:latin typeface="Meiryo"/>
                 <a:ea typeface="Meiryo"/>
               </a:rPr>
-              <a:t>64bit開発PCでコードを読む</a:t>
+              <a:t>再起動手順が2種混在</a:t>
             </a:r>
           </a:p>
         </p:txBody>
@@ -6880,7 +6938,7 @@
           <p:cNvPr id="25" name="S36">
             <a:extLst>
               <a:ext uri="{FF2B5EF4-FFF2-40B4-BE49-F238E27FC236}">
-                <a16:creationId id="{9AA1D80A-7EAB-E5E8-2EB1-FC55B36AF4FB}"/>
+                <a16:creationId xmlns:a16="http://schemas.microsoft.com/office/drawing/2014/main" id="{9AA1D80A-7EAB-E5E8-2EB1-FC55B36AF4FB}"/>
               </a:ext>
             </a:extLst>
           </p:cNvPr>
@@ -6922,7 +6980,7 @@
           <p:cNvPr id="27" name="S37">
             <a:extLst>
               <a:ext uri="{FF2B5EF4-FFF2-40B4-BE49-F238E27FC236}">
-                <a16:creationId id="{575B3615-02E5-2F13-6748-B3B281746601}"/>
+                <a16:creationId xmlns:a16="http://schemas.microsoft.com/office/drawing/2014/main" id="{575B3615-02E5-2F13-6748-B3B281746601}"/>
               </a:ext>
             </a:extLst>
           </p:cNvPr>
@@ -6965,7 +7023,7 @@
                 <a:latin typeface="Meiryo"/>
                 <a:ea typeface="Meiryo"/>
               </a:rPr>
-              <a:t>コンパイルエラー2つと診断(9/28)</a:t>
+              <a:t>停止と起動の区切りが無い</a:t>
             </a:r>
           </a:p>
         </p:txBody>
@@ -6975,7 +7033,7 @@
           <p:cNvPr id="29" name="S38">
             <a:extLst>
               <a:ext uri="{FF2B5EF4-FFF2-40B4-BE49-F238E27FC236}">
-                <a16:creationId id="{A3A85E53-59E3-14F1-A43D-43A5D5555EB0}"/>
+                <a16:creationId xmlns:a16="http://schemas.microsoft.com/office/drawing/2014/main" id="{A3A85E53-59E3-14F1-A43D-43A5D5555EB0}"/>
               </a:ext>
             </a:extLst>
           </p:cNvPr>
@@ -7017,7 +7075,7 @@
           <p:cNvPr id="31" name="S39">
             <a:extLst>
               <a:ext uri="{FF2B5EF4-FFF2-40B4-BE49-F238E27FC236}">
-                <a16:creationId id="{4360A1D8-3337-5B5F-A527-4558554291F7}"/>
+                <a16:creationId xmlns:a16="http://schemas.microsoft.com/office/drawing/2014/main" id="{4360A1D8-3337-5B5F-A527-4558554291F7}"/>
               </a:ext>
             </a:extLst>
           </p:cNvPr>
@@ -7060,7 +7118,7 @@
                 <a:latin typeface="Meiryo"/>
                 <a:ea typeface="Meiryo"/>
               </a:rPr>
-              <a:t>修正版コードを作成</a:t>
+              <a:t>誤って流すと生産停止</a:t>
             </a:r>
           </a:p>
         </p:txBody>
@@ -7070,7 +7128,7 @@
           <p:cNvPr id="21505" name="TB40">
             <a:extLst>
               <a:ext uri="{FF2B5EF4-FFF2-40B4-BE49-F238E27FC236}">
-                <a16:creationId id="{927C2915-20BF-81E6-ADAB-0B263E213E91}"/>
+                <a16:creationId xmlns:a16="http://schemas.microsoft.com/office/drawing/2014/main" id="{927C2915-20BF-81E6-ADAB-0B263E213E91}"/>
               </a:ext>
             </a:extLst>
           </p:cNvPr>
@@ -7109,7 +7167,7 @@
                 <a:latin typeface="Meiryo"/>
                 <a:ea typeface="Meiryo"/>
               </a:rPr>
-              <a:t>→ 実機での確認が済んでおらず、修正の正しさも検証できないままだった</a:t>
+              <a:t>→ 異常時の手順は「全ラインの生産と作業を停止」から始まり、月次と区別できる整理が必要だった</a:t>
             </a:r>
           </a:p>
         </p:txBody>
@@ -7119,7 +7177,7 @@
           <p:cNvPr id="21508" name="TB41">
             <a:extLst>
               <a:ext uri="{FF2B5EF4-FFF2-40B4-BE49-F238E27FC236}">
-                <a16:creationId id="{2292334C-0E0C-4611-CBB3-F1ED8685F0EE}"/>
+                <a16:creationId xmlns:a16="http://schemas.microsoft.com/office/drawing/2014/main" id="{2292334C-0E0C-4611-CBB3-F1ED8685F0EE}"/>
               </a:ext>
             </a:extLst>
           </p:cNvPr>
@@ -7168,7 +7226,7 @@
           <p:cNvPr id="21510" name="S42">
             <a:extLst>
               <a:ext uri="{FF2B5EF4-FFF2-40B4-BE49-F238E27FC236}">
-                <a16:creationId id="{43FF9372-D4F3-024E-F5FB-EEBCEE3D6C53}"/>
+                <a16:creationId xmlns:a16="http://schemas.microsoft.com/office/drawing/2014/main" id="{43FF9372-D4F3-024E-F5FB-EEBCEE3D6C53}"/>
               </a:ext>
             </a:extLst>
           </p:cNvPr>
@@ -7211,7 +7269,7 @@
                 <a:latin typeface="Meiryo"/>
                 <a:ea typeface="Meiryo"/>
               </a:rPr>
-              <a:t>実機で実行(10/2)</a:t>
+              <a:t>公式資料から本文を反映</a:t>
             </a:r>
           </a:p>
         </p:txBody>
@@ -7221,7 +7279,7 @@
           <p:cNvPr id="21512" name="S43">
             <a:extLst>
               <a:ext uri="{FF2B5EF4-FFF2-40B4-BE49-F238E27FC236}">
-                <a16:creationId id="{89D92C62-0182-0465-1688-F4417EC2F72B}"/>
+                <a16:creationId xmlns:a16="http://schemas.microsoft.com/office/drawing/2014/main" id="{89D92C62-0182-0465-1688-F4417EC2F72B}"/>
               </a:ext>
             </a:extLst>
           </p:cNvPr>
@@ -7263,7 +7321,7 @@
           <p:cNvPr id="21514" name="S44">
             <a:extLst>
               <a:ext uri="{FF2B5EF4-FFF2-40B4-BE49-F238E27FC236}">
-                <a16:creationId id="{D0A4DD7B-04A4-164A-EDDF-A00AC17F588E}"/>
+                <a16:creationId xmlns:a16="http://schemas.microsoft.com/office/drawing/2014/main" id="{D0A4DD7B-04A4-164A-EDDF-A00AC17F588E}"/>
               </a:ext>
             </a:extLst>
           </p:cNvPr>
@@ -7306,7 +7364,7 @@
                 <a:latin typeface="Meiryo"/>
                 <a:ea typeface="Meiryo"/>
               </a:rPr>
-              <a:t>何も変更せずに成功</a:t>
+              <a:t>月次と異常時を分離</a:t>
             </a:r>
           </a:p>
         </p:txBody>
@@ -7316,7 +7374,7 @@
           <p:cNvPr id="21516" name="S45">
             <a:extLst>
               <a:ext uri="{FF2B5EF4-FFF2-40B4-BE49-F238E27FC236}">
-                <a16:creationId id="{CE12C862-B8D7-8680-F5A6-9D5626C05174}"/>
+                <a16:creationId xmlns:a16="http://schemas.microsoft.com/office/drawing/2014/main" id="{CE12C862-B8D7-8680-F5A6-9D5626C05174}"/>
               </a:ext>
             </a:extLst>
           </p:cNvPr>
@@ -7358,7 +7416,7 @@
           <p:cNvPr id="21518" name="S46">
             <a:extLst>
               <a:ext uri="{FF2B5EF4-FFF2-40B4-BE49-F238E27FC236}">
-                <a16:creationId id="{0B1D0BFE-19E5-BEBB-29BF-6206205D297A}"/>
+                <a16:creationId xmlns:a16="http://schemas.microsoft.com/office/drawing/2014/main" id="{0B1D0BFE-19E5-BEBB-29BF-6206205D297A}"/>
               </a:ext>
             </a:extLst>
           </p:cNvPr>
@@ -7401,7 +7459,7 @@
                 <a:latin typeface="Meiryo"/>
                 <a:ea typeface="Meiryo"/>
               </a:rPr>
-              <a:t>診断は誤りと判明(現場PCは32bit)</a:t>
+              <a:t>停止1〜6／起動7〜14</a:t>
             </a:r>
           </a:p>
         </p:txBody>
@@ -7411,7 +7469,7 @@
           <p:cNvPr id="21520" name="S47">
             <a:extLst>
               <a:ext uri="{FF2B5EF4-FFF2-40B4-BE49-F238E27FC236}">
-                <a16:creationId id="{07C8C824-0855-F504-5ED2-033E183E5AC7}"/>
+                <a16:creationId xmlns:a16="http://schemas.microsoft.com/office/drawing/2014/main" id="{07C8C824-0855-F504-5ED2-033E183E5AC7}"/>
               </a:ext>
             </a:extLst>
           </p:cNvPr>
@@ -7453,7 +7511,7 @@
           <p:cNvPr id="21522" name="S48">
             <a:extLst>
               <a:ext uri="{FF2B5EF4-FFF2-40B4-BE49-F238E27FC236}">
-                <a16:creationId id="{23394E18-7729-EF9C-1A57-D32D35698E0B}"/>
+                <a16:creationId xmlns:a16="http://schemas.microsoft.com/office/drawing/2014/main" id="{23394E18-7729-EF9C-1A57-D32D35698E0B}"/>
               </a:ext>
             </a:extLst>
           </p:cNvPr>
@@ -7498,7 +7556,7 @@
                 <a:latin typeface="Meiryo"/>
                 <a:ea typeface="Meiryo"/>
               </a:rPr>
-              <a:t>ver.2を無変更で採用</a:t>
+              <a:t>管理手順書案2冊を作成</a:t>
             </a:r>
           </a:p>
         </p:txBody>
@@ -7508,7 +7566,7 @@
           <p:cNvPr id="21527" name="右大かっこ 21526">
             <a:extLst>
               <a:ext uri="{FF2B5EF4-FFF2-40B4-BE49-F238E27FC236}">
-                <a16:creationId id="{231EE372-2D83-A895-742F-441F2D69583B}"/>
+                <a16:creationId xmlns:a16="http://schemas.microsoft.com/office/drawing/2014/main" id="{231EE372-2D83-A895-742F-441F2D69583B}"/>
               </a:ext>
             </a:extLst>
           </p:cNvPr>
@@ -7559,7 +7617,7 @@
           <p:cNvPr id="21529" name="TB28">
             <a:extLst>
               <a:ext uri="{FF2B5EF4-FFF2-40B4-BE49-F238E27FC236}">
-                <a16:creationId id="{08D3BE1E-A7CA-BEB2-ADB6-594EF66852D4}"/>
+                <a16:creationId xmlns:a16="http://schemas.microsoft.com/office/drawing/2014/main" id="{08D3BE1E-A7CA-BEB2-ADB6-594EF66852D4}"/>
               </a:ext>
             </a:extLst>
           </p:cNvPr>
@@ -7608,7 +7666,7 @@
           <p:cNvPr id="21531" name="TB29">
             <a:extLst>
               <a:ext uri="{FF2B5EF4-FFF2-40B4-BE49-F238E27FC236}">
-                <a16:creationId id="{0E081BA2-CF81-69EE-3F51-8B71713AA293}"/>
+                <a16:creationId xmlns:a16="http://schemas.microsoft.com/office/drawing/2014/main" id="{0E081BA2-CF81-69EE-3F51-8B71713AA293}"/>
               </a:ext>
             </a:extLst>
           </p:cNvPr>
@@ -7647,7 +7705,7 @@
                 <a:latin typeface="Meiryo"/>
                 <a:ea typeface="Meiryo"/>
               </a:rPr>
-              <a:t>・採用版は完走版(SHA-256 419F…)。実行は松井さんまたは茂木(由美子)係長(運用確定質問票の回答済み)。</a:t>
+              <a:t>・管理書v0.12、LNB管理書v0.11に反映し、管理手順書案2冊(xlsx・PDF)を作成(未承認)。</a:t>
             </a:r>
             <a:endParaRPr lang="en-US" altLang="ja-JP" b="0" dirty="0">
               <a:solidFill>
@@ -7674,7 +7732,7 @@
                 <a:latin typeface="Meiryo"/>
                 <a:ea typeface="Meiryo"/>
               </a:rPr>
-              <a:t>・変更仕様書は「破棄(適用せず)」に訂正。修正版コードは当てない。文書は残す。</a:t>
+              <a:t>・再起動手順を停止1〜6/起動7〜14に分割し、月次と異常時を分けた。</a:t>
             </a:r>
             <a:endParaRPr lang="en-US" altLang="ja-JP" b="0" dirty="0">
               <a:solidFill>
@@ -7701,7 +7759,7 @@
                 <a:latin typeface="Meiryo"/>
                 <a:ea typeface="Meiryo"/>
               </a:rPr>
-              <a:t>・残る確認7件(採用版の特定/空白の扱い/停止方法など)を潰してから本番全件。</a:t>
+              <a:t>・相関図と画像の追加は10/28まで。LNB点検項目の登録は12/28。</a:t>
             </a:r>
             <a:endParaRPr lang="en-US" altLang="ja-JP" b="0" dirty="0">
               <a:solidFill>
@@ -7718,7 +7776,7 @@
           <p:cNvPr id="21533" name="テキスト ボックス 21532">
             <a:extLst>
               <a:ext uri="{FF2B5EF4-FFF2-40B4-BE49-F238E27FC236}">
-                <a16:creationId id="{B85F4D50-9C37-7186-F9DF-DF2611B8DAE4}"/>
+                <a16:creationId xmlns:a16="http://schemas.microsoft.com/office/drawing/2014/main" id="{B85F4D50-9C37-7186-F9DF-DF2611B8DAE4}"/>
               </a:ext>
             </a:extLst>
           </p:cNvPr>
@@ -7727,8 +7785,8 @@
         </p:nvSpPr>
         <p:spPr>
           <a:xfrm>
-            <a:off x="4820167" y="1137917"/>
-            <a:ext cx="2095665" cy="350865"/>
+            <a:off x="4068000" y="1137917"/>
+            <a:ext cx="3600000" cy="350865"/>
           </a:xfrm>
           <a:prstGeom prst="rect">
             <a:avLst/>
@@ -7762,7 +7820,7 @@
                 <a:latin typeface="Meiryo"/>
                 <a:ea typeface="Meiryo"/>
               </a:rPr>
-              <a:t>実機で未確認だった</a:t>
+              <a:t>10/14 会議で統合方針を決定</a:t>
             </a:r>
             <a:endParaRPr lang="ja-JP" altLang="en-US" sz="1600" b="0" dirty="0">
               <a:solidFill>
@@ -7782,7 +7840,7 @@
           <p:cNvPr id="21535" name="R20">
             <a:extLst>
               <a:ext uri="{FF2B5EF4-FFF2-40B4-BE49-F238E27FC236}">
-                <a16:creationId id="{2E47C8EF-6705-D95C-B05D-E243520E31E0}"/>
+                <a16:creationId xmlns:a16="http://schemas.microsoft.com/office/drawing/2014/main" id="{2E47C8EF-6705-D95C-B05D-E243520E31E0}"/>
               </a:ext>
             </a:extLst>
           </p:cNvPr>
@@ -7818,7 +7876,7 @@
     </p:spTree>
     <p:extLst>
       <p:ext uri="{BB962C8B-B14F-4D97-AF65-F5344CB8AC3E}">
-        <ns3:creationId val="2460916238"/>
+        <p14:creationId xmlns:p14="http://schemas.microsoft.com/office/powerpoint/2010/main" val="2460916238"/>
       </p:ext>
     </p:extLst>
   </p:cSld>
@@ -7829,14 +7887,14 @@
 </file>
 
 <file path=ppt/slides/slide5.xml><?xml version="1.0" encoding="utf-8"?>
-<p:sld xmlns:a="http://schemas.openxmlformats.org/drawingml/2006/main" xmlns:a16="http://schemas.microsoft.com/office/drawing/2014/main" xmlns:ns3="http://schemas.microsoft.com/office/powerpoint/2010/main" xmlns:p="http://schemas.openxmlformats.org/presentationml/2006/main">
+<p:sld xmlns:a="http://schemas.openxmlformats.org/drawingml/2006/main" xmlns:r="http://schemas.openxmlformats.org/officeDocument/2006/relationships" xmlns:p="http://schemas.openxmlformats.org/presentationml/2006/main">
   <p:cSld>
     <p:spTree>
       <p:nvGrpSpPr>
         <p:cNvPr id="1" name="">
           <a:extLst>
             <a:ext uri="{FF2B5EF4-FFF2-40B4-BE49-F238E27FC236}">
-              <a16:creationId id="{379447C5-4718-8CD9-96CE-75F71C72756D}"/>
+              <a16:creationId xmlns:a16="http://schemas.microsoft.com/office/drawing/2014/main" id="{379447C5-4718-8CD9-96CE-75F71C72756D}"/>
             </a:ext>
           </a:extLst>
         </p:cNvPr>
@@ -7856,7 +7914,7 @@
           <p:cNvPr id="21506" name="Rectangle 2">
             <a:extLst>
               <a:ext uri="{FF2B5EF4-FFF2-40B4-BE49-F238E27FC236}">
-                <a16:creationId id="{64226943-6F0D-9B1F-EB98-B1CB9F46A659}"/>
+                <a16:creationId xmlns:a16="http://schemas.microsoft.com/office/drawing/2014/main" id="{64226943-6F0D-9B1F-EB98-B1CB9F46A659}"/>
               </a:ext>
             </a:extLst>
           </p:cNvPr>
@@ -7885,27 +7943,7 @@
                 <a:latin typeface="Meiryo"/>
                 <a:ea typeface="Meiryo"/>
               </a:rPr>
-              <a:t>Topics</a:t>
-            </a:r>
-            <a:r>
-              <a:rPr lang="en-US" altLang="ja-JP" sz="3600" b="1" dirty="0">
-                <a:solidFill>
-                  <a:schemeClr val="bg1"/>
-                </a:solidFill>
-                <a:latin typeface="Meiryo"/>
-                <a:ea typeface="Meiryo"/>
-              </a:rPr>
-              <a:t>2</a:t>
-            </a:r>
-            <a:r>
-              <a:rPr lang="ja-JP" altLang="en-US" sz="3600" b="1" dirty="0">
-                <a:solidFill>
-                  <a:schemeClr val="bg1"/>
-                </a:solidFill>
-                <a:latin typeface="Meiryo"/>
-                <a:ea typeface="Meiryo"/>
-              </a:rPr>
-              <a:t>　LNB・Pana-CIM管理文書の作成</a:t>
+              <a:t>Topics 3　固定テーブル棚卸しマクロver.2の改修</a:t>
             </a:r>
             <a:endParaRPr lang="ja-JP" altLang="en-US" sz="3600" dirty="0">
               <a:solidFill>
@@ -7920,7 +7958,7 @@
           <p:cNvPr id="6" name="TB54">
             <a:extLst>
               <a:ext uri="{FF2B5EF4-FFF2-40B4-BE49-F238E27FC236}">
-                <a16:creationId id="{9F0FB3CC-52F3-1B56-A3C9-4771819CFED5}"/>
+                <a16:creationId xmlns:a16="http://schemas.microsoft.com/office/drawing/2014/main" id="{9F0FB3CC-52F3-1B56-A3C9-4771819CFED5}"/>
               </a:ext>
             </a:extLst>
           </p:cNvPr>
@@ -7969,7 +8007,7 @@
           <p:cNvPr id="10" name="TB55">
             <a:extLst>
               <a:ext uri="{FF2B5EF4-FFF2-40B4-BE49-F238E27FC236}">
-                <a16:creationId id="{A99D0592-4AAB-EE9D-86AD-508AC56407B7}"/>
+                <a16:creationId xmlns:a16="http://schemas.microsoft.com/office/drawing/2014/main" id="{A99D0592-4AAB-EE9D-86AD-508AC56407B7}"/>
               </a:ext>
             </a:extLst>
           </p:cNvPr>
@@ -8008,7 +8046,7 @@
                 <a:latin typeface="Meiryo"/>
                 <a:ea typeface="Meiryo"/>
               </a:rPr>
-              <a:t>・点検や操作の手順が人に依存している。</a:t>
+              <a:t>・旧版は現場で動く実績がある一方、空欄の扱い・送信漏れなど直すべき点が判明していた。</a:t>
             </a:r>
           </a:p>
           <a:p>
@@ -8028,7 +8066,7 @@
                 <a:latin typeface="Meiryo"/>
                 <a:ea typeface="Meiryo"/>
               </a:rPr>
-              <a:t>・過去のバックアップ障害2件は「成否を確認する担当が決まっていなかった」ことで長期化(EGProサブサーバー1年以上/nksv523 6月から)。</a:t>
+              <a:t>・実機での検証工程が無く、本番までに動作を確かめる方法が残されていなかった。</a:t>
             </a:r>
           </a:p>
         </p:txBody>
@@ -8038,7 +8076,7 @@
           <p:cNvPr id="14" name="TB56">
             <a:extLst>
               <a:ext uri="{FF2B5EF4-FFF2-40B4-BE49-F238E27FC236}">
-                <a16:creationId id="{E01BB2FC-B37F-D766-FE9D-4C8FAD15E35A}"/>
+                <a16:creationId xmlns:a16="http://schemas.microsoft.com/office/drawing/2014/main" id="{E01BB2FC-B37F-D766-FE9D-4C8FAD15E35A}"/>
               </a:ext>
             </a:extLst>
           </p:cNvPr>
@@ -8087,7 +8125,7 @@
           <p:cNvPr id="18" name="TB57">
             <a:extLst>
               <a:ext uri="{FF2B5EF4-FFF2-40B4-BE49-F238E27FC236}">
-                <a16:creationId id="{65F3A6C4-9A81-1EF9-8F56-E2D36B994E0B}"/>
+                <a16:creationId xmlns:a16="http://schemas.microsoft.com/office/drawing/2014/main" id="{65F3A6C4-9A81-1EF9-8F56-E2D36B994E0B}"/>
               </a:ext>
             </a:extLst>
           </p:cNvPr>
@@ -8126,7 +8164,7 @@
                 <a:latin typeface="Meiryo"/>
                 <a:ea typeface="Meiryo"/>
               </a:rPr>
-              <a:t>・管理書+SOPの二層構造で作成。本番のみの手順には「操作の種別/取り消し可否/中断条件」の三欄を追加。</a:t>
+              <a:t>・改良点だけをver.2本体へ統合(設定読み込み1回化・空欄スキップ・送信漏れで中断)。</a:t>
             </a:r>
             <a:endParaRPr lang="ja-JP" altLang="en-US" sz="1600" b="0" dirty="0">
               <a:solidFill>
@@ -8153,7 +8191,7 @@
                 <a:latin typeface="Meiryo"/>
                 <a:ea typeface="Meiryo"/>
               </a:rPr>
-              <a:t>・公式操作手順書(0494-912039(06))から再起動・バックアップ手順を本文転記(10/5)。月次の計画再起動と異常時の14ステップ(停止1〜6/起動7〜14)は章を分けて記載。</a:t>
+              <a:t>・旧版の実績を尊重し、勝手な書き換えはしない方針で改修。</a:t>
             </a:r>
             <a:endParaRPr lang="ja-JP" altLang="en-US" sz="1600" b="0" dirty="0">
               <a:solidFill>
@@ -8163,6 +8201,33 @@
               <a:ea typeface="Meiryo"/>
             </a:endParaRPr>
           </a:p>
+          <a:p>
+            <a:pPr algn="l">
+              <a:lnSpc>
+                <a:spcPct val="112000"/>
+              </a:lnSpc>
+              <a:spcAft>
+                <a:spcPts val="400"/>
+              </a:spcAft>
+            </a:pPr>
+            <a:r>
+              <a:rPr lang="ja-JP" altLang="en-US" sz="1600" b="0" dirty="0">
+                <a:solidFill>
+                  <a:srgbClr val="000000"/>
+                </a:solidFill>
+                <a:latin typeface="Meiryo"/>
+                <a:ea typeface="Meiryo"/>
+              </a:rPr>
+              <a:t>・テストケース47件を作成し、コンパイル→試し実行10件→本番1件→10件の段階で検証する。</a:t>
+            </a:r>
+            <a:endParaRPr lang="ja-JP" altLang="en-US" sz="1600" b="0" dirty="0">
+              <a:solidFill>
+                <a:srgbClr val="000000"/>
+              </a:solidFill>
+              <a:latin typeface="Meiryo"/>
+              <a:ea typeface="Meiryo"/>
+            </a:endParaRPr>
+          </a:p>
         </p:txBody>
       </p:sp>
       <p:sp>
@@ -8170,7 +8235,7 @@
           <p:cNvPr id="21" name="TB58">
             <a:extLst>
               <a:ext uri="{FF2B5EF4-FFF2-40B4-BE49-F238E27FC236}">
-                <a16:creationId id="{51637B88-5226-9238-B14D-891D3D348264}"/>
+                <a16:creationId xmlns:a16="http://schemas.microsoft.com/office/drawing/2014/main" id="{51637B88-5226-9238-B14D-891D3D348264}"/>
               </a:ext>
             </a:extLst>
           </p:cNvPr>
@@ -8219,7 +8284,7 @@
           <p:cNvPr id="23" name="T59">
             <a:extLst>
               <a:ext uri="{FF2B5EF4-FFF2-40B4-BE49-F238E27FC236}">
-                <a16:creationId id="{A1CE0432-81FE-9A98-8528-48DD5FFDE362}"/>
+                <a16:creationId xmlns:a16="http://schemas.microsoft.com/office/drawing/2014/main" id="{A1CE0432-81FE-9A98-8528-48DD5FFDE362}"/>
               </a:ext>
             </a:extLst>
           </p:cNvPr>
@@ -8229,14 +8294,14 @@
           <p:nvPr>
             <p:extLst>
               <p:ext uri="{D42A27DB-BD31-4B8C-83A1-F6EECF244321}">
-                <ns3:modId val="2037148714"/>
+                <p14:modId xmlns:p14="http://schemas.microsoft.com/office/powerpoint/2010/main" val="2037148714"/>
               </p:ext>
             </p:extLst>
           </p:nvPr>
         </p:nvGraphicFramePr>
         <p:xfrm>
           <a:off x="756000" y="3996000"/>
-          <a:ext cx="10656000" cy="2195998"/>
+          <a:ext cx="10656000" cy="1568570"/>
         </p:xfrm>
         <a:graphic>
           <a:graphicData uri="http://schemas.openxmlformats.org/drawingml/2006/table">
@@ -8246,21 +8311,21 @@
                 <a:gridCol w="2232000">
                   <a:extLst>
                     <a:ext uri="{9D8B030D-6E8A-4147-A177-3AD203B41FA5}">
-                      <a16:colId val="20000"/>
+                      <a16:colId xmlns:a16="http://schemas.microsoft.com/office/drawing/2014/main" val="20000"/>
                     </a:ext>
                   </a:extLst>
                 </a:gridCol>
                 <a:gridCol w="5688000">
                   <a:extLst>
                     <a:ext uri="{9D8B030D-6E8A-4147-A177-3AD203B41FA5}">
-                      <a16:colId val="20001"/>
+                      <a16:colId xmlns:a16="http://schemas.microsoft.com/office/drawing/2014/main" val="20001"/>
                     </a:ext>
                   </a:extLst>
                 </a:gridCol>
                 <a:gridCol w="2736000">
                   <a:extLst>
                     <a:ext uri="{9D8B030D-6E8A-4147-A177-3AD203B41FA5}">
-                      <a16:colId val="20002"/>
+                      <a16:colId xmlns:a16="http://schemas.microsoft.com/office/drawing/2014/main" val="20002"/>
                     </a:ext>
                   </a:extLst>
                 </a:gridCol>
@@ -8400,7 +8465,7 @@
                 </a:tc>
                 <a:extLst>
                   <a:ext uri="{0D108BD9-81ED-4DB2-BD59-A6C34878D82A}">
-                    <a16:rowId val="10000"/>
+                    <a16:rowId xmlns:a16="http://schemas.microsoft.com/office/drawing/2014/main" val="10000"/>
                   </a:ext>
                 </a:extLst>
               </a:tr>
@@ -8419,7 +8484,7 @@
                           <a:latin typeface="Meiryo"/>
                           <a:ea typeface="Meiryo"/>
                         </a:rPr>
-                        <a:t>Pana-CIM管理書</a:t>
+                        <a:t>改修の統合</a:t>
                       </a:r>
                     </a:p>
                   </a:txBody>
@@ -8463,7 +8528,7 @@
                           <a:latin typeface="Meiryo"/>
                           <a:ea typeface="Meiryo"/>
                         </a:rPr>
-                        <a:t>再起動・バックアップ手順を本文転記済み</a:t>
+                        <a:t>ver.2本体へ統合(3点)</a:t>
                       </a:r>
                     </a:p>
                   </a:txBody>
@@ -8507,7 +8572,7 @@
                           <a:latin typeface="Meiryo"/>
                           <a:ea typeface="Meiryo"/>
                         </a:rPr>
-                        <a:t>草案 v0.12</a:t>
+                        <a:t>完了(未検証)</a:t>
                       </a:r>
                     </a:p>
                   </a:txBody>
@@ -8539,7 +8604,7 @@
                 </a:tc>
                 <a:extLst>
                   <a:ext uri="{0D108BD9-81ED-4DB2-BD59-A6C34878D82A}">
-                    <a16:rowId val="10001"/>
+                    <a16:rowId xmlns:a16="http://schemas.microsoft.com/office/drawing/2014/main" val="10001"/>
                   </a:ext>
                 </a:extLst>
               </a:tr>
@@ -8558,7 +8623,7 @@
                           <a:latin typeface="Meiryo"/>
                           <a:ea typeface="Meiryo"/>
                         </a:rPr>
-                        <a:t>LNB管理書</a:t>
+                        <a:t>テストケース</a:t>
                       </a:r>
                     </a:p>
                   </a:txBody>
@@ -8602,7 +8667,7 @@
                           <a:latin typeface="Meiryo"/>
                           <a:ea typeface="Meiryo"/>
                         </a:rPr>
-                        <a:t>接続先3系統を反映。点検項目は聞き取り待ち</a:t>
+                        <a:t>47件を作成</a:t>
                       </a:r>
                     </a:p>
                   </a:txBody>
@@ -8646,7 +8711,7 @@
                           <a:latin typeface="Meiryo"/>
                           <a:ea typeface="Meiryo"/>
                         </a:rPr>
-                        <a:t>草案 v0.11</a:t>
+                        <a:t>完了</a:t>
                       </a:r>
                     </a:p>
                   </a:txBody>
@@ -8678,7 +8743,7 @@
                 </a:tc>
                 <a:extLst>
                   <a:ext uri="{0D108BD9-81ED-4DB2-BD59-A6C34878D82A}">
-                    <a16:rowId val="10002"/>
+                    <a16:rowId xmlns:a16="http://schemas.microsoft.com/office/drawing/2014/main" val="10002"/>
                   </a:ext>
                 </a:extLst>
               </a:tr>
@@ -8697,7 +8762,7 @@
                           <a:latin typeface="Meiryo"/>
                           <a:ea typeface="Meiryo"/>
                         </a:rPr>
-                        <a:t>管理手順書案2冊</a:t>
+                        <a:t>実機検証</a:t>
                       </a:r>
                     </a:p>
                   </a:txBody>
@@ -8741,7 +8806,7 @@
                           <a:latin typeface="Meiryo"/>
                           <a:ea typeface="Meiryo"/>
                         </a:rPr>
-                        <a:t>Pana-CIM 107頁/LNB 99頁(10/15作成)</a:t>
+                        <a:t>コンパイル→試し実行10件→本番1件→10件</a:t>
                       </a:r>
                     </a:p>
                   </a:txBody>
@@ -8785,7 +8850,7 @@
                           <a:latin typeface="Meiryo"/>
                           <a:ea typeface="Meiryo"/>
                         </a:rPr>
-                        <a:t>未承認</a:t>
+                        <a:t>未実施</a:t>
                       </a:r>
                     </a:p>
                   </a:txBody>
@@ -8817,7 +8882,7 @@
                 </a:tc>
                 <a:extLst>
                   <a:ext uri="{0D108BD9-81ED-4DB2-BD59-A6C34878D82A}">
-                    <a16:rowId val="10003"/>
+                    <a16:rowId xmlns:a16="http://schemas.microsoft.com/office/drawing/2014/main" val="10003"/>
                   </a:ext>
                 </a:extLst>
               </a:tr>
@@ -8836,7 +8901,7 @@
                           <a:latin typeface="Meiryo"/>
                           <a:ea typeface="Meiryo"/>
                         </a:rPr>
-                        <a:t>相関図</a:t>
+                        <a:t>本番</a:t>
                       </a:r>
                     </a:p>
                   </a:txBody>
@@ -8880,7 +8945,7 @@
                           <a:latin typeface="Meiryo"/>
                           <a:ea typeface="Meiryo"/>
                         </a:rPr>
-                        <a:t>手順と文書の関係を図示</a:t>
+                        <a:t>生産終了ラインから順に棚卸しを実施</a:t>
                       </a:r>
                     </a:p>
                   </a:txBody>
@@ -8924,7 +8989,7 @@
                           <a:latin typeface="Meiryo"/>
                           <a:ea typeface="Meiryo"/>
                         </a:rPr>
-                        <a:t>10/28期限</a:t>
+                        <a:t>10/23〜26(予定)</a:t>
                       </a:r>
                     </a:p>
                   </a:txBody>
@@ -8956,285 +9021,7 @@
                 </a:tc>
                 <a:extLst>
                   <a:ext uri="{0D108BD9-81ED-4DB2-BD59-A6C34878D82A}">
-                    <a16:rowId val="10004"/>
-                  </a:ext>
-                </a:extLst>
-              </a:tr>
-              <a:tr h="313714">
-                <a:tc>
-                  <a:txBody>
-                    <a:bodyPr/>
-                    <a:lstStyle/>
-                    <a:p>
-                      <a:pPr algn="l"/>
-                      <a:r>
-                        <a:rPr lang="ja-JP" altLang="en-US" sz="1400" b="0" dirty="0">
-                          <a:solidFill>
-                            <a:srgbClr val="000000"/>
-                          </a:solidFill>
-                          <a:latin typeface="Meiryo"/>
-                          <a:ea typeface="Meiryo"/>
-                        </a:rPr>
-                        <a:t>LNB点検項目の聞き取り</a:t>
-                      </a:r>
-                    </a:p>
-                  </a:txBody>
-                  <a:tcPr marL="72000" marR="72000" marT="36000" marB="36000" anchor="ctr">
-                    <a:lnL w="9525" cap="flat">
-                      <a:solidFill>
-                        <a:srgbClr val="9B9B9B"/>
-                      </a:solidFill>
-                    </a:lnL>
-                    <a:lnR w="9525" cap="flat">
-                      <a:solidFill>
-                        <a:srgbClr val="9B9B9B"/>
-                      </a:solidFill>
-                    </a:lnR>
-                    <a:lnT w="9525" cap="flat">
-                      <a:solidFill>
-                        <a:srgbClr val="9B9B9B"/>
-                      </a:solidFill>
-                    </a:lnT>
-                    <a:lnB w="9525" cap="flat">
-                      <a:solidFill>
-                        <a:srgbClr val="9B9B9B"/>
-                      </a:solidFill>
-                    </a:lnB>
-                    <a:solidFill>
-                      <a:srgbClr val="FFFFFF"/>
-                    </a:solidFill>
-                  </a:tcPr>
-                </a:tc>
-                <a:tc>
-                  <a:txBody>
-                    <a:bodyPr/>
-                    <a:lstStyle/>
-                    <a:p>
-                      <a:pPr algn="l"/>
-                      <a:r>
-                        <a:rPr lang="ja-JP" altLang="en-US" sz="1400" b="0" dirty="0">
-                          <a:solidFill>
-                            <a:srgbClr val="000000"/>
-                          </a:solidFill>
-                          <a:latin typeface="Meiryo"/>
-                          <a:ea typeface="Meiryo"/>
-                        </a:rPr>
-                        <a:t>対象はL1〜L3端末と稼働LNBソフト</a:t>
-                      </a:r>
-                    </a:p>
-                  </a:txBody>
-                  <a:tcPr marL="72000" marR="72000" marT="36000" marB="36000" anchor="ctr">
-                    <a:lnL w="9525" cap="flat">
-                      <a:solidFill>
-                        <a:srgbClr val="9B9B9B"/>
-                      </a:solidFill>
-                    </a:lnL>
-                    <a:lnR w="9525" cap="flat">
-                      <a:solidFill>
-                        <a:srgbClr val="9B9B9B"/>
-                      </a:solidFill>
-                    </a:lnR>
-                    <a:lnT w="9525" cap="flat">
-                      <a:solidFill>
-                        <a:srgbClr val="9B9B9B"/>
-                      </a:solidFill>
-                    </a:lnT>
-                    <a:lnB w="9525" cap="flat">
-                      <a:solidFill>
-                        <a:srgbClr val="9B9B9B"/>
-                      </a:solidFill>
-                    </a:lnB>
-                    <a:solidFill>
-                      <a:srgbClr val="FFFFFF"/>
-                    </a:solidFill>
-                  </a:tcPr>
-                </a:tc>
-                <a:tc>
-                  <a:txBody>
-                    <a:bodyPr/>
-                    <a:lstStyle/>
-                    <a:p>
-                      <a:pPr algn="l"/>
-                      <a:r>
-                        <a:rPr lang="ja-JP" altLang="en-US" sz="1400" b="0" dirty="0">
-                          <a:solidFill>
-                            <a:srgbClr val="000000"/>
-                          </a:solidFill>
-                          <a:latin typeface="Meiryo"/>
-                          <a:ea typeface="Meiryo"/>
-                        </a:rPr>
-                        <a:t>未着手(登録期限12/28)</a:t>
-                      </a:r>
-                    </a:p>
-                  </a:txBody>
-                  <a:tcPr marL="72000" marR="72000" marT="36000" marB="36000" anchor="ctr">
-                    <a:lnL w="9525" cap="flat">
-                      <a:solidFill>
-                        <a:srgbClr val="9B9B9B"/>
-                      </a:solidFill>
-                    </a:lnL>
-                    <a:lnR w="9525" cap="flat">
-                      <a:solidFill>
-                        <a:srgbClr val="9B9B9B"/>
-                      </a:solidFill>
-                    </a:lnR>
-                    <a:lnT w="9525" cap="flat">
-                      <a:solidFill>
-                        <a:srgbClr val="9B9B9B"/>
-                      </a:solidFill>
-                    </a:lnT>
-                    <a:lnB w="9525" cap="flat">
-                      <a:solidFill>
-                        <a:srgbClr val="9B9B9B"/>
-                      </a:solidFill>
-                    </a:lnB>
-                    <a:solidFill>
-                      <a:srgbClr val="FFFFFF"/>
-                    </a:solidFill>
-                  </a:tcPr>
-                </a:tc>
-                <a:extLst>
-                  <a:ext uri="{0D108BD9-81ED-4DB2-BD59-A6C34878D82A}">
-                    <a16:rowId val="10005"/>
-                  </a:ext>
-                </a:extLst>
-              </a:tr>
-              <a:tr h="313714">
-                <a:tc>
-                  <a:txBody>
-                    <a:bodyPr/>
-                    <a:lstStyle/>
-                    <a:p>
-                      <a:pPr algn="l"/>
-                      <a:r>
-                        <a:rPr lang="ja-JP" altLang="en-US" sz="1400" b="0" dirty="0">
-                          <a:solidFill>
-                            <a:srgbClr val="000000"/>
-                          </a:solidFill>
-                          <a:latin typeface="Meiryo"/>
-                          <a:ea typeface="Meiryo"/>
-                        </a:rPr>
-                        <a:t>対象設備の確定</a:t>
-                      </a:r>
-                    </a:p>
-                  </a:txBody>
-                  <a:tcPr marL="72000" marR="72000" marT="36000" marB="36000" anchor="ctr">
-                    <a:lnL w="9525" cap="flat">
-                      <a:solidFill>
-                        <a:srgbClr val="9B9B9B"/>
-                      </a:solidFill>
-                    </a:lnL>
-                    <a:lnR w="9525" cap="flat">
-                      <a:solidFill>
-                        <a:srgbClr val="9B9B9B"/>
-                      </a:solidFill>
-                    </a:lnR>
-                    <a:lnT w="9525" cap="flat">
-                      <a:solidFill>
-                        <a:srgbClr val="9B9B9B"/>
-                      </a:solidFill>
-                    </a:lnT>
-                    <a:lnB w="9525" cap="flat">
-                      <a:solidFill>
-                        <a:srgbClr val="9B9B9B"/>
-                      </a:solidFill>
-                    </a:lnB>
-                    <a:solidFill>
-                      <a:srgbClr val="FFFFFF"/>
-                    </a:solidFill>
-                  </a:tcPr>
-                </a:tc>
-                <a:tc>
-                  <a:txBody>
-                    <a:bodyPr/>
-                    <a:lstStyle/>
-                    <a:p>
-                      <a:pPr algn="l"/>
-                      <a:r>
-                        <a:rPr lang="ja-JP" altLang="en-US" sz="1400" b="0" dirty="0">
-                          <a:solidFill>
-                            <a:srgbClr val="000000"/>
-                          </a:solidFill>
-                          <a:latin typeface="Meiryo"/>
-                          <a:ea typeface="Meiryo"/>
-                        </a:rPr>
-                        <a:t>会議の継続議題</a:t>
-                      </a:r>
-                    </a:p>
-                  </a:txBody>
-                  <a:tcPr marL="72000" marR="72000" marT="36000" marB="36000" anchor="ctr">
-                    <a:lnL w="9525" cap="flat">
-                      <a:solidFill>
-                        <a:srgbClr val="9B9B9B"/>
-                      </a:solidFill>
-                    </a:lnL>
-                    <a:lnR w="9525" cap="flat">
-                      <a:solidFill>
-                        <a:srgbClr val="9B9B9B"/>
-                      </a:solidFill>
-                    </a:lnR>
-                    <a:lnT w="9525" cap="flat">
-                      <a:solidFill>
-                        <a:srgbClr val="9B9B9B"/>
-                      </a:solidFill>
-                    </a:lnT>
-                    <a:lnB w="9525" cap="flat">
-                      <a:solidFill>
-                        <a:srgbClr val="9B9B9B"/>
-                      </a:solidFill>
-                    </a:lnB>
-                    <a:solidFill>
-                      <a:srgbClr val="FFFFFF"/>
-                    </a:solidFill>
-                  </a:tcPr>
-                </a:tc>
-                <a:tc>
-                  <a:txBody>
-                    <a:bodyPr/>
-                    <a:lstStyle/>
-                    <a:p>
-                      <a:pPr algn="l"/>
-                      <a:r>
-                        <a:rPr lang="ja-JP" altLang="en-US" sz="1400" b="0" dirty="0">
-                          <a:solidFill>
-                            <a:srgbClr val="000000"/>
-                          </a:solidFill>
-                          <a:latin typeface="Meiryo"/>
-                          <a:ea typeface="Meiryo"/>
-                        </a:rPr>
-                        <a:t>未決(10/28持ち越し)</a:t>
-                      </a:r>
-                    </a:p>
-                  </a:txBody>
-                  <a:tcPr marL="72000" marR="72000" marT="36000" marB="36000" anchor="ctr">
-                    <a:lnL w="9525" cap="flat">
-                      <a:solidFill>
-                        <a:srgbClr val="9B9B9B"/>
-                      </a:solidFill>
-                    </a:lnL>
-                    <a:lnR w="9525" cap="flat">
-                      <a:solidFill>
-                        <a:srgbClr val="9B9B9B"/>
-                      </a:solidFill>
-                    </a:lnR>
-                    <a:lnT w="9525" cap="flat">
-                      <a:solidFill>
-                        <a:srgbClr val="9B9B9B"/>
-                      </a:solidFill>
-                    </a:lnT>
-                    <a:lnB w="9525" cap="flat">
-                      <a:solidFill>
-                        <a:srgbClr val="9B9B9B"/>
-                      </a:solidFill>
-                    </a:lnB>
-                    <a:solidFill>
-                      <a:srgbClr val="FFFFFF"/>
-                    </a:solidFill>
-                  </a:tcPr>
-                </a:tc>
-                <a:extLst>
-                  <a:ext uri="{0D108BD9-81ED-4DB2-BD59-A6C34878D82A}">
-                    <a16:rowId val="10006"/>
+                    <a16:rowId xmlns:a16="http://schemas.microsoft.com/office/drawing/2014/main" val="10004"/>
                   </a:ext>
                 </a:extLst>
               </a:tr>
@@ -9247,7 +9034,7 @@
           <p:cNvPr id="25" name="TB60">
             <a:extLst>
               <a:ext uri="{FF2B5EF4-FFF2-40B4-BE49-F238E27FC236}">
-                <a16:creationId id="{90B734DB-F072-0773-4A91-F2D0428DC85B}"/>
+                <a16:creationId xmlns:a16="http://schemas.microsoft.com/office/drawing/2014/main" id="{90B734DB-F072-0773-4A91-F2D0428DC85B}"/>
               </a:ext>
             </a:extLst>
           </p:cNvPr>
@@ -9257,7 +9044,7 @@
         <p:spPr>
           <a:xfrm>
             <a:off x="756000" y="6231929"/>
-            <a:ext cx="4112333" cy="324000"/>
+            <a:ext cx="6500000" cy="324000"/>
           </a:xfrm>
           <a:prstGeom prst="rect">
             <a:avLst/>
@@ -9286,7 +9073,7 @@
                 <a:latin typeface="Meiryo"/>
                 <a:ea typeface="Meiryo"/>
               </a:rPr>
-              <a:t>→ 承認後に運用開始。相関図と画像の追加は10/28まで</a:t>
+              <a:t>→ 10月末の本番前に実機検証を完了させる</a:t>
             </a:r>
           </a:p>
         </p:txBody>
@@ -9296,7 +9083,7 @@
           <p:cNvPr id="27" name="R20">
             <a:extLst>
               <a:ext uri="{FF2B5EF4-FFF2-40B4-BE49-F238E27FC236}">
-                <a16:creationId id="{4196054C-6AD3-7A06-15DA-5D1815E3D737}"/>
+                <a16:creationId xmlns:a16="http://schemas.microsoft.com/office/drawing/2014/main" id="{4196054C-6AD3-7A06-15DA-5D1815E3D737}"/>
               </a:ext>
             </a:extLst>
           </p:cNvPr>
@@ -9334,7 +9121,7 @@
           <p:cNvPr id="29" name="TB21">
             <a:extLst>
               <a:ext uri="{FF2B5EF4-FFF2-40B4-BE49-F238E27FC236}">
-                <a16:creationId id="{0E469F14-DE54-B50C-65FD-4EF61E57F230}"/>
+                <a16:creationId xmlns:a16="http://schemas.microsoft.com/office/drawing/2014/main" id="{0E469F14-DE54-B50C-65FD-4EF61E57F230}"/>
               </a:ext>
             </a:extLst>
           </p:cNvPr>
@@ -9373,7 +9160,7 @@
                 <a:latin typeface="Meiryo"/>
                 <a:ea typeface="Meiryo"/>
               </a:rPr>
-              <a:t>実施時期：9月16日以降(進行中)</a:t>
+              <a:t>実施時期：10月末 本番(予定)</a:t>
             </a:r>
             <a:endParaRPr lang="ja-JP" altLang="en-US" sz="1400" b="0" dirty="0">
               <a:solidFill>
@@ -9388,7 +9175,7 @@
     </p:spTree>
     <p:extLst>
       <p:ext uri="{BB962C8B-B14F-4D97-AF65-F5344CB8AC3E}">
-        <ns3:creationId val="147431364"/>
+        <p14:creationId xmlns:p14="http://schemas.microsoft.com/office/powerpoint/2010/main" val="147431364"/>
       </p:ext>
     </p:extLst>
   </p:cSld>
@@ -9399,14 +9186,14 @@
 </file>
 
 <file path=ppt/slides/slide6.xml><?xml version="1.0" encoding="utf-8"?>
-<p:sld xmlns:a="http://schemas.openxmlformats.org/drawingml/2006/main" xmlns:a16="http://schemas.microsoft.com/office/drawing/2014/main" xmlns:ns3="http://schemas.microsoft.com/office/powerpoint/2010/main" xmlns:p="http://schemas.openxmlformats.org/presentationml/2006/main">
+<p:sld xmlns:a="http://schemas.openxmlformats.org/drawingml/2006/main" xmlns:r="http://schemas.openxmlformats.org/officeDocument/2006/relationships" xmlns:p="http://schemas.openxmlformats.org/presentationml/2006/main">
   <p:cSld>
     <p:spTree>
       <p:nvGrpSpPr>
         <p:cNvPr id="1" name="">
           <a:extLst>
             <a:ext uri="{FF2B5EF4-FFF2-40B4-BE49-F238E27FC236}">
-              <a16:creationId id="{AB684C36-7EDB-A0A5-2342-3C34CBCE0AC3}"/>
+              <a16:creationId xmlns:a16="http://schemas.microsoft.com/office/drawing/2014/main" id="{AB684C36-7EDB-A0A5-2342-3C34CBCE0AC3}"/>
             </a:ext>
           </a:extLst>
         </p:cNvPr>
@@ -9426,7 +9213,7 @@
           <p:cNvPr id="21506" name="Rectangle 2">
             <a:extLst>
               <a:ext uri="{FF2B5EF4-FFF2-40B4-BE49-F238E27FC236}">
-                <a16:creationId id="{EE83C36C-337B-3CAA-0B83-0A1517A40289}"/>
+                <a16:creationId xmlns:a16="http://schemas.microsoft.com/office/drawing/2014/main" id="{EE83C36C-337B-3CAA-0B83-0A1517A40289}"/>
               </a:ext>
             </a:extLst>
           </p:cNvPr>
@@ -9470,7 +9257,7 @@
           <p:cNvPr id="27" name="R20">
             <a:extLst>
               <a:ext uri="{FF2B5EF4-FFF2-40B4-BE49-F238E27FC236}">
-                <a16:creationId id="{6633C88A-6AB1-478B-040B-00151FCAFBE3}"/>
+                <a16:creationId xmlns:a16="http://schemas.microsoft.com/office/drawing/2014/main" id="{6633C88A-6AB1-478B-040B-00151FCAFBE3}"/>
               </a:ext>
             </a:extLst>
           </p:cNvPr>
@@ -9508,7 +9295,7 @@
           <p:cNvPr id="8" name="T63">
             <a:extLst>
               <a:ext uri="{FF2B5EF4-FFF2-40B4-BE49-F238E27FC236}">
-                <a16:creationId id="{58D35AA5-77A7-64BC-8911-FEFE11A99615}"/>
+                <a16:creationId xmlns:a16="http://schemas.microsoft.com/office/drawing/2014/main" id="{58D35AA5-77A7-64BC-8911-FEFE11A99615}"/>
               </a:ext>
             </a:extLst>
           </p:cNvPr>
@@ -9518,14 +9305,14 @@
           <p:nvPr>
             <p:extLst>
               <p:ext uri="{D42A27DB-BD31-4B8C-83A1-F6EECF244321}">
-                <ns3:modId val="3853445471"/>
+                <p14:modId xmlns:p14="http://schemas.microsoft.com/office/powerpoint/2010/main" val="3853445471"/>
               </p:ext>
             </p:extLst>
           </p:nvPr>
         </p:nvGraphicFramePr>
         <p:xfrm>
           <a:off x="272980" y="2128477"/>
-          <a:ext cx="11646040" cy="2601046"/>
+          <a:ext cx="11646040" cy="3037370"/>
         </p:xfrm>
         <a:graphic>
           <a:graphicData uri="http://schemas.openxmlformats.org/drawingml/2006/table">
@@ -9535,21 +9322,21 @@
                 <a:gridCol w="2722451">
                   <a:extLst>
                     <a:ext uri="{9D8B030D-6E8A-4147-A177-3AD203B41FA5}">
-                      <a16:colId val="20000"/>
+                      <a16:colId xmlns:a16="http://schemas.microsoft.com/office/drawing/2014/main" val="20000"/>
                     </a:ext>
                   </a:extLst>
                 </a:gridCol>
                 <a:gridCol w="6579256">
                   <a:extLst>
                     <a:ext uri="{9D8B030D-6E8A-4147-A177-3AD203B41FA5}">
-                      <a16:colId val="20001"/>
+                      <a16:colId xmlns:a16="http://schemas.microsoft.com/office/drawing/2014/main" val="20001"/>
                     </a:ext>
                   </a:extLst>
                 </a:gridCol>
                 <a:gridCol w="2344333">
                   <a:extLst>
                     <a:ext uri="{9D8B030D-6E8A-4147-A177-3AD203B41FA5}">
-                      <a16:colId val="20002"/>
+                      <a16:colId xmlns:a16="http://schemas.microsoft.com/office/drawing/2014/main" val="20002"/>
                     </a:ext>
                   </a:extLst>
                 </a:gridCol>
@@ -9689,7 +9476,7 @@
                 </a:tc>
                 <a:extLst>
                   <a:ext uri="{0D108BD9-81ED-4DB2-BD59-A6C34878D82A}">
-                    <a16:rowId val="10000"/>
+                    <a16:rowId xmlns:a16="http://schemas.microsoft.com/office/drawing/2014/main" val="10000"/>
                   </a:ext>
                 </a:extLst>
               </a:tr>
@@ -9708,7 +9495,7 @@
                           <a:latin typeface="Meiryo"/>
                           <a:ea typeface="Meiryo"/>
                         </a:rPr>
-                        <a:t>棚卸し本番(固定テーブル)</a:t>
+                        <a:t>相関図と画像の追加</a:t>
                       </a:r>
                     </a:p>
                   </a:txBody>
@@ -9752,7 +9539,7 @@
                           <a:latin typeface="Meiryo"/>
                           <a:ea typeface="Meiryo"/>
                         </a:rPr>
-                        <a:t>0確認→消し込み(判断:天野さん)→仮部品倉庫への移動(SQL一括)</a:t>
+                        <a:t>PanaCIM・LNB管理手順書へ追加し、会議で報告</a:t>
                       </a:r>
                       <a:endParaRPr lang="en-US" altLang="ja-JP" sz="1600" b="0" dirty="0">
                         <a:solidFill>
@@ -9803,7 +9590,7 @@
                           <a:latin typeface="Meiryo"/>
                           <a:ea typeface="Meiryo"/>
                         </a:rPr>
-                        <a:t>10/23〜26予定</a:t>
+                        <a:t>10/28</a:t>
                       </a:r>
                     </a:p>
                   </a:txBody>
@@ -9835,7 +9622,7 @@
                 </a:tc>
                 <a:extLst>
                   <a:ext uri="{0D108BD9-81ED-4DB2-BD59-A6C34878D82A}">
-                    <a16:rowId val="10001"/>
+                    <a16:rowId xmlns:a16="http://schemas.microsoft.com/office/drawing/2014/main" val="10001"/>
                   </a:ext>
                 </a:extLst>
               </a:tr>
@@ -9854,7 +9641,7 @@
                           <a:latin typeface="Meiryo"/>
                           <a:ea typeface="Meiryo"/>
                         </a:rPr>
-                        <a:t>0確認マクロの残る確認</a:t>
+                        <a:t>一括バックアップ可否の調査</a:t>
                       </a:r>
                     </a:p>
                   </a:txBody>
@@ -9898,7 +9685,7 @@
                           <a:latin typeface="Meiryo"/>
                           <a:ea typeface="Meiryo"/>
                         </a:rPr>
-                        <a:t>採用版の特定・停止方法など7件を潰してから少数から実行</a:t>
+                        <a:t>Pana-CIM DBの一括バックアップの可否を調査して報告</a:t>
                       </a:r>
                     </a:p>
                   </a:txBody>
@@ -9942,7 +9729,7 @@
                           <a:latin typeface="Meiryo"/>
                           <a:ea typeface="Meiryo"/>
                         </a:rPr>
-                        <a:t>本番前</a:t>
+                        <a:t>10/28</a:t>
                       </a:r>
                     </a:p>
                   </a:txBody>
@@ -9974,146 +9761,7 @@
                 </a:tc>
                 <a:extLst>
                   <a:ext uri="{0D108BD9-81ED-4DB2-BD59-A6C34878D82A}">
-                    <a16:rowId val="10002"/>
-                  </a:ext>
-                </a:extLst>
-              </a:tr>
-              <a:tr h="436324">
-                <a:tc>
-                  <a:txBody>
-                    <a:bodyPr/>
-                    <a:lstStyle/>
-                    <a:p>
-                      <a:pPr algn="l"/>
-                      <a:r>
-                        <a:rPr lang="ja-JP" altLang="en-US" sz="1600" b="0" dirty="0">
-                          <a:solidFill>
-                            <a:srgbClr val="000000"/>
-                          </a:solidFill>
-                          <a:latin typeface="Meiryo"/>
-                          <a:ea typeface="Meiryo"/>
-                        </a:rPr>
-                        <a:t>管理文書の承認と相関図</a:t>
-                      </a:r>
-                    </a:p>
-                  </a:txBody>
-                  <a:tcPr marL="72000" marR="72000" marT="36000" marB="36000" anchor="ctr">
-                    <a:lnL w="9525" cap="flat">
-                      <a:solidFill>
-                        <a:srgbClr val="9B9B9B"/>
-                      </a:solidFill>
-                    </a:lnL>
-                    <a:lnR w="9525" cap="flat">
-                      <a:solidFill>
-                        <a:srgbClr val="9B9B9B"/>
-                      </a:solidFill>
-                    </a:lnR>
-                    <a:lnT w="9525" cap="flat">
-                      <a:solidFill>
-                        <a:srgbClr val="9B9B9B"/>
-                      </a:solidFill>
-                    </a:lnT>
-                    <a:lnB w="9525" cap="flat">
-                      <a:solidFill>
-                        <a:srgbClr val="9B9B9B"/>
-                      </a:solidFill>
-                    </a:lnB>
-                    <a:solidFill>
-                      <a:srgbClr val="FFFFFF"/>
-                    </a:solidFill>
-                  </a:tcPr>
-                </a:tc>
-                <a:tc>
-                  <a:txBody>
-                    <a:bodyPr/>
-                    <a:lstStyle/>
-                    <a:p>
-                      <a:pPr algn="l"/>
-                      <a:r>
-                        <a:rPr lang="ja-JP" altLang="en-US" sz="1600" b="0" dirty="0">
-                          <a:solidFill>
-                            <a:srgbClr val="000000"/>
-                          </a:solidFill>
-                          <a:latin typeface="Meiryo"/>
-                          <a:ea typeface="Meiryo"/>
-                        </a:rPr>
-                        <a:t>相関図と画像の追加(10/28)、手順書案2冊の承認</a:t>
-                      </a:r>
-                    </a:p>
-                  </a:txBody>
-                  <a:tcPr marL="72000" marR="72000" marT="36000" marB="36000" anchor="ctr">
-                    <a:lnL w="9525" cap="flat">
-                      <a:solidFill>
-                        <a:srgbClr val="9B9B9B"/>
-                      </a:solidFill>
-                    </a:lnL>
-                    <a:lnR w="9525" cap="flat">
-                      <a:solidFill>
-                        <a:srgbClr val="9B9B9B"/>
-                      </a:solidFill>
-                    </a:lnR>
-                    <a:lnT w="9525" cap="flat">
-                      <a:solidFill>
-                        <a:srgbClr val="9B9B9B"/>
-                      </a:solidFill>
-                    </a:lnT>
-                    <a:lnB w="9525" cap="flat">
-                      <a:solidFill>
-                        <a:srgbClr val="9B9B9B"/>
-                      </a:solidFill>
-                    </a:lnB>
-                    <a:solidFill>
-                      <a:srgbClr val="FFFFFF"/>
-                    </a:solidFill>
-                  </a:tcPr>
-                </a:tc>
-                <a:tc>
-                  <a:txBody>
-                    <a:bodyPr/>
-                    <a:lstStyle/>
-                    <a:p>
-                      <a:pPr algn="l"/>
-                      <a:r>
-                        <a:rPr lang="ja-JP" altLang="en-US" sz="1600" b="0" dirty="0">
-                          <a:solidFill>
-                            <a:srgbClr val="000000"/>
-                          </a:solidFill>
-                          <a:latin typeface="Meiryo"/>
-                          <a:ea typeface="Meiryo"/>
-                        </a:rPr>
-                        <a:t>10/28〜</a:t>
-                      </a:r>
-                    </a:p>
-                  </a:txBody>
-                  <a:tcPr marL="72000" marR="72000" marT="36000" marB="36000" anchor="ctr">
-                    <a:lnL w="9525" cap="flat">
-                      <a:solidFill>
-                        <a:srgbClr val="9B9B9B"/>
-                      </a:solidFill>
-                    </a:lnL>
-                    <a:lnR w="9525" cap="flat">
-                      <a:solidFill>
-                        <a:srgbClr val="9B9B9B"/>
-                      </a:solidFill>
-                    </a:lnR>
-                    <a:lnT w="9525" cap="flat">
-                      <a:solidFill>
-                        <a:srgbClr val="9B9B9B"/>
-                      </a:solidFill>
-                    </a:lnT>
-                    <a:lnB w="9525" cap="flat">
-                      <a:solidFill>
-                        <a:srgbClr val="9B9B9B"/>
-                      </a:solidFill>
-                    </a:lnB>
-                    <a:solidFill>
-                      <a:srgbClr val="FFFFFF"/>
-                    </a:solidFill>
-                  </a:tcPr>
-                </a:tc>
-                <a:extLst>
-                  <a:ext uri="{0D108BD9-81ED-4DB2-BD59-A6C34878D82A}">
-                    <a16:rowId val="10003"/>
+                    <a16:rowId xmlns:a16="http://schemas.microsoft.com/office/drawing/2014/main" val="10002"/>
                   </a:ext>
                 </a:extLst>
               </a:tr>
@@ -10176,7 +9824,7 @@
                           <a:latin typeface="Meiryo"/>
                           <a:ea typeface="Meiryo"/>
                         </a:rPr>
-                        <a:t>コンパイル→試し実行10件→本番1件→10件</a:t>
+                        <a:t>テストケース47件で段階的に検証(本番1件→10件)</a:t>
                       </a:r>
                     </a:p>
                   </a:txBody>
@@ -10220,7 +9868,7 @@
                           <a:latin typeface="Meiryo"/>
                           <a:ea typeface="Meiryo"/>
                         </a:rPr>
-                        <a:t>10月末〜11月</a:t>
+                        <a:t>10月末(本番前)</a:t>
                       </a:r>
                     </a:p>
                   </a:txBody>
@@ -10252,7 +9900,285 @@
                 </a:tc>
                 <a:extLst>
                   <a:ext uri="{0D108BD9-81ED-4DB2-BD59-A6C34878D82A}">
-                    <a16:rowId val="10004"/>
+                    <a16:rowId xmlns:a16="http://schemas.microsoft.com/office/drawing/2014/main" val="10003"/>
+                  </a:ext>
+                </a:extLst>
+              </a:tr>
+              <a:tr h="436324">
+                <a:tc>
+                  <a:txBody>
+                    <a:bodyPr/>
+                    <a:lstStyle/>
+                    <a:p>
+                      <a:pPr algn="l"/>
+                      <a:r>
+                        <a:rPr lang="ja-JP" altLang="en-US" sz="1600" b="0" dirty="0">
+                          <a:solidFill>
+                            <a:srgbClr val="000000"/>
+                          </a:solidFill>
+                          <a:latin typeface="Meiryo"/>
+                          <a:ea typeface="Meiryo"/>
+                        </a:rPr>
+                        <a:t>固定テーブル棚卸しの本番</a:t>
+                      </a:r>
+                    </a:p>
+                  </a:txBody>
+                  <a:tcPr marL="72000" marR="72000" marT="36000" marB="36000" anchor="ctr">
+                    <a:lnL w="9525" cap="flat">
+                      <a:solidFill>
+                        <a:srgbClr val="9B9B9B"/>
+                      </a:solidFill>
+                    </a:lnL>
+                    <a:lnR w="9525" cap="flat">
+                      <a:solidFill>
+                        <a:srgbClr val="9B9B9B"/>
+                      </a:solidFill>
+                    </a:lnR>
+                    <a:lnT w="9525" cap="flat">
+                      <a:solidFill>
+                        <a:srgbClr val="9B9B9B"/>
+                      </a:solidFill>
+                    </a:lnT>
+                    <a:lnB w="9525" cap="flat">
+                      <a:solidFill>
+                        <a:srgbClr val="9B9B9B"/>
+                      </a:solidFill>
+                    </a:lnB>
+                    <a:solidFill>
+                      <a:srgbClr val="FFFFFF"/>
+                    </a:solidFill>
+                  </a:tcPr>
+                </a:tc>
+                <a:tc>
+                  <a:txBody>
+                    <a:bodyPr/>
+                    <a:lstStyle/>
+                    <a:p>
+                      <a:pPr algn="l"/>
+                      <a:r>
+                        <a:rPr lang="ja-JP" altLang="en-US" sz="1600" b="0" dirty="0">
+                          <a:solidFill>
+                            <a:srgbClr val="000000"/>
+                          </a:solidFill>
+                          <a:latin typeface="Meiryo"/>
+                          <a:ea typeface="Meiryo"/>
+                        </a:rPr>
+                        <a:t>生産終了ラインから順に実施</a:t>
+                      </a:r>
+                    </a:p>
+                  </a:txBody>
+                  <a:tcPr marL="72000" marR="72000" marT="36000" marB="36000" anchor="ctr">
+                    <a:lnL w="9525" cap="flat">
+                      <a:solidFill>
+                        <a:srgbClr val="9B9B9B"/>
+                      </a:solidFill>
+                    </a:lnL>
+                    <a:lnR w="9525" cap="flat">
+                      <a:solidFill>
+                        <a:srgbClr val="9B9B9B"/>
+                      </a:solidFill>
+                    </a:lnR>
+                    <a:lnT w="9525" cap="flat">
+                      <a:solidFill>
+                        <a:srgbClr val="9B9B9B"/>
+                      </a:solidFill>
+                    </a:lnT>
+                    <a:lnB w="9525" cap="flat">
+                      <a:solidFill>
+                        <a:srgbClr val="9B9B9B"/>
+                      </a:solidFill>
+                    </a:lnB>
+                    <a:solidFill>
+                      <a:srgbClr val="FFFFFF"/>
+                    </a:solidFill>
+                  </a:tcPr>
+                </a:tc>
+                <a:tc>
+                  <a:txBody>
+                    <a:bodyPr/>
+                    <a:lstStyle/>
+                    <a:p>
+                      <a:pPr algn="l"/>
+                      <a:r>
+                        <a:rPr lang="ja-JP" altLang="en-US" sz="1600" b="0" dirty="0">
+                          <a:solidFill>
+                            <a:srgbClr val="000000"/>
+                          </a:solidFill>
+                          <a:latin typeface="Meiryo"/>
+                          <a:ea typeface="Meiryo"/>
+                        </a:rPr>
+                        <a:t>10/23〜26(予定)</a:t>
+                      </a:r>
+                    </a:p>
+                  </a:txBody>
+                  <a:tcPr marL="72000" marR="72000" marT="36000" marB="36000" anchor="ctr">
+                    <a:lnL w="9525" cap="flat">
+                      <a:solidFill>
+                        <a:srgbClr val="9B9B9B"/>
+                      </a:solidFill>
+                    </a:lnL>
+                    <a:lnR w="9525" cap="flat">
+                      <a:solidFill>
+                        <a:srgbClr val="9B9B9B"/>
+                      </a:solidFill>
+                    </a:lnR>
+                    <a:lnT w="9525" cap="flat">
+                      <a:solidFill>
+                        <a:srgbClr val="9B9B9B"/>
+                      </a:solidFill>
+                    </a:lnT>
+                    <a:lnB w="9525" cap="flat">
+                      <a:solidFill>
+                        <a:srgbClr val="9B9B9B"/>
+                      </a:solidFill>
+                    </a:lnB>
+                    <a:solidFill>
+                      <a:srgbClr val="FFFFFF"/>
+                    </a:solidFill>
+                  </a:tcPr>
+                </a:tc>
+                <a:extLst>
+                  <a:ext uri="{0D108BD9-81ED-4DB2-BD59-A6C34878D82A}">
+                    <a16:rowId xmlns:a16="http://schemas.microsoft.com/office/drawing/2014/main" val="10004"/>
+                  </a:ext>
+                </a:extLst>
+              </a:tr>
+              <a:tr h="436324">
+                <a:tc>
+                  <a:txBody>
+                    <a:bodyPr/>
+                    <a:lstStyle/>
+                    <a:p>
+                      <a:pPr algn="l"/>
+                      <a:r>
+                        <a:rPr lang="ja-JP" altLang="en-US" sz="1600" b="0" dirty="0">
+                          <a:solidFill>
+                            <a:srgbClr val="000000"/>
+                          </a:solidFill>
+                          <a:latin typeface="Meiryo"/>
+                          <a:ea typeface="Meiryo"/>
+                        </a:rPr>
+                        <a:t>LNB点検項目の聞き取りと登録</a:t>
+                      </a:r>
+                    </a:p>
+                  </a:txBody>
+                  <a:tcPr marL="72000" marR="72000" marT="36000" marB="36000" anchor="ctr">
+                    <a:lnL w="9525" cap="flat">
+                      <a:solidFill>
+                        <a:srgbClr val="9B9B9B"/>
+                      </a:solidFill>
+                    </a:lnL>
+                    <a:lnR w="9525" cap="flat">
+                      <a:solidFill>
+                        <a:srgbClr val="9B9B9B"/>
+                      </a:solidFill>
+                    </a:lnR>
+                    <a:lnT w="9525" cap="flat">
+                      <a:solidFill>
+                        <a:srgbClr val="9B9B9B"/>
+                      </a:solidFill>
+                    </a:lnT>
+                    <a:lnB w="9525" cap="flat">
+                      <a:solidFill>
+                        <a:srgbClr val="9B9B9B"/>
+                      </a:solidFill>
+                    </a:lnB>
+                    <a:solidFill>
+                      <a:srgbClr val="FFFFFF"/>
+                    </a:solidFill>
+                  </a:tcPr>
+                </a:tc>
+                <a:tc>
+                  <a:txBody>
+                    <a:bodyPr/>
+                    <a:lstStyle/>
+                    <a:p>
+                      <a:pPr algn="l"/>
+                      <a:r>
+                        <a:rPr lang="ja-JP" altLang="en-US" sz="1600" b="0" dirty="0">
+                          <a:solidFill>
+                            <a:srgbClr val="000000"/>
+                          </a:solidFill>
+                          <a:latin typeface="Meiryo"/>
+                          <a:ea typeface="Meiryo"/>
+                        </a:rPr>
+                        <a:t>現行実施者への聞き取りから着手</a:t>
+                      </a:r>
+                    </a:p>
+                  </a:txBody>
+                  <a:tcPr marL="72000" marR="72000" marT="36000" marB="36000" anchor="ctr">
+                    <a:lnL w="9525" cap="flat">
+                      <a:solidFill>
+                        <a:srgbClr val="9B9B9B"/>
+                      </a:solidFill>
+                    </a:lnL>
+                    <a:lnR w="9525" cap="flat">
+                      <a:solidFill>
+                        <a:srgbClr val="9B9B9B"/>
+                      </a:solidFill>
+                    </a:lnR>
+                    <a:lnT w="9525" cap="flat">
+                      <a:solidFill>
+                        <a:srgbClr val="9B9B9B"/>
+                      </a:solidFill>
+                    </a:lnT>
+                    <a:lnB w="9525" cap="flat">
+                      <a:solidFill>
+                        <a:srgbClr val="9B9B9B"/>
+                      </a:solidFill>
+                    </a:lnB>
+                    <a:solidFill>
+                      <a:srgbClr val="FFFFFF"/>
+                    </a:solidFill>
+                  </a:tcPr>
+                </a:tc>
+                <a:tc>
+                  <a:txBody>
+                    <a:bodyPr/>
+                    <a:lstStyle/>
+                    <a:p>
+                      <a:pPr algn="l"/>
+                      <a:r>
+                        <a:rPr lang="ja-JP" altLang="en-US" sz="1600" b="0" dirty="0">
+                          <a:solidFill>
+                            <a:srgbClr val="000000"/>
+                          </a:solidFill>
+                          <a:latin typeface="Meiryo"/>
+                          <a:ea typeface="Meiryo"/>
+                        </a:rPr>
+                        <a:t>12/28まで</a:t>
+                      </a:r>
+                    </a:p>
+                  </a:txBody>
+                  <a:tcPr marL="72000" marR="72000" marT="36000" marB="36000" anchor="ctr">
+                    <a:lnL w="9525" cap="flat">
+                      <a:solidFill>
+                        <a:srgbClr val="9B9B9B"/>
+                      </a:solidFill>
+                    </a:lnL>
+                    <a:lnR w="9525" cap="flat">
+                      <a:solidFill>
+                        <a:srgbClr val="9B9B9B"/>
+                      </a:solidFill>
+                    </a:lnR>
+                    <a:lnT w="9525" cap="flat">
+                      <a:solidFill>
+                        <a:srgbClr val="9B9B9B"/>
+                      </a:solidFill>
+                    </a:lnT>
+                    <a:lnB w="9525" cap="flat">
+                      <a:solidFill>
+                        <a:srgbClr val="9B9B9B"/>
+                      </a:solidFill>
+                    </a:lnB>
+                    <a:solidFill>
+                      <a:srgbClr val="FFFFFF"/>
+                    </a:solidFill>
+                  </a:tcPr>
+                </a:tc>
+                <a:extLst>
+                  <a:ext uri="{0D108BD9-81ED-4DB2-BD59-A6C34878D82A}">
+                    <a16:rowId xmlns:a16="http://schemas.microsoft.com/office/drawing/2014/main" val="10004"/>
                   </a:ext>
                 </a:extLst>
               </a:tr>
@@ -10263,7 +10189,7 @@
     </p:spTree>
     <p:extLst>
       <p:ext uri="{BB962C8B-B14F-4D97-AF65-F5344CB8AC3E}">
-        <ns3:creationId val="3249971736"/>
+        <p14:creationId xmlns:p14="http://schemas.microsoft.com/office/powerpoint/2010/main" val="3249971736"/>
       </p:ext>
     </p:extLst>
   </p:cSld>
@@ -10995,42 +10921,4 @@
 <clbl:labelList xmlns:clbl="http://schemas.microsoft.com/office/2020/mipLabelMetadata">
   <clbl:label id="{ca9c2885-f052-48d0-98f2-4ee2bfc5cc07}" enabled="0" method="" siteId="{ca9c2885-f052-48d0-98f2-4ee2bfc5cc07}" removed="1"/>
 </clbl:labelList>
-</file>
-
-<file path=root_tag.txt><?xml version="1.0" encoding="UTF-8" standalone="yes"?>
-</file>
-
-<file path=rootns.txt>slide1: <p:sld xmlns:a="http://schemas.openxmlformats.org/drawingml/2006/main" xmlns:r="http://schemas.openxmlformats.org/officeDocument/2006/relationships" xmlns:p="http://schemas.openxmlformats.org/presentationml/2006/main">
-
-slide2: <p:sld xmlns:a="http://schemas.openxmlformats.org/drawingml/2006/main" xmlns:r="http://schemas.openxmlformats.org/officeDocument/2006/relationships" xmlns:p="http://schemas.openxmlformats.org/presentationml/2006/main">
-
-slide3: <p:sld xmlns:a="http://schemas.openxmlformats.org/drawingml/2006/main" xmlns:r="http://schemas.openxmlformats.org/officeDocument/2006/relationships" xmlns:p="http://schemas.openxmlformats.org/presentationml/2006/main">
-
-slide4: <p:sld xmlns:a="http://schemas.openxmlformats.org/drawingml/2006/main" xmlns:r="http://schemas.openxmlformats.org/officeDocument/2006/relationships" xmlns:p="http://schemas.openxmlformats.org/presentationml/2006/main">
-
-slide5: <p:sld xmlns:a="http://schemas.openxmlformats.org/drawingml/2006/main" xmlns:r="http://schemas.openxmlformats.org/officeDocument/2006/relationships" xmlns:p="http://schemas.openxmlformats.org/presentationml/2006/main">
-
-slide6: <p:sld xmlns:a="http://schemas.openxmlformats.org/drawingml/2006/main" xmlns:r="http://schemas.openxmlformats.org/officeDocument/2006/relationships" xmlns:p="http://schemas.openxmlformats.org/presentationml/2006/main">
-
-
-</file>
-
-<file path=slide3_tb23_sample.txt>="0"><a:solidFill><a:srgbClr val="000000"/></a:solidFill><a:latin typeface="Meiryo"/><a:ea typeface="Meiryo"/></a:rPr><a:t>&#35506;&#38988;</a:t></a:r></a:p></p:txBody></p:sp><p:sp><p:nvSpPr><p:cNvPr id="11" name="TB23"><a:extLst><a:ext uri="{FF2B5EF4-FFF2-40B4-BE49-F238E27FC236}"><a16:creationId xmlns:a16="http://schemas.microsoft.com/office/drawing/2014/main" id="{334C37F2-BE3E-BFC0-CAB9-D3917FDC0606}"/></a:ext></a:extLst></p:cNvPr><p:cNvSpPr txBox="1"/><p:nvPr/></p:nvSpPr><p:spPr><a:xfrm><a:off x="756000" y="1813174"/><a:ext cx="10656000" cy="1119581"/></a:xfrm><a:prstGeom prst="rect"><a:avLst/></a:prstGeom><a:noFill/></p:spPr><p:txBody><a:bodyPr wrap="square" lIns="0" tIns="0" rIns="0" bIns="0" anchor="t"><a:noAutofit/></a:bodyPr><a:lstStyle/><a:p><a:pPr algn="l"><a:lnSpc><a:spcPct val="112000"/></a:lnSpc><a:spcAft><a:spcPts val="400"/></a:spcAft></a:pPr><a:r><a:rPr lang="ja-JP" altLang="en-US" b="0" dirty="0"><a:solidFill><a:srgbClr val="000000"/></a:solidFill><a:latin typeface="Meiryo"/><a:ea typeface="Meiryo"/></a:rPr><a:t>&#12539;&#29694;&#22580;&#12391;&#23455;&#38555;&#12395;&#29983;&#12376;&#12383;&#37096;&#21697;&#12398;&#28187;&#12426;&#12364;</a:t></a:r><a:r><a:rPr lang="ja-JP" altLang="en-US" dirty="0"><a:solidFill><a:srgbClr val="000000"/></a:solidFill><a:latin typeface="Meiryo"/><a:ea typeface="Meiryo"/></a:rPr><a:t>&#12472;&#12519;&#12502;&#20316;&#25104;&#19978;&#12398;&#22312;&#24235;&#25968;&#12395;</a:t></a:r><a:r><a:rPr lang="ja-JP" altLang="en-US" b="0" dirty="0"><a:solidFill><a:srgbClr val="000000"/></a:solidFill><a:latin typeface="Meiryo"/><a:ea typeface="Meiryo"/></a:rPr><a:t>&#20837;&#12425;&#12378;&#12289;&#12522;&#12473;&#12488;&#19978;&#12399;&#22312;&#24235;&#12364;&#12354;&#12427;&#12398;&#12395;&#29694;&#22580;&#12395;&#12399;&#28961;&#12356;&#12289;&#12392;&#12356;&#12358;&#39135;&#12356;&#36949;&#12356;&#12364;&#36215;&#12365;&#12390;&#12356;&#12383;&#12290;&#8658;&#20104;&#20633;&#37096;&#21697;&#12434;&#20489;&#24235;&#12395;&#21462;&#12426;&#12395;&#34892;&#12367;&#25163;&#38291;&#12364;&#29983;&#12376;&#12390;&#12356;&#12383;&#12290;</a:t></a:r><a:endParaRPr lang="en-US" altLang="ja-JP" b="0" dirty="0"><a:solidFill><a:srgbClr val="000000"/></a:solidFill><a:latin typeface="Meiryo"/><a:ea typeface="Meiryo"/></a:endParaRPr></a:p><a:p><a:pPr algn="l"><a:lnSpc><a:spcPct val="112000"/></a:lnSpc><a:spcAft><a:spcPts val="400"/></a:spcAft></a:pPr><a:r><a:rPr lang="ja-JP" altLang="en-US" dirty="0"><a:solidFill><a:srgbClr val="000000"/></a:solidFill><a:latin typeface="Meiryo"/><a:ea typeface="Meiryo"/></a:rPr><a:t>&#12539;&#20351;&#29992;&#12375;&#12390;&#12356;&#12383;&#12484;&#12540;&#12523;&#12289;&#26368;&#32066;&#30340;&#12394;&#12468;&#12540;&#12523;&#12399;&#21028;&#26126;&#12375;&#12390;&#12356;&#12427;&#12364;&#12289;&#25163;&#38918;&#12399;&#19981;&#26126;&#12384;&#12387;&#12383;&#12290;</a:t></a:r><a:endParaRPr lang="en-US" altLang="ja-JP" b="0" dirty="0"><a:solidFill><a:srgbClr val="000000"/></a:solidFill><a:latin typeface="Meiryo"/><a:ea typeface="Meiryo"/></a:endParaRPr></a:p></p:txBody></p:sp><p:sp><p:nvSpPr><p:cNvPr id="13" name="TB24"><a:extLst><a:ext uri="{FF2B5EF4-FFF2-40B4-BE49-F238E27FC236}"><a16:creationId xmlns:a16="http://schemas.microsoft.com/office/drawing/2014
-</file>
-
-<file path=tables.txt>--- slide5: 7 rows ---
-&#38917;&#30446; || &#20869;&#23481; || &#29366;&#27841;
-&#24037;&#31243;&#12398;&#25991;&#26360;&#21270; || &#28310;&#20633;&#12363;&#12425;&#26842;&#21368;&#12375;&#12539;&#37096;&#21697;&#25147;&#12375;&#12414;&#12391;&#12398;&#20027;&#35201;&#24037;&#31243; || &#23436;&#20102;
-&#22259;&#35299; || &#20316;&#26989;&#20998;&#25285;&#12392;&#21028;&#26029;&#12398;&#27969;&#12428; || &#23436;&#20102;
-&#29694;&#22580;&#32862;&#12365;&#21462;&#12426; || &#23550;&#35937;&#31684;&#22258;&#12539;&#20489;&#24235;&#12398;&#21306;&#20998;&#12539;&#20363;&#22806;&#26178;&#12398;&#25201;&#12356; || &#30906;&#23450;&#20998;&#12399;&#23436;&#20102;/&#19968;&#37096;&#26410;&#30906;&#35469;
-&#25163;&#38918;&#26360; || &#23455;&#20316;&#26989;&#32773;&#12364;&#35501;&#12435;&#12391;&#20316;&#26989;&#12391;&#12365;&#12427;&#24418; || &#20316;&#25104;&#20013;
-&#20966;&#29702;&#12398;&#25913;&#20462; || &#12496;&#12483;&#12463;&#12450;&#12483;&#12503;&#12539;&#20214;&#25968;&#30906;&#35469;&#12539;&#21462;&#28040;&#12398;&#20181;&#32068;&#12415;&#12434;&#36861;&#21152; || &#25913;&#20462;&#28168;&#12415;/&#23455;&#12487;&#12540;&#12479;&#26410;&#26908;&#35388;
-&#26842;&#21368;&#12375;&#21069;&#12398;&#22312;&#24235;&#30906;&#35469; || &#23550;&#35937;&#12398;&#27770;&#12417;&#26041;&#12392;&#23455;&#34892;&#26465;&#20214; || &#35519;&#26619;&#20013;
---- slide6: 5 rows ---
-&#12420;&#12427;&#12371;&#12392; || &#20869;&#23481; || &#26178;&#26399;
-&#26410;&#30906;&#35469;&#12398;&#26465;&#20214;&#12434;&#30906;&#23450;&#12377;&#12427; || &#26842;&#21368;&#12375;&#21069;&#12398;&#22312;&#24235;&#30906;&#35469;&#12398;&#23550;&#35937;&#12392;&#23455;&#26045;&#26178;&#26399;&#20363;&#22806;&#26178;&#12398;&#25201;&#12356;&#12289;&#20489;&#24235;&#21306;&#20998;&#12398;&#31649;&#29702;&#26041;&#27861; || 9&#26376;&#20013;
-&#20966;&#29702;&#12434;&#26908;&#35388;&#12377;&#12427; || &#25913;&#20462;&#12375;&#12383;&#20966;&#29702;&#12434;&#26842;&#21368;&#12375;&#12398;&#12487;&#12540;&#12479;&#12391;&#30906;&#35469;&#65288;&#12496;&#12483;&#12463;&#12450;&#12483;&#12503;&#12392;&#21462;&#28040;&#12364;&#27491;&#12375;&#12367;&#21205;&#12367;&#12363;&#65289; || 10&#26376;&#12398;&#26842;&#21368;&#12375;&#21069;
-&#25163;&#38918;&#26360;&#12434;&#23436;&#25104;&#12373;&#12379;&#12427; || &#20316;&#26989;&#12434;&#36890;&#12375;&#12391;&#30906;&#35469;&#12375;&#12289;&#25285;&#24403;&#12364;&#20195;&#12431;&#12387;&#12390;&#12418;&#23455;&#26045;&#12391;&#12365;&#12427;&#29366;&#24907;&#12395;&#12377;&#12427; || 10&#26376;
-&#26842;&#21368;&#12375;&#12434;&#23455;&#26045;&#12377;&#12427; || &#29983;&#29987;&#12364;&#32066;&#12431;&#12387;&#12383;&#12521;&#12452;&#12531;&#12363;&#12425;&#38918;&#12395;&#23455;&#26045; || 10&#26376;&#65288;&#20104;&#23450;&#65289;
-
 </file>
</xml_diff>

<commit_message>
sync(workvault): 2026-10-21 15:42 差分 39 件
</commit_message>
<xml_diff>
--- a/workvault-sync/10_業務全般/業務報告/10月業務報告(篠原).pptx
+++ b/workvault-sync/10_業務全般/業務報告/10月業務報告(篠原).pptx
@@ -5838,7 +5838,7 @@
                 <a:latin typeface="Meiryo"/>
                 <a:ea typeface="Meiryo"/>
               </a:rPr>
-              <a:t>業務内容</a:t>
+              <a:t>結論</a:t>
             </a:r>
           </a:p>
         </p:txBody>
@@ -5858,7 +5858,7 @@
         <p:spPr>
           <a:xfrm>
             <a:off x="540000" y="1572621"/>
-            <a:ext cx="10656000" cy="2200000"/>
+            <a:ext cx="10656000" cy="2600000"/>
           </a:xfrm>
           <a:prstGeom prst="rect">
             <a:avLst/>
@@ -5887,7 +5887,7 @@
                 <a:latin typeface="Meiryo"/>
                 <a:ea typeface="Meiryo"/>
               </a:rPr>
-              <a:t>前任者が開発・運用・保守を担当していた在庫・棚卸し業務の引継ぎ(継続)</a:t>
+              <a:t>在庫差異修正と0確認マクロの運用を確定させ、管理手順書の案2冊と棚卸しマクロver.2の改修を本番準備まで進めた。</a:t>
             </a:r>
             <a:endParaRPr lang="en-US" altLang="ja-JP" b="0" dirty="0">
               <a:solidFill>
@@ -5914,7 +5914,7 @@
                 <a:latin typeface="Meiryo"/>
                 <a:ea typeface="Meiryo"/>
               </a:rPr>
-              <a:t>　 - 在庫差異修正：B列のL2限定差異修正を9/24に完了</a:t>
+              <a:t>　業務内容：前任者が開発・運用・保守を担当していた在庫・棚卸し業務の引継ぎ(継続)</a:t>
             </a:r>
             <a:endParaRPr lang="en-US" altLang="ja-JP" b="0" dirty="0">
               <a:solidFill>
@@ -5941,7 +5941,34 @@
                 <a:latin typeface="Meiryo"/>
                 <a:ea typeface="Meiryo"/>
               </a:rPr>
-              <a:t>　 - 0確認マクロver.2：無変更のまま実機で動作を確認、運用を確定</a:t>
+              <a:t>　 - 在庫差異修正：B列のL2限定差異修正を9/24に完了</a:t>
+            </a:r>
+            <a:endParaRPr lang="en-US" altLang="ja-JP" b="0" dirty="0">
+              <a:solidFill>
+                <a:srgbClr val="000000"/>
+              </a:solidFill>
+              <a:latin typeface="Meiryo"/>
+              <a:ea typeface="Meiryo"/>
+            </a:endParaRPr>
+          </a:p>
+          <a:p>
+            <a:pPr algn="l">
+              <a:lnSpc>
+                <a:spcPct val="112000"/>
+              </a:lnSpc>
+              <a:spcAft>
+                <a:spcPts val="400"/>
+              </a:spcAft>
+            </a:pPr>
+            <a:r>
+              <a:rPr lang="ja-JP" altLang="en-US" b="0" dirty="0">
+                <a:solidFill>
+                  <a:srgbClr val="000000"/>
+                </a:solidFill>
+                <a:latin typeface="Meiryo"/>
+                <a:ea typeface="Meiryo"/>
+              </a:rPr>
+              <a:t>　 - 0確認マクロver.2：無変更のまま実機で動作を確認、質問票35問の回答を運用手順書へ反映</a:t>
             </a:r>
             <a:endParaRPr lang="en-US" altLang="ja-JP" b="0" dirty="0">
               <a:solidFill>
@@ -6278,7 +6305,7 @@
                 <a:latin typeface="Meiryo"/>
                 <a:ea typeface="Meiryo"/>
               </a:rPr>
-              <a:t>課題</a:t>
+              <a:t>背景</a:t>
             </a:r>
           </a:p>
         </p:txBody>
@@ -6410,7 +6437,7 @@
                 <a:latin typeface="Meiryo"/>
                 <a:ea typeface="Meiryo"/>
               </a:rPr>
-              <a:t>何をした</a:t>
+              <a:t>やったこと</a:t>
             </a:r>
           </a:p>
         </p:txBody>
@@ -6542,7 +6569,7 @@
                 <a:latin typeface="Meiryo"/>
                 <a:ea typeface="Meiryo"/>
               </a:rPr>
-              <a:t>どのように</a:t>
+              <a:t>数字</a:t>
             </a:r>
           </a:p>
         </p:txBody>
@@ -6611,7 +6638,7 @@
                 <a:latin typeface="Meiryo"/>
                 <a:ea typeface="Meiryo"/>
               </a:rPr>
-              <a:t>・再計算スクリプトで10/2版CSV(29,345行)も記録値と一致することを確認。</a:t>
+              <a:t>・再計算スクリプトで10/2版CSV(29,345行)も記録値6,084件と一致することを確認。</a:t>
             </a:r>
           </a:p>
           <a:p>
@@ -6631,7 +6658,7 @@
                 <a:latin typeface="Meiryo"/>
                 <a:ea typeface="Meiryo"/>
               </a:rPr>
-              <a:t>・運用確定質問票(35問)に回答を記入し、正本を共有サーバーの「0確認マクロ_ver2.xlsm」に確定。</a:t>
+              <a:t>・運用確定質問票(35問)の回答を運用手順書へ反映(10/15)。正本は共有サーバーの「0確認マクロ_ver2.xlsm」。</a:t>
             </a:r>
           </a:p>
           <a:p>
@@ -6651,7 +6678,7 @@
                 <a:latin typeface="Meiryo"/>
                 <a:ea typeface="Meiryo"/>
               </a:rPr>
-              <a:t>・残る確認は7件。10月末の棚卸し本番で仕上げる。</a:t>
+              <a:t>→ 次の展開：未決4件とxlsmへの実装2件が残る。全件照合と消し込み結果は本番で確認する。</a:t>
             </a:r>
           </a:p>
         </p:txBody>
@@ -6780,7 +6807,7 @@
                 <a:latin typeface="Meiryo"/>
                 <a:ea typeface="Meiryo"/>
               </a:rPr>
-              <a:t>解決前</a:t>
+              <a:t>背景（解決前）</a:t>
             </a:r>
           </a:p>
         </p:txBody>
@@ -7216,7 +7243,7 @@
                 <a:latin typeface="Meiryo"/>
                 <a:ea typeface="Meiryo"/>
               </a:rPr>
-              <a:t>解決後</a:t>
+              <a:t>やったこと（解決後）</a:t>
             </a:r>
           </a:p>
         </p:txBody>
@@ -7656,7 +7683,7 @@
                 <a:latin typeface="Meiryo"/>
                 <a:ea typeface="Meiryo"/>
               </a:rPr>
-              <a:t>結果</a:t>
+              <a:t>数字</a:t>
             </a:r>
           </a:p>
         </p:txBody>
@@ -7705,7 +7732,7 @@
                 <a:latin typeface="Meiryo"/>
                 <a:ea typeface="Meiryo"/>
               </a:rPr>
-              <a:t>・管理書v0.12、LNB管理書v0.11に反映し、管理手順書案2冊(xlsx・PDF)を作成(未承認)。</a:t>
+              <a:t>・管理書v0.12、LNB管理書v0.11に反映し、管理手順書案2冊(xlsx・PDF・107頁/99頁)を作成(未承認)。</a:t>
             </a:r>
             <a:endParaRPr lang="en-US" altLang="ja-JP" b="0" dirty="0">
               <a:solidFill>
@@ -7732,7 +7759,7 @@
                 <a:latin typeface="Meiryo"/>
                 <a:ea typeface="Meiryo"/>
               </a:rPr>
-              <a:t>・再起動手順を停止1〜6/起動7〜14に分割し、月次と異常時を分けた。</a:t>
+              <a:t>・10/14の会議で再起動手順の統合掲載を決定。停止1〜6/起動7〜14に分割し、月次と異常時を分けた。</a:t>
             </a:r>
             <a:endParaRPr lang="en-US" altLang="ja-JP" b="0" dirty="0">
               <a:solidFill>
@@ -7759,7 +7786,7 @@
                 <a:latin typeface="Meiryo"/>
                 <a:ea typeface="Meiryo"/>
               </a:rPr>
-              <a:t>・相関図と画像の追加は10/28まで。LNB点検項目の登録は12/28。</a:t>
+              <a:t>→ 次の展開：相関図と画像の追加は10/28まで。LNB点検項目の登録は12/28。</a:t>
             </a:r>
             <a:endParaRPr lang="en-US" altLang="ja-JP" b="0" dirty="0">
               <a:solidFill>
@@ -7997,7 +8024,7 @@
                 <a:latin typeface="Meiryo"/>
                 <a:ea typeface="Meiryo"/>
               </a:rPr>
-              <a:t>課題</a:t>
+              <a:t>背景</a:t>
             </a:r>
           </a:p>
         </p:txBody>
@@ -8115,7 +8142,7 @@
                 <a:latin typeface="Meiryo"/>
                 <a:ea typeface="Meiryo"/>
               </a:rPr>
-              <a:t>どのように</a:t>
+              <a:t>やったこと</a:t>
             </a:r>
           </a:p>
         </p:txBody>
@@ -8274,7 +8301,7 @@
                 <a:latin typeface="Meiryo"/>
                 <a:ea typeface="Meiryo"/>
               </a:rPr>
-              <a:t>進捗</a:t>
+              <a:t>数字</a:t>
             </a:r>
           </a:p>
         </p:txBody>
@@ -8989,7 +9016,7 @@
                           <a:latin typeface="Meiryo"/>
                           <a:ea typeface="Meiryo"/>
                         </a:rPr>
-                        <a:t>10/23〜26(予定)</a:t>
+                        <a:t>10月末(予定)</a:t>
                       </a:r>
                     </a:p>
                   </a:txBody>
@@ -9073,7 +9100,7 @@
                 <a:latin typeface="Meiryo"/>
                 <a:ea typeface="Meiryo"/>
               </a:rPr>
-              <a:t>→ 10月末の本番前に実機検証を完了させる</a:t>
+              <a:t>→ 次の展開：10月末の本番前に実機検証を完了させる</a:t>
             </a:r>
           </a:p>
         </p:txBody>
@@ -9312,7 +9339,7 @@
         </p:nvGraphicFramePr>
         <p:xfrm>
           <a:off x="272980" y="2128477"/>
-          <a:ext cx="11646040" cy="3037370"/>
+          <a:ext cx="11646040" cy="2860000"/>
         </p:xfrm>
         <a:graphic>
           <a:graphicData uri="http://schemas.openxmlformats.org/drawingml/2006/table">
@@ -9341,7 +9368,7 @@
                   </a:extLst>
                 </a:gridCol>
               </a:tblGrid>
-              <a:tr h="436324">
+              <a:tr h="460000">
                 <a:tc>
                   <a:txBody>
                     <a:bodyPr/>
@@ -9480,7 +9507,7 @@
                   </a:ext>
                 </a:extLst>
               </a:tr>
-              <a:tr h="646037">
+              <a:tr h="400000">
                 <a:tc>
                   <a:txBody>
                     <a:bodyPr/>
@@ -9626,7 +9653,7 @@
                   </a:ext>
                 </a:extLst>
               </a:tr>
-              <a:tr h="646037">
+              <a:tr h="400000">
                 <a:tc>
                   <a:txBody>
                     <a:bodyPr/>
@@ -9765,7 +9792,146 @@
                   </a:ext>
                 </a:extLst>
               </a:tr>
-              <a:tr h="436324">
+              <a:tr h="400000">
+                <a:tc>
+                  <a:txBody>
+                    <a:bodyPr/>
+                    <a:lstStyle/>
+                    <a:p>
+                      <a:pPr algn="l"/>
+                      <a:r>
+                        <a:rPr lang="ja-JP" altLang="en-US" sz="1600" b="0" dirty="0">
+                          <a:solidFill>
+                            <a:srgbClr val="000000"/>
+                          </a:solidFill>
+                          <a:latin typeface="Meiryo"/>
+                          <a:ea typeface="Meiryo"/>
+                        </a:rPr>
+                        <a:t>実機確認の日程と停止判断者の確定</a:t>
+                      </a:r>
+                    </a:p>
+                  </a:txBody>
+                  <a:tcPr marL="72000" marR="72000" marT="36000" marB="36000" anchor="ctr">
+                    <a:lnL w="9525" cap="flat">
+                      <a:solidFill>
+                        <a:srgbClr val="9B9B9B"/>
+                      </a:solidFill>
+                    </a:lnL>
+                    <a:lnR w="9525" cap="flat">
+                      <a:solidFill>
+                        <a:srgbClr val="9B9B9B"/>
+                      </a:solidFill>
+                    </a:lnR>
+                    <a:lnT w="9525" cap="flat">
+                      <a:solidFill>
+                        <a:srgbClr val="9B9B9B"/>
+                      </a:solidFill>
+                    </a:lnT>
+                    <a:lnB w="9525" cap="flat">
+                      <a:solidFill>
+                        <a:srgbClr val="9B9B9B"/>
+                      </a:solidFill>
+                    </a:lnB>
+                    <a:solidFill>
+                      <a:srgbClr val="FFFFFF"/>
+                    </a:solidFill>
+                  </a:tcPr>
+                </a:tc>
+                <a:tc>
+                  <a:txBody>
+                    <a:bodyPr/>
+                    <a:lstStyle/>
+                    <a:p>
+                      <a:pPr algn="l"/>
+                      <a:r>
+                        <a:rPr lang="ja-JP" altLang="en-US" sz="1600" b="0" dirty="0">
+                          <a:solidFill>
+                            <a:srgbClr val="000000"/>
+                          </a:solidFill>
+                          <a:latin typeface="Meiryo"/>
+                          <a:ea typeface="Meiryo"/>
+                        </a:rPr>
+                        <a:t>10/14会議で未決。次回会議で協議</a:t>
+                      </a:r>
+                    </a:p>
+                  </a:txBody>
+                  <a:tcPr marL="72000" marR="72000" marT="36000" marB="36000" anchor="ctr">
+                    <a:lnL w="9525" cap="flat">
+                      <a:solidFill>
+                        <a:srgbClr val="9B9B9B"/>
+                      </a:solidFill>
+                    </a:lnL>
+                    <a:lnR w="9525" cap="flat">
+                      <a:solidFill>
+                        <a:srgbClr val="9B9B9B"/>
+                      </a:solidFill>
+                    </a:lnR>
+                    <a:lnT w="9525" cap="flat">
+                      <a:solidFill>
+                        <a:srgbClr val="9B9B9B"/>
+                      </a:solidFill>
+                    </a:lnT>
+                    <a:lnB w="9525" cap="flat">
+                      <a:solidFill>
+                        <a:srgbClr val="9B9B9B"/>
+                      </a:solidFill>
+                    </a:lnB>
+                    <a:solidFill>
+                      <a:srgbClr val="FFFFFF"/>
+                    </a:solidFill>
+                  </a:tcPr>
+                </a:tc>
+                <a:tc>
+                  <a:txBody>
+                    <a:bodyPr/>
+                    <a:lstStyle/>
+                    <a:p>
+                      <a:pPr algn="l"/>
+                      <a:r>
+                        <a:rPr lang="ja-JP" altLang="en-US" sz="1600" b="0" dirty="0">
+                          <a:solidFill>
+                            <a:srgbClr val="000000"/>
+                          </a:solidFill>
+                          <a:latin typeface="Meiryo"/>
+                          <a:ea typeface="Meiryo"/>
+                        </a:rPr>
+                        <a:t>10/28</a:t>
+                      </a:r>
+                    </a:p>
+                  </a:txBody>
+                  <a:tcPr marL="72000" marR="72000" marT="36000" marB="36000" anchor="ctr">
+                    <a:lnL w="9525" cap="flat">
+                      <a:solidFill>
+                        <a:srgbClr val="9B9B9B"/>
+                      </a:solidFill>
+                    </a:lnL>
+                    <a:lnR w="9525" cap="flat">
+                      <a:solidFill>
+                        <a:srgbClr val="9B9B9B"/>
+                      </a:solidFill>
+                    </a:lnR>
+                    <a:lnT w="9525" cap="flat">
+                      <a:solidFill>
+                        <a:srgbClr val="9B9B9B"/>
+                      </a:solidFill>
+                    </a:lnT>
+                    <a:lnB w="9525" cap="flat">
+                      <a:solidFill>
+                        <a:srgbClr val="9B9B9B"/>
+                      </a:solidFill>
+                    </a:lnB>
+                    <a:solidFill>
+                      <a:srgbClr val="FFFFFF"/>
+                    </a:solidFill>
+                  </a:tcPr>
+                </a:tc>
+                <a:extLst>
+                  <a:ext uri="{0D108BD9-81ED-4DB2-BD59-A6C34878D82A}">
+                    <a16:rowId xmlns:a16="http://schemas.microsoft.com/office/drawing/2014/main" val="10003"/>
+                  </a:ext>
+                </a:extLst>
+              </a:tr>
+              <a:tr h="400000">
                 <a:tc>
                   <a:txBody>
                     <a:bodyPr/>
@@ -9900,11 +10066,11 @@
                 </a:tc>
                 <a:extLst>
                   <a:ext uri="{0D108BD9-81ED-4DB2-BD59-A6C34878D82A}">
-                    <a16:rowId xmlns:a16="http://schemas.microsoft.com/office/drawing/2014/main" val="10003"/>
+                    <a16:rowId xmlns:a16="http://schemas.microsoft.com/office/drawing/2014/main" val="10004"/>
                   </a:ext>
                 </a:extLst>
               </a:tr>
-              <a:tr h="436324">
+              <a:tr h="400000">
                 <a:tc>
                   <a:txBody>
                     <a:bodyPr/>
@@ -10007,7 +10173,7 @@
                           <a:latin typeface="Meiryo"/>
                           <a:ea typeface="Meiryo"/>
                         </a:rPr>
-                        <a:t>10/23〜26(予定)</a:t>
+                        <a:t>10月末(予定)</a:t>
                       </a:r>
                     </a:p>
                   </a:txBody>
@@ -10043,7 +10209,7 @@
                   </a:ext>
                 </a:extLst>
               </a:tr>
-              <a:tr h="436324">
+              <a:tr h="400000">
                 <a:tc>
                   <a:txBody>
                     <a:bodyPr/>

</xml_diff>

<commit_message>
sync(workvault): 2026-10-21 16:30 差分 5 件
</commit_message>
<xml_diff>
--- a/workvault-sync/10_業務全般/業務報告/10月業務報告(篠原).pptx
+++ b/workvault-sync/10_業務全般/業務報告/10月業務報告(篠原).pptx
@@ -5771,18 +5771,7 @@
                 <a:ea typeface="Amazon Ember" panose="020B0603020204020204" pitchFamily="34" charset="0"/>
                 <a:cs typeface="Amazon Ember" panose="020B0603020204020204" pitchFamily="34" charset="0"/>
               </a:rPr>
-              <a:t>Summary</a:t>
-            </a:r>
-            <a:r>
-              <a:rPr lang="ja-JP" altLang="en-US" sz="3600" b="1" dirty="0">
-                <a:solidFill>
-                  <a:schemeClr val="bg1"/>
-                </a:solidFill>
-                <a:latin typeface="Amazon Ember" panose="020B0603020204020204" pitchFamily="34" charset="0"/>
-                <a:ea typeface="Meiryo"/>
-                <a:cs typeface="Amazon Ember" panose="020B0603020204020204" pitchFamily="34" charset="0"/>
-              </a:rPr>
-              <a:t>　 業務テーマ</a:t>
+              <a:t>定型業務と当月の位置づけ</a:t>
             </a:r>
             <a:endParaRPr lang="ja-JP" altLang="en-US" sz="3600" dirty="0">
               <a:solidFill>
@@ -5858,7 +5847,7 @@
         <p:spPr>
           <a:xfrm>
             <a:off x="540000" y="1572621"/>
-            <a:ext cx="10656000" cy="2600000"/>
+            <a:ext cx="10656000" cy="1000000"/>
           </a:xfrm>
           <a:prstGeom prst="rect">
             <a:avLst/>
@@ -5887,7 +5876,7 @@
                 <a:latin typeface="Meiryo"/>
                 <a:ea typeface="Meiryo"/>
               </a:rPr>
-              <a:t>在庫差異修正と0確認マクロの運用を確定させ、管理手順書の案2冊と棚卸しマクロver.2の改修を本番準備まで進めた。</a:t>
+              <a:t>引継ぎ3テーマを集中遂行：0確認マクロは運用確定、管理手順書は案2冊(未承認)、棚卸しマクロは実機検証待ち。</a:t>
             </a:r>
             <a:endParaRPr lang="en-US" altLang="ja-JP" b="0" dirty="0">
               <a:solidFill>
@@ -5914,142 +5903,7 @@
                 <a:latin typeface="Meiryo"/>
                 <a:ea typeface="Meiryo"/>
               </a:rPr>
-              <a:t>　業務内容：前任者が開発・運用・保守を担当していた在庫・棚卸し業務の引継ぎ(継続)</a:t>
-            </a:r>
-            <a:endParaRPr lang="en-US" altLang="ja-JP" b="0" dirty="0">
-              <a:solidFill>
-                <a:srgbClr val="000000"/>
-              </a:solidFill>
-              <a:latin typeface="Meiryo"/>
-              <a:ea typeface="Meiryo"/>
-            </a:endParaRPr>
-          </a:p>
-          <a:p>
-            <a:pPr algn="l">
-              <a:lnSpc>
-                <a:spcPct val="112000"/>
-              </a:lnSpc>
-              <a:spcAft>
-                <a:spcPts val="400"/>
-              </a:spcAft>
-            </a:pPr>
-            <a:r>
-              <a:rPr lang="ja-JP" altLang="en-US" b="0" dirty="0">
-                <a:solidFill>
-                  <a:srgbClr val="000000"/>
-                </a:solidFill>
-                <a:latin typeface="Meiryo"/>
-                <a:ea typeface="Meiryo"/>
-              </a:rPr>
-              <a:t>　 - 在庫差異修正：B列のL2限定差異修正を9/24に完了</a:t>
-            </a:r>
-            <a:endParaRPr lang="en-US" altLang="ja-JP" b="0" dirty="0">
-              <a:solidFill>
-                <a:srgbClr val="000000"/>
-              </a:solidFill>
-              <a:latin typeface="Meiryo"/>
-              <a:ea typeface="Meiryo"/>
-            </a:endParaRPr>
-          </a:p>
-          <a:p>
-            <a:pPr algn="l">
-              <a:lnSpc>
-                <a:spcPct val="112000"/>
-              </a:lnSpc>
-              <a:spcAft>
-                <a:spcPts val="400"/>
-              </a:spcAft>
-            </a:pPr>
-            <a:r>
-              <a:rPr lang="ja-JP" altLang="en-US" b="0" dirty="0">
-                <a:solidFill>
-                  <a:srgbClr val="000000"/>
-                </a:solidFill>
-                <a:latin typeface="Meiryo"/>
-                <a:ea typeface="Meiryo"/>
-              </a:rPr>
-              <a:t>　 - 0確認マクロver.2：無変更のまま実機で動作を確認、質問票35問の回答を運用手順書へ反映</a:t>
-            </a:r>
-            <a:endParaRPr lang="en-US" altLang="ja-JP" b="0" dirty="0">
-              <a:solidFill>
-                <a:srgbClr val="000000"/>
-              </a:solidFill>
-              <a:latin typeface="Meiryo"/>
-              <a:ea typeface="Meiryo"/>
-            </a:endParaRPr>
-          </a:p>
-          <a:p>
-            <a:pPr algn="l">
-              <a:lnSpc>
-                <a:spcPct val="112000"/>
-              </a:lnSpc>
-              <a:spcAft>
-                <a:spcPts val="400"/>
-              </a:spcAft>
-            </a:pPr>
-            <a:r>
-              <a:rPr lang="ja-JP" altLang="en-US" b="0" dirty="0">
-                <a:solidFill>
-                  <a:srgbClr val="000000"/>
-                </a:solidFill>
-                <a:latin typeface="Meiryo"/>
-                <a:ea typeface="Meiryo"/>
-              </a:rPr>
-              <a:t>　 - PanaCIM・LNB管理手順書：会議で統合方針を決定、案2冊を作成</a:t>
-            </a:r>
-            <a:endParaRPr lang="en-US" altLang="ja-JP" b="0" dirty="0">
-              <a:solidFill>
-                <a:srgbClr val="000000"/>
-              </a:solidFill>
-              <a:latin typeface="Meiryo"/>
-              <a:ea typeface="Meiryo"/>
-            </a:endParaRPr>
-          </a:p>
-          <a:p>
-            <a:pPr algn="l">
-              <a:lnSpc>
-                <a:spcPct val="112000"/>
-              </a:lnSpc>
-              <a:spcAft>
-                <a:spcPts val="400"/>
-              </a:spcAft>
-            </a:pPr>
-            <a:r>
-              <a:rPr lang="ja-JP" altLang="en-US" b="0" dirty="0">
-                <a:solidFill>
-                  <a:srgbClr val="000000"/>
-                </a:solidFill>
-                <a:latin typeface="Meiryo"/>
-                <a:ea typeface="Meiryo"/>
-              </a:rPr>
-              <a:t>　 - 固定テーブル棚卸しマクロ：改修をver.2へ統合、テストケース47件</a:t>
-            </a:r>
-            <a:endParaRPr lang="en-US" altLang="ja-JP" b="0" dirty="0">
-              <a:solidFill>
-                <a:srgbClr val="000000"/>
-              </a:solidFill>
-              <a:latin typeface="Meiryo"/>
-              <a:ea typeface="Meiryo"/>
-            </a:endParaRPr>
-          </a:p>
-          <a:p>
-            <a:pPr algn="l">
-              <a:lnSpc>
-                <a:spcPct val="112000"/>
-              </a:lnSpc>
-              <a:spcAft>
-                <a:spcPts val="400"/>
-              </a:spcAft>
-            </a:pPr>
-            <a:r>
-              <a:rPr lang="ja-JP" altLang="en-US" b="0" dirty="0">
-                <a:solidFill>
-                  <a:srgbClr val="000000"/>
-                </a:solidFill>
-                <a:latin typeface="Meiryo"/>
-                <a:ea typeface="Meiryo"/>
-              </a:rPr>
-              <a:t>　 - 保管庫の整理・BOSS計画の解析・鹿島引き込みマクロの分析・PowerBI改修準備</a:t>
+              <a:t>定型業務(JOB作成・設計変更対応)は当月実績0件。記録・基盤の運用と整備に集中した(下表)。</a:t>
             </a:r>
             <a:endParaRPr lang="en-US" altLang="ja-JP" b="0" dirty="0">
               <a:solidFill>
@@ -6099,6 +5953,756 @@
           </a:p>
         </p:txBody>
       </p:sp>
+      <p:graphicFrame>
+        <p:nvGraphicFramePr>
+          <p:cNvPr id="23" name="T59">
+            <a:extLst>
+              <a:ext uri="{FF2B5EF4-FFF2-40B4-BE49-F238E27FC236}">
+                <a16:creationId xmlns:a16="http://schemas.microsoft.com/office/drawing/2014/main" id="{A1CE0432-81FE-9A98-8528-48DD5FFDE362}"/>
+              </a:ext>
+            </a:extLst>
+          </p:cNvPr>
+          <p:cNvGraphicFramePr>
+            <a:graphicFrameLocks noGrp="1"/>
+          </p:cNvGraphicFramePr>
+          <p:nvPr>
+            <p:extLst>
+              <p:ext uri="{D42A27DB-BD31-4B8C-83A1-F6EECF244321}">
+                <p14:modId xmlns:p14="http://schemas.microsoft.com/office/powerpoint/2010/main" val="2037148714"/>
+              </p:ext>
+            </p:extLst>
+          </p:nvPr>
+        </p:nvGraphicFramePr>
+        <p:xfrm>
+          <a:off x="540000" y="2800000"/>
+          <a:ext cx="10656000" cy="2060000"/>
+        </p:xfrm>
+        <a:graphic>
+          <a:graphicData uri="http://schemas.openxmlformats.org/drawingml/2006/table">
+            <a:tbl>
+              <a:tblPr firstRow="1"/>
+              <a:tblGrid>
+                <a:gridCol w="3200000">
+                  <a:extLst>
+                    <a:ext uri="{9D8B030D-6E8A-4147-A177-3AD203B41FA5}">
+                      <a16:colId xmlns:a16="http://schemas.microsoft.com/office/drawing/2014/main" val="20000"/>
+                    </a:ext>
+                  </a:extLst>
+                </a:gridCol>
+                <a:gridCol w="2900000">
+                  <a:extLst>
+                    <a:ext uri="{9D8B030D-6E8A-4147-A177-3AD203B41FA5}">
+                      <a16:colId xmlns:a16="http://schemas.microsoft.com/office/drawing/2014/main" val="20001"/>
+                    </a:ext>
+                  </a:extLst>
+                </a:gridCol>
+                <a:gridCol w="4556000">
+                  <a:extLst>
+                    <a:ext uri="{9D8B030D-6E8A-4147-A177-3AD203B41FA5}">
+                      <a16:colId xmlns:a16="http://schemas.microsoft.com/office/drawing/2014/main" val="20002"/>
+                    </a:ext>
+                  </a:extLst>
+                </a:gridCol>
+              </a:tblGrid>
+              <a:tr h="460000">
+                <a:tc>
+                  <a:txBody>
+                    <a:bodyPr/>
+                    <a:lstStyle/>
+                    <a:p>
+                      <a:pPr algn="l"/>
+                      <a:r>
+                        <a:rPr lang="ja-JP" altLang="en-US" sz="1400" b="1" dirty="0">
+                          <a:solidFill>
+                            <a:srgbClr val="000000"/>
+                          </a:solidFill>
+                          <a:latin typeface="Meiryo"/>
+                          <a:ea typeface="Meiryo"/>
+                        </a:rPr>
+                        <a:t>業務</a:t>
+                      </a:r>
+                    </a:p>
+                  </a:txBody>
+                  <a:tcPr marL="72000" marR="72000" marT="36000" marB="36000" anchor="ctr">
+                    <a:lnL w="9525" cap="flat">
+                      <a:solidFill>
+                        <a:srgbClr val="9B9B9B"/>
+                      </a:solidFill>
+                    </a:lnL>
+                    <a:lnR w="9525" cap="flat">
+                      <a:solidFill>
+                        <a:srgbClr val="9B9B9B"/>
+                      </a:solidFill>
+                    </a:lnR>
+                    <a:lnT w="9525" cap="flat">
+                      <a:solidFill>
+                        <a:srgbClr val="9B9B9B"/>
+                      </a:solidFill>
+                    </a:lnT>
+                    <a:lnB w="9525" cap="flat">
+                      <a:solidFill>
+                        <a:srgbClr val="9B9B9B"/>
+                      </a:solidFill>
+                    </a:lnB>
+                    <a:solidFill>
+                      <a:srgbClr val="E9E9E9"/>
+                    </a:solidFill>
+                  </a:tcPr>
+                </a:tc>
+                <a:tc>
+                  <a:txBody>
+                    <a:bodyPr/>
+                    <a:lstStyle/>
+                    <a:p>
+                      <a:pPr algn="l"/>
+                      <a:r>
+                        <a:rPr lang="ja-JP" altLang="en-US" sz="1400" b="1" dirty="0">
+                          <a:solidFill>
+                            <a:srgbClr val="000000"/>
+                          </a:solidFill>
+                          <a:latin typeface="Meiryo"/>
+                          <a:ea typeface="Meiryo"/>
+                        </a:rPr>
+                        <a:t>10月実績</a:t>
+                      </a:r>
+                    </a:p>
+                  </a:txBody>
+                  <a:tcPr marL="72000" marR="72000" marT="36000" marB="36000" anchor="ctr">
+                    <a:lnL w="9525" cap="flat">
+                      <a:solidFill>
+                        <a:srgbClr val="9B9B9B"/>
+                      </a:solidFill>
+                    </a:lnL>
+                    <a:lnR w="9525" cap="flat">
+                      <a:solidFill>
+                        <a:srgbClr val="9B9B9B"/>
+                      </a:solidFill>
+                    </a:lnR>
+                    <a:lnT w="9525" cap="flat">
+                      <a:solidFill>
+                        <a:srgbClr val="9B9B9B"/>
+                      </a:solidFill>
+                    </a:lnT>
+                    <a:lnB w="9525" cap="flat">
+                      <a:solidFill>
+                        <a:srgbClr val="9B9B9B"/>
+                      </a:solidFill>
+                    </a:lnB>
+                    <a:solidFill>
+                      <a:srgbClr val="E9E9E9"/>
+                    </a:solidFill>
+                  </a:tcPr>
+                </a:tc>
+                <a:tc>
+                  <a:txBody>
+                    <a:bodyPr/>
+                    <a:lstStyle/>
+                    <a:p>
+                      <a:pPr algn="l"/>
+                      <a:r>
+                        <a:rPr lang="ja-JP" altLang="en-US" sz="1400" b="1" dirty="0">
+                          <a:solidFill>
+                            <a:srgbClr val="000000"/>
+                          </a:solidFill>
+                          <a:latin typeface="Meiryo"/>
+                          <a:ea typeface="Meiryo"/>
+                        </a:rPr>
+                        <a:t>備考</a:t>
+                      </a:r>
+                    </a:p>
+                  </a:txBody>
+                  <a:tcPr marL="72000" marR="72000" marT="36000" marB="36000" anchor="ctr">
+                    <a:lnL w="9525" cap="flat">
+                      <a:solidFill>
+                        <a:srgbClr val="9B9B9B"/>
+                      </a:solidFill>
+                    </a:lnL>
+                    <a:lnR w="9525" cap="flat">
+                      <a:solidFill>
+                        <a:srgbClr val="9B9B9B"/>
+                      </a:solidFill>
+                    </a:lnR>
+                    <a:lnT w="9525" cap="flat">
+                      <a:solidFill>
+                        <a:srgbClr val="9B9B9B"/>
+                      </a:solidFill>
+                    </a:lnT>
+                    <a:lnB w="9525" cap="flat">
+                      <a:solidFill>
+                        <a:srgbClr val="9B9B9B"/>
+                      </a:solidFill>
+                    </a:lnB>
+                    <a:solidFill>
+                      <a:srgbClr val="E9E9E9"/>
+                    </a:solidFill>
+                  </a:tcPr>
+                </a:tc>
+                <a:extLst>
+                  <a:ext uri="{0D108BD9-81ED-4DB2-BD59-A6C34878D82A}">
+                    <a16:rowId xmlns:a16="http://schemas.microsoft.com/office/drawing/2014/main" val="10000"/>
+                  </a:ext>
+                </a:extLst>
+              </a:tr>
+              <a:tr h="400000">
+                <a:tc>
+                  <a:txBody>
+                    <a:bodyPr/>
+                    <a:lstStyle/>
+                    <a:p>
+                      <a:pPr algn="l"/>
+                      <a:r>
+                        <a:rPr lang="ja-JP" altLang="en-US" sz="1400" b="0" dirty="0">
+                          <a:solidFill>
+                            <a:srgbClr val="000000"/>
+                          </a:solidFill>
+                          <a:latin typeface="Meiryo"/>
+                          <a:ea typeface="Meiryo"/>
+                        </a:rPr>
+                        <a:t>JOB作成(不足部品リスト作成)</a:t>
+                      </a:r>
+                    </a:p>
+                  </a:txBody>
+                  <a:tcPr marL="72000" marR="72000" marT="36000" marB="36000" anchor="ctr">
+                    <a:lnL w="9525" cap="flat">
+                      <a:solidFill>
+                        <a:srgbClr val="9B9B9B"/>
+                      </a:solidFill>
+                    </a:lnL>
+                    <a:lnR w="9525" cap="flat">
+                      <a:solidFill>
+                        <a:srgbClr val="9B9B9B"/>
+                      </a:solidFill>
+                    </a:lnR>
+                    <a:lnT w="9525" cap="flat">
+                      <a:solidFill>
+                        <a:srgbClr val="9B9B9B"/>
+                      </a:solidFill>
+                    </a:lnT>
+                    <a:lnB w="9525" cap="flat">
+                      <a:solidFill>
+                        <a:srgbClr val="9B9B9B"/>
+                      </a:solidFill>
+                    </a:lnB>
+                    <a:solidFill>
+                      <a:srgbClr val="FFFFFF"/>
+                    </a:solidFill>
+                  </a:tcPr>
+                </a:tc>
+                <a:tc>
+                  <a:txBody>
+                    <a:bodyPr/>
+                    <a:lstStyle/>
+                    <a:p>
+                      <a:pPr algn="l"/>
+                      <a:r>
+                        <a:rPr lang="ja-JP" altLang="en-US" sz="1400" b="0" dirty="0">
+                          <a:solidFill>
+                            <a:srgbClr val="000000"/>
+                          </a:solidFill>
+                          <a:latin typeface="Meiryo"/>
+                          <a:ea typeface="Meiryo"/>
+                        </a:rPr>
+                        <a:t>0件</a:t>
+                      </a:r>
+                    </a:p>
+                  </a:txBody>
+                  <a:tcPr marL="72000" marR="72000" marT="36000" marB="36000" anchor="ctr">
+                    <a:lnL w="9525" cap="flat">
+                      <a:solidFill>
+                        <a:srgbClr val="9B9B9B"/>
+                      </a:solidFill>
+                    </a:lnL>
+                    <a:lnR w="9525" cap="flat">
+                      <a:solidFill>
+                        <a:srgbClr val="9B9B9B"/>
+                      </a:solidFill>
+                    </a:lnR>
+                    <a:lnT w="9525" cap="flat">
+                      <a:solidFill>
+                        <a:srgbClr val="9B9B9B"/>
+                      </a:solidFill>
+                    </a:lnT>
+                    <a:lnB w="9525" cap="flat">
+                      <a:solidFill>
+                        <a:srgbClr val="9B9B9B"/>
+                      </a:solidFill>
+                    </a:lnB>
+                    <a:solidFill>
+                      <a:srgbClr val="FFFFFF"/>
+                    </a:solidFill>
+                  </a:tcPr>
+                </a:tc>
+                <a:tc>
+                  <a:txBody>
+                    <a:bodyPr/>
+                    <a:lstStyle/>
+                    <a:p>
+                      <a:pPr algn="l"/>
+                      <a:r>
+                        <a:rPr lang="ja-JP" altLang="en-US" sz="1400" b="0" dirty="0">
+                          <a:solidFill>
+                            <a:srgbClr val="000000"/>
+                          </a:solidFill>
+                          <a:latin typeface="Meiryo"/>
+                          <a:ea typeface="Meiryo"/>
+                        </a:rPr>
+                        <a:t>引継ぎの整備を優先。運用開始は11月以降</a:t>
+                      </a:r>
+                    </a:p>
+                  </a:txBody>
+                  <a:tcPr marL="72000" marR="72000" marT="36000" marB="36000" anchor="ctr">
+                    <a:lnL w="9525" cap="flat">
+                      <a:solidFill>
+                        <a:srgbClr val="9B9B9B"/>
+                      </a:solidFill>
+                    </a:lnL>
+                    <a:lnR w="9525" cap="flat">
+                      <a:solidFill>
+                        <a:srgbClr val="9B9B9B"/>
+                      </a:solidFill>
+                    </a:lnR>
+                    <a:lnT w="9525" cap="flat">
+                      <a:solidFill>
+                        <a:srgbClr val="9B9B9B"/>
+                      </a:solidFill>
+                    </a:lnT>
+                    <a:lnB w="9525" cap="flat">
+                      <a:solidFill>
+                        <a:srgbClr val="9B9B9B"/>
+                      </a:solidFill>
+                    </a:lnB>
+                    <a:solidFill>
+                      <a:srgbClr val="FFFFFF"/>
+                    </a:solidFill>
+                  </a:tcPr>
+                </a:tc>
+                <a:extLst>
+                  <a:ext uri="{0D108BD9-81ED-4DB2-BD59-A6C34878D82A}">
+                    <a16:rowId xmlns:a16="http://schemas.microsoft.com/office/drawing/2014/main" val="10001"/>
+                  </a:ext>
+                </a:extLst>
+              </a:tr>
+              <a:tr h="400000">
+                <a:tc>
+                  <a:txBody>
+                    <a:bodyPr/>
+                    <a:lstStyle/>
+                    <a:p>
+                      <a:pPr algn="l"/>
+                      <a:r>
+                        <a:rPr lang="ja-JP" altLang="en-US" sz="1400" b="0" dirty="0">
+                          <a:solidFill>
+                            <a:srgbClr val="000000"/>
+                          </a:solidFill>
+                          <a:latin typeface="Meiryo"/>
+                          <a:ea typeface="Meiryo"/>
+                        </a:rPr>
+                        <a:t>記録の運用</a:t>
+                      </a:r>
+                    </a:p>
+                  </a:txBody>
+                  <a:tcPr marL="72000" marR="72000" marT="36000" marB="36000" anchor="ctr">
+                    <a:lnL w="9525" cap="flat">
+                      <a:solidFill>
+                        <a:srgbClr val="9B9B9B"/>
+                      </a:solidFill>
+                    </a:lnL>
+                    <a:lnR w="9525" cap="flat">
+                      <a:solidFill>
+                        <a:srgbClr val="9B9B9B"/>
+                      </a:solidFill>
+                    </a:lnR>
+                    <a:lnT w="9525" cap="flat">
+                      <a:solidFill>
+                        <a:srgbClr val="9B9B9B"/>
+                      </a:solidFill>
+                    </a:lnT>
+                    <a:lnB w="9525" cap="flat">
+                      <a:solidFill>
+                        <a:srgbClr val="9B9B9B"/>
+                      </a:solidFill>
+                    </a:lnB>
+                    <a:solidFill>
+                      <a:srgbClr val="FFFFFF"/>
+                    </a:solidFill>
+                  </a:tcPr>
+                </a:tc>
+                <a:tc>
+                  <a:txBody>
+                    <a:bodyPr/>
+                    <a:lstStyle/>
+                    <a:p>
+                      <a:pPr algn="l"/>
+                      <a:r>
+                        <a:rPr lang="ja-JP" altLang="en-US" sz="1400" b="0" dirty="0">
+                          <a:solidFill>
+                            <a:srgbClr val="000000"/>
+                          </a:solidFill>
+                          <a:latin typeface="Meiryo"/>
+                          <a:ea typeface="Meiryo"/>
+                        </a:rPr>
+                        <a:t>日報11本/週報3本</a:t>
+                      </a:r>
+                    </a:p>
+                  </a:txBody>
+                  <a:tcPr marL="72000" marR="72000" marT="36000" marB="36000" anchor="ctr">
+                    <a:lnL w="9525" cap="flat">
+                      <a:solidFill>
+                        <a:srgbClr val="9B9B9B"/>
+                      </a:solidFill>
+                    </a:lnL>
+                    <a:lnR w="9525" cap="flat">
+                      <a:solidFill>
+                        <a:srgbClr val="9B9B9B"/>
+                      </a:solidFill>
+                    </a:lnR>
+                    <a:lnT w="9525" cap="flat">
+                      <a:solidFill>
+                        <a:srgbClr val="9B9B9B"/>
+                      </a:solidFill>
+                    </a:lnT>
+                    <a:lnB w="9525" cap="flat">
+                      <a:solidFill>
+                        <a:srgbClr val="9B9B9B"/>
+                      </a:solidFill>
+                    </a:lnB>
+                    <a:solidFill>
+                      <a:srgbClr val="FFFFFF"/>
+                    </a:solidFill>
+                  </a:tcPr>
+                </a:tc>
+                <a:tc>
+                  <a:txBody>
+                    <a:bodyPr/>
+                    <a:lstStyle/>
+                    <a:p>
+                      <a:pPr algn="l"/>
+                      <a:r>
+                        <a:rPr lang="ja-JP" altLang="en-US" sz="1400" b="0" dirty="0">
+                          <a:solidFill>
+                            <a:srgbClr val="000000"/>
+                          </a:solidFill>
+                          <a:latin typeface="Meiryo"/>
+                          <a:ea typeface="Meiryo"/>
+                        </a:rPr>
+                        <a:t>毎日作成。W42は完了済み</a:t>
+                      </a:r>
+                    </a:p>
+                  </a:txBody>
+                  <a:tcPr marL="72000" marR="72000" marT="36000" marB="36000" anchor="ctr">
+                    <a:lnL w="9525" cap="flat">
+                      <a:solidFill>
+                        <a:srgbClr val="9B9B9B"/>
+                      </a:solidFill>
+                    </a:lnL>
+                    <a:lnR w="9525" cap="flat">
+                      <a:solidFill>
+                        <a:srgbClr val="9B9B9B"/>
+                      </a:solidFill>
+                    </a:lnR>
+                    <a:lnT w="9525" cap="flat">
+                      <a:solidFill>
+                        <a:srgbClr val="9B9B9B"/>
+                      </a:solidFill>
+                    </a:lnT>
+                    <a:lnB w="9525" cap="flat">
+                      <a:solidFill>
+                        <a:srgbClr val="9B9B9B"/>
+                      </a:solidFill>
+                    </a:lnB>
+                    <a:solidFill>
+                      <a:srgbClr val="FFFFFF"/>
+                    </a:solidFill>
+                  </a:tcPr>
+                </a:tc>
+                <a:extLst>
+                  <a:ext uri="{0D108BD9-81ED-4DB2-BD59-A6C34878D82A}">
+                    <a16:rowId xmlns:a16="http://schemas.microsoft.com/office/drawing/2014/main" val="10002"/>
+                  </a:ext>
+                </a:extLst>
+              </a:tr>
+              <a:tr h="400000">
+                <a:tc>
+                  <a:txBody>
+                    <a:bodyPr/>
+                    <a:lstStyle/>
+                    <a:p>
+                      <a:pPr algn="l"/>
+                      <a:r>
+                        <a:rPr lang="ja-JP" altLang="en-US" sz="1400" b="0" dirty="0">
+                          <a:solidFill>
+                            <a:srgbClr val="000000"/>
+                          </a:solidFill>
+                          <a:latin typeface="Meiryo"/>
+                          <a:ea typeface="Meiryo"/>
+                        </a:rPr>
+                        <a:t>保管庫のGitHub移管</a:t>
+                      </a:r>
+                    </a:p>
+                  </a:txBody>
+                  <a:tcPr marL="72000" marR="72000" marT="36000" marB="36000" anchor="ctr">
+                    <a:lnL w="9525" cap="flat">
+                      <a:solidFill>
+                        <a:srgbClr val="9B9B9B"/>
+                      </a:solidFill>
+                    </a:lnL>
+                    <a:lnR w="9525" cap="flat">
+                      <a:solidFill>
+                        <a:srgbClr val="9B9B9B"/>
+                      </a:solidFill>
+                    </a:lnR>
+                    <a:lnT w="9525" cap="flat">
+                      <a:solidFill>
+                        <a:srgbClr val="9B9B9B"/>
+                      </a:solidFill>
+                    </a:lnT>
+                    <a:lnB w="9525" cap="flat">
+                      <a:solidFill>
+                        <a:srgbClr val="9B9B9B"/>
+                      </a:solidFill>
+                    </a:lnB>
+                    <a:solidFill>
+                      <a:srgbClr val="FFFFFF"/>
+                    </a:solidFill>
+                  </a:tcPr>
+                </a:tc>
+                <a:tc>
+                  <a:txBody>
+                    <a:bodyPr/>
+                    <a:lstStyle/>
+                    <a:p>
+                      <a:pPr algn="l"/>
+                      <a:r>
+                        <a:rPr lang="ja-JP" altLang="en-US" sz="1400" b="0" dirty="0">
+                          <a:solidFill>
+                            <a:srgbClr val="000000"/>
+                          </a:solidFill>
+                          <a:latin typeface="Meiryo"/>
+                          <a:ea typeface="Meiryo"/>
+                        </a:rPr>
+                        <a:t>3,135ファイル・issue57件</a:t>
+                      </a:r>
+                    </a:p>
+                  </a:txBody>
+                  <a:tcPr marL="72000" marR="72000" marT="36000" marB="36000" anchor="ctr">
+                    <a:lnL w="9525" cap="flat">
+                      <a:solidFill>
+                        <a:srgbClr val="9B9B9B"/>
+                      </a:solidFill>
+                    </a:lnL>
+                    <a:lnR w="9525" cap="flat">
+                      <a:solidFill>
+                        <a:srgbClr val="9B9B9B"/>
+                      </a:solidFill>
+                    </a:lnR>
+                    <a:lnT w="9525" cap="flat">
+                      <a:solidFill>
+                        <a:srgbClr val="9B9B9B"/>
+                      </a:solidFill>
+                    </a:lnT>
+                    <a:lnB w="9525" cap="flat">
+                      <a:solidFill>
+                        <a:srgbClr val="9B9B9B"/>
+                      </a:solidFill>
+                    </a:lnB>
+                    <a:solidFill>
+                      <a:srgbClr val="FFFFFF"/>
+                    </a:solidFill>
+                  </a:tcPr>
+                </a:tc>
+                <a:tc>
+                  <a:txBody>
+                    <a:bodyPr/>
+                    <a:lstStyle/>
+                    <a:p>
+                      <a:pPr algn="l"/>
+                      <a:r>
+                        <a:rPr lang="ja-JP" altLang="en-US" sz="1400" b="0" dirty="0">
+                          <a:solidFill>
+                            <a:srgbClr val="000000"/>
+                          </a:solidFill>
+                          <a:latin typeface="Meiryo"/>
+                          <a:ea typeface="Meiryo"/>
+                        </a:rPr>
+                        <a:t>同期は毎日17:30に自動実行</a:t>
+                      </a:r>
+                    </a:p>
+                  </a:txBody>
+                  <a:tcPr marL="72000" marR="72000" marT="36000" marB="36000" anchor="ctr">
+                    <a:lnL w="9525" cap="flat">
+                      <a:solidFill>
+                        <a:srgbClr val="9B9B9B"/>
+                      </a:solidFill>
+                    </a:lnL>
+                    <a:lnR w="9525" cap="flat">
+                      <a:solidFill>
+                        <a:srgbClr val="9B9B9B"/>
+                      </a:solidFill>
+                    </a:lnR>
+                    <a:lnT w="9525" cap="flat">
+                      <a:solidFill>
+                        <a:srgbClr val="9B9B9B"/>
+                      </a:solidFill>
+                    </a:lnT>
+                    <a:lnB w="9525" cap="flat">
+                      <a:solidFill>
+                        <a:srgbClr val="9B9B9B"/>
+                      </a:solidFill>
+                    </a:lnB>
+                    <a:solidFill>
+                      <a:srgbClr val="FFFFFF"/>
+                    </a:solidFill>
+                  </a:tcPr>
+                </a:tc>
+                <a:extLst>
+                  <a:ext uri="{0D108BD9-81ED-4DB2-BD59-A6C34878D82A}">
+                    <a16:rowId xmlns:a16="http://schemas.microsoft.com/office/drawing/2014/main" val="10003"/>
+                  </a:ext>
+                </a:extLst>
+              </a:tr>
+              <a:tr h="400000">
+                <a:tc>
+                  <a:txBody>
+                    <a:bodyPr/>
+                    <a:lstStyle/>
+                    <a:p>
+                      <a:pPr algn="l"/>
+                      <a:r>
+                        <a:rPr lang="ja-JP" altLang="en-US" sz="1400" b="0" dirty="0">
+                          <a:solidFill>
+                            <a:srgbClr val="000000"/>
+                          </a:solidFill>
+                          <a:latin typeface="Meiryo"/>
+                          <a:ea typeface="Meiryo"/>
+                        </a:rPr>
+                        <a:t>スナップショット容量</a:t>
+                      </a:r>
+                    </a:p>
+                  </a:txBody>
+                  <a:tcPr marL="72000" marR="72000" marT="36000" marB="36000" anchor="ctr">
+                    <a:lnL w="9525" cap="flat">
+                      <a:solidFill>
+                        <a:srgbClr val="9B9B9B"/>
+                      </a:solidFill>
+                    </a:lnL>
+                    <a:lnR w="9525" cap="flat">
+                      <a:solidFill>
+                        <a:srgbClr val="9B9B9B"/>
+                      </a:solidFill>
+                    </a:lnR>
+                    <a:lnT w="9525" cap="flat">
+                      <a:solidFill>
+                        <a:srgbClr val="9B9B9B"/>
+                      </a:solidFill>
+                    </a:lnT>
+                    <a:lnB w="9525" cap="flat">
+                      <a:solidFill>
+                        <a:srgbClr val="9B9B9B"/>
+                      </a:solidFill>
+                    </a:lnB>
+                    <a:solidFill>
+                      <a:srgbClr val="FFFFFF"/>
+                    </a:solidFill>
+                  </a:tcPr>
+                </a:tc>
+                <a:tc>
+                  <a:txBody>
+                    <a:bodyPr/>
+                    <a:lstStyle/>
+                    <a:p>
+                      <a:pPr algn="l"/>
+                      <a:r>
+                        <a:rPr lang="ja-JP" altLang="en-US" sz="1400" b="0" dirty="0">
+                          <a:solidFill>
+                            <a:srgbClr val="000000"/>
+                          </a:solidFill>
+                          <a:latin typeface="Meiryo"/>
+                          <a:ea typeface="Meiryo"/>
+                        </a:rPr>
+                        <a:t>56.1GB→0.59GB</a:t>
+                      </a:r>
+                    </a:p>
+                  </a:txBody>
+                  <a:tcPr marL="72000" marR="72000" marT="36000" marB="36000" anchor="ctr">
+                    <a:lnL w="9525" cap="flat">
+                      <a:solidFill>
+                        <a:srgbClr val="9B9B9B"/>
+                      </a:solidFill>
+                    </a:lnL>
+                    <a:lnR w="9525" cap="flat">
+                      <a:solidFill>
+                        <a:srgbClr val="9B9B9B"/>
+                      </a:solidFill>
+                    </a:lnR>
+                    <a:lnT w="9525" cap="flat">
+                      <a:solidFill>
+                        <a:srgbClr val="9B9B9B"/>
+                      </a:solidFill>
+                    </a:lnT>
+                    <a:lnB w="9525" cap="flat">
+                      <a:solidFill>
+                        <a:srgbClr val="9B9B9B"/>
+                      </a:solidFill>
+                    </a:lnB>
+                    <a:solidFill>
+                      <a:srgbClr val="FFFFFF"/>
+                    </a:solidFill>
+                  </a:tcPr>
+                </a:tc>
+                <a:tc>
+                  <a:txBody>
+                    <a:bodyPr/>
+                    <a:lstStyle/>
+                    <a:p>
+                      <a:pPr algn="l"/>
+                      <a:r>
+                        <a:rPr lang="ja-JP" altLang="en-US" sz="1400" b="0" dirty="0">
+                          <a:solidFill>
+                            <a:srgbClr val="000000"/>
+                          </a:solidFill>
+                          <a:latin typeface="Meiryo"/>
+                          <a:ea typeface="Meiryo"/>
+                        </a:rPr>
+                        <a:t>除外を許可リスト化(10/8)</a:t>
+                      </a:r>
+                    </a:p>
+                  </a:txBody>
+                  <a:tcPr marL="72000" marR="72000" marT="36000" marB="36000" anchor="ctr">
+                    <a:lnL w="9525" cap="flat">
+                      <a:solidFill>
+                        <a:srgbClr val="9B9B9B"/>
+                      </a:solidFill>
+                    </a:lnL>
+                    <a:lnR w="9525" cap="flat">
+                      <a:solidFill>
+                        <a:srgbClr val="9B9B9B"/>
+                      </a:solidFill>
+                    </a:lnR>
+                    <a:lnT w="9525" cap="flat">
+                      <a:solidFill>
+                        <a:srgbClr val="9B9B9B"/>
+                      </a:solidFill>
+                    </a:lnT>
+                    <a:lnB w="9525" cap="flat">
+                      <a:solidFill>
+                        <a:srgbClr val="9B9B9B"/>
+                      </a:solidFill>
+                    </a:lnB>
+                    <a:solidFill>
+                      <a:srgbClr val="FFFFFF"/>
+                    </a:solidFill>
+                  </a:tcPr>
+                </a:tc>
+                <a:extLst>
+                  <a:ext uri="{0D108BD9-81ED-4DB2-BD59-A6C34878D82A}">
+                    <a16:rowId xmlns:a16="http://schemas.microsoft.com/office/drawing/2014/main" val="10004"/>
+                  </a:ext>
+                </a:extLst>
+              </a:tr>
+            </a:tbl>
+          </a:graphicData>
+        </a:graphic>
+      </p:graphicFrame>
     </p:spTree>
   </p:cSld>
   <p:clrMapOvr>
@@ -6164,7 +6768,7 @@
                 <a:latin typeface="Meiryo"/>
                 <a:ea typeface="Meiryo"/>
               </a:rPr>
-              <a:t>Topics 1　0確認マクロver.2の運用確定</a:t>
+              <a:t>テーマ1　0確認マクロver.2の運用確定</a:t>
             </a:r>
             <a:endParaRPr lang="ja-JP" altLang="en-US" sz="3600" dirty="0">
               <a:solidFill>
@@ -6305,7 +6909,7 @@
                 <a:latin typeface="Meiryo"/>
                 <a:ea typeface="Meiryo"/>
               </a:rPr>
-              <a:t>背景</a:t>
+              <a:t>目標と実績</a:t>
             </a:r>
           </a:p>
         </p:txBody>
@@ -6354,7 +6958,7 @@
                 <a:latin typeface="Meiryo"/>
                 <a:ea typeface="Meiryo"/>
               </a:rPr>
-              <a:t>・0確認は棚卸し前の必須作業だが、手順書が残らず担当者も不在で、動かない原因を切り分けられなかった。</a:t>
+              <a:t>・月間目標：質問票35問の回答を運用手順書へ反映し、本番準備を完了させる。</a:t>
             </a:r>
             <a:endParaRPr lang="en-US" altLang="ja-JP" b="0" dirty="0">
               <a:solidFill>
@@ -6381,7 +6985,7 @@
                 <a:latin typeface="Meiryo"/>
                 <a:ea typeface="Meiryo"/>
               </a:rPr>
-              <a:t>・原因が入力CSVかマクロかを判別する方法が無く、推測に頼った報告になっていた。</a:t>
+              <a:t>・実績：反映は完了(10/15)。本番は10月末(予定)で、日程は10/28会議で確定。</a:t>
             </a:r>
             <a:endParaRPr lang="en-US" altLang="ja-JP" b="0" dirty="0">
               <a:solidFill>
@@ -6486,7 +7090,7 @@
                 <a:latin typeface="Meiryo"/>
                 <a:ea typeface="Meiryo"/>
               </a:rPr>
-              <a:t>・マクロと入力CSVを照合するスクリプトを作成し、原因の切り分けを機械化した。</a:t>
+              <a:t>・照合スクリプトで原因の切り分け(入力CSV起因/マクロ起因)を機械化した。</a:t>
             </a:r>
             <a:endParaRPr lang="en-US" altLang="ja-JP" b="0" dirty="0">
               <a:solidFill>
@@ -6513,7 +7117,7 @@
                 <a:latin typeface="Meiryo"/>
                 <a:ea typeface="Meiryo"/>
               </a:rPr>
-              <a:t>・9/28にコンパイルエラー2つが原因と報告したが誤診断。10/2に無変更で実機成功し訂正。</a:t>
+              <a:t>・10/2に無変更のまま実機で成功し、ver.2を運用として採用した。</a:t>
             </a:r>
             <a:endParaRPr lang="en-US" altLang="ja-JP" b="0" dirty="0">
               <a:solidFill>
@@ -6618,7 +7222,7 @@
                 <a:latin typeface="Meiryo"/>
                 <a:ea typeface="Meiryo"/>
               </a:rPr>
-              <a:t>・9/28時点の対象件数は5,848件(入力CSVは29,246行)。</a:t>
+              <a:t>・対象5,848件(入力CSV 29,246行)。10/2版は再計算で6,084件と一致。</a:t>
             </a:r>
           </a:p>
           <a:p>
@@ -6638,7 +7242,7 @@
                 <a:latin typeface="Meiryo"/>
                 <a:ea typeface="Meiryo"/>
               </a:rPr>
-              <a:t>・再計算スクリプトで10/2版CSV(29,345行)も記録値6,084件と一致することを確認。</a:t>
+              <a:t>・正本は共有サーバーの「0確認マクロ_ver2.xlsm」。反映は10/15。</a:t>
             </a:r>
           </a:p>
           <a:p>
@@ -6658,7 +7262,7 @@
                 <a:latin typeface="Meiryo"/>
                 <a:ea typeface="Meiryo"/>
               </a:rPr>
-              <a:t>・運用確定質問票(35問)の回答を運用手順書へ反映(10/15)。正本は共有サーバーの「0確認マクロ_ver2.xlsm」。</a:t>
+              <a:t>・効果：原因の切り分けを機械化(推測→照合)。工数の前後比較は本番時に測定(未測定)。</a:t>
             </a:r>
           </a:p>
           <a:p>
@@ -6678,7 +7282,7 @@
                 <a:latin typeface="Meiryo"/>
                 <a:ea typeface="Meiryo"/>
               </a:rPr>
-              <a:t>→ 次の展開：未決4件とxlsmへの実装2件が残る。全件照合と消し込み結果は本番で確認する。</a:t>
+              <a:t>→ 次の展開：未決4件とxlsmへの実装2件を消化し、本番で全件照合と消し込み結果を確認する。</a:t>
             </a:r>
           </a:p>
         </p:txBody>
@@ -6753,7 +7357,7 @@
                 <a:latin typeface="Meiryo"/>
                 <a:ea typeface="Meiryo"/>
               </a:rPr>
-              <a:t>Topics 2　PanaCIM・LNB管理手順書の整備</a:t>
+              <a:t>テーマ2　PanaCIM・LNB管理手順書の整備</a:t>
             </a:r>
             <a:endParaRPr lang="ja-JP" altLang="en-US" sz="3600" dirty="0">
               <a:solidFill>
@@ -7732,7 +8336,7 @@
                 <a:latin typeface="Meiryo"/>
                 <a:ea typeface="Meiryo"/>
               </a:rPr>
-              <a:t>・管理書v0.12、LNB管理書v0.11に反映し、管理手順書案2冊(xlsx・PDF・107頁/99頁)を作成(未承認)。</a:t>
+              <a:t>・月間目標：案2冊の承認 → 実績：案2冊を作成(107頁/99頁、未承認)。管理書v0.12・LNB管理書v0.11に反映。</a:t>
             </a:r>
             <a:endParaRPr lang="en-US" altLang="ja-JP" b="0" dirty="0">
               <a:solidFill>
@@ -7970,7 +8574,7 @@
                 <a:latin typeface="Meiryo"/>
                 <a:ea typeface="Meiryo"/>
               </a:rPr>
-              <a:t>Topics 3　固定テーブル棚卸しマクロver.2の改修</a:t>
+              <a:t>テーマ3　固定テーブル棚卸しマクロver.2の改修</a:t>
             </a:r>
             <a:endParaRPr lang="ja-JP" altLang="en-US" sz="3600" dirty="0">
               <a:solidFill>
@@ -8328,7 +8932,7 @@
         </p:nvGraphicFramePr>
         <p:xfrm>
           <a:off x="756000" y="3996000"/>
-          <a:ext cx="10656000" cy="1568570"/>
+          <a:ext cx="10656000" cy="1882284"/>
         </p:xfrm>
         <a:graphic>
           <a:graphicData uri="http://schemas.openxmlformats.org/drawingml/2006/table">
@@ -8789,7 +9393,7 @@
                           <a:latin typeface="Meiryo"/>
                           <a:ea typeface="Meiryo"/>
                         </a:rPr>
-                        <a:t>実機検証</a:t>
+                        <a:t>実機検証(4段階)</a:t>
                       </a:r>
                     </a:p>
                   </a:txBody>
@@ -8877,7 +9481,7 @@
                           <a:latin typeface="Meiryo"/>
                           <a:ea typeface="Meiryo"/>
                         </a:rPr>
-                        <a:t>未実施</a:t>
+                        <a:t>0/4段階(未着手)</a:t>
                       </a:r>
                     </a:p>
                   </a:txBody>
@@ -8928,6 +9532,145 @@
                           <a:latin typeface="Meiryo"/>
                           <a:ea typeface="Meiryo"/>
                         </a:rPr>
+                        <a:t>処理時間の効果</a:t>
+                      </a:r>
+                    </a:p>
+                  </a:txBody>
+                  <a:tcPr marL="72000" marR="72000" marT="36000" marB="36000" anchor="ctr">
+                    <a:lnL w="9525" cap="flat">
+                      <a:solidFill>
+                        <a:srgbClr val="9B9B9B"/>
+                      </a:solidFill>
+                    </a:lnL>
+                    <a:lnR w="9525" cap="flat">
+                      <a:solidFill>
+                        <a:srgbClr val="9B9B9B"/>
+                      </a:solidFill>
+                    </a:lnR>
+                    <a:lnT w="9525" cap="flat">
+                      <a:solidFill>
+                        <a:srgbClr val="9B9B9B"/>
+                      </a:solidFill>
+                    </a:lnT>
+                    <a:lnB w="9525" cap="flat">
+                      <a:solidFill>
+                        <a:srgbClr val="9B9B9B"/>
+                      </a:solidFill>
+                    </a:lnB>
+                    <a:solidFill>
+                      <a:srgbClr val="FFFFFF"/>
+                    </a:solidFill>
+                  </a:tcPr>
+                </a:tc>
+                <a:tc>
+                  <a:txBody>
+                    <a:bodyPr/>
+                    <a:lstStyle/>
+                    <a:p>
+                      <a:pPr algn="l"/>
+                      <a:r>
+                        <a:rPr lang="ja-JP" altLang="en-US" sz="1400" b="0" dirty="0">
+                          <a:solidFill>
+                            <a:srgbClr val="000000"/>
+                          </a:solidFill>
+                          <a:latin typeface="Meiryo"/>
+                          <a:ea typeface="Meiryo"/>
+                        </a:rPr>
+                        <a:t>旧版との前後比較</a:t>
+                      </a:r>
+                    </a:p>
+                  </a:txBody>
+                  <a:tcPr marL="72000" marR="72000" marT="36000" marB="36000" anchor="ctr">
+                    <a:lnL w="9525" cap="flat">
+                      <a:solidFill>
+                        <a:srgbClr val="9B9B9B"/>
+                      </a:solidFill>
+                    </a:lnL>
+                    <a:lnR w="9525" cap="flat">
+                      <a:solidFill>
+                        <a:srgbClr val="9B9B9B"/>
+                      </a:solidFill>
+                    </a:lnR>
+                    <a:lnT w="9525" cap="flat">
+                      <a:solidFill>
+                        <a:srgbClr val="9B9B9B"/>
+                      </a:solidFill>
+                    </a:lnT>
+                    <a:lnB w="9525" cap="flat">
+                      <a:solidFill>
+                        <a:srgbClr val="9B9B9B"/>
+                      </a:solidFill>
+                    </a:lnB>
+                    <a:solidFill>
+                      <a:srgbClr val="FFFFFF"/>
+                    </a:solidFill>
+                  </a:tcPr>
+                </a:tc>
+                <a:tc>
+                  <a:txBody>
+                    <a:bodyPr/>
+                    <a:lstStyle/>
+                    <a:p>
+                      <a:pPr algn="l"/>
+                      <a:r>
+                        <a:rPr lang="ja-JP" altLang="en-US" sz="1400" b="0" dirty="0">
+                          <a:solidFill>
+                            <a:srgbClr val="000000"/>
+                          </a:solidFill>
+                          <a:latin typeface="Meiryo"/>
+                          <a:ea typeface="Meiryo"/>
+                        </a:rPr>
+                        <a:t>未測定(実機検証時に測定)</a:t>
+                      </a:r>
+                    </a:p>
+                  </a:txBody>
+                  <a:tcPr marL="72000" marR="72000" marT="36000" marB="36000" anchor="ctr">
+                    <a:lnL w="9525" cap="flat">
+                      <a:solidFill>
+                        <a:srgbClr val="9B9B9B"/>
+                      </a:solidFill>
+                    </a:lnL>
+                    <a:lnR w="9525" cap="flat">
+                      <a:solidFill>
+                        <a:srgbClr val="9B9B9B"/>
+                      </a:solidFill>
+                    </a:lnR>
+                    <a:lnT w="9525" cap="flat">
+                      <a:solidFill>
+                        <a:srgbClr val="9B9B9B"/>
+                      </a:solidFill>
+                    </a:lnT>
+                    <a:lnB w="9525" cap="flat">
+                      <a:solidFill>
+                        <a:srgbClr val="9B9B9B"/>
+                      </a:solidFill>
+                    </a:lnB>
+                    <a:solidFill>
+                      <a:srgbClr val="FFFFFF"/>
+                    </a:solidFill>
+                  </a:tcPr>
+                </a:tc>
+                <a:extLst>
+                  <a:ext uri="{0D108BD9-81ED-4DB2-BD59-A6C34878D82A}">
+                    <a16:rowId xmlns:a16="http://schemas.microsoft.com/office/drawing/2014/main" val="10004"/>
+                  </a:ext>
+                </a:extLst>
+              </a:tr>
+              <a:tr h="313714">
+                <a:tc>
+                  <a:txBody>
+                    <a:bodyPr/>
+                    <a:lstStyle/>
+                    <a:p>
+                      <a:pPr algn="l"/>
+                      <a:r>
+                        <a:rPr lang="ja-JP" altLang="en-US" sz="1400" b="0" dirty="0">
+                          <a:solidFill>
+                            <a:srgbClr val="000000"/>
+                          </a:solidFill>
+                          <a:latin typeface="Meiryo"/>
+                          <a:ea typeface="Meiryo"/>
+                        </a:rPr>
                         <a:t>本番</a:t>
                       </a:r>
                     </a:p>
@@ -9048,7 +9791,7 @@
                 </a:tc>
                 <a:extLst>
                   <a:ext uri="{0D108BD9-81ED-4DB2-BD59-A6C34878D82A}">
-                    <a16:rowId xmlns:a16="http://schemas.microsoft.com/office/drawing/2014/main" val="10004"/>
+                    <a16:rowId xmlns:a16="http://schemas.microsoft.com/office/drawing/2014/main" val="10005"/>
                   </a:ext>
                 </a:extLst>
               </a:tr>
@@ -9100,7 +9843,7 @@
                 <a:latin typeface="Meiryo"/>
                 <a:ea typeface="Meiryo"/>
               </a:rPr>
-              <a:t>→ 次の展開：10月末の本番前に実機検証を完了させる</a:t>
+              <a:t>→ 次の展開：10月末の本番前に実機検証(4段階)を完了させる</a:t>
             </a:r>
           </a:p>
         </p:txBody>
@@ -9269,7 +10012,7 @@
                 <a:latin typeface="Meiryo"/>
                 <a:ea typeface="Meiryo"/>
               </a:rPr>
-              <a:t>今後の進め方</a:t>
+              <a:t>成果と翌月のアクション</a:t>
             </a:r>
             <a:endParaRPr lang="ja-JP" altLang="en-US" sz="3600" dirty="0">
               <a:solidFill>
@@ -9339,7 +10082,7 @@
         </p:nvGraphicFramePr>
         <p:xfrm>
           <a:off x="272980" y="2128477"/>
-          <a:ext cx="11646040" cy="2860000"/>
+          <a:ext cx="11646040" cy="3600000"/>
         </p:xfrm>
         <a:graphic>
           <a:graphicData uri="http://schemas.openxmlformats.org/drawingml/2006/table">
@@ -9368,7 +10111,7 @@
                   </a:extLst>
                 </a:gridCol>
               </a:tblGrid>
-              <a:tr h="460000">
+              <a:tr h="400000">
                 <a:tc>
                   <a:txBody>
                     <a:bodyPr/>
@@ -9383,7 +10126,7 @@
                           <a:latin typeface="Meiryo"/>
                           <a:ea typeface="Meiryo"/>
                         </a:rPr>
-                        <a:t>やること</a:t>
+                        <a:t>区分</a:t>
                       </a:r>
                     </a:p>
                   </a:txBody>
@@ -9522,7 +10265,7 @@
                           <a:latin typeface="Meiryo"/>
                           <a:ea typeface="Meiryo"/>
                         </a:rPr>
-                        <a:t>相関図と画像の追加</a:t>
+                        <a:t>成果✓</a:t>
                       </a:r>
                     </a:p>
                   </a:txBody>
@@ -9566,7 +10309,7 @@
                           <a:latin typeface="Meiryo"/>
                           <a:ea typeface="Meiryo"/>
                         </a:rPr>
-                        <a:t>PanaCIM・LNB管理手順書へ追加し、会議で報告</a:t>
+                        <a:t>0確認マクロver.2を運用確定(質問票35問を運用手順書へ反映)</a:t>
                       </a:r>
                       <a:endParaRPr lang="en-US" altLang="ja-JP" sz="1600" b="0" dirty="0">
                         <a:solidFill>
@@ -9617,7 +10360,7 @@
                           <a:latin typeface="Meiryo"/>
                           <a:ea typeface="Meiryo"/>
                         </a:rPr>
-                        <a:t>10/28</a:t>
+                        <a:t>完了</a:t>
                       </a:r>
                     </a:p>
                   </a:txBody>
@@ -9668,7 +10411,7 @@
                           <a:latin typeface="Meiryo"/>
                           <a:ea typeface="Meiryo"/>
                         </a:rPr>
-                        <a:t>一括バックアップ可否の調査</a:t>
+                        <a:t>成果✓</a:t>
                       </a:r>
                     </a:p>
                   </a:txBody>
@@ -9712,7 +10455,7 @@
                           <a:latin typeface="Meiryo"/>
                           <a:ea typeface="Meiryo"/>
                         </a:rPr>
-                        <a:t>Pana-CIM DBの一括バックアップの可否を調査して報告</a:t>
+                        <a:t>管理手順書案2冊を作成(107頁/99頁・未承認)</a:t>
                       </a:r>
                     </a:p>
                   </a:txBody>
@@ -9756,7 +10499,7 @@
                           <a:latin typeface="Meiryo"/>
                           <a:ea typeface="Meiryo"/>
                         </a:rPr>
-                        <a:t>10/28</a:t>
+                        <a:t>完了</a:t>
                       </a:r>
                     </a:p>
                   </a:txBody>
@@ -9807,7 +10550,7 @@
                           <a:latin typeface="Meiryo"/>
                           <a:ea typeface="Meiryo"/>
                         </a:rPr>
-                        <a:t>実機確認の日程と停止判断者の確定</a:t>
+                        <a:t>成果✓</a:t>
                       </a:r>
                     </a:p>
                   </a:txBody>
@@ -9851,7 +10594,7 @@
                           <a:latin typeface="Meiryo"/>
                           <a:ea typeface="Meiryo"/>
                         </a:rPr>
-                        <a:t>10/14会議で未決。次回会議で協議</a:t>
+                        <a:t>棚卸しマクロver.2の改修完了(テストケース47件)</a:t>
                       </a:r>
                     </a:p>
                   </a:txBody>
@@ -9895,7 +10638,7 @@
                           <a:latin typeface="Meiryo"/>
                           <a:ea typeface="Meiryo"/>
                         </a:rPr>
-                        <a:t>10/28</a:t>
+                        <a:t>完了(未検証)</a:t>
                       </a:r>
                     </a:p>
                   </a:txBody>
@@ -9946,7 +10689,7 @@
                           <a:latin typeface="Meiryo"/>
                           <a:ea typeface="Meiryo"/>
                         </a:rPr>
-                        <a:t>棚卸しマクロver.2の実機検証</a:t>
+                        <a:t>01</a:t>
                       </a:r>
                     </a:p>
                   </a:txBody>
@@ -9990,7 +10733,7 @@
                           <a:latin typeface="Meiryo"/>
                           <a:ea typeface="Meiryo"/>
                         </a:rPr>
-                        <a:t>テストケース47件で段階的に検証(本番1件→10件)</a:t>
+                        <a:t>実機確認の日程と停止判断者を会議で確定</a:t>
                       </a:r>
                     </a:p>
                   </a:txBody>
@@ -10034,7 +10777,7 @@
                           <a:latin typeface="Meiryo"/>
                           <a:ea typeface="Meiryo"/>
                         </a:rPr>
-                        <a:t>10月末(本番前)</a:t>
+                        <a:t>10/28(最優先)</a:t>
                       </a:r>
                     </a:p>
                   </a:txBody>
@@ -10085,7 +10828,7 @@
                           <a:latin typeface="Meiryo"/>
                           <a:ea typeface="Meiryo"/>
                         </a:rPr>
-                        <a:t>固定テーブル棚卸しの本番</a:t>
+                        <a:t>02</a:t>
                       </a:r>
                     </a:p>
                   </a:txBody>
@@ -10129,7 +10872,7 @@
                           <a:latin typeface="Meiryo"/>
                           <a:ea typeface="Meiryo"/>
                         </a:rPr>
-                        <a:t>生産終了ラインから順に実施</a:t>
+                        <a:t>管理手順書の承認・相関図と画像の追加・一括バックアップの報告</a:t>
                       </a:r>
                     </a:p>
                   </a:txBody>
@@ -10173,7 +10916,7 @@
                           <a:latin typeface="Meiryo"/>
                           <a:ea typeface="Meiryo"/>
                         </a:rPr>
-                        <a:t>10月末(予定)</a:t>
+                        <a:t>10/28</a:t>
                       </a:r>
                     </a:p>
                   </a:txBody>
@@ -10224,7 +10967,7 @@
                           <a:latin typeface="Meiryo"/>
                           <a:ea typeface="Meiryo"/>
                         </a:rPr>
-                        <a:t>LNB点検項目の聞き取りと登録</a:t>
+                        <a:t>03</a:t>
                       </a:r>
                     </a:p>
                   </a:txBody>
@@ -10268,7 +11011,285 @@
                           <a:latin typeface="Meiryo"/>
                           <a:ea typeface="Meiryo"/>
                         </a:rPr>
-                        <a:t>現行実施者への聞き取りから着手</a:t>
+                        <a:t>棚卸しマクロver.2の実機検証(4段階)→固定テーブル棚卸しの本番</a:t>
+                      </a:r>
+                    </a:p>
+                  </a:txBody>
+                  <a:tcPr marL="72000" marR="72000" marT="36000" marB="36000" anchor="ctr">
+                    <a:lnL w="9525" cap="flat">
+                      <a:solidFill>
+                        <a:srgbClr val="9B9B9B"/>
+                      </a:solidFill>
+                    </a:lnL>
+                    <a:lnR w="9525" cap="flat">
+                      <a:solidFill>
+                        <a:srgbClr val="9B9B9B"/>
+                      </a:solidFill>
+                    </a:lnR>
+                    <a:lnT w="9525" cap="flat">
+                      <a:solidFill>
+                        <a:srgbClr val="9B9B9B"/>
+                      </a:solidFill>
+                    </a:lnT>
+                    <a:lnB w="9525" cap="flat">
+                      <a:solidFill>
+                        <a:srgbClr val="9B9B9B"/>
+                      </a:solidFill>
+                    </a:lnB>
+                    <a:solidFill>
+                      <a:srgbClr val="FFFFFF"/>
+                    </a:solidFill>
+                  </a:tcPr>
+                </a:tc>
+                <a:tc>
+                  <a:txBody>
+                    <a:bodyPr/>
+                    <a:lstStyle/>
+                    <a:p>
+                      <a:pPr algn="l"/>
+                      <a:r>
+                        <a:rPr lang="ja-JP" altLang="en-US" sz="1600" b="0" dirty="0">
+                          <a:solidFill>
+                            <a:srgbClr val="000000"/>
+                          </a:solidFill>
+                          <a:latin typeface="Meiryo"/>
+                          <a:ea typeface="Meiryo"/>
+                        </a:rPr>
+                        <a:t>10月末</a:t>
+                      </a:r>
+                    </a:p>
+                  </a:txBody>
+                  <a:tcPr marL="72000" marR="72000" marT="36000" marB="36000" anchor="ctr">
+                    <a:lnL w="9525" cap="flat">
+                      <a:solidFill>
+                        <a:srgbClr val="9B9B9B"/>
+                      </a:solidFill>
+                    </a:lnL>
+                    <a:lnR w="9525" cap="flat">
+                      <a:solidFill>
+                        <a:srgbClr val="9B9B9B"/>
+                      </a:solidFill>
+                    </a:lnR>
+                    <a:lnT w="9525" cap="flat">
+                      <a:solidFill>
+                        <a:srgbClr val="9B9B9B"/>
+                      </a:solidFill>
+                    </a:lnT>
+                    <a:lnB w="9525" cap="flat">
+                      <a:solidFill>
+                        <a:srgbClr val="9B9B9B"/>
+                      </a:solidFill>
+                    </a:lnB>
+                    <a:solidFill>
+                      <a:srgbClr val="FFFFFF"/>
+                    </a:solidFill>
+                  </a:tcPr>
+                </a:tc>
+                <a:extLst>
+                  <a:ext uri="{0D108BD9-81ED-4DB2-BD59-A6C34878D82A}">
+                    <a16:rowId xmlns:a16="http://schemas.microsoft.com/office/drawing/2014/main" val="10004"/>
+                  </a:ext>
+                </a:extLst>
+              </a:tr>
+              <a:tr h="400000">
+                <a:tc>
+                  <a:txBody>
+                    <a:bodyPr/>
+                    <a:lstStyle/>
+                    <a:p>
+                      <a:pPr algn="l"/>
+                      <a:r>
+                        <a:rPr lang="ja-JP" altLang="en-US" sz="1600" b="0" dirty="0">
+                          <a:solidFill>
+                            <a:srgbClr val="000000"/>
+                          </a:solidFill>
+                          <a:latin typeface="Meiryo"/>
+                          <a:ea typeface="Meiryo"/>
+                        </a:rPr>
+                        <a:t>04</a:t>
+                      </a:r>
+                    </a:p>
+                  </a:txBody>
+                  <a:tcPr marL="72000" marR="72000" marT="36000" marB="36000" anchor="ctr">
+                    <a:lnL w="9525" cap="flat">
+                      <a:solidFill>
+                        <a:srgbClr val="9B9B9B"/>
+                      </a:solidFill>
+                    </a:lnL>
+                    <a:lnR w="9525" cap="flat">
+                      <a:solidFill>
+                        <a:srgbClr val="9B9B9B"/>
+                      </a:solidFill>
+                    </a:lnR>
+                    <a:lnT w="9525" cap="flat">
+                      <a:solidFill>
+                        <a:srgbClr val="9B9B9B"/>
+                      </a:solidFill>
+                    </a:lnT>
+                    <a:lnB w="9525" cap="flat">
+                      <a:solidFill>
+                        <a:srgbClr val="9B9B9B"/>
+                      </a:solidFill>
+                    </a:lnB>
+                    <a:solidFill>
+                      <a:srgbClr val="FFFFFF"/>
+                    </a:solidFill>
+                  </a:tcPr>
+                </a:tc>
+                <a:tc>
+                  <a:txBody>
+                    <a:bodyPr/>
+                    <a:lstStyle/>
+                    <a:p>
+                      <a:pPr algn="l"/>
+                      <a:r>
+                        <a:rPr lang="ja-JP" altLang="en-US" sz="1600" b="0" dirty="0">
+                          <a:solidFill>
+                            <a:srgbClr val="000000"/>
+                          </a:solidFill>
+                          <a:latin typeface="Meiryo"/>
+                          <a:ea typeface="Meiryo"/>
+                        </a:rPr>
+                        <a:t>0確認マクロの本番実行と確認工数の測定</a:t>
+                      </a:r>
+                    </a:p>
+                  </a:txBody>
+                  <a:tcPr marL="72000" marR="72000" marT="36000" marB="36000" anchor="ctr">
+                    <a:lnL w="9525" cap="flat">
+                      <a:solidFill>
+                        <a:srgbClr val="9B9B9B"/>
+                      </a:solidFill>
+                    </a:lnL>
+                    <a:lnR w="9525" cap="flat">
+                      <a:solidFill>
+                        <a:srgbClr val="9B9B9B"/>
+                      </a:solidFill>
+                    </a:lnR>
+                    <a:lnT w="9525" cap="flat">
+                      <a:solidFill>
+                        <a:srgbClr val="9B9B9B"/>
+                      </a:solidFill>
+                    </a:lnT>
+                    <a:lnB w="9525" cap="flat">
+                      <a:solidFill>
+                        <a:srgbClr val="9B9B9B"/>
+                      </a:solidFill>
+                    </a:lnB>
+                    <a:solidFill>
+                      <a:srgbClr val="FFFFFF"/>
+                    </a:solidFill>
+                  </a:tcPr>
+                </a:tc>
+                <a:tc>
+                  <a:txBody>
+                    <a:bodyPr/>
+                    <a:lstStyle/>
+                    <a:p>
+                      <a:pPr algn="l"/>
+                      <a:r>
+                        <a:rPr lang="ja-JP" altLang="en-US" sz="1600" b="0" dirty="0">
+                          <a:solidFill>
+                            <a:srgbClr val="000000"/>
+                          </a:solidFill>
+                          <a:latin typeface="Meiryo"/>
+                          <a:ea typeface="Meiryo"/>
+                        </a:rPr>
+                        <a:t>10月末</a:t>
+                      </a:r>
+                    </a:p>
+                  </a:txBody>
+                  <a:tcPr marL="72000" marR="72000" marT="36000" marB="36000" anchor="ctr">
+                    <a:lnL w="9525" cap="flat">
+                      <a:solidFill>
+                        <a:srgbClr val="9B9B9B"/>
+                      </a:solidFill>
+                    </a:lnL>
+                    <a:lnR w="9525" cap="flat">
+                      <a:solidFill>
+                        <a:srgbClr val="9B9B9B"/>
+                      </a:solidFill>
+                    </a:lnR>
+                    <a:lnT w="9525" cap="flat">
+                      <a:solidFill>
+                        <a:srgbClr val="9B9B9B"/>
+                      </a:solidFill>
+                    </a:lnT>
+                    <a:lnB w="9525" cap="flat">
+                      <a:solidFill>
+                        <a:srgbClr val="9B9B9B"/>
+                      </a:solidFill>
+                    </a:lnB>
+                    <a:solidFill>
+                      <a:srgbClr val="FFFFFF"/>
+                    </a:solidFill>
+                  </a:tcPr>
+                </a:tc>
+                <a:extLst>
+                  <a:ext uri="{0D108BD9-81ED-4DB2-BD59-A6C34878D82A}">
+                    <a16:rowId xmlns:a16="http://schemas.microsoft.com/office/drawing/2014/main" val="10004"/>
+                  </a:ext>
+                </a:extLst>
+              </a:tr>
+              <a:tr h="400000">
+                <a:tc>
+                  <a:txBody>
+                    <a:bodyPr/>
+                    <a:lstStyle/>
+                    <a:p>
+                      <a:pPr algn="l"/>
+                      <a:r>
+                        <a:rPr lang="ja-JP" altLang="en-US" sz="1600" b="0" dirty="0">
+                          <a:solidFill>
+                            <a:srgbClr val="000000"/>
+                          </a:solidFill>
+                          <a:latin typeface="Meiryo"/>
+                          <a:ea typeface="Meiryo"/>
+                        </a:rPr>
+                        <a:t>05</a:t>
+                      </a:r>
+                    </a:p>
+                  </a:txBody>
+                  <a:tcPr marL="72000" marR="72000" marT="36000" marB="36000" anchor="ctr">
+                    <a:lnL w="9525" cap="flat">
+                      <a:solidFill>
+                        <a:srgbClr val="9B9B9B"/>
+                      </a:solidFill>
+                    </a:lnL>
+                    <a:lnR w="9525" cap="flat">
+                      <a:solidFill>
+                        <a:srgbClr val="9B9B9B"/>
+                      </a:solidFill>
+                    </a:lnR>
+                    <a:lnT w="9525" cap="flat">
+                      <a:solidFill>
+                        <a:srgbClr val="9B9B9B"/>
+                      </a:solidFill>
+                    </a:lnT>
+                    <a:lnB w="9525" cap="flat">
+                      <a:solidFill>
+                        <a:srgbClr val="9B9B9B"/>
+                      </a:solidFill>
+                    </a:lnB>
+                    <a:solidFill>
+                      <a:srgbClr val="FFFFFF"/>
+                    </a:solidFill>
+                  </a:tcPr>
+                </a:tc>
+                <a:tc>
+                  <a:txBody>
+                    <a:bodyPr/>
+                    <a:lstStyle/>
+                    <a:p>
+                      <a:pPr algn="l"/>
+                      <a:r>
+                        <a:rPr lang="ja-JP" altLang="en-US" sz="1600" b="0" dirty="0">
+                          <a:solidFill>
+                            <a:srgbClr val="000000"/>
+                          </a:solidFill>
+                          <a:latin typeface="Meiryo"/>
+                          <a:ea typeface="Meiryo"/>
+                        </a:rPr>
+                        <a:t>LNB点検項目の聞き取りと登録</a:t>
                       </a:r>
                     </a:p>
                   </a:txBody>

</xml_diff>

<commit_message>
sync(workvault): 2026-10-21 17:27 差分 2 件
</commit_message>
<xml_diff>
--- a/workvault-sync/10_業務全般/業務報告/10月業務報告(篠原).pptx
+++ b/workvault-sync/10_業務全般/業務報告/10月業務報告(篠原).pptx
@@ -117,1298 +117,30 @@
 </p:presentation>
 </file>
 
-<file path=ppt/revisionInfo.xml><?xml version="1.0" encoding="utf-8"?>
-<p1510:revInfo xmlns:a="http://schemas.openxmlformats.org/drawingml/2006/main" xmlns:r="http://schemas.openxmlformats.org/officeDocument/2006/relationships" xmlns:p1510="http://schemas.microsoft.com/office/powerpoint/2015/10/main">
-  <p1510:revLst>
-    <p1510:client id="{A13B977E-83BD-4364-9C7A-8EA8A549CE76}" v="67" dt="2026-09-18T06:10:57.359"/>
-  </p1510:revLst>
-</p1510:revInfo>
-</file>
-
 <file path=ppt/changesInfos/changesInfo1.xml><?xml version="1.0" encoding="utf-8"?>
 <pc:chgInfo xmlns:a="http://schemas.openxmlformats.org/drawingml/2006/main" xmlns:r="http://schemas.openxmlformats.org/officeDocument/2006/relationships" xmlns:ac="http://schemas.microsoft.com/office/drawing/2013/main/command" xmlns:pc="http://schemas.microsoft.com/office/powerpoint/2013/main/command">
   <pc:docChgLst>
     <pc:chgData name="SHINOHARA Soshi (篠原 想詩)" userId="309c0b21-8b61-4cd5-9d32-07652c56306e" providerId="ADAL" clId="{60D42A6B-AE32-4A06-B461-AA9486421C3B}"/>
     <pc:docChg chg="undo custSel addSld delSld modSld sldOrd delMainMaster">
-      <pc:chgData name="SHINOHARA Soshi (篠原 想詩)" userId="309c0b21-8b61-4cd5-9d32-07652c56306e" providerId="ADAL" clId="{60D42A6B-AE32-4A06-B461-AA9486421C3B}" dt="2026-09-18T07:27:41.343" v="2583" actId="20577"/>
+      <pc:chgData name="SHINOHARA Soshi (篠原 想詩)" userId="309c0b21-8b61-4cd5-9d32-07652c56306e" providerId="ADAL" clId="{60D42A6B-AE32-4A06-B461-AA9486421C3B}" dt="2026-10-21T08:22:14.415" v="2588" actId="20577"/>
       <pc:docMkLst>
         <pc:docMk/>
       </pc:docMkLst>
-      <pc:sldChg chg="del">
-        <pc:chgData name="SHINOHARA Soshi (篠原 想詩)" userId="309c0b21-8b61-4cd5-9d32-07652c56306e" providerId="ADAL" clId="{60D42A6B-AE32-4A06-B461-AA9486421C3B}" dt="2026-09-18T06:09:00.715" v="2395" actId="47"/>
-        <pc:sldMkLst>
-          <pc:docMk/>
-          <pc:sldMk cId="2775494873" sldId="256"/>
-        </pc:sldMkLst>
-      </pc:sldChg>
-      <pc:sldChg chg="addSp delSp modSp new del mod">
-        <pc:chgData name="SHINOHARA Soshi (篠原 想詩)" userId="309c0b21-8b61-4cd5-9d32-07652c56306e" providerId="ADAL" clId="{60D42A6B-AE32-4A06-B461-AA9486421C3B}" dt="2026-09-18T06:09:01.320" v="2396" actId="47"/>
-        <pc:sldMkLst>
-          <pc:docMk/>
-          <pc:sldMk cId="2238980019" sldId="257"/>
-        </pc:sldMkLst>
-        <pc:spChg chg="del">
-          <ac:chgData name="SHINOHARA Soshi (篠原 想詩)" userId="309c0b21-8b61-4cd5-9d32-07652c56306e" providerId="ADAL" clId="{60D42A6B-AE32-4A06-B461-AA9486421C3B}" dt="2026-09-18T05:11:48.559" v="2" actId="478"/>
-          <ac:spMkLst>
-            <pc:docMk/>
-            <pc:sldMk cId="2238980019" sldId="257"/>
-            <ac:spMk id="2" creationId="{394D9B7B-7D5B-7DBA-ABDB-D47E65809127}"/>
-          </ac:spMkLst>
-        </pc:spChg>
-        <pc:spChg chg="del">
-          <ac:chgData name="SHINOHARA Soshi (篠原 想詩)" userId="309c0b21-8b61-4cd5-9d32-07652c56306e" providerId="ADAL" clId="{60D42A6B-AE32-4A06-B461-AA9486421C3B}" dt="2026-09-18T05:11:47.940" v="1" actId="478"/>
-          <ac:spMkLst>
-            <pc:docMk/>
-            <pc:sldMk cId="2238980019" sldId="257"/>
-            <ac:spMk id="3" creationId="{26DF8E07-B2DA-7105-C165-EE27C7BA2409}"/>
-          </ac:spMkLst>
-        </pc:spChg>
-        <pc:graphicFrameChg chg="add del mod">
-          <ac:chgData name="SHINOHARA Soshi (篠原 想詩)" userId="309c0b21-8b61-4cd5-9d32-07652c56306e" providerId="ADAL" clId="{60D42A6B-AE32-4A06-B461-AA9486421C3B}" dt="2026-09-18T05:12:05.751" v="5" actId="478"/>
-          <ac:graphicFrameMkLst>
-            <pc:docMk/>
-            <pc:sldMk cId="2238980019" sldId="257"/>
-            <ac:graphicFrameMk id="4" creationId="{492B0FED-8F60-8C69-B5F2-5450775EA0FF}"/>
-          </ac:graphicFrameMkLst>
-        </pc:graphicFrameChg>
-      </pc:sldChg>
       <pc:sldChg chg="addSp delSp modSp add del mod">
-        <pc:chgData name="SHINOHARA Soshi (篠原 想詩)" userId="309c0b21-8b61-4cd5-9d32-07652c56306e" providerId="ADAL" clId="{60D42A6B-AE32-4A06-B461-AA9486421C3B}" dt="2026-09-18T05:52:20.736" v="1612" actId="20577"/>
+        <pc:chgData name="SHINOHARA Soshi (篠原 想詩)" userId="309c0b21-8b61-4cd5-9d32-07652c56306e" providerId="ADAL" clId="{60D42A6B-AE32-4A06-B461-AA9486421C3B}" dt="2026-10-21T08:22:14.415" v="2588" actId="20577"/>
         <pc:sldMkLst>
           <pc:docMk/>
           <pc:sldMk cId="0" sldId="258"/>
         </pc:sldMkLst>
-        <pc:spChg chg="add del mod">
-          <ac:chgData name="SHINOHARA Soshi (篠原 想詩)" userId="309c0b21-8b61-4cd5-9d32-07652c56306e" providerId="ADAL" clId="{60D42A6B-AE32-4A06-B461-AA9486421C3B}" dt="2026-09-18T05:15:21.052" v="58" actId="21"/>
-          <ac:spMkLst>
-            <pc:docMk/>
-            <pc:sldMk cId="0" sldId="258"/>
-            <ac:spMk id="2" creationId="{94DD132E-067B-7378-CD64-23C9EC5B506B}"/>
-          </ac:spMkLst>
-        </pc:spChg>
         <pc:spChg chg="add mod">
-          <ac:chgData name="SHINOHARA Soshi (篠原 想詩)" userId="309c0b21-8b61-4cd5-9d32-07652c56306e" providerId="ADAL" clId="{60D42A6B-AE32-4A06-B461-AA9486421C3B}" dt="2026-09-18T05:52:20.736" v="1612" actId="20577"/>
-          <ac:spMkLst>
-            <pc:docMk/>
-            <pc:sldMk cId="0" sldId="258"/>
-            <ac:spMk id="3" creationId="{D8611FDF-9B1D-9612-327D-9456F6143916}"/>
-          </ac:spMkLst>
-        </pc:spChg>
-        <pc:spChg chg="add del mod">
-          <ac:chgData name="SHINOHARA Soshi (篠原 想詩)" userId="309c0b21-8b61-4cd5-9d32-07652c56306e" providerId="ADAL" clId="{60D42A6B-AE32-4A06-B461-AA9486421C3B}" dt="2026-09-18T05:15:29.082" v="64" actId="478"/>
-          <ac:spMkLst>
-            <pc:docMk/>
-            <pc:sldMk cId="0" sldId="258"/>
-            <ac:spMk id="4" creationId="{EB812D85-C2CF-8FAD-F086-3119E0647715}"/>
-          </ac:spMkLst>
-        </pc:spChg>
-        <pc:spChg chg="add del mod">
-          <ac:chgData name="SHINOHARA Soshi (篠原 想詩)" userId="309c0b21-8b61-4cd5-9d32-07652c56306e" providerId="ADAL" clId="{60D42A6B-AE32-4A06-B461-AA9486421C3B}" dt="2026-09-18T05:15:27.457" v="63" actId="21"/>
-          <ac:spMkLst>
-            <pc:docMk/>
-            <pc:sldMk cId="0" sldId="258"/>
-            <ac:spMk id="6" creationId="{31E1ED1F-4204-68E6-245A-F1A17FB2943C}"/>
-          </ac:spMkLst>
-        </pc:spChg>
-        <pc:spChg chg="add mod">
-          <ac:chgData name="SHINOHARA Soshi (篠原 想詩)" userId="309c0b21-8b61-4cd5-9d32-07652c56306e" providerId="ADAL" clId="{60D42A6B-AE32-4A06-B461-AA9486421C3B}" dt="2026-09-18T05:21:48.287" v="207" actId="1076"/>
+          <ac:chgData name="SHINOHARA Soshi (篠原 想詩)" userId="309c0b21-8b61-4cd5-9d32-07652c56306e" providerId="ADAL" clId="{60D42A6B-AE32-4A06-B461-AA9486421C3B}" dt="2026-10-21T08:22:14.415" v="2588" actId="20577"/>
           <ac:spMkLst>
             <pc:docMk/>
             <pc:sldMk cId="0" sldId="258"/>
             <ac:spMk id="8" creationId="{D2FA8936-D68E-6874-8EB3-C9A079275CE7}"/>
           </ac:spMkLst>
         </pc:spChg>
-        <pc:spChg chg="del mod">
-          <ac:chgData name="SHINOHARA Soshi (篠原 想詩)" userId="309c0b21-8b61-4cd5-9d32-07652c56306e" providerId="ADAL" clId="{60D42A6B-AE32-4A06-B461-AA9486421C3B}" dt="2026-09-18T05:15:22.292" v="59" actId="478"/>
-          <ac:spMkLst>
-            <pc:docMk/>
-            <pc:sldMk cId="0" sldId="258"/>
-            <ac:spMk id="5125" creationId="{ED21CF95-DAEB-0ED1-2F64-90E9C5261A33}"/>
-          </ac:spMkLst>
-        </pc:spChg>
-        <pc:spChg chg="del">
-          <ac:chgData name="SHINOHARA Soshi (篠原 想詩)" userId="309c0b21-8b61-4cd5-9d32-07652c56306e" providerId="ADAL" clId="{60D42A6B-AE32-4A06-B461-AA9486421C3B}" dt="2026-09-18T05:15:34.042" v="66" actId="478"/>
-          <ac:spMkLst>
-            <pc:docMk/>
-            <pc:sldMk cId="0" sldId="258"/>
-            <ac:spMk id="5126" creationId="{7F2BCA0B-F299-74C5-96D3-C3D6EF19918A}"/>
-          </ac:spMkLst>
-        </pc:spChg>
       </pc:sldChg>
-      <pc:sldChg chg="addSp delSp modSp add del mod">
-        <pc:chgData name="SHINOHARA Soshi (篠原 想詩)" userId="309c0b21-8b61-4cd5-9d32-07652c56306e" providerId="ADAL" clId="{60D42A6B-AE32-4A06-B461-AA9486421C3B}" dt="2026-09-18T06:10:48.715" v="2475" actId="47"/>
-        <pc:sldMkLst>
-          <pc:docMk/>
-          <pc:sldMk cId="0" sldId="259"/>
-        </pc:sldMkLst>
-        <pc:spChg chg="add del">
-          <ac:chgData name="SHINOHARA Soshi (篠原 想詩)" userId="309c0b21-8b61-4cd5-9d32-07652c56306e" providerId="ADAL" clId="{60D42A6B-AE32-4A06-B461-AA9486421C3B}" dt="2026-09-18T05:24:57.783" v="258" actId="21"/>
-          <ac:spMkLst>
-            <pc:docMk/>
-            <pc:sldMk cId="0" sldId="259"/>
-            <ac:spMk id="5" creationId="{16BEEDCE-E230-E6CC-9D69-9CE4C12B6E65}"/>
-          </ac:spMkLst>
-        </pc:spChg>
-        <pc:spChg chg="add del">
-          <ac:chgData name="SHINOHARA Soshi (篠原 想詩)" userId="309c0b21-8b61-4cd5-9d32-07652c56306e" providerId="ADAL" clId="{60D42A6B-AE32-4A06-B461-AA9486421C3B}" dt="2026-09-18T05:24:57.783" v="258" actId="21"/>
-          <ac:spMkLst>
-            <pc:docMk/>
-            <pc:sldMk cId="0" sldId="259"/>
-            <ac:spMk id="7" creationId="{794BAA89-82D5-064F-1037-F3EDA1FF681E}"/>
-          </ac:spMkLst>
-        </pc:spChg>
-        <pc:spChg chg="add del">
-          <ac:chgData name="SHINOHARA Soshi (篠原 想詩)" userId="309c0b21-8b61-4cd5-9d32-07652c56306e" providerId="ADAL" clId="{60D42A6B-AE32-4A06-B461-AA9486421C3B}" dt="2026-09-18T05:24:57.783" v="258" actId="21"/>
-          <ac:spMkLst>
-            <pc:docMk/>
-            <pc:sldMk cId="0" sldId="259"/>
-            <ac:spMk id="13" creationId="{DB6929EC-8CFE-8684-4905-C662CE9BE12D}"/>
-          </ac:spMkLst>
-        </pc:spChg>
-        <pc:spChg chg="add del">
-          <ac:chgData name="SHINOHARA Soshi (篠原 想詩)" userId="309c0b21-8b61-4cd5-9d32-07652c56306e" providerId="ADAL" clId="{60D42A6B-AE32-4A06-B461-AA9486421C3B}" dt="2026-09-18T05:24:57.783" v="258" actId="21"/>
-          <ac:spMkLst>
-            <pc:docMk/>
-            <pc:sldMk cId="0" sldId="259"/>
-            <ac:spMk id="15" creationId="{416E2D99-8C5A-832E-B72D-3136EB456A41}"/>
-          </ac:spMkLst>
-        </pc:spChg>
-        <pc:spChg chg="add del">
-          <ac:chgData name="SHINOHARA Soshi (篠原 想詩)" userId="309c0b21-8b61-4cd5-9d32-07652c56306e" providerId="ADAL" clId="{60D42A6B-AE32-4A06-B461-AA9486421C3B}" dt="2026-09-18T05:24:57.783" v="258" actId="21"/>
-          <ac:spMkLst>
-            <pc:docMk/>
-            <pc:sldMk cId="0" sldId="259"/>
-            <ac:spMk id="17" creationId="{2B21E95C-2D0A-5FC1-3149-E4B9CCFAD21E}"/>
-          </ac:spMkLst>
-        </pc:spChg>
-        <pc:spChg chg="add del">
-          <ac:chgData name="SHINOHARA Soshi (篠原 想詩)" userId="309c0b21-8b61-4cd5-9d32-07652c56306e" providerId="ADAL" clId="{60D42A6B-AE32-4A06-B461-AA9486421C3B}" dt="2026-09-18T05:24:57.783" v="258" actId="21"/>
-          <ac:spMkLst>
-            <pc:docMk/>
-            <pc:sldMk cId="0" sldId="259"/>
-            <ac:spMk id="23" creationId="{419E1F2C-F215-144D-EDD1-43FD3B28E70F}"/>
-          </ac:spMkLst>
-        </pc:spChg>
-        <pc:spChg chg="add del">
-          <ac:chgData name="SHINOHARA Soshi (篠原 想詩)" userId="309c0b21-8b61-4cd5-9d32-07652c56306e" providerId="ADAL" clId="{60D42A6B-AE32-4A06-B461-AA9486421C3B}" dt="2026-09-18T05:24:57.783" v="258" actId="21"/>
-          <ac:spMkLst>
-            <pc:docMk/>
-            <pc:sldMk cId="0" sldId="259"/>
-            <ac:spMk id="29" creationId="{6A6720B2-6AE5-C69A-25D4-DA3CC3F19CCD}"/>
-          </ac:spMkLst>
-        </pc:spChg>
-        <pc:spChg chg="add del">
-          <ac:chgData name="SHINOHARA Soshi (篠原 想詩)" userId="309c0b21-8b61-4cd5-9d32-07652c56306e" providerId="ADAL" clId="{60D42A6B-AE32-4A06-B461-AA9486421C3B}" dt="2026-09-18T05:24:57.783" v="258" actId="21"/>
-          <ac:spMkLst>
-            <pc:docMk/>
-            <pc:sldMk cId="0" sldId="259"/>
-            <ac:spMk id="31" creationId="{A0DD7059-571E-3CD1-FCA7-1BE1DCA6BE1C}"/>
-          </ac:spMkLst>
-        </pc:spChg>
-        <pc:spChg chg="del">
-          <ac:chgData name="SHINOHARA Soshi (篠原 想詩)" userId="309c0b21-8b61-4cd5-9d32-07652c56306e" providerId="ADAL" clId="{60D42A6B-AE32-4A06-B461-AA9486421C3B}" dt="2026-09-18T05:24:39.639" v="251" actId="478"/>
-          <ac:spMkLst>
-            <pc:docMk/>
-            <pc:sldMk cId="0" sldId="259"/>
-            <ac:spMk id="20482" creationId="{C2E6D61F-0D42-AF61-3931-B76E4F1180F0}"/>
-          </ac:spMkLst>
-        </pc:spChg>
-        <pc:spChg chg="del">
-          <ac:chgData name="SHINOHARA Soshi (篠原 想詩)" userId="309c0b21-8b61-4cd5-9d32-07652c56306e" providerId="ADAL" clId="{60D42A6B-AE32-4A06-B461-AA9486421C3B}" dt="2026-09-18T05:24:38.450" v="250" actId="478"/>
-          <ac:spMkLst>
-            <pc:docMk/>
-            <pc:sldMk cId="0" sldId="259"/>
-            <ac:spMk id="20483" creationId="{84BA23FB-9E78-A665-BF63-41765197AD3A}"/>
-          </ac:spMkLst>
-        </pc:spChg>
-        <pc:spChg chg="add del">
-          <ac:chgData name="SHINOHARA Soshi (篠原 想詩)" userId="309c0b21-8b61-4cd5-9d32-07652c56306e" providerId="ADAL" clId="{60D42A6B-AE32-4A06-B461-AA9486421C3B}" dt="2026-09-18T05:24:57.783" v="258" actId="21"/>
-          <ac:spMkLst>
-            <pc:docMk/>
-            <pc:sldMk cId="0" sldId="259"/>
-            <ac:spMk id="20485" creationId="{DF9AC646-2B61-3D6E-DFEB-A5150BDEB0C4}"/>
-          </ac:spMkLst>
-        </pc:spChg>
-        <pc:spChg chg="add del">
-          <ac:chgData name="SHINOHARA Soshi (篠原 想詩)" userId="309c0b21-8b61-4cd5-9d32-07652c56306e" providerId="ADAL" clId="{60D42A6B-AE32-4A06-B461-AA9486421C3B}" dt="2026-09-18T05:24:57.783" v="258" actId="21"/>
-          <ac:spMkLst>
-            <pc:docMk/>
-            <pc:sldMk cId="0" sldId="259"/>
-            <ac:spMk id="20487" creationId="{F7FC0BCA-043E-0E54-8C10-046E4FE3C7D0}"/>
-          </ac:spMkLst>
-        </pc:spChg>
-        <pc:spChg chg="add del">
-          <ac:chgData name="SHINOHARA Soshi (篠原 想詩)" userId="309c0b21-8b61-4cd5-9d32-07652c56306e" providerId="ADAL" clId="{60D42A6B-AE32-4A06-B461-AA9486421C3B}" dt="2026-09-18T05:54:47.953" v="1670" actId="21"/>
-          <ac:spMkLst>
-            <pc:docMk/>
-            <pc:sldMk cId="0" sldId="259"/>
-            <ac:spMk id="20495" creationId="{A4D9F973-0BFC-4A86-98E9-A2CEAA78CA76}"/>
-          </ac:spMkLst>
-        </pc:spChg>
-        <pc:spChg chg="add del">
-          <ac:chgData name="SHINOHARA Soshi (篠原 想詩)" userId="309c0b21-8b61-4cd5-9d32-07652c56306e" providerId="ADAL" clId="{60D42A6B-AE32-4A06-B461-AA9486421C3B}" dt="2026-09-18T05:54:47.953" v="1670" actId="21"/>
-          <ac:spMkLst>
-            <pc:docMk/>
-            <pc:sldMk cId="0" sldId="259"/>
-            <ac:spMk id="20497" creationId="{60E1E6C4-9748-E7D8-1558-58C343E33BE3}"/>
-          </ac:spMkLst>
-        </pc:spChg>
-        <pc:spChg chg="add del">
-          <ac:chgData name="SHINOHARA Soshi (篠原 想詩)" userId="309c0b21-8b61-4cd5-9d32-07652c56306e" providerId="ADAL" clId="{60D42A6B-AE32-4A06-B461-AA9486421C3B}" dt="2026-09-18T05:54:47.953" v="1670" actId="21"/>
-          <ac:spMkLst>
-            <pc:docMk/>
-            <pc:sldMk cId="0" sldId="259"/>
-            <ac:spMk id="20499" creationId="{EAA122E3-0D87-FCBF-BA03-998D81E61207}"/>
-          </ac:spMkLst>
-        </pc:spChg>
-        <pc:spChg chg="add del">
-          <ac:chgData name="SHINOHARA Soshi (篠原 想詩)" userId="309c0b21-8b61-4cd5-9d32-07652c56306e" providerId="ADAL" clId="{60D42A6B-AE32-4A06-B461-AA9486421C3B}" dt="2026-09-18T05:54:47.953" v="1670" actId="21"/>
-          <ac:spMkLst>
-            <pc:docMk/>
-            <pc:sldMk cId="0" sldId="259"/>
-            <ac:spMk id="20501" creationId="{CC951E02-3EED-A2A4-78BA-01B7677F5FE0}"/>
-          </ac:spMkLst>
-        </pc:spChg>
-        <pc:spChg chg="add del">
-          <ac:chgData name="SHINOHARA Soshi (篠原 想詩)" userId="309c0b21-8b61-4cd5-9d32-07652c56306e" providerId="ADAL" clId="{60D42A6B-AE32-4A06-B461-AA9486421C3B}" dt="2026-09-18T05:54:47.953" v="1670" actId="21"/>
-          <ac:spMkLst>
-            <pc:docMk/>
-            <pc:sldMk cId="0" sldId="259"/>
-            <ac:spMk id="20503" creationId="{8BD3BB66-8271-E186-77BC-128680E7F29E}"/>
-          </ac:spMkLst>
-        </pc:spChg>
-        <pc:spChg chg="add del">
-          <ac:chgData name="SHINOHARA Soshi (篠原 想詩)" userId="309c0b21-8b61-4cd5-9d32-07652c56306e" providerId="ADAL" clId="{60D42A6B-AE32-4A06-B461-AA9486421C3B}" dt="2026-09-18T05:54:47.953" v="1670" actId="21"/>
-          <ac:spMkLst>
-            <pc:docMk/>
-            <pc:sldMk cId="0" sldId="259"/>
-            <ac:spMk id="20505" creationId="{CD1701D2-1FA7-DA35-1AE9-70AF37EB9638}"/>
-          </ac:spMkLst>
-        </pc:spChg>
-        <pc:spChg chg="add del">
-          <ac:chgData name="SHINOHARA Soshi (篠原 想詩)" userId="309c0b21-8b61-4cd5-9d32-07652c56306e" providerId="ADAL" clId="{60D42A6B-AE32-4A06-B461-AA9486421C3B}" dt="2026-09-18T05:54:47.953" v="1670" actId="21"/>
-          <ac:spMkLst>
-            <pc:docMk/>
-            <pc:sldMk cId="0" sldId="259"/>
-            <ac:spMk id="20509" creationId="{F4B2CC77-088B-2831-4A36-A00BB8BF21FF}"/>
-          </ac:spMkLst>
-        </pc:spChg>
-        <pc:spChg chg="add del mod">
-          <ac:chgData name="SHINOHARA Soshi (篠原 想詩)" userId="309c0b21-8b61-4cd5-9d32-07652c56306e" providerId="ADAL" clId="{60D42A6B-AE32-4A06-B461-AA9486421C3B}" dt="2026-09-18T06:10:46.655" v="2473" actId="21"/>
-          <ac:spMkLst>
-            <pc:docMk/>
-            <pc:sldMk cId="0" sldId="259"/>
-            <ac:spMk id="20511" creationId="{EFF9C31E-7D98-E5C9-EF36-0A4482974082}"/>
-          </ac:spMkLst>
-        </pc:spChg>
-        <pc:spChg chg="add del">
-          <ac:chgData name="SHINOHARA Soshi (篠原 想詩)" userId="309c0b21-8b61-4cd5-9d32-07652c56306e" providerId="ADAL" clId="{60D42A6B-AE32-4A06-B461-AA9486421C3B}" dt="2026-09-18T06:10:46.655" v="2473" actId="21"/>
-          <ac:spMkLst>
-            <pc:docMk/>
-            <pc:sldMk cId="0" sldId="259"/>
-            <ac:spMk id="20513" creationId="{69CA037E-58DF-B94A-390E-DB0582B51D3E}"/>
-          </ac:spMkLst>
-        </pc:spChg>
-        <pc:graphicFrameChg chg="add del">
-          <ac:chgData name="SHINOHARA Soshi (篠原 想詩)" userId="309c0b21-8b61-4cd5-9d32-07652c56306e" providerId="ADAL" clId="{60D42A6B-AE32-4A06-B461-AA9486421C3B}" dt="2026-09-18T05:54:47.953" v="1670" actId="21"/>
-          <ac:graphicFrameMkLst>
-            <pc:docMk/>
-            <pc:sldMk cId="0" sldId="259"/>
-            <ac:graphicFrameMk id="20507" creationId="{8E7682B8-07FA-EC1B-AB2C-C18C0BCA5CD5}"/>
-          </ac:graphicFrameMkLst>
-        </pc:graphicFrameChg>
-        <pc:graphicFrameChg chg="add del mod modGraphic">
-          <ac:chgData name="SHINOHARA Soshi (篠原 想詩)" userId="309c0b21-8b61-4cd5-9d32-07652c56306e" providerId="ADAL" clId="{60D42A6B-AE32-4A06-B461-AA9486421C3B}" dt="2026-09-18T06:10:46.655" v="2473" actId="21"/>
-          <ac:graphicFrameMkLst>
-            <pc:docMk/>
-            <pc:sldMk cId="0" sldId="259"/>
-            <ac:graphicFrameMk id="20515" creationId="{BF03AD17-F94C-3F17-1164-5D87486DAD35}"/>
-          </ac:graphicFrameMkLst>
-        </pc:graphicFrameChg>
-      </pc:sldChg>
-      <pc:sldChg chg="addSp delSp modSp add del mod ord">
-        <pc:chgData name="SHINOHARA Soshi (篠原 想詩)" userId="309c0b21-8b61-4cd5-9d32-07652c56306e" providerId="ADAL" clId="{60D42A6B-AE32-4A06-B461-AA9486421C3B}" dt="2026-09-18T06:11:40.624" v="2511" actId="20577"/>
-        <pc:sldMkLst>
-          <pc:docMk/>
-          <pc:sldMk cId="0" sldId="260"/>
-        </pc:sldMkLst>
-        <pc:spChg chg="add del mod">
-          <ac:chgData name="SHINOHARA Soshi (篠原 想詩)" userId="309c0b21-8b61-4cd5-9d32-07652c56306e" providerId="ADAL" clId="{60D42A6B-AE32-4A06-B461-AA9486421C3B}" dt="2026-09-18T05:20:53.246" v="189" actId="478"/>
-          <ac:spMkLst>
-            <pc:docMk/>
-            <pc:sldMk cId="0" sldId="260"/>
-            <ac:spMk id="3" creationId="{4F55B57D-F8B6-6C1D-4BEA-FDF1012D8018}"/>
-          </ac:spMkLst>
-        </pc:spChg>
-        <pc:spChg chg="add del">
-          <ac:chgData name="SHINOHARA Soshi (篠原 想詩)" userId="309c0b21-8b61-4cd5-9d32-07652c56306e" providerId="ADAL" clId="{60D42A6B-AE32-4A06-B461-AA9486421C3B}" dt="2026-09-18T06:08:16.468" v="2383" actId="478"/>
-          <ac:spMkLst>
-            <pc:docMk/>
-            <pc:sldMk cId="0" sldId="260"/>
-            <ac:spMk id="5" creationId="{431B13A8-3DD4-DFA4-DE7E-C5BF855B41E7}"/>
-          </ac:spMkLst>
-        </pc:spChg>
-        <pc:spChg chg="add del">
-          <ac:chgData name="SHINOHARA Soshi (篠原 想詩)" userId="309c0b21-8b61-4cd5-9d32-07652c56306e" providerId="ADAL" clId="{60D42A6B-AE32-4A06-B461-AA9486421C3B}" dt="2026-09-18T05:37:16.287" v="719" actId="478"/>
-          <ac:spMkLst>
-            <pc:docMk/>
-            <pc:sldMk cId="0" sldId="260"/>
-            <ac:spMk id="7" creationId="{ABD3EDD7-62E8-46C9-CEEB-FFED12304482}"/>
-          </ac:spMkLst>
-        </pc:spChg>
-        <pc:spChg chg="add mod">
-          <ac:chgData name="SHINOHARA Soshi (篠原 想詩)" userId="309c0b21-8b61-4cd5-9d32-07652c56306e" providerId="ADAL" clId="{60D42A6B-AE32-4A06-B461-AA9486421C3B}" dt="2026-09-18T05:53:03.442" v="1652" actId="20577"/>
-          <ac:spMkLst>
-            <pc:docMk/>
-            <pc:sldMk cId="0" sldId="260"/>
-            <ac:spMk id="9" creationId="{286AF094-EB23-DE59-C364-CE66702F5820}"/>
-          </ac:spMkLst>
-        </pc:spChg>
-        <pc:spChg chg="add mod">
-          <ac:chgData name="SHINOHARA Soshi (篠原 想詩)" userId="309c0b21-8b61-4cd5-9d32-07652c56306e" providerId="ADAL" clId="{60D42A6B-AE32-4A06-B461-AA9486421C3B}" dt="2026-09-18T06:11:40.624" v="2511" actId="20577"/>
-          <ac:spMkLst>
-            <pc:docMk/>
-            <pc:sldMk cId="0" sldId="260"/>
-            <ac:spMk id="11" creationId="{9062C9EA-A562-CB3D-30B1-0D2FE45C706F}"/>
-          </ac:spMkLst>
-        </pc:spChg>
-        <pc:spChg chg="add del mod">
-          <ac:chgData name="SHINOHARA Soshi (篠原 想詩)" userId="309c0b21-8b61-4cd5-9d32-07652c56306e" providerId="ADAL" clId="{60D42A6B-AE32-4A06-B461-AA9486421C3B}" dt="2026-09-18T05:26:57.954" v="316" actId="478"/>
-          <ac:spMkLst>
-            <pc:docMk/>
-            <pc:sldMk cId="0" sldId="260"/>
-            <ac:spMk id="13" creationId="{3932B18D-C369-43F3-4CDD-B87A63732FDB}"/>
-          </ac:spMkLst>
-        </pc:spChg>
-        <pc:spChg chg="add del mod">
-          <ac:chgData name="SHINOHARA Soshi (篠原 想詩)" userId="309c0b21-8b61-4cd5-9d32-07652c56306e" providerId="ADAL" clId="{60D42A6B-AE32-4A06-B461-AA9486421C3B}" dt="2026-09-18T05:27:00.072" v="317" actId="478"/>
-          <ac:spMkLst>
-            <pc:docMk/>
-            <pc:sldMk cId="0" sldId="260"/>
-            <ac:spMk id="15" creationId="{89E8F5CB-8474-8F3C-1087-5370B299E16C}"/>
-          </ac:spMkLst>
-        </pc:spChg>
-        <pc:spChg chg="add del mod">
-          <ac:chgData name="SHINOHARA Soshi (篠原 想詩)" userId="309c0b21-8b61-4cd5-9d32-07652c56306e" providerId="ADAL" clId="{60D42A6B-AE32-4A06-B461-AA9486421C3B}" dt="2026-09-18T05:26:57.954" v="316" actId="478"/>
-          <ac:spMkLst>
-            <pc:docMk/>
-            <pc:sldMk cId="0" sldId="260"/>
-            <ac:spMk id="17" creationId="{5F4B4C21-10CC-7BB4-8886-097CC3FBD6A2}"/>
-          </ac:spMkLst>
-        </pc:spChg>
-        <pc:spChg chg="add del mod">
-          <ac:chgData name="SHINOHARA Soshi (篠原 想詩)" userId="309c0b21-8b61-4cd5-9d32-07652c56306e" providerId="ADAL" clId="{60D42A6B-AE32-4A06-B461-AA9486421C3B}" dt="2026-09-18T05:27:00.072" v="317" actId="478"/>
-          <ac:spMkLst>
-            <pc:docMk/>
-            <pc:sldMk cId="0" sldId="260"/>
-            <ac:spMk id="19" creationId="{6566FDEC-E851-4FD8-440B-9AB7B75D8615}"/>
-          </ac:spMkLst>
-        </pc:spChg>
-        <pc:spChg chg="del mod">
-          <ac:chgData name="SHINOHARA Soshi (篠原 想詩)" userId="309c0b21-8b61-4cd5-9d32-07652c56306e" providerId="ADAL" clId="{60D42A6B-AE32-4A06-B461-AA9486421C3B}" dt="2026-09-18T05:26:57.954" v="316" actId="478"/>
-          <ac:spMkLst>
-            <pc:docMk/>
-            <pc:sldMk cId="0" sldId="260"/>
-            <ac:spMk id="21" creationId="{59F512A8-F464-D0D0-9A1A-D5A3570BFD77}"/>
-          </ac:spMkLst>
-        </pc:spChg>
-        <pc:spChg chg="add del mod">
-          <ac:chgData name="SHINOHARA Soshi (篠原 想詩)" userId="309c0b21-8b61-4cd5-9d32-07652c56306e" providerId="ADAL" clId="{60D42A6B-AE32-4A06-B461-AA9486421C3B}" dt="2026-09-18T05:27:00.072" v="317" actId="478"/>
-          <ac:spMkLst>
-            <pc:docMk/>
-            <pc:sldMk cId="0" sldId="260"/>
-            <ac:spMk id="23" creationId="{0790BCF8-C3A8-E5A4-D36A-2A9AED582F98}"/>
-          </ac:spMkLst>
-        </pc:spChg>
-        <pc:spChg chg="add">
-          <ac:chgData name="SHINOHARA Soshi (篠原 想詩)" userId="309c0b21-8b61-4cd5-9d32-07652c56306e" providerId="ADAL" clId="{60D42A6B-AE32-4A06-B461-AA9486421C3B}" dt="2026-09-18T06:08:16.898" v="2384" actId="22"/>
-          <ac:spMkLst>
-            <pc:docMk/>
-            <pc:sldMk cId="0" sldId="260"/>
-            <ac:spMk id="29" creationId="{99BBA5A8-AC1B-3C0B-F774-2765F922C93F}"/>
-          </ac:spMkLst>
-        </pc:spChg>
-        <pc:spChg chg="add del">
-          <ac:chgData name="SHINOHARA Soshi (篠原 想詩)" userId="309c0b21-8b61-4cd5-9d32-07652c56306e" providerId="ADAL" clId="{60D42A6B-AE32-4A06-B461-AA9486421C3B}" dt="2026-09-18T06:08:18.731" v="2385" actId="478"/>
-          <ac:spMkLst>
-            <pc:docMk/>
-            <pc:sldMk cId="0" sldId="260"/>
-            <ac:spMk id="31" creationId="{FA40E3C3-CB5B-5524-9202-BA4ECA6CB4A9}"/>
-          </ac:spMkLst>
-        </pc:spChg>
-        <pc:spChg chg="mod">
-          <ac:chgData name="SHINOHARA Soshi (篠原 想詩)" userId="309c0b21-8b61-4cd5-9d32-07652c56306e" providerId="ADAL" clId="{60D42A6B-AE32-4A06-B461-AA9486421C3B}" dt="2026-09-18T05:53:44.989" v="1660" actId="20577"/>
-          <ac:spMkLst>
-            <pc:docMk/>
-            <pc:sldMk cId="0" sldId="260"/>
-            <ac:spMk id="21506" creationId="{F73DBF07-353A-1DAE-881E-450898FCC584}"/>
-          </ac:spMkLst>
-        </pc:spChg>
-        <pc:spChg chg="del">
-          <ac:chgData name="SHINOHARA Soshi (篠原 想詩)" userId="309c0b21-8b61-4cd5-9d32-07652c56306e" providerId="ADAL" clId="{60D42A6B-AE32-4A06-B461-AA9486421C3B}" dt="2026-09-18T05:18:05.097" v="175" actId="478"/>
-          <ac:spMkLst>
-            <pc:docMk/>
-            <pc:sldMk cId="0" sldId="260"/>
-            <ac:spMk id="21507" creationId="{A317CE7C-B655-40C7-01E2-46D229D3A532}"/>
-          </ac:spMkLst>
-        </pc:spChg>
-        <pc:picChg chg="add del mod">
-          <ac:chgData name="SHINOHARA Soshi (篠原 想詩)" userId="309c0b21-8b61-4cd5-9d32-07652c56306e" providerId="ADAL" clId="{60D42A6B-AE32-4A06-B461-AA9486421C3B}" dt="2026-09-18T05:33:08.130" v="603" actId="478"/>
-          <ac:picMkLst>
-            <pc:docMk/>
-            <pc:sldMk cId="0" sldId="260"/>
-            <ac:picMk id="25" creationId="{FD94B394-67AA-AAF2-7110-7A9DA3C55AB5}"/>
-          </ac:picMkLst>
-        </pc:picChg>
-        <pc:picChg chg="add mod">
-          <ac:chgData name="SHINOHARA Soshi (篠原 想詩)" userId="309c0b21-8b61-4cd5-9d32-07652c56306e" providerId="ADAL" clId="{60D42A6B-AE32-4A06-B461-AA9486421C3B}" dt="2026-09-18T05:54:06.120" v="1663" actId="1076"/>
-          <ac:picMkLst>
-            <pc:docMk/>
-            <pc:sldMk cId="0" sldId="260"/>
-            <ac:picMk id="27" creationId="{9FFAB5E6-B58F-408D-66BD-F06FEFD51917}"/>
-          </ac:picMkLst>
-        </pc:picChg>
-      </pc:sldChg>
-      <pc:sldChg chg="addSp delSp modSp add mod">
-        <pc:chgData name="SHINOHARA Soshi (篠原 想詩)" userId="309c0b21-8b61-4cd5-9d32-07652c56306e" providerId="ADAL" clId="{60D42A6B-AE32-4A06-B461-AA9486421C3B}" dt="2026-09-18T07:24:11.208" v="2544" actId="207"/>
-        <pc:sldMkLst>
-          <pc:docMk/>
-          <pc:sldMk cId="2460916238" sldId="261"/>
-        </pc:sldMkLst>
-        <pc:spChg chg="add del mod">
-          <ac:chgData name="SHINOHARA Soshi (篠原 想詩)" userId="309c0b21-8b61-4cd5-9d32-07652c56306e" providerId="ADAL" clId="{60D42A6B-AE32-4A06-B461-AA9486421C3B}" dt="2026-09-18T05:25:08.832" v="262" actId="478"/>
-          <ac:spMkLst>
-            <pc:docMk/>
-            <pc:sldMk cId="2460916238" sldId="261"/>
-            <ac:spMk id="3" creationId="{CA4D1F53-A14A-7162-186C-AA71923C274E}"/>
-          </ac:spMkLst>
-        </pc:spChg>
-        <pc:spChg chg="add del mod">
-          <ac:chgData name="SHINOHARA Soshi (篠原 想詩)" userId="309c0b21-8b61-4cd5-9d32-07652c56306e" providerId="ADAL" clId="{60D42A6B-AE32-4A06-B461-AA9486421C3B}" dt="2026-09-18T06:07:30.410" v="2336" actId="478"/>
-          <ac:spMkLst>
-            <pc:docMk/>
-            <pc:sldMk cId="2460916238" sldId="261"/>
-            <ac:spMk id="5" creationId="{BE7B8D1F-E32B-7814-B7DE-5AAAAD2D4181}"/>
-          </ac:spMkLst>
-        </pc:spChg>
-        <pc:spChg chg="del">
-          <ac:chgData name="SHINOHARA Soshi (篠原 想詩)" userId="309c0b21-8b61-4cd5-9d32-07652c56306e" providerId="ADAL" clId="{60D42A6B-AE32-4A06-B461-AA9486421C3B}" dt="2026-09-18T06:07:26.110" v="2333" actId="478"/>
-          <ac:spMkLst>
-            <pc:docMk/>
-            <pc:sldMk cId="2460916238" sldId="261"/>
-            <ac:spMk id="6" creationId="{7F4E5446-F46C-48CC-6E65-7B7B2E9503FE}"/>
-          </ac:spMkLst>
-        </pc:spChg>
-        <pc:spChg chg="add del">
-          <ac:chgData name="SHINOHARA Soshi (篠原 想詩)" userId="309c0b21-8b61-4cd5-9d32-07652c56306e" providerId="ADAL" clId="{60D42A6B-AE32-4A06-B461-AA9486421C3B}" dt="2026-09-18T05:24:54.695" v="257" actId="478"/>
-          <ac:spMkLst>
-            <pc:docMk/>
-            <pc:sldMk cId="2460916238" sldId="261"/>
-            <ac:spMk id="7" creationId="{01CE3EA1-F0A8-7424-66A3-DBA858822732}"/>
-          </ac:spMkLst>
-        </pc:spChg>
-        <pc:spChg chg="add del">
-          <ac:chgData name="SHINOHARA Soshi (篠原 想詩)" userId="309c0b21-8b61-4cd5-9d32-07652c56306e" providerId="ADAL" clId="{60D42A6B-AE32-4A06-B461-AA9486421C3B}" dt="2026-09-18T05:24:54.695" v="257" actId="478"/>
-          <ac:spMkLst>
-            <pc:docMk/>
-            <pc:sldMk cId="2460916238" sldId="261"/>
-            <ac:spMk id="9" creationId="{8D09A15F-04FF-CD0E-4017-A04FA5ABA722}"/>
-          </ac:spMkLst>
-        </pc:spChg>
-        <pc:spChg chg="mod">
-          <ac:chgData name="SHINOHARA Soshi (篠原 想詩)" userId="309c0b21-8b61-4cd5-9d32-07652c56306e" providerId="ADAL" clId="{60D42A6B-AE32-4A06-B461-AA9486421C3B}" dt="2026-09-18T06:10:12.703" v="2455" actId="20577"/>
-          <ac:spMkLst>
-            <pc:docMk/>
-            <pc:sldMk cId="2460916238" sldId="261"/>
-            <ac:spMk id="10" creationId="{3ED9BB57-B053-F70B-D524-9A419F78B21D}"/>
-          </ac:spMkLst>
-        </pc:spChg>
-        <pc:spChg chg="add del">
-          <ac:chgData name="SHINOHARA Soshi (篠原 想詩)" userId="309c0b21-8b61-4cd5-9d32-07652c56306e" providerId="ADAL" clId="{60D42A6B-AE32-4A06-B461-AA9486421C3B}" dt="2026-09-18T05:24:54.695" v="257" actId="478"/>
-          <ac:spMkLst>
-            <pc:docMk/>
-            <pc:sldMk cId="2460916238" sldId="261"/>
-            <ac:spMk id="11" creationId="{21434601-AF06-911A-86DB-6D766E08ACF6}"/>
-          </ac:spMkLst>
-        </pc:spChg>
-        <pc:spChg chg="add del">
-          <ac:chgData name="SHINOHARA Soshi (篠原 想詩)" userId="309c0b21-8b61-4cd5-9d32-07652c56306e" providerId="ADAL" clId="{60D42A6B-AE32-4A06-B461-AA9486421C3B}" dt="2026-09-18T05:24:54.695" v="257" actId="478"/>
-          <ac:spMkLst>
-            <pc:docMk/>
-            <pc:sldMk cId="2460916238" sldId="261"/>
-            <ac:spMk id="13" creationId="{0A844F94-308C-40E7-389C-C85C23048104}"/>
-          </ac:spMkLst>
-        </pc:spChg>
-        <pc:spChg chg="mod">
-          <ac:chgData name="SHINOHARA Soshi (篠原 想詩)" userId="309c0b21-8b61-4cd5-9d32-07652c56306e" providerId="ADAL" clId="{60D42A6B-AE32-4A06-B461-AA9486421C3B}" dt="2026-09-18T05:47:59.610" v="1393" actId="1076"/>
-          <ac:spMkLst>
-            <pc:docMk/>
-            <pc:sldMk cId="2460916238" sldId="261"/>
-            <ac:spMk id="14" creationId="{5B0E15B8-93C6-B5DC-8BC8-AE4DFDADDF16}"/>
-          </ac:spMkLst>
-        </pc:spChg>
-        <pc:spChg chg="add del mod">
-          <ac:chgData name="SHINOHARA Soshi (篠原 想詩)" userId="309c0b21-8b61-4cd5-9d32-07652c56306e" providerId="ADAL" clId="{60D42A6B-AE32-4A06-B461-AA9486421C3B}" dt="2026-09-18T05:24:54.695" v="257" actId="478"/>
-          <ac:spMkLst>
-            <pc:docMk/>
-            <pc:sldMk cId="2460916238" sldId="261"/>
-            <ac:spMk id="15" creationId="{95656763-70B1-A3A4-369F-7EF7B623D55F}"/>
-          </ac:spMkLst>
-        </pc:spChg>
-        <pc:spChg chg="add del">
-          <ac:chgData name="SHINOHARA Soshi (篠原 想詩)" userId="309c0b21-8b61-4cd5-9d32-07652c56306e" providerId="ADAL" clId="{60D42A6B-AE32-4A06-B461-AA9486421C3B}" dt="2026-09-18T05:24:54.695" v="257" actId="478"/>
-          <ac:spMkLst>
-            <pc:docMk/>
-            <pc:sldMk cId="2460916238" sldId="261"/>
-            <ac:spMk id="17" creationId="{0F5239F4-8C8C-B0DF-B4B5-A862F57DEB1C}"/>
-          </ac:spMkLst>
-        </pc:spChg>
-        <pc:spChg chg="mod">
-          <ac:chgData name="SHINOHARA Soshi (篠原 想詩)" userId="309c0b21-8b61-4cd5-9d32-07652c56306e" providerId="ADAL" clId="{60D42A6B-AE32-4A06-B461-AA9486421C3B}" dt="2026-09-18T05:47:59.610" v="1393" actId="1076"/>
-          <ac:spMkLst>
-            <pc:docMk/>
-            <pc:sldMk cId="2460916238" sldId="261"/>
-            <ac:spMk id="18" creationId="{497756DF-3408-5C63-2891-8CB7EF569B47}"/>
-          </ac:spMkLst>
-        </pc:spChg>
-        <pc:spChg chg="add del">
-          <ac:chgData name="SHINOHARA Soshi (篠原 想詩)" userId="309c0b21-8b61-4cd5-9d32-07652c56306e" providerId="ADAL" clId="{60D42A6B-AE32-4A06-B461-AA9486421C3B}" dt="2026-09-18T05:24:54.695" v="257" actId="478"/>
-          <ac:spMkLst>
-            <pc:docMk/>
-            <pc:sldMk cId="2460916238" sldId="261"/>
-            <ac:spMk id="19" creationId="{7826C402-562F-4BD5-7C6B-D0FDFEAA603D}"/>
-          </ac:spMkLst>
-        </pc:spChg>
-        <pc:spChg chg="add del">
-          <ac:chgData name="SHINOHARA Soshi (篠原 想詩)" userId="309c0b21-8b61-4cd5-9d32-07652c56306e" providerId="ADAL" clId="{60D42A6B-AE32-4A06-B461-AA9486421C3B}" dt="2026-09-18T05:24:54.695" v="257" actId="478"/>
-          <ac:spMkLst>
-            <pc:docMk/>
-            <pc:sldMk cId="2460916238" sldId="261"/>
-            <ac:spMk id="21" creationId="{6F4993EC-9588-F220-45D8-1A365416A0CA}"/>
-          </ac:spMkLst>
-        </pc:spChg>
-        <pc:spChg chg="mod">
-          <ac:chgData name="SHINOHARA Soshi (篠原 想詩)" userId="309c0b21-8b61-4cd5-9d32-07652c56306e" providerId="ADAL" clId="{60D42A6B-AE32-4A06-B461-AA9486421C3B}" dt="2026-09-18T05:50:02.179" v="1414" actId="1076"/>
-          <ac:spMkLst>
-            <pc:docMk/>
-            <pc:sldMk cId="2460916238" sldId="261"/>
-            <ac:spMk id="22" creationId="{1ED71925-19F6-F7EB-DF01-3604792C541E}"/>
-          </ac:spMkLst>
-        </pc:spChg>
-        <pc:spChg chg="add del">
-          <ac:chgData name="SHINOHARA Soshi (篠原 想詩)" userId="309c0b21-8b61-4cd5-9d32-07652c56306e" providerId="ADAL" clId="{60D42A6B-AE32-4A06-B461-AA9486421C3B}" dt="2026-09-18T05:24:54.695" v="257" actId="478"/>
-          <ac:spMkLst>
-            <pc:docMk/>
-            <pc:sldMk cId="2460916238" sldId="261"/>
-            <ac:spMk id="23" creationId="{9958C36B-2683-47BF-00EE-254029DB53E4}"/>
-          </ac:spMkLst>
-        </pc:spChg>
-        <pc:spChg chg="add mod">
-          <ac:chgData name="SHINOHARA Soshi (篠原 想詩)" userId="309c0b21-8b61-4cd5-9d32-07652c56306e" providerId="ADAL" clId="{60D42A6B-AE32-4A06-B461-AA9486421C3B}" dt="2026-09-18T05:50:02.179" v="1414" actId="1076"/>
-          <ac:spMkLst>
-            <pc:docMk/>
-            <pc:sldMk cId="2460916238" sldId="261"/>
-            <ac:spMk id="25" creationId="{9AA1D80A-7EAB-E5E8-2EB1-FC55B36AF4FB}"/>
-          </ac:spMkLst>
-        </pc:spChg>
-        <pc:spChg chg="add mod">
-          <ac:chgData name="SHINOHARA Soshi (篠原 想詩)" userId="309c0b21-8b61-4cd5-9d32-07652c56306e" providerId="ADAL" clId="{60D42A6B-AE32-4A06-B461-AA9486421C3B}" dt="2026-09-18T05:50:02.179" v="1414" actId="1076"/>
-          <ac:spMkLst>
-            <pc:docMk/>
-            <pc:sldMk cId="2460916238" sldId="261"/>
-            <ac:spMk id="29" creationId="{A3A85E53-59E3-14F1-A43D-43A5D5555EB0}"/>
-          </ac:spMkLst>
-        </pc:spChg>
-        <pc:spChg chg="add mod">
-          <ac:chgData name="SHINOHARA Soshi (篠原 想詩)" userId="309c0b21-8b61-4cd5-9d32-07652c56306e" providerId="ADAL" clId="{60D42A6B-AE32-4A06-B461-AA9486421C3B}" dt="2026-09-18T05:50:02.179" v="1414" actId="1076"/>
-          <ac:spMkLst>
-            <pc:docMk/>
-            <pc:sldMk cId="2460916238" sldId="261"/>
-            <ac:spMk id="31" creationId="{4360A1D8-3337-5B5F-A527-4558554291F7}"/>
-          </ac:spMkLst>
-        </pc:spChg>
-        <pc:spChg chg="add mod">
-          <ac:chgData name="SHINOHARA Soshi (篠原 想詩)" userId="309c0b21-8b61-4cd5-9d32-07652c56306e" providerId="ADAL" clId="{60D42A6B-AE32-4A06-B461-AA9486421C3B}" dt="2026-09-18T05:50:02.179" v="1414" actId="1076"/>
-          <ac:spMkLst>
-            <pc:docMk/>
-            <pc:sldMk cId="2460916238" sldId="261"/>
-            <ac:spMk id="21505" creationId="{927C2915-20BF-81E6-ADAB-0B263E213E91}"/>
-          </ac:spMkLst>
-        </pc:spChg>
-        <pc:spChg chg="mod">
-          <ac:chgData name="SHINOHARA Soshi (篠原 想詩)" userId="309c0b21-8b61-4cd5-9d32-07652c56306e" providerId="ADAL" clId="{60D42A6B-AE32-4A06-B461-AA9486421C3B}" dt="2026-09-18T05:46:55.708" v="1359" actId="403"/>
-          <ac:spMkLst>
-            <pc:docMk/>
-            <pc:sldMk cId="2460916238" sldId="261"/>
-            <ac:spMk id="21506" creationId="{8B5E1CCB-E003-0B0A-94DD-5D464AE71E1F}"/>
-          </ac:spMkLst>
-        </pc:spChg>
-        <pc:spChg chg="add mod">
-          <ac:chgData name="SHINOHARA Soshi (篠原 想詩)" userId="309c0b21-8b61-4cd5-9d32-07652c56306e" providerId="ADAL" clId="{60D42A6B-AE32-4A06-B461-AA9486421C3B}" dt="2026-09-18T06:10:16.367" v="2466" actId="20577"/>
-          <ac:spMkLst>
-            <pc:docMk/>
-            <pc:sldMk cId="2460916238" sldId="261"/>
-            <ac:spMk id="21508" creationId="{2292334C-0E0C-4611-CBB3-F1ED8685F0EE}"/>
-          </ac:spMkLst>
-        </pc:spChg>
-        <pc:spChg chg="mod">
-          <ac:chgData name="SHINOHARA Soshi (篠原 想詩)" userId="309c0b21-8b61-4cd5-9d32-07652c56306e" providerId="ADAL" clId="{60D42A6B-AE32-4A06-B461-AA9486421C3B}" dt="2026-09-18T05:47:59.610" v="1393" actId="1076"/>
-          <ac:spMkLst>
-            <pc:docMk/>
-            <pc:sldMk cId="2460916238" sldId="261"/>
-            <ac:spMk id="21510" creationId="{43FF9372-D4F3-024E-F5FB-EEBCEE3D6C53}"/>
-          </ac:spMkLst>
-        </pc:spChg>
-        <pc:spChg chg="mod">
-          <ac:chgData name="SHINOHARA Soshi (篠原 想詩)" userId="309c0b21-8b61-4cd5-9d32-07652c56306e" providerId="ADAL" clId="{60D42A6B-AE32-4A06-B461-AA9486421C3B}" dt="2026-09-18T05:47:59.610" v="1393" actId="1076"/>
-          <ac:spMkLst>
-            <pc:docMk/>
-            <pc:sldMk cId="2460916238" sldId="261"/>
-            <ac:spMk id="21512" creationId="{89D92C62-0182-0465-1688-F4417EC2F72B}"/>
-          </ac:spMkLst>
-        </pc:spChg>
-        <pc:spChg chg="mod">
-          <ac:chgData name="SHINOHARA Soshi (篠原 想詩)" userId="309c0b21-8b61-4cd5-9d32-07652c56306e" providerId="ADAL" clId="{60D42A6B-AE32-4A06-B461-AA9486421C3B}" dt="2026-09-18T05:50:02.179" v="1414" actId="1076"/>
-          <ac:spMkLst>
-            <pc:docMk/>
-            <pc:sldMk cId="2460916238" sldId="261"/>
-            <ac:spMk id="21514" creationId="{D0A4DD7B-04A4-164A-EDDF-A00AC17F588E}"/>
-          </ac:spMkLst>
-        </pc:spChg>
-        <pc:spChg chg="add mod">
-          <ac:chgData name="SHINOHARA Soshi (篠原 想詩)" userId="309c0b21-8b61-4cd5-9d32-07652c56306e" providerId="ADAL" clId="{60D42A6B-AE32-4A06-B461-AA9486421C3B}" dt="2026-09-18T05:50:02.179" v="1414" actId="1076"/>
-          <ac:spMkLst>
-            <pc:docMk/>
-            <pc:sldMk cId="2460916238" sldId="261"/>
-            <ac:spMk id="21516" creationId="{CE12C862-B8D7-8680-F5A6-9D5626C05174}"/>
-          </ac:spMkLst>
-        </pc:spChg>
-        <pc:spChg chg="add mod">
-          <ac:chgData name="SHINOHARA Soshi (篠原 想詩)" userId="309c0b21-8b61-4cd5-9d32-07652c56306e" providerId="ADAL" clId="{60D42A6B-AE32-4A06-B461-AA9486421C3B}" dt="2026-09-18T05:50:02.179" v="1414" actId="1076"/>
-          <ac:spMkLst>
-            <pc:docMk/>
-            <pc:sldMk cId="2460916238" sldId="261"/>
-            <ac:spMk id="21518" creationId="{0B1D0BFE-19E5-BEBB-29BF-6206205D297A}"/>
-          </ac:spMkLst>
-        </pc:spChg>
-        <pc:spChg chg="add mod">
-          <ac:chgData name="SHINOHARA Soshi (篠原 想詩)" userId="309c0b21-8b61-4cd5-9d32-07652c56306e" providerId="ADAL" clId="{60D42A6B-AE32-4A06-B461-AA9486421C3B}" dt="2026-09-18T07:24:11.208" v="2544" actId="207"/>
-          <ac:spMkLst>
-            <pc:docMk/>
-            <pc:sldMk cId="2460916238" sldId="261"/>
-            <ac:spMk id="21522" creationId="{23394E18-7729-EF9C-1A57-D32D35698E0B}"/>
-          </ac:spMkLst>
-        </pc:spChg>
-        <pc:spChg chg="add del mod">
-          <ac:chgData name="SHINOHARA Soshi (篠原 想詩)" userId="309c0b21-8b61-4cd5-9d32-07652c56306e" providerId="ADAL" clId="{60D42A6B-AE32-4A06-B461-AA9486421C3B}" dt="2026-09-18T05:47:51.381" v="1392" actId="478"/>
-          <ac:spMkLst>
-            <pc:docMk/>
-            <pc:sldMk cId="2460916238" sldId="261"/>
-            <ac:spMk id="21524" creationId="{B2F10FD7-6ED5-4E6F-4153-33B85EE2B03E}"/>
-          </ac:spMkLst>
-        </pc:spChg>
-        <pc:spChg chg="del mod">
-          <ac:chgData name="SHINOHARA Soshi (篠原 想詩)" userId="309c0b21-8b61-4cd5-9d32-07652c56306e" providerId="ADAL" clId="{60D42A6B-AE32-4A06-B461-AA9486421C3B}" dt="2026-09-18T05:47:49.117" v="1391" actId="478"/>
-          <ac:spMkLst>
-            <pc:docMk/>
-            <pc:sldMk cId="2460916238" sldId="261"/>
-            <ac:spMk id="21526" creationId="{720EA9A5-F780-985C-4940-3F9A5D2FEC2F}"/>
-          </ac:spMkLst>
-        </pc:spChg>
-        <pc:spChg chg="add mod">
-          <ac:chgData name="SHINOHARA Soshi (篠原 想詩)" userId="309c0b21-8b61-4cd5-9d32-07652c56306e" providerId="ADAL" clId="{60D42A6B-AE32-4A06-B461-AA9486421C3B}" dt="2026-09-18T06:03:14.359" v="2304" actId="1582"/>
-          <ac:spMkLst>
-            <pc:docMk/>
-            <pc:sldMk cId="2460916238" sldId="261"/>
-            <ac:spMk id="21527" creationId="{231EE372-2D83-A895-742F-441F2D69583B}"/>
-          </ac:spMkLst>
-        </pc:spChg>
-        <pc:spChg chg="add mod">
-          <ac:chgData name="SHINOHARA Soshi (篠原 想詩)" userId="309c0b21-8b61-4cd5-9d32-07652c56306e" providerId="ADAL" clId="{60D42A6B-AE32-4A06-B461-AA9486421C3B}" dt="2026-09-18T05:49:47.348" v="1412" actId="1076"/>
-          <ac:spMkLst>
-            <pc:docMk/>
-            <pc:sldMk cId="2460916238" sldId="261"/>
-            <ac:spMk id="21529" creationId="{08D3BE1E-A7CA-BEB2-ADB6-594EF66852D4}"/>
-          </ac:spMkLst>
-        </pc:spChg>
-        <pc:spChg chg="add mod">
-          <ac:chgData name="SHINOHARA Soshi (篠原 想詩)" userId="309c0b21-8b61-4cd5-9d32-07652c56306e" providerId="ADAL" clId="{60D42A6B-AE32-4A06-B461-AA9486421C3B}" dt="2026-09-18T06:09:45.821" v="2404" actId="20577"/>
-          <ac:spMkLst>
-            <pc:docMk/>
-            <pc:sldMk cId="2460916238" sldId="261"/>
-            <ac:spMk id="21531" creationId="{0E081BA2-CF81-69EE-3F51-8B71713AA293}"/>
-          </ac:spMkLst>
-        </pc:spChg>
-        <pc:spChg chg="add mod">
-          <ac:chgData name="SHINOHARA Soshi (篠原 想詩)" userId="309c0b21-8b61-4cd5-9d32-07652c56306e" providerId="ADAL" clId="{60D42A6B-AE32-4A06-B461-AA9486421C3B}" dt="2026-09-18T06:03:40.075" v="2308" actId="1076"/>
-          <ac:spMkLst>
-            <pc:docMk/>
-            <pc:sldMk cId="2460916238" sldId="261"/>
-            <ac:spMk id="21533" creationId="{B85F4D50-9C37-7186-F9DF-DF2611B8DAE4}"/>
-          </ac:spMkLst>
-        </pc:spChg>
-        <pc:spChg chg="add">
-          <ac:chgData name="SHINOHARA Soshi (篠原 想詩)" userId="309c0b21-8b61-4cd5-9d32-07652c56306e" providerId="ADAL" clId="{60D42A6B-AE32-4A06-B461-AA9486421C3B}" dt="2026-09-18T06:07:26.395" v="2334" actId="22"/>
-          <ac:spMkLst>
-            <pc:docMk/>
-            <pc:sldMk cId="2460916238" sldId="261"/>
-            <ac:spMk id="21535" creationId="{2E47C8EF-6705-D95C-B05D-E243520E31E0}"/>
-          </ac:spMkLst>
-        </pc:spChg>
-        <pc:spChg chg="add del">
-          <ac:chgData name="SHINOHARA Soshi (篠原 想詩)" userId="309c0b21-8b61-4cd5-9d32-07652c56306e" providerId="ADAL" clId="{60D42A6B-AE32-4A06-B461-AA9486421C3B}" dt="2026-09-18T06:07:28.184" v="2335" actId="478"/>
-          <ac:spMkLst>
-            <pc:docMk/>
-            <pc:sldMk cId="2460916238" sldId="261"/>
-            <ac:spMk id="21537" creationId="{24243219-7C45-AC1E-0C8D-E3B5C1DED6B2}"/>
-          </ac:spMkLst>
-        </pc:spChg>
-      </pc:sldChg>
-      <pc:sldChg chg="add del">
-        <pc:chgData name="SHINOHARA Soshi (篠原 想詩)" userId="309c0b21-8b61-4cd5-9d32-07652c56306e" providerId="ADAL" clId="{60D42A6B-AE32-4A06-B461-AA9486421C3B}" dt="2026-09-18T05:26:41.898" v="310"/>
-        <pc:sldMkLst>
-          <pc:docMk/>
-          <pc:sldMk cId="986264629" sldId="262"/>
-        </pc:sldMkLst>
-      </pc:sldChg>
-      <pc:sldChg chg="add del">
-        <pc:chgData name="SHINOHARA Soshi (篠原 想詩)" userId="309c0b21-8b61-4cd5-9d32-07652c56306e" providerId="ADAL" clId="{60D42A6B-AE32-4A06-B461-AA9486421C3B}" dt="2026-09-18T05:26:52.924" v="315" actId="47"/>
-        <pc:sldMkLst>
-          <pc:docMk/>
-          <pc:sldMk cId="3842469057" sldId="262"/>
-        </pc:sldMkLst>
-      </pc:sldChg>
-      <pc:sldChg chg="delSp modSp add mod">
-        <pc:chgData name="SHINOHARA Soshi (篠原 想詩)" userId="309c0b21-8b61-4cd5-9d32-07652c56306e" providerId="ADAL" clId="{60D42A6B-AE32-4A06-B461-AA9486421C3B}" dt="2026-09-18T07:18:17.875" v="2543" actId="1076"/>
-        <pc:sldMkLst>
-          <pc:docMk/>
-          <pc:sldMk cId="2416652295" sldId="263"/>
-        </pc:sldMkLst>
-        <pc:spChg chg="mod">
-          <ac:chgData name="SHINOHARA Soshi (篠原 想詩)" userId="309c0b21-8b61-4cd5-9d32-07652c56306e" providerId="ADAL" clId="{60D42A6B-AE32-4A06-B461-AA9486421C3B}" dt="2026-09-18T06:06:58.138" v="2327" actId="14100"/>
-          <ac:spMkLst>
-            <pc:docMk/>
-            <pc:sldMk cId="2416652295" sldId="263"/>
-            <ac:spMk id="5" creationId="{03ADD616-96E1-C816-722E-D432D1B1434B}"/>
-          </ac:spMkLst>
-        </pc:spChg>
-        <pc:spChg chg="mod">
-          <ac:chgData name="SHINOHARA Soshi (篠原 想詩)" userId="309c0b21-8b61-4cd5-9d32-07652c56306e" providerId="ADAL" clId="{60D42A6B-AE32-4A06-B461-AA9486421C3B}" dt="2026-09-18T06:07:20.645" v="2332" actId="14100"/>
-          <ac:spMkLst>
-            <pc:docMk/>
-            <pc:sldMk cId="2416652295" sldId="263"/>
-            <ac:spMk id="7" creationId="{9D8E4493-09ED-D66D-BB69-F4E17FDDAAE5}"/>
-          </ac:spMkLst>
-        </pc:spChg>
-        <pc:spChg chg="mod">
-          <ac:chgData name="SHINOHARA Soshi (篠原 想詩)" userId="309c0b21-8b61-4cd5-9d32-07652c56306e" providerId="ADAL" clId="{60D42A6B-AE32-4A06-B461-AA9486421C3B}" dt="2026-09-18T05:50:15.383" v="1415" actId="1076"/>
-          <ac:spMkLst>
-            <pc:docMk/>
-            <pc:sldMk cId="2416652295" sldId="263"/>
-            <ac:spMk id="9" creationId="{A76CBF8E-780A-F613-552A-79DF92A79B34}"/>
-          </ac:spMkLst>
-        </pc:spChg>
-        <pc:spChg chg="mod">
-          <ac:chgData name="SHINOHARA Soshi (篠原 想詩)" userId="309c0b21-8b61-4cd5-9d32-07652c56306e" providerId="ADAL" clId="{60D42A6B-AE32-4A06-B461-AA9486421C3B}" dt="2026-09-18T07:18:08.613" v="2541" actId="14100"/>
-          <ac:spMkLst>
-            <pc:docMk/>
-            <pc:sldMk cId="2416652295" sldId="263"/>
-            <ac:spMk id="11" creationId="{334C37F2-BE3E-BFC0-CAB9-D3917FDC0606}"/>
-          </ac:spMkLst>
-        </pc:spChg>
-        <pc:spChg chg="mod">
-          <ac:chgData name="SHINOHARA Soshi (篠原 想詩)" userId="309c0b21-8b61-4cd5-9d32-07652c56306e" providerId="ADAL" clId="{60D42A6B-AE32-4A06-B461-AA9486421C3B}" dt="2026-09-18T06:09:13.314" v="2397" actId="1076"/>
-          <ac:spMkLst>
-            <pc:docMk/>
-            <pc:sldMk cId="2416652295" sldId="263"/>
-            <ac:spMk id="13" creationId="{CFA581EB-E5DD-E949-61AD-F14177A9CC17}"/>
-          </ac:spMkLst>
-        </pc:spChg>
-        <pc:spChg chg="mod">
-          <ac:chgData name="SHINOHARA Soshi (篠原 想詩)" userId="309c0b21-8b61-4cd5-9d32-07652c56306e" providerId="ADAL" clId="{60D42A6B-AE32-4A06-B461-AA9486421C3B}" dt="2026-09-18T06:09:13.314" v="2397" actId="1076"/>
-          <ac:spMkLst>
-            <pc:docMk/>
-            <pc:sldMk cId="2416652295" sldId="263"/>
-            <ac:spMk id="15" creationId="{CBB4D034-4453-9918-E427-6F3BF26F1E67}"/>
-          </ac:spMkLst>
-        </pc:spChg>
-        <pc:spChg chg="mod">
-          <ac:chgData name="SHINOHARA Soshi (篠原 想詩)" userId="309c0b21-8b61-4cd5-9d32-07652c56306e" providerId="ADAL" clId="{60D42A6B-AE32-4A06-B461-AA9486421C3B}" dt="2026-09-18T06:09:17.823" v="2398" actId="1076"/>
-          <ac:spMkLst>
-            <pc:docMk/>
-            <pc:sldMk cId="2416652295" sldId="263"/>
-            <ac:spMk id="17" creationId="{9EA7CA49-8438-F8C9-4C30-426972466047}"/>
-          </ac:spMkLst>
-        </pc:spChg>
-        <pc:spChg chg="mod">
-          <ac:chgData name="SHINOHARA Soshi (篠原 想詩)" userId="309c0b21-8b61-4cd5-9d32-07652c56306e" providerId="ADAL" clId="{60D42A6B-AE32-4A06-B461-AA9486421C3B}" dt="2026-09-18T07:18:17.875" v="2543" actId="1076"/>
-          <ac:spMkLst>
-            <pc:docMk/>
-            <pc:sldMk cId="2416652295" sldId="263"/>
-            <ac:spMk id="19" creationId="{0E391B8E-AB01-AC75-D1D9-4BA5617A534F}"/>
-          </ac:spMkLst>
-        </pc:spChg>
-        <pc:spChg chg="del mod">
-          <ac:chgData name="SHINOHARA Soshi (篠原 想詩)" userId="309c0b21-8b61-4cd5-9d32-07652c56306e" providerId="ADAL" clId="{60D42A6B-AE32-4A06-B461-AA9486421C3B}" dt="2026-09-18T05:49:37.448" v="1407" actId="21"/>
-          <ac:spMkLst>
-            <pc:docMk/>
-            <pc:sldMk cId="2416652295" sldId="263"/>
-            <ac:spMk id="21" creationId="{0A34CEB6-CCB9-988E-2DFF-1ECD24F42D9F}"/>
-          </ac:spMkLst>
-        </pc:spChg>
-        <pc:spChg chg="del mod">
-          <ac:chgData name="SHINOHARA Soshi (篠原 想詩)" userId="309c0b21-8b61-4cd5-9d32-07652c56306e" providerId="ADAL" clId="{60D42A6B-AE32-4A06-B461-AA9486421C3B}" dt="2026-09-18T05:49:37.448" v="1407" actId="21"/>
-          <ac:spMkLst>
-            <pc:docMk/>
-            <pc:sldMk cId="2416652295" sldId="263"/>
-            <ac:spMk id="23" creationId="{00857F23-C44E-A666-426E-21F27FF95978}"/>
-          </ac:spMkLst>
-        </pc:spChg>
-        <pc:spChg chg="mod">
-          <ac:chgData name="SHINOHARA Soshi (篠原 想詩)" userId="309c0b21-8b61-4cd5-9d32-07652c56306e" providerId="ADAL" clId="{60D42A6B-AE32-4A06-B461-AA9486421C3B}" dt="2026-09-18T05:46:41.920" v="1358" actId="1076"/>
-          <ac:spMkLst>
-            <pc:docMk/>
-            <pc:sldMk cId="2416652295" sldId="263"/>
-            <ac:spMk id="21506" creationId="{BBF3B7B6-7F4A-254F-EB33-2638E125F1E0}"/>
-          </ac:spMkLst>
-        </pc:spChg>
-      </pc:sldChg>
-      <pc:sldChg chg="addSp delSp modSp add mod ord">
-        <pc:chgData name="SHINOHARA Soshi (篠原 想詩)" userId="309c0b21-8b61-4cd5-9d32-07652c56306e" providerId="ADAL" clId="{60D42A6B-AE32-4A06-B461-AA9486421C3B}" dt="2026-09-18T07:27:41.343" v="2583" actId="20577"/>
-        <pc:sldMkLst>
-          <pc:docMk/>
-          <pc:sldMk cId="147431364" sldId="264"/>
-        </pc:sldMkLst>
-        <pc:spChg chg="add del mod">
-          <ac:chgData name="SHINOHARA Soshi (篠原 想詩)" userId="309c0b21-8b61-4cd5-9d32-07652c56306e" providerId="ADAL" clId="{60D42A6B-AE32-4A06-B461-AA9486421C3B}" dt="2026-09-18T06:07:39.375" v="2340" actId="478"/>
-          <ac:spMkLst>
-            <pc:docMk/>
-            <pc:sldMk cId="147431364" sldId="264"/>
-            <ac:spMk id="3" creationId="{307B1FFF-4372-E844-97E8-30ADF086F187}"/>
-          </ac:spMkLst>
-        </pc:spChg>
-        <pc:spChg chg="del">
-          <ac:chgData name="SHINOHARA Soshi (篠原 想詩)" userId="309c0b21-8b61-4cd5-9d32-07652c56306e" providerId="ADAL" clId="{60D42A6B-AE32-4A06-B461-AA9486421C3B}" dt="2026-09-18T06:07:36.040" v="2337" actId="478"/>
-          <ac:spMkLst>
-            <pc:docMk/>
-            <pc:sldMk cId="147431364" sldId="264"/>
-            <ac:spMk id="5" creationId="{05EB874F-BED0-70CE-2524-0004B0E0A7AB}"/>
-          </ac:spMkLst>
-        </pc:spChg>
-        <pc:spChg chg="add mod">
-          <ac:chgData name="SHINOHARA Soshi (篠原 想詩)" userId="309c0b21-8b61-4cd5-9d32-07652c56306e" providerId="ADAL" clId="{60D42A6B-AE32-4A06-B461-AA9486421C3B}" dt="2026-09-18T05:55:29.688" v="1687" actId="1076"/>
-          <ac:spMkLst>
-            <pc:docMk/>
-            <pc:sldMk cId="147431364" sldId="264"/>
-            <ac:spMk id="6" creationId="{9F0FB3CC-52F3-1B56-A3C9-4771819CFED5}"/>
-          </ac:spMkLst>
-        </pc:spChg>
-        <pc:spChg chg="del">
-          <ac:chgData name="SHINOHARA Soshi (篠原 想詩)" userId="309c0b21-8b61-4cd5-9d32-07652c56306e" providerId="ADAL" clId="{60D42A6B-AE32-4A06-B461-AA9486421C3B}" dt="2026-09-18T05:54:43.421" v="1669" actId="478"/>
-          <ac:spMkLst>
-            <pc:docMk/>
-            <pc:sldMk cId="147431364" sldId="264"/>
-            <ac:spMk id="7" creationId="{32051751-D992-8D98-D7B3-5B3E77D972D0}"/>
-          </ac:spMkLst>
-        </pc:spChg>
-        <pc:spChg chg="del">
-          <ac:chgData name="SHINOHARA Soshi (篠原 想詩)" userId="309c0b21-8b61-4cd5-9d32-07652c56306e" providerId="ADAL" clId="{60D42A6B-AE32-4A06-B461-AA9486421C3B}" dt="2026-09-18T05:54:42.710" v="1668" actId="478"/>
-          <ac:spMkLst>
-            <pc:docMk/>
-            <pc:sldMk cId="147431364" sldId="264"/>
-            <ac:spMk id="9" creationId="{40DA71E2-5169-C226-9716-1D29245292DA}"/>
-          </ac:spMkLst>
-        </pc:spChg>
-        <pc:spChg chg="add mod">
-          <ac:chgData name="SHINOHARA Soshi (篠原 想詩)" userId="309c0b21-8b61-4cd5-9d32-07652c56306e" providerId="ADAL" clId="{60D42A6B-AE32-4A06-B461-AA9486421C3B}" dt="2026-09-18T05:57:01.641" v="1782" actId="20577"/>
-          <ac:spMkLst>
-            <pc:docMk/>
-            <pc:sldMk cId="147431364" sldId="264"/>
-            <ac:spMk id="10" creationId="{A99D0592-4AAB-EE9D-86AD-508AC56407B7}"/>
-          </ac:spMkLst>
-        </pc:spChg>
-        <pc:spChg chg="del">
-          <ac:chgData name="SHINOHARA Soshi (篠原 想詩)" userId="309c0b21-8b61-4cd5-9d32-07652c56306e" providerId="ADAL" clId="{60D42A6B-AE32-4A06-B461-AA9486421C3B}" dt="2026-09-18T05:54:42.710" v="1668" actId="478"/>
-          <ac:spMkLst>
-            <pc:docMk/>
-            <pc:sldMk cId="147431364" sldId="264"/>
-            <ac:spMk id="11" creationId="{5A0F1061-0D3B-DF52-4C20-A9727B3AD83E}"/>
-          </ac:spMkLst>
-        </pc:spChg>
-        <pc:spChg chg="del">
-          <ac:chgData name="SHINOHARA Soshi (篠原 想詩)" userId="309c0b21-8b61-4cd5-9d32-07652c56306e" providerId="ADAL" clId="{60D42A6B-AE32-4A06-B461-AA9486421C3B}" dt="2026-09-18T05:54:42.710" v="1668" actId="478"/>
-          <ac:spMkLst>
-            <pc:docMk/>
-            <pc:sldMk cId="147431364" sldId="264"/>
-            <ac:spMk id="13" creationId="{F83BA511-67DA-15B1-A537-77506D5113E2}"/>
-          </ac:spMkLst>
-        </pc:spChg>
-        <pc:spChg chg="add mod">
-          <ac:chgData name="SHINOHARA Soshi (篠原 想詩)" userId="309c0b21-8b61-4cd5-9d32-07652c56306e" providerId="ADAL" clId="{60D42A6B-AE32-4A06-B461-AA9486421C3B}" dt="2026-09-18T06:08:39.880" v="2390" actId="1076"/>
-          <ac:spMkLst>
-            <pc:docMk/>
-            <pc:sldMk cId="147431364" sldId="264"/>
-            <ac:spMk id="14" creationId="{E01BB2FC-B37F-D766-FE9D-4C8FAD15E35A}"/>
-          </ac:spMkLst>
-        </pc:spChg>
-        <pc:spChg chg="del">
-          <ac:chgData name="SHINOHARA Soshi (篠原 想詩)" userId="309c0b21-8b61-4cd5-9d32-07652c56306e" providerId="ADAL" clId="{60D42A6B-AE32-4A06-B461-AA9486421C3B}" dt="2026-09-18T05:54:42.710" v="1668" actId="478"/>
-          <ac:spMkLst>
-            <pc:docMk/>
-            <pc:sldMk cId="147431364" sldId="264"/>
-            <ac:spMk id="15" creationId="{17E3DE3F-0A9D-878D-5147-69C69CDCFAB7}"/>
-          </ac:spMkLst>
-        </pc:spChg>
-        <pc:spChg chg="del">
-          <ac:chgData name="SHINOHARA Soshi (篠原 想詩)" userId="309c0b21-8b61-4cd5-9d32-07652c56306e" providerId="ADAL" clId="{60D42A6B-AE32-4A06-B461-AA9486421C3B}" dt="2026-09-18T05:54:42.710" v="1668" actId="478"/>
-          <ac:spMkLst>
-            <pc:docMk/>
-            <pc:sldMk cId="147431364" sldId="264"/>
-            <ac:spMk id="17" creationId="{F414B563-D382-0346-6704-8887DDD4FEDF}"/>
-          </ac:spMkLst>
-        </pc:spChg>
-        <pc:spChg chg="add mod">
-          <ac:chgData name="SHINOHARA Soshi (篠原 想詩)" userId="309c0b21-8b61-4cd5-9d32-07652c56306e" providerId="ADAL" clId="{60D42A6B-AE32-4A06-B461-AA9486421C3B}" dt="2026-09-18T07:27:41.343" v="2583" actId="20577"/>
-          <ac:spMkLst>
-            <pc:docMk/>
-            <pc:sldMk cId="147431364" sldId="264"/>
-            <ac:spMk id="18" creationId="{65F3A6C4-9A81-1EF9-8F56-E2D36B994E0B}"/>
-          </ac:spMkLst>
-        </pc:spChg>
-        <pc:spChg chg="del">
-          <ac:chgData name="SHINOHARA Soshi (篠原 想詩)" userId="309c0b21-8b61-4cd5-9d32-07652c56306e" providerId="ADAL" clId="{60D42A6B-AE32-4A06-B461-AA9486421C3B}" dt="2026-09-18T05:54:42.710" v="1668" actId="478"/>
-          <ac:spMkLst>
-            <pc:docMk/>
-            <pc:sldMk cId="147431364" sldId="264"/>
-            <ac:spMk id="19" creationId="{3CA7ABDB-9CF4-7419-A3F0-372837F4CA68}"/>
-          </ac:spMkLst>
-        </pc:spChg>
-        <pc:spChg chg="add mod">
-          <ac:chgData name="SHINOHARA Soshi (篠原 想詩)" userId="309c0b21-8b61-4cd5-9d32-07652c56306e" providerId="ADAL" clId="{60D42A6B-AE32-4A06-B461-AA9486421C3B}" dt="2026-09-18T06:08:39.880" v="2390" actId="1076"/>
-          <ac:spMkLst>
-            <pc:docMk/>
-            <pc:sldMk cId="147431364" sldId="264"/>
-            <ac:spMk id="21" creationId="{51637B88-5226-9238-B14D-891D3D348264}"/>
-          </ac:spMkLst>
-        </pc:spChg>
-        <pc:spChg chg="add mod">
-          <ac:chgData name="SHINOHARA Soshi (篠原 想詩)" userId="309c0b21-8b61-4cd5-9d32-07652c56306e" providerId="ADAL" clId="{60D42A6B-AE32-4A06-B461-AA9486421C3B}" dt="2026-09-18T06:08:34.632" v="2389" actId="1076"/>
-          <ac:spMkLst>
-            <pc:docMk/>
-            <pc:sldMk cId="147431364" sldId="264"/>
-            <ac:spMk id="25" creationId="{90B734DB-F072-0773-4A91-F2D0428DC85B}"/>
-          </ac:spMkLst>
-        </pc:spChg>
-        <pc:spChg chg="add">
-          <ac:chgData name="SHINOHARA Soshi (篠原 想詩)" userId="309c0b21-8b61-4cd5-9d32-07652c56306e" providerId="ADAL" clId="{60D42A6B-AE32-4A06-B461-AA9486421C3B}" dt="2026-09-18T06:07:36.711" v="2338" actId="22"/>
-          <ac:spMkLst>
-            <pc:docMk/>
-            <pc:sldMk cId="147431364" sldId="264"/>
-            <ac:spMk id="27" creationId="{4196054C-6AD3-7A06-15DA-5D1815E3D737}"/>
-          </ac:spMkLst>
-        </pc:spChg>
-        <pc:spChg chg="add mod">
-          <ac:chgData name="SHINOHARA Soshi (篠原 想詩)" userId="309c0b21-8b61-4cd5-9d32-07652c56306e" providerId="ADAL" clId="{60D42A6B-AE32-4A06-B461-AA9486421C3B}" dt="2026-09-18T06:08:55.477" v="2393" actId="14100"/>
-          <ac:spMkLst>
-            <pc:docMk/>
-            <pc:sldMk cId="147431364" sldId="264"/>
-            <ac:spMk id="29" creationId="{0E469F14-DE54-B50C-65FD-4EF61E57F230}"/>
-          </ac:spMkLst>
-        </pc:spChg>
-        <pc:spChg chg="mod">
-          <ac:chgData name="SHINOHARA Soshi (篠原 想詩)" userId="309c0b21-8b61-4cd5-9d32-07652c56306e" providerId="ADAL" clId="{60D42A6B-AE32-4A06-B461-AA9486421C3B}" dt="2026-09-18T06:01:54.966" v="2261" actId="207"/>
-          <ac:spMkLst>
-            <pc:docMk/>
-            <pc:sldMk cId="147431364" sldId="264"/>
-            <ac:spMk id="21506" creationId="{64226943-6F0D-9B1F-EB98-B1CB9F46A659}"/>
-          </ac:spMkLst>
-        </pc:spChg>
-        <pc:graphicFrameChg chg="add mod modGraphic">
-          <ac:chgData name="SHINOHARA Soshi (篠原 想詩)" userId="309c0b21-8b61-4cd5-9d32-07652c56306e" providerId="ADAL" clId="{60D42A6B-AE32-4A06-B461-AA9486421C3B}" dt="2026-09-18T06:11:57.996" v="2515" actId="20577"/>
-          <ac:graphicFrameMkLst>
-            <pc:docMk/>
-            <pc:sldMk cId="147431364" sldId="264"/>
-            <ac:graphicFrameMk id="23" creationId="{A1CE0432-81FE-9A98-8528-48DD5FFDE362}"/>
-          </ac:graphicFrameMkLst>
-        </pc:graphicFrameChg>
-      </pc:sldChg>
-      <pc:sldChg chg="addSp delSp add del mod">
-        <pc:chgData name="SHINOHARA Soshi (篠原 想詩)" userId="309c0b21-8b61-4cd5-9d32-07652c56306e" providerId="ADAL" clId="{60D42A6B-AE32-4A06-B461-AA9486421C3B}" dt="2026-09-18T06:08:57.444" v="2394" actId="47"/>
-        <pc:sldMkLst>
-          <pc:docMk/>
-          <pc:sldMk cId="1314201938" sldId="265"/>
-        </pc:sldMkLst>
-        <pc:spChg chg="del">
-          <ac:chgData name="SHINOHARA Soshi (篠原 想詩)" userId="309c0b21-8b61-4cd5-9d32-07652c56306e" providerId="ADAL" clId="{60D42A6B-AE32-4A06-B461-AA9486421C3B}" dt="2026-09-18T06:05:23.662" v="2314" actId="478"/>
-          <ac:spMkLst>
-            <pc:docMk/>
-            <pc:sldMk cId="1314201938" sldId="265"/>
-            <ac:spMk id="3" creationId="{E7EF5306-233C-D888-C4F9-869857861AC2}"/>
-          </ac:spMkLst>
-        </pc:spChg>
-        <pc:spChg chg="add del">
-          <ac:chgData name="SHINOHARA Soshi (篠原 想詩)" userId="309c0b21-8b61-4cd5-9d32-07652c56306e" providerId="ADAL" clId="{60D42A6B-AE32-4A06-B461-AA9486421C3B}" dt="2026-09-18T06:08:07.935" v="2381" actId="478"/>
-          <ac:spMkLst>
-            <pc:docMk/>
-            <pc:sldMk cId="1314201938" sldId="265"/>
-            <ac:spMk id="5" creationId="{2FA5BB3F-AB34-D2DF-4D36-1FCD30EAFEBF}"/>
-          </ac:spMkLst>
-        </pc:spChg>
-        <pc:spChg chg="del">
-          <ac:chgData name="SHINOHARA Soshi (篠原 想詩)" userId="309c0b21-8b61-4cd5-9d32-07652c56306e" providerId="ADAL" clId="{60D42A6B-AE32-4A06-B461-AA9486421C3B}" dt="2026-09-18T06:05:19.005" v="2313" actId="478"/>
-          <ac:spMkLst>
-            <pc:docMk/>
-            <pc:sldMk cId="1314201938" sldId="265"/>
-            <ac:spMk id="6" creationId="{5A1063EE-9E6D-631E-F8F0-44B6D334FDDF}"/>
-          </ac:spMkLst>
-        </pc:spChg>
-        <pc:spChg chg="del">
-          <ac:chgData name="SHINOHARA Soshi (篠原 想詩)" userId="309c0b21-8b61-4cd5-9d32-07652c56306e" providerId="ADAL" clId="{60D42A6B-AE32-4A06-B461-AA9486421C3B}" dt="2026-09-18T06:05:19.005" v="2313" actId="478"/>
-          <ac:spMkLst>
-            <pc:docMk/>
-            <pc:sldMk cId="1314201938" sldId="265"/>
-            <ac:spMk id="10" creationId="{36257D8E-473D-A3A2-03E5-7CA4F72923D1}"/>
-          </ac:spMkLst>
-        </pc:spChg>
-        <pc:spChg chg="del">
-          <ac:chgData name="SHINOHARA Soshi (篠原 想詩)" userId="309c0b21-8b61-4cd5-9d32-07652c56306e" providerId="ADAL" clId="{60D42A6B-AE32-4A06-B461-AA9486421C3B}" dt="2026-09-18T06:05:19.005" v="2313" actId="478"/>
-          <ac:spMkLst>
-            <pc:docMk/>
-            <pc:sldMk cId="1314201938" sldId="265"/>
-            <ac:spMk id="14" creationId="{97ED53A4-D1E1-F356-C32D-C4DF01E9D78A}"/>
-          </ac:spMkLst>
-        </pc:spChg>
-        <pc:spChg chg="del">
-          <ac:chgData name="SHINOHARA Soshi (篠原 想詩)" userId="309c0b21-8b61-4cd5-9d32-07652c56306e" providerId="ADAL" clId="{60D42A6B-AE32-4A06-B461-AA9486421C3B}" dt="2026-09-18T06:05:19.005" v="2313" actId="478"/>
-          <ac:spMkLst>
-            <pc:docMk/>
-            <pc:sldMk cId="1314201938" sldId="265"/>
-            <ac:spMk id="18" creationId="{C7C043CB-6ECC-E00B-D998-006A6A1A1EE3}"/>
-          </ac:spMkLst>
-        </pc:spChg>
-        <pc:spChg chg="del">
-          <ac:chgData name="SHINOHARA Soshi (篠原 想詩)" userId="309c0b21-8b61-4cd5-9d32-07652c56306e" providerId="ADAL" clId="{60D42A6B-AE32-4A06-B461-AA9486421C3B}" dt="2026-09-18T06:05:19.005" v="2313" actId="478"/>
-          <ac:spMkLst>
-            <pc:docMk/>
-            <pc:sldMk cId="1314201938" sldId="265"/>
-            <ac:spMk id="21" creationId="{01BC4F24-814E-B738-E9F9-62CD2ECE9CD4}"/>
-          </ac:spMkLst>
-        </pc:spChg>
-        <pc:spChg chg="del">
-          <ac:chgData name="SHINOHARA Soshi (篠原 想詩)" userId="309c0b21-8b61-4cd5-9d32-07652c56306e" providerId="ADAL" clId="{60D42A6B-AE32-4A06-B461-AA9486421C3B}" dt="2026-09-18T06:05:30.240" v="2316" actId="478"/>
-          <ac:spMkLst>
-            <pc:docMk/>
-            <pc:sldMk cId="1314201938" sldId="265"/>
-            <ac:spMk id="25" creationId="{5E0BD695-208B-8E25-EE99-545B14AAEDDD}"/>
-          </ac:spMkLst>
-        </pc:spChg>
-        <pc:graphicFrameChg chg="del">
-          <ac:chgData name="SHINOHARA Soshi (篠原 想詩)" userId="309c0b21-8b61-4cd5-9d32-07652c56306e" providerId="ADAL" clId="{60D42A6B-AE32-4A06-B461-AA9486421C3B}" dt="2026-09-18T06:05:27.563" v="2315" actId="478"/>
-          <ac:graphicFrameMkLst>
-            <pc:docMk/>
-            <pc:sldMk cId="1314201938" sldId="265"/>
-            <ac:graphicFrameMk id="23" creationId="{1EE2691D-2C68-50A1-72EA-5FC142209032}"/>
-          </ac:graphicFrameMkLst>
-        </pc:graphicFrameChg>
-      </pc:sldChg>
-      <pc:sldChg chg="addSp delSp modSp add mod">
-        <pc:chgData name="SHINOHARA Soshi (篠原 想詩)" userId="309c0b21-8b61-4cd5-9d32-07652c56306e" providerId="ADAL" clId="{60D42A6B-AE32-4A06-B461-AA9486421C3B}" dt="2026-09-18T06:15:35.154" v="2535" actId="1076"/>
-        <pc:sldMkLst>
-          <pc:docMk/>
-          <pc:sldMk cId="3249971736" sldId="265"/>
-        </pc:sldMkLst>
-        <pc:spChg chg="add del">
-          <ac:chgData name="SHINOHARA Soshi (篠原 想詩)" userId="309c0b21-8b61-4cd5-9d32-07652c56306e" providerId="ADAL" clId="{60D42A6B-AE32-4A06-B461-AA9486421C3B}" dt="2026-09-18T06:10:53.489" v="2476" actId="478"/>
-          <ac:spMkLst>
-            <pc:docMk/>
-            <pc:sldMk cId="3249971736" sldId="265"/>
-            <ac:spMk id="3" creationId="{6455A74A-3145-43E9-0FEA-96984B6C3345}"/>
-          </ac:spMkLst>
-        </pc:spChg>
-        <pc:spChg chg="add del">
-          <ac:chgData name="SHINOHARA Soshi (篠原 想詩)" userId="309c0b21-8b61-4cd5-9d32-07652c56306e" providerId="ADAL" clId="{60D42A6B-AE32-4A06-B461-AA9486421C3B}" dt="2026-09-18T06:10:55.834" v="2477" actId="478"/>
-          <ac:spMkLst>
-            <pc:docMk/>
-            <pc:sldMk cId="3249971736" sldId="265"/>
-            <ac:spMk id="5" creationId="{A951B59B-374D-286A-33A5-2D7F49AA888B}"/>
-          </ac:spMkLst>
-        </pc:spChg>
-        <pc:spChg chg="del">
-          <ac:chgData name="SHINOHARA Soshi (篠原 想詩)" userId="309c0b21-8b61-4cd5-9d32-07652c56306e" providerId="ADAL" clId="{60D42A6B-AE32-4A06-B461-AA9486421C3B}" dt="2026-09-18T06:10:42.448" v="2472" actId="478"/>
-          <ac:spMkLst>
-            <pc:docMk/>
-            <pc:sldMk cId="3249971736" sldId="265"/>
-            <ac:spMk id="6" creationId="{1CF1F0CB-11DA-7A96-97F4-CD39540D3032}"/>
-          </ac:spMkLst>
-        </pc:spChg>
-        <pc:spChg chg="del">
-          <ac:chgData name="SHINOHARA Soshi (篠原 想詩)" userId="309c0b21-8b61-4cd5-9d32-07652c56306e" providerId="ADAL" clId="{60D42A6B-AE32-4A06-B461-AA9486421C3B}" dt="2026-09-18T06:10:42.448" v="2472" actId="478"/>
-          <ac:spMkLst>
-            <pc:docMk/>
-            <pc:sldMk cId="3249971736" sldId="265"/>
-            <ac:spMk id="10" creationId="{9D0F0D21-0F87-47E7-8D1D-9E026C31F900}"/>
-          </ac:spMkLst>
-        </pc:spChg>
-        <pc:spChg chg="del">
-          <ac:chgData name="SHINOHARA Soshi (篠原 想詩)" userId="309c0b21-8b61-4cd5-9d32-07652c56306e" providerId="ADAL" clId="{60D42A6B-AE32-4A06-B461-AA9486421C3B}" dt="2026-09-18T06:10:42.448" v="2472" actId="478"/>
-          <ac:spMkLst>
-            <pc:docMk/>
-            <pc:sldMk cId="3249971736" sldId="265"/>
-            <ac:spMk id="14" creationId="{84292A5C-EF93-1D6D-D96F-63339C36B5DA}"/>
-          </ac:spMkLst>
-        </pc:spChg>
-        <pc:spChg chg="del">
-          <ac:chgData name="SHINOHARA Soshi (篠原 想詩)" userId="309c0b21-8b61-4cd5-9d32-07652c56306e" providerId="ADAL" clId="{60D42A6B-AE32-4A06-B461-AA9486421C3B}" dt="2026-09-18T06:10:42.448" v="2472" actId="478"/>
-          <ac:spMkLst>
-            <pc:docMk/>
-            <pc:sldMk cId="3249971736" sldId="265"/>
-            <ac:spMk id="18" creationId="{000861EA-2373-894B-6A08-36763DE3141E}"/>
-          </ac:spMkLst>
-        </pc:spChg>
-        <pc:spChg chg="del">
-          <ac:chgData name="SHINOHARA Soshi (篠原 想詩)" userId="309c0b21-8b61-4cd5-9d32-07652c56306e" providerId="ADAL" clId="{60D42A6B-AE32-4A06-B461-AA9486421C3B}" dt="2026-09-18T06:10:42.448" v="2472" actId="478"/>
-          <ac:spMkLst>
-            <pc:docMk/>
-            <pc:sldMk cId="3249971736" sldId="265"/>
-            <ac:spMk id="21" creationId="{70FA87B6-0C29-4AC4-3931-2C2B3D9862AC}"/>
-          </ac:spMkLst>
-        </pc:spChg>
-        <pc:spChg chg="del">
-          <ac:chgData name="SHINOHARA Soshi (篠原 想詩)" userId="309c0b21-8b61-4cd5-9d32-07652c56306e" providerId="ADAL" clId="{60D42A6B-AE32-4A06-B461-AA9486421C3B}" dt="2026-09-18T06:10:42.448" v="2472" actId="478"/>
-          <ac:spMkLst>
-            <pc:docMk/>
-            <pc:sldMk cId="3249971736" sldId="265"/>
-            <ac:spMk id="25" creationId="{892490C8-31AD-E3FF-0ABF-416A7E172DAD}"/>
-          </ac:spMkLst>
-        </pc:spChg>
-        <pc:spChg chg="del mod">
-          <ac:chgData name="SHINOHARA Soshi (篠原 想詩)" userId="309c0b21-8b61-4cd5-9d32-07652c56306e" providerId="ADAL" clId="{60D42A6B-AE32-4A06-B461-AA9486421C3B}" dt="2026-09-18T06:10:40.390" v="2471" actId="478"/>
-          <ac:spMkLst>
-            <pc:docMk/>
-            <pc:sldMk cId="3249971736" sldId="265"/>
-            <ac:spMk id="29" creationId="{B46D97C3-DBD4-B9B1-258F-034692CBEEA3}"/>
-          </ac:spMkLst>
-        </pc:spChg>
-        <pc:spChg chg="mod">
-          <ac:chgData name="SHINOHARA Soshi (篠原 想詩)" userId="309c0b21-8b61-4cd5-9d32-07652c56306e" providerId="ADAL" clId="{60D42A6B-AE32-4A06-B461-AA9486421C3B}" dt="2026-09-18T06:11:01.130" v="2507" actId="20577"/>
-          <ac:spMkLst>
-            <pc:docMk/>
-            <pc:sldMk cId="3249971736" sldId="265"/>
-            <ac:spMk id="21506" creationId="{EE83C36C-337B-3CAA-0B83-0A1517A40289}"/>
-          </ac:spMkLst>
-        </pc:spChg>
-        <pc:graphicFrameChg chg="add mod modGraphic">
-          <ac:chgData name="SHINOHARA Soshi (篠原 想詩)" userId="309c0b21-8b61-4cd5-9d32-07652c56306e" providerId="ADAL" clId="{60D42A6B-AE32-4A06-B461-AA9486421C3B}" dt="2026-09-18T06:15:35.154" v="2535" actId="1076"/>
-          <ac:graphicFrameMkLst>
-            <pc:docMk/>
-            <pc:sldMk cId="3249971736" sldId="265"/>
-            <ac:graphicFrameMk id="8" creationId="{58D35AA5-77A7-64BC-8911-FEFE11A99615}"/>
-          </ac:graphicFrameMkLst>
-        </pc:graphicFrameChg>
-        <pc:graphicFrameChg chg="del">
-          <ac:chgData name="SHINOHARA Soshi (篠原 想詩)" userId="309c0b21-8b61-4cd5-9d32-07652c56306e" providerId="ADAL" clId="{60D42A6B-AE32-4A06-B461-AA9486421C3B}" dt="2026-09-18T06:10:42.448" v="2472" actId="478"/>
-          <ac:graphicFrameMkLst>
-            <pc:docMk/>
-            <pc:sldMk cId="3249971736" sldId="265"/>
-            <ac:graphicFrameMk id="23" creationId="{CA1BBA50-64D8-27C8-734A-9DB62746C46C}"/>
-          </ac:graphicFrameMkLst>
-        </pc:graphicFrameChg>
-      </pc:sldChg>
-      <pc:sldMasterChg chg="del delSldLayout">
-        <pc:chgData name="SHINOHARA Soshi (篠原 想詩)" userId="309c0b21-8b61-4cd5-9d32-07652c56306e" providerId="ADAL" clId="{60D42A6B-AE32-4A06-B461-AA9486421C3B}" dt="2026-09-18T06:09:01.320" v="2396" actId="47"/>
-        <pc:sldMasterMkLst>
-          <pc:docMk/>
-          <pc:sldMasterMk cId="3019807980" sldId="2147483648"/>
-        </pc:sldMasterMkLst>
-        <pc:sldLayoutChg chg="del">
-          <pc:chgData name="SHINOHARA Soshi (篠原 想詩)" userId="309c0b21-8b61-4cd5-9d32-07652c56306e" providerId="ADAL" clId="{60D42A6B-AE32-4A06-B461-AA9486421C3B}" dt="2026-09-18T06:09:01.320" v="2396" actId="47"/>
-          <pc:sldLayoutMkLst>
-            <pc:docMk/>
-            <pc:sldMasterMk cId="3019807980" sldId="2147483648"/>
-            <pc:sldLayoutMk cId="181740245" sldId="2147483649"/>
-          </pc:sldLayoutMkLst>
-        </pc:sldLayoutChg>
-        <pc:sldLayoutChg chg="del">
-          <pc:chgData name="SHINOHARA Soshi (篠原 想詩)" userId="309c0b21-8b61-4cd5-9d32-07652c56306e" providerId="ADAL" clId="{60D42A6B-AE32-4A06-B461-AA9486421C3B}" dt="2026-09-18T06:09:01.320" v="2396" actId="47"/>
-          <pc:sldLayoutMkLst>
-            <pc:docMk/>
-            <pc:sldMasterMk cId="3019807980" sldId="2147483648"/>
-            <pc:sldLayoutMk cId="1262986352" sldId="2147483650"/>
-          </pc:sldLayoutMkLst>
-        </pc:sldLayoutChg>
-        <pc:sldLayoutChg chg="del">
-          <pc:chgData name="SHINOHARA Soshi (篠原 想詩)" userId="309c0b21-8b61-4cd5-9d32-07652c56306e" providerId="ADAL" clId="{60D42A6B-AE32-4A06-B461-AA9486421C3B}" dt="2026-09-18T06:09:01.320" v="2396" actId="47"/>
-          <pc:sldLayoutMkLst>
-            <pc:docMk/>
-            <pc:sldMasterMk cId="3019807980" sldId="2147483648"/>
-            <pc:sldLayoutMk cId="1801365498" sldId="2147483651"/>
-          </pc:sldLayoutMkLst>
-        </pc:sldLayoutChg>
-        <pc:sldLayoutChg chg="del">
-          <pc:chgData name="SHINOHARA Soshi (篠原 想詩)" userId="309c0b21-8b61-4cd5-9d32-07652c56306e" providerId="ADAL" clId="{60D42A6B-AE32-4A06-B461-AA9486421C3B}" dt="2026-09-18T06:09:01.320" v="2396" actId="47"/>
-          <pc:sldLayoutMkLst>
-            <pc:docMk/>
-            <pc:sldMasterMk cId="3019807980" sldId="2147483648"/>
-            <pc:sldLayoutMk cId="1707429675" sldId="2147483652"/>
-          </pc:sldLayoutMkLst>
-        </pc:sldLayoutChg>
-        <pc:sldLayoutChg chg="del">
-          <pc:chgData name="SHINOHARA Soshi (篠原 想詩)" userId="309c0b21-8b61-4cd5-9d32-07652c56306e" providerId="ADAL" clId="{60D42A6B-AE32-4A06-B461-AA9486421C3B}" dt="2026-09-18T06:09:01.320" v="2396" actId="47"/>
-          <pc:sldLayoutMkLst>
-            <pc:docMk/>
-            <pc:sldMasterMk cId="3019807980" sldId="2147483648"/>
-            <pc:sldLayoutMk cId="3447607662" sldId="2147483653"/>
-          </pc:sldLayoutMkLst>
-        </pc:sldLayoutChg>
-        <pc:sldLayoutChg chg="del">
-          <pc:chgData name="SHINOHARA Soshi (篠原 想詩)" userId="309c0b21-8b61-4cd5-9d32-07652c56306e" providerId="ADAL" clId="{60D42A6B-AE32-4A06-B461-AA9486421C3B}" dt="2026-09-18T06:09:01.320" v="2396" actId="47"/>
-          <pc:sldLayoutMkLst>
-            <pc:docMk/>
-            <pc:sldMasterMk cId="3019807980" sldId="2147483648"/>
-            <pc:sldLayoutMk cId="3774007086" sldId="2147483654"/>
-          </pc:sldLayoutMkLst>
-        </pc:sldLayoutChg>
-        <pc:sldLayoutChg chg="del">
-          <pc:chgData name="SHINOHARA Soshi (篠原 想詩)" userId="309c0b21-8b61-4cd5-9d32-07652c56306e" providerId="ADAL" clId="{60D42A6B-AE32-4A06-B461-AA9486421C3B}" dt="2026-09-18T06:09:01.320" v="2396" actId="47"/>
-          <pc:sldLayoutMkLst>
-            <pc:docMk/>
-            <pc:sldMasterMk cId="3019807980" sldId="2147483648"/>
-            <pc:sldLayoutMk cId="2525697723" sldId="2147483655"/>
-          </pc:sldLayoutMkLst>
-        </pc:sldLayoutChg>
-        <pc:sldLayoutChg chg="del">
-          <pc:chgData name="SHINOHARA Soshi (篠原 想詩)" userId="309c0b21-8b61-4cd5-9d32-07652c56306e" providerId="ADAL" clId="{60D42A6B-AE32-4A06-B461-AA9486421C3B}" dt="2026-09-18T06:09:01.320" v="2396" actId="47"/>
-          <pc:sldLayoutMkLst>
-            <pc:docMk/>
-            <pc:sldMasterMk cId="3019807980" sldId="2147483648"/>
-            <pc:sldLayoutMk cId="1592917292" sldId="2147483656"/>
-          </pc:sldLayoutMkLst>
-        </pc:sldLayoutChg>
-        <pc:sldLayoutChg chg="del">
-          <pc:chgData name="SHINOHARA Soshi (篠原 想詩)" userId="309c0b21-8b61-4cd5-9d32-07652c56306e" providerId="ADAL" clId="{60D42A6B-AE32-4A06-B461-AA9486421C3B}" dt="2026-09-18T06:09:01.320" v="2396" actId="47"/>
-          <pc:sldLayoutMkLst>
-            <pc:docMk/>
-            <pc:sldMasterMk cId="3019807980" sldId="2147483648"/>
-            <pc:sldLayoutMk cId="2073493225" sldId="2147483657"/>
-          </pc:sldLayoutMkLst>
-        </pc:sldLayoutChg>
-        <pc:sldLayoutChg chg="del">
-          <pc:chgData name="SHINOHARA Soshi (篠原 想詩)" userId="309c0b21-8b61-4cd5-9d32-07652c56306e" providerId="ADAL" clId="{60D42A6B-AE32-4A06-B461-AA9486421C3B}" dt="2026-09-18T06:09:01.320" v="2396" actId="47"/>
-          <pc:sldLayoutMkLst>
-            <pc:docMk/>
-            <pc:sldMasterMk cId="3019807980" sldId="2147483648"/>
-            <pc:sldLayoutMk cId="468604226" sldId="2147483658"/>
-          </pc:sldLayoutMkLst>
-        </pc:sldLayoutChg>
-        <pc:sldLayoutChg chg="del">
-          <pc:chgData name="SHINOHARA Soshi (篠原 想詩)" userId="309c0b21-8b61-4cd5-9d32-07652c56306e" providerId="ADAL" clId="{60D42A6B-AE32-4A06-B461-AA9486421C3B}" dt="2026-09-18T06:09:01.320" v="2396" actId="47"/>
-          <pc:sldLayoutMkLst>
-            <pc:docMk/>
-            <pc:sldMasterMk cId="3019807980" sldId="2147483648"/>
-            <pc:sldLayoutMk cId="1426030442" sldId="2147483659"/>
-          </pc:sldLayoutMkLst>
-        </pc:sldLayoutChg>
-      </pc:sldMasterChg>
     </pc:docChg>
   </pc:docChgLst>
 </pc:chgInfo>
@@ -5695,7 +4427,7 @@
                   </a:schemeClr>
                 </a:solidFill>
               </a:rPr>
-              <a:t>10</a:t>
+              <a:t>9</a:t>
             </a:r>
             <a:r>
               <a:rPr lang="ja-JP" altLang="en-US" sz="5400" kern="0" dirty="0">
@@ -8797,13 +7529,6 @@
               </a:rPr>
               <a:t>・改良点だけをver.2本体へ統合(設定読み込み1回化・空欄スキップ・送信漏れで中断)。</a:t>
             </a:r>
-            <a:endParaRPr lang="ja-JP" altLang="en-US" sz="1600" b="0" dirty="0">
-              <a:solidFill>
-                <a:srgbClr val="000000"/>
-              </a:solidFill>
-              <a:latin typeface="Meiryo"/>
-              <a:ea typeface="Meiryo"/>
-            </a:endParaRPr>
           </a:p>
           <a:p>
             <a:pPr algn="l">
@@ -8824,13 +7549,6 @@
               </a:rPr>
               <a:t>・旧版の実績を尊重し、勝手な書き換えはしない方針で改修。</a:t>
             </a:r>
-            <a:endParaRPr lang="ja-JP" altLang="en-US" sz="1600" b="0" dirty="0">
-              <a:solidFill>
-                <a:srgbClr val="000000"/>
-              </a:solidFill>
-              <a:latin typeface="Meiryo"/>
-              <a:ea typeface="Meiryo"/>
-            </a:endParaRPr>
           </a:p>
           <a:p>
             <a:pPr algn="l">
@@ -8851,13 +7569,6 @@
               </a:rPr>
               <a:t>・テストケース47件を作成し、コンパイル→試し実行10件→本番1件→10件の段階で検証する。</a:t>
             </a:r>
-            <a:endParaRPr lang="ja-JP" altLang="en-US" sz="1600" b="0" dirty="0">
-              <a:solidFill>
-                <a:srgbClr val="000000"/>
-              </a:solidFill>
-              <a:latin typeface="Meiryo"/>
-              <a:ea typeface="Meiryo"/>
-            </a:endParaRPr>
           </a:p>
         </p:txBody>
       </p:sp>
@@ -9932,13 +8643,6 @@
               </a:rPr>
               <a:t>実施時期：10月末 本番(予定)</a:t>
             </a:r>
-            <a:endParaRPr lang="ja-JP" altLang="en-US" sz="1400" b="0" dirty="0">
-              <a:solidFill>
-                <a:srgbClr val="666666"/>
-              </a:solidFill>
-              <a:latin typeface="Meiryo"/>
-              <a:ea typeface="Meiryo"/>
-            </a:endParaRPr>
           </a:p>
         </p:txBody>
       </p:sp>
@@ -10948,7 +9652,7 @@
                 </a:tc>
                 <a:extLst>
                   <a:ext uri="{0D108BD9-81ED-4DB2-BD59-A6C34878D82A}">
-                    <a16:rowId xmlns:a16="http://schemas.microsoft.com/office/drawing/2014/main" val="10004"/>
+                    <a16:rowId xmlns:a16="http://schemas.microsoft.com/office/drawing/2014/main" val="3817583905"/>
                   </a:ext>
                 </a:extLst>
               </a:tr>
@@ -11087,7 +9791,7 @@
                 </a:tc>
                 <a:extLst>
                   <a:ext uri="{0D108BD9-81ED-4DB2-BD59-A6C34878D82A}">
-                    <a16:rowId xmlns:a16="http://schemas.microsoft.com/office/drawing/2014/main" val="10004"/>
+                    <a16:rowId xmlns:a16="http://schemas.microsoft.com/office/drawing/2014/main" val="2954010635"/>
                   </a:ext>
                 </a:extLst>
               </a:tr>
@@ -11226,7 +9930,7 @@
                 </a:tc>
                 <a:extLst>
                   <a:ext uri="{0D108BD9-81ED-4DB2-BD59-A6C34878D82A}">
-                    <a16:rowId xmlns:a16="http://schemas.microsoft.com/office/drawing/2014/main" val="10004"/>
+                    <a16:rowId xmlns:a16="http://schemas.microsoft.com/office/drawing/2014/main" val="1548618165"/>
                   </a:ext>
                 </a:extLst>
               </a:tr>
@@ -11365,7 +10069,7 @@
                 </a:tc>
                 <a:extLst>
                   <a:ext uri="{0D108BD9-81ED-4DB2-BD59-A6C34878D82A}">
-                    <a16:rowId xmlns:a16="http://schemas.microsoft.com/office/drawing/2014/main" val="10004"/>
+                    <a16:rowId xmlns:a16="http://schemas.microsoft.com/office/drawing/2014/main" val="230949805"/>
                   </a:ext>
                 </a:extLst>
               </a:tr>

</xml_diff>

<commit_message>
sync(workvault): 2026-10-21 17:34 差分 2 件
</commit_message>
<xml_diff>
--- a/workvault-sync/10_業務全般/業務報告/10月業務報告(篠原).pptx
+++ b/workvault-sync/10_業務全般/業務報告/10月業務報告(篠原).pptx
@@ -117,30 +117,1298 @@
 </p:presentation>
 </file>
 
+<file path=ppt/revisionInfo.xml><?xml version="1.0" encoding="utf-8"?>
+<p1510:revInfo xmlns:a="http://schemas.openxmlformats.org/drawingml/2006/main" xmlns:r="http://schemas.openxmlformats.org/officeDocument/2006/relationships" xmlns:p1510="http://schemas.microsoft.com/office/powerpoint/2015/10/main">
+  <p1510:revLst>
+    <p1510:client id="{A13B977E-83BD-4364-9C7A-8EA8A549CE76}" v="67" dt="2026-09-18T06:10:57.359"/>
+  </p1510:revLst>
+</p1510:revInfo>
+</file>
+
 <file path=ppt/changesInfos/changesInfo1.xml><?xml version="1.0" encoding="utf-8"?>
 <pc:chgInfo xmlns:a="http://schemas.openxmlformats.org/drawingml/2006/main" xmlns:r="http://schemas.openxmlformats.org/officeDocument/2006/relationships" xmlns:ac="http://schemas.microsoft.com/office/drawing/2013/main/command" xmlns:pc="http://schemas.microsoft.com/office/powerpoint/2013/main/command">
   <pc:docChgLst>
     <pc:chgData name="SHINOHARA Soshi (篠原 想詩)" userId="309c0b21-8b61-4cd5-9d32-07652c56306e" providerId="ADAL" clId="{60D42A6B-AE32-4A06-B461-AA9486421C3B}"/>
     <pc:docChg chg="undo custSel addSld delSld modSld sldOrd delMainMaster">
-      <pc:chgData name="SHINOHARA Soshi (篠原 想詩)" userId="309c0b21-8b61-4cd5-9d32-07652c56306e" providerId="ADAL" clId="{60D42A6B-AE32-4A06-B461-AA9486421C3B}" dt="2026-10-21T08:22:14.415" v="2588" actId="20577"/>
+      <pc:chgData name="SHINOHARA Soshi (篠原 想詩)" userId="309c0b21-8b61-4cd5-9d32-07652c56306e" providerId="ADAL" clId="{60D42A6B-AE32-4A06-B461-AA9486421C3B}" dt="2026-09-18T07:27:41.343" v="2583" actId="20577"/>
       <pc:docMkLst>
         <pc:docMk/>
       </pc:docMkLst>
+      <pc:sldChg chg="del">
+        <pc:chgData name="SHINOHARA Soshi (篠原 想詩)" userId="309c0b21-8b61-4cd5-9d32-07652c56306e" providerId="ADAL" clId="{60D42A6B-AE32-4A06-B461-AA9486421C3B}" dt="2026-09-18T06:09:00.715" v="2395" actId="47"/>
+        <pc:sldMkLst>
+          <pc:docMk/>
+          <pc:sldMk cId="2775494873" sldId="256"/>
+        </pc:sldMkLst>
+      </pc:sldChg>
+      <pc:sldChg chg="addSp delSp modSp new del mod">
+        <pc:chgData name="SHINOHARA Soshi (篠原 想詩)" userId="309c0b21-8b61-4cd5-9d32-07652c56306e" providerId="ADAL" clId="{60D42A6B-AE32-4A06-B461-AA9486421C3B}" dt="2026-09-18T06:09:01.320" v="2396" actId="47"/>
+        <pc:sldMkLst>
+          <pc:docMk/>
+          <pc:sldMk cId="2238980019" sldId="257"/>
+        </pc:sldMkLst>
+        <pc:spChg chg="del">
+          <ac:chgData name="SHINOHARA Soshi (篠原 想詩)" userId="309c0b21-8b61-4cd5-9d32-07652c56306e" providerId="ADAL" clId="{60D42A6B-AE32-4A06-B461-AA9486421C3B}" dt="2026-09-18T05:11:48.559" v="2" actId="478"/>
+          <ac:spMkLst>
+            <pc:docMk/>
+            <pc:sldMk cId="2238980019" sldId="257"/>
+            <ac:spMk id="2" creationId="{394D9B7B-7D5B-7DBA-ABDB-D47E65809127}"/>
+          </ac:spMkLst>
+        </pc:spChg>
+        <pc:spChg chg="del">
+          <ac:chgData name="SHINOHARA Soshi (篠原 想詩)" userId="309c0b21-8b61-4cd5-9d32-07652c56306e" providerId="ADAL" clId="{60D42A6B-AE32-4A06-B461-AA9486421C3B}" dt="2026-09-18T05:11:47.940" v="1" actId="478"/>
+          <ac:spMkLst>
+            <pc:docMk/>
+            <pc:sldMk cId="2238980019" sldId="257"/>
+            <ac:spMk id="3" creationId="{26DF8E07-B2DA-7105-C165-EE27C7BA2409}"/>
+          </ac:spMkLst>
+        </pc:spChg>
+        <pc:graphicFrameChg chg="add del mod">
+          <ac:chgData name="SHINOHARA Soshi (篠原 想詩)" userId="309c0b21-8b61-4cd5-9d32-07652c56306e" providerId="ADAL" clId="{60D42A6B-AE32-4A06-B461-AA9486421C3B}" dt="2026-09-18T05:12:05.751" v="5" actId="478"/>
+          <ac:graphicFrameMkLst>
+            <pc:docMk/>
+            <pc:sldMk cId="2238980019" sldId="257"/>
+            <ac:graphicFrameMk id="4" creationId="{492B0FED-8F60-8C69-B5F2-5450775EA0FF}"/>
+          </ac:graphicFrameMkLst>
+        </pc:graphicFrameChg>
+      </pc:sldChg>
       <pc:sldChg chg="addSp delSp modSp add del mod">
-        <pc:chgData name="SHINOHARA Soshi (篠原 想詩)" userId="309c0b21-8b61-4cd5-9d32-07652c56306e" providerId="ADAL" clId="{60D42A6B-AE32-4A06-B461-AA9486421C3B}" dt="2026-10-21T08:22:14.415" v="2588" actId="20577"/>
+        <pc:chgData name="SHINOHARA Soshi (篠原 想詩)" userId="309c0b21-8b61-4cd5-9d32-07652c56306e" providerId="ADAL" clId="{60D42A6B-AE32-4A06-B461-AA9486421C3B}" dt="2026-09-18T05:52:20.736" v="1612" actId="20577"/>
         <pc:sldMkLst>
           <pc:docMk/>
           <pc:sldMk cId="0" sldId="258"/>
         </pc:sldMkLst>
+        <pc:spChg chg="add del mod">
+          <ac:chgData name="SHINOHARA Soshi (篠原 想詩)" userId="309c0b21-8b61-4cd5-9d32-07652c56306e" providerId="ADAL" clId="{60D42A6B-AE32-4A06-B461-AA9486421C3B}" dt="2026-09-18T05:15:21.052" v="58" actId="21"/>
+          <ac:spMkLst>
+            <pc:docMk/>
+            <pc:sldMk cId="0" sldId="258"/>
+            <ac:spMk id="2" creationId="{94DD132E-067B-7378-CD64-23C9EC5B506B}"/>
+          </ac:spMkLst>
+        </pc:spChg>
         <pc:spChg chg="add mod">
-          <ac:chgData name="SHINOHARA Soshi (篠原 想詩)" userId="309c0b21-8b61-4cd5-9d32-07652c56306e" providerId="ADAL" clId="{60D42A6B-AE32-4A06-B461-AA9486421C3B}" dt="2026-10-21T08:22:14.415" v="2588" actId="20577"/>
+          <ac:chgData name="SHINOHARA Soshi (篠原 想詩)" userId="309c0b21-8b61-4cd5-9d32-07652c56306e" providerId="ADAL" clId="{60D42A6B-AE32-4A06-B461-AA9486421C3B}" dt="2026-09-18T05:52:20.736" v="1612" actId="20577"/>
+          <ac:spMkLst>
+            <pc:docMk/>
+            <pc:sldMk cId="0" sldId="258"/>
+            <ac:spMk id="3" creationId="{D8611FDF-9B1D-9612-327D-9456F6143916}"/>
+          </ac:spMkLst>
+        </pc:spChg>
+        <pc:spChg chg="add del mod">
+          <ac:chgData name="SHINOHARA Soshi (篠原 想詩)" userId="309c0b21-8b61-4cd5-9d32-07652c56306e" providerId="ADAL" clId="{60D42A6B-AE32-4A06-B461-AA9486421C3B}" dt="2026-09-18T05:15:29.082" v="64" actId="478"/>
+          <ac:spMkLst>
+            <pc:docMk/>
+            <pc:sldMk cId="0" sldId="258"/>
+            <ac:spMk id="4" creationId="{EB812D85-C2CF-8FAD-F086-3119E0647715}"/>
+          </ac:spMkLst>
+        </pc:spChg>
+        <pc:spChg chg="add del mod">
+          <ac:chgData name="SHINOHARA Soshi (篠原 想詩)" userId="309c0b21-8b61-4cd5-9d32-07652c56306e" providerId="ADAL" clId="{60D42A6B-AE32-4A06-B461-AA9486421C3B}" dt="2026-09-18T05:15:27.457" v="63" actId="21"/>
+          <ac:spMkLst>
+            <pc:docMk/>
+            <pc:sldMk cId="0" sldId="258"/>
+            <ac:spMk id="6" creationId="{31E1ED1F-4204-68E6-245A-F1A17FB2943C}"/>
+          </ac:spMkLst>
+        </pc:spChg>
+        <pc:spChg chg="add mod">
+          <ac:chgData name="SHINOHARA Soshi (篠原 想詩)" userId="309c0b21-8b61-4cd5-9d32-07652c56306e" providerId="ADAL" clId="{60D42A6B-AE32-4A06-B461-AA9486421C3B}" dt="2026-09-18T05:21:48.287" v="207" actId="1076"/>
           <ac:spMkLst>
             <pc:docMk/>
             <pc:sldMk cId="0" sldId="258"/>
             <ac:spMk id="8" creationId="{D2FA8936-D68E-6874-8EB3-C9A079275CE7}"/>
           </ac:spMkLst>
         </pc:spChg>
+        <pc:spChg chg="del mod">
+          <ac:chgData name="SHINOHARA Soshi (篠原 想詩)" userId="309c0b21-8b61-4cd5-9d32-07652c56306e" providerId="ADAL" clId="{60D42A6B-AE32-4A06-B461-AA9486421C3B}" dt="2026-09-18T05:15:22.292" v="59" actId="478"/>
+          <ac:spMkLst>
+            <pc:docMk/>
+            <pc:sldMk cId="0" sldId="258"/>
+            <ac:spMk id="5125" creationId="{ED21CF95-DAEB-0ED1-2F64-90E9C5261A33}"/>
+          </ac:spMkLst>
+        </pc:spChg>
+        <pc:spChg chg="del">
+          <ac:chgData name="SHINOHARA Soshi (篠原 想詩)" userId="309c0b21-8b61-4cd5-9d32-07652c56306e" providerId="ADAL" clId="{60D42A6B-AE32-4A06-B461-AA9486421C3B}" dt="2026-09-18T05:15:34.042" v="66" actId="478"/>
+          <ac:spMkLst>
+            <pc:docMk/>
+            <pc:sldMk cId="0" sldId="258"/>
+            <ac:spMk id="5126" creationId="{7F2BCA0B-F299-74C5-96D3-C3D6EF19918A}"/>
+          </ac:spMkLst>
+        </pc:spChg>
       </pc:sldChg>
+      <pc:sldChg chg="addSp delSp modSp add del mod">
+        <pc:chgData name="SHINOHARA Soshi (篠原 想詩)" userId="309c0b21-8b61-4cd5-9d32-07652c56306e" providerId="ADAL" clId="{60D42A6B-AE32-4A06-B461-AA9486421C3B}" dt="2026-09-18T06:10:48.715" v="2475" actId="47"/>
+        <pc:sldMkLst>
+          <pc:docMk/>
+          <pc:sldMk cId="0" sldId="259"/>
+        </pc:sldMkLst>
+        <pc:spChg chg="add del">
+          <ac:chgData name="SHINOHARA Soshi (篠原 想詩)" userId="309c0b21-8b61-4cd5-9d32-07652c56306e" providerId="ADAL" clId="{60D42A6B-AE32-4A06-B461-AA9486421C3B}" dt="2026-09-18T05:24:57.783" v="258" actId="21"/>
+          <ac:spMkLst>
+            <pc:docMk/>
+            <pc:sldMk cId="0" sldId="259"/>
+            <ac:spMk id="5" creationId="{16BEEDCE-E230-E6CC-9D69-9CE4C12B6E65}"/>
+          </ac:spMkLst>
+        </pc:spChg>
+        <pc:spChg chg="add del">
+          <ac:chgData name="SHINOHARA Soshi (篠原 想詩)" userId="309c0b21-8b61-4cd5-9d32-07652c56306e" providerId="ADAL" clId="{60D42A6B-AE32-4A06-B461-AA9486421C3B}" dt="2026-09-18T05:24:57.783" v="258" actId="21"/>
+          <ac:spMkLst>
+            <pc:docMk/>
+            <pc:sldMk cId="0" sldId="259"/>
+            <ac:spMk id="7" creationId="{794BAA89-82D5-064F-1037-F3EDA1FF681E}"/>
+          </ac:spMkLst>
+        </pc:spChg>
+        <pc:spChg chg="add del">
+          <ac:chgData name="SHINOHARA Soshi (篠原 想詩)" userId="309c0b21-8b61-4cd5-9d32-07652c56306e" providerId="ADAL" clId="{60D42A6B-AE32-4A06-B461-AA9486421C3B}" dt="2026-09-18T05:24:57.783" v="258" actId="21"/>
+          <ac:spMkLst>
+            <pc:docMk/>
+            <pc:sldMk cId="0" sldId="259"/>
+            <ac:spMk id="13" creationId="{DB6929EC-8CFE-8684-4905-C662CE9BE12D}"/>
+          </ac:spMkLst>
+        </pc:spChg>
+        <pc:spChg chg="add del">
+          <ac:chgData name="SHINOHARA Soshi (篠原 想詩)" userId="309c0b21-8b61-4cd5-9d32-07652c56306e" providerId="ADAL" clId="{60D42A6B-AE32-4A06-B461-AA9486421C3B}" dt="2026-09-18T05:24:57.783" v="258" actId="21"/>
+          <ac:spMkLst>
+            <pc:docMk/>
+            <pc:sldMk cId="0" sldId="259"/>
+            <ac:spMk id="15" creationId="{416E2D99-8C5A-832E-B72D-3136EB456A41}"/>
+          </ac:spMkLst>
+        </pc:spChg>
+        <pc:spChg chg="add del">
+          <ac:chgData name="SHINOHARA Soshi (篠原 想詩)" userId="309c0b21-8b61-4cd5-9d32-07652c56306e" providerId="ADAL" clId="{60D42A6B-AE32-4A06-B461-AA9486421C3B}" dt="2026-09-18T05:24:57.783" v="258" actId="21"/>
+          <ac:spMkLst>
+            <pc:docMk/>
+            <pc:sldMk cId="0" sldId="259"/>
+            <ac:spMk id="17" creationId="{2B21E95C-2D0A-5FC1-3149-E4B9CCFAD21E}"/>
+          </ac:spMkLst>
+        </pc:spChg>
+        <pc:spChg chg="add del">
+          <ac:chgData name="SHINOHARA Soshi (篠原 想詩)" userId="309c0b21-8b61-4cd5-9d32-07652c56306e" providerId="ADAL" clId="{60D42A6B-AE32-4A06-B461-AA9486421C3B}" dt="2026-09-18T05:24:57.783" v="258" actId="21"/>
+          <ac:spMkLst>
+            <pc:docMk/>
+            <pc:sldMk cId="0" sldId="259"/>
+            <ac:spMk id="23" creationId="{419E1F2C-F215-144D-EDD1-43FD3B28E70F}"/>
+          </ac:spMkLst>
+        </pc:spChg>
+        <pc:spChg chg="add del">
+          <ac:chgData name="SHINOHARA Soshi (篠原 想詩)" userId="309c0b21-8b61-4cd5-9d32-07652c56306e" providerId="ADAL" clId="{60D42A6B-AE32-4A06-B461-AA9486421C3B}" dt="2026-09-18T05:24:57.783" v="258" actId="21"/>
+          <ac:spMkLst>
+            <pc:docMk/>
+            <pc:sldMk cId="0" sldId="259"/>
+            <ac:spMk id="29" creationId="{6A6720B2-6AE5-C69A-25D4-DA3CC3F19CCD}"/>
+          </ac:spMkLst>
+        </pc:spChg>
+        <pc:spChg chg="add del">
+          <ac:chgData name="SHINOHARA Soshi (篠原 想詩)" userId="309c0b21-8b61-4cd5-9d32-07652c56306e" providerId="ADAL" clId="{60D42A6B-AE32-4A06-B461-AA9486421C3B}" dt="2026-09-18T05:24:57.783" v="258" actId="21"/>
+          <ac:spMkLst>
+            <pc:docMk/>
+            <pc:sldMk cId="0" sldId="259"/>
+            <ac:spMk id="31" creationId="{A0DD7059-571E-3CD1-FCA7-1BE1DCA6BE1C}"/>
+          </ac:spMkLst>
+        </pc:spChg>
+        <pc:spChg chg="del">
+          <ac:chgData name="SHINOHARA Soshi (篠原 想詩)" userId="309c0b21-8b61-4cd5-9d32-07652c56306e" providerId="ADAL" clId="{60D42A6B-AE32-4A06-B461-AA9486421C3B}" dt="2026-09-18T05:24:39.639" v="251" actId="478"/>
+          <ac:spMkLst>
+            <pc:docMk/>
+            <pc:sldMk cId="0" sldId="259"/>
+            <ac:spMk id="20482" creationId="{C2E6D61F-0D42-AF61-3931-B76E4F1180F0}"/>
+          </ac:spMkLst>
+        </pc:spChg>
+        <pc:spChg chg="del">
+          <ac:chgData name="SHINOHARA Soshi (篠原 想詩)" userId="309c0b21-8b61-4cd5-9d32-07652c56306e" providerId="ADAL" clId="{60D42A6B-AE32-4A06-B461-AA9486421C3B}" dt="2026-09-18T05:24:38.450" v="250" actId="478"/>
+          <ac:spMkLst>
+            <pc:docMk/>
+            <pc:sldMk cId="0" sldId="259"/>
+            <ac:spMk id="20483" creationId="{84BA23FB-9E78-A665-BF63-41765197AD3A}"/>
+          </ac:spMkLst>
+        </pc:spChg>
+        <pc:spChg chg="add del">
+          <ac:chgData name="SHINOHARA Soshi (篠原 想詩)" userId="309c0b21-8b61-4cd5-9d32-07652c56306e" providerId="ADAL" clId="{60D42A6B-AE32-4A06-B461-AA9486421C3B}" dt="2026-09-18T05:24:57.783" v="258" actId="21"/>
+          <ac:spMkLst>
+            <pc:docMk/>
+            <pc:sldMk cId="0" sldId="259"/>
+            <ac:spMk id="20485" creationId="{DF9AC646-2B61-3D6E-DFEB-A5150BDEB0C4}"/>
+          </ac:spMkLst>
+        </pc:spChg>
+        <pc:spChg chg="add del">
+          <ac:chgData name="SHINOHARA Soshi (篠原 想詩)" userId="309c0b21-8b61-4cd5-9d32-07652c56306e" providerId="ADAL" clId="{60D42A6B-AE32-4A06-B461-AA9486421C3B}" dt="2026-09-18T05:24:57.783" v="258" actId="21"/>
+          <ac:spMkLst>
+            <pc:docMk/>
+            <pc:sldMk cId="0" sldId="259"/>
+            <ac:spMk id="20487" creationId="{F7FC0BCA-043E-0E54-8C10-046E4FE3C7D0}"/>
+          </ac:spMkLst>
+        </pc:spChg>
+        <pc:spChg chg="add del">
+          <ac:chgData name="SHINOHARA Soshi (篠原 想詩)" userId="309c0b21-8b61-4cd5-9d32-07652c56306e" providerId="ADAL" clId="{60D42A6B-AE32-4A06-B461-AA9486421C3B}" dt="2026-09-18T05:54:47.953" v="1670" actId="21"/>
+          <ac:spMkLst>
+            <pc:docMk/>
+            <pc:sldMk cId="0" sldId="259"/>
+            <ac:spMk id="20495" creationId="{A4D9F973-0BFC-4A86-98E9-A2CEAA78CA76}"/>
+          </ac:spMkLst>
+        </pc:spChg>
+        <pc:spChg chg="add del">
+          <ac:chgData name="SHINOHARA Soshi (篠原 想詩)" userId="309c0b21-8b61-4cd5-9d32-07652c56306e" providerId="ADAL" clId="{60D42A6B-AE32-4A06-B461-AA9486421C3B}" dt="2026-09-18T05:54:47.953" v="1670" actId="21"/>
+          <ac:spMkLst>
+            <pc:docMk/>
+            <pc:sldMk cId="0" sldId="259"/>
+            <ac:spMk id="20497" creationId="{60E1E6C4-9748-E7D8-1558-58C343E33BE3}"/>
+          </ac:spMkLst>
+        </pc:spChg>
+        <pc:spChg chg="add del">
+          <ac:chgData name="SHINOHARA Soshi (篠原 想詩)" userId="309c0b21-8b61-4cd5-9d32-07652c56306e" providerId="ADAL" clId="{60D42A6B-AE32-4A06-B461-AA9486421C3B}" dt="2026-09-18T05:54:47.953" v="1670" actId="21"/>
+          <ac:spMkLst>
+            <pc:docMk/>
+            <pc:sldMk cId="0" sldId="259"/>
+            <ac:spMk id="20499" creationId="{EAA122E3-0D87-FCBF-BA03-998D81E61207}"/>
+          </ac:spMkLst>
+        </pc:spChg>
+        <pc:spChg chg="add del">
+          <ac:chgData name="SHINOHARA Soshi (篠原 想詩)" userId="309c0b21-8b61-4cd5-9d32-07652c56306e" providerId="ADAL" clId="{60D42A6B-AE32-4A06-B461-AA9486421C3B}" dt="2026-09-18T05:54:47.953" v="1670" actId="21"/>
+          <ac:spMkLst>
+            <pc:docMk/>
+            <pc:sldMk cId="0" sldId="259"/>
+            <ac:spMk id="20501" creationId="{CC951E02-3EED-A2A4-78BA-01B7677F5FE0}"/>
+          </ac:spMkLst>
+        </pc:spChg>
+        <pc:spChg chg="add del">
+          <ac:chgData name="SHINOHARA Soshi (篠原 想詩)" userId="309c0b21-8b61-4cd5-9d32-07652c56306e" providerId="ADAL" clId="{60D42A6B-AE32-4A06-B461-AA9486421C3B}" dt="2026-09-18T05:54:47.953" v="1670" actId="21"/>
+          <ac:spMkLst>
+            <pc:docMk/>
+            <pc:sldMk cId="0" sldId="259"/>
+            <ac:spMk id="20503" creationId="{8BD3BB66-8271-E186-77BC-128680E7F29E}"/>
+          </ac:spMkLst>
+        </pc:spChg>
+        <pc:spChg chg="add del">
+          <ac:chgData name="SHINOHARA Soshi (篠原 想詩)" userId="309c0b21-8b61-4cd5-9d32-07652c56306e" providerId="ADAL" clId="{60D42A6B-AE32-4A06-B461-AA9486421C3B}" dt="2026-09-18T05:54:47.953" v="1670" actId="21"/>
+          <ac:spMkLst>
+            <pc:docMk/>
+            <pc:sldMk cId="0" sldId="259"/>
+            <ac:spMk id="20505" creationId="{CD1701D2-1FA7-DA35-1AE9-70AF37EB9638}"/>
+          </ac:spMkLst>
+        </pc:spChg>
+        <pc:spChg chg="add del">
+          <ac:chgData name="SHINOHARA Soshi (篠原 想詩)" userId="309c0b21-8b61-4cd5-9d32-07652c56306e" providerId="ADAL" clId="{60D42A6B-AE32-4A06-B461-AA9486421C3B}" dt="2026-09-18T05:54:47.953" v="1670" actId="21"/>
+          <ac:spMkLst>
+            <pc:docMk/>
+            <pc:sldMk cId="0" sldId="259"/>
+            <ac:spMk id="20509" creationId="{F4B2CC77-088B-2831-4A36-A00BB8BF21FF}"/>
+          </ac:spMkLst>
+        </pc:spChg>
+        <pc:spChg chg="add del mod">
+          <ac:chgData name="SHINOHARA Soshi (篠原 想詩)" userId="309c0b21-8b61-4cd5-9d32-07652c56306e" providerId="ADAL" clId="{60D42A6B-AE32-4A06-B461-AA9486421C3B}" dt="2026-09-18T06:10:46.655" v="2473" actId="21"/>
+          <ac:spMkLst>
+            <pc:docMk/>
+            <pc:sldMk cId="0" sldId="259"/>
+            <ac:spMk id="20511" creationId="{EFF9C31E-7D98-E5C9-EF36-0A4482974082}"/>
+          </ac:spMkLst>
+        </pc:spChg>
+        <pc:spChg chg="add del">
+          <ac:chgData name="SHINOHARA Soshi (篠原 想詩)" userId="309c0b21-8b61-4cd5-9d32-07652c56306e" providerId="ADAL" clId="{60D42A6B-AE32-4A06-B461-AA9486421C3B}" dt="2026-09-18T06:10:46.655" v="2473" actId="21"/>
+          <ac:spMkLst>
+            <pc:docMk/>
+            <pc:sldMk cId="0" sldId="259"/>
+            <ac:spMk id="20513" creationId="{69CA037E-58DF-B94A-390E-DB0582B51D3E}"/>
+          </ac:spMkLst>
+        </pc:spChg>
+        <pc:graphicFrameChg chg="add del">
+          <ac:chgData name="SHINOHARA Soshi (篠原 想詩)" userId="309c0b21-8b61-4cd5-9d32-07652c56306e" providerId="ADAL" clId="{60D42A6B-AE32-4A06-B461-AA9486421C3B}" dt="2026-09-18T05:54:47.953" v="1670" actId="21"/>
+          <ac:graphicFrameMkLst>
+            <pc:docMk/>
+            <pc:sldMk cId="0" sldId="259"/>
+            <ac:graphicFrameMk id="20507" creationId="{8E7682B8-07FA-EC1B-AB2C-C18C0BCA5CD5}"/>
+          </ac:graphicFrameMkLst>
+        </pc:graphicFrameChg>
+        <pc:graphicFrameChg chg="add del mod modGraphic">
+          <ac:chgData name="SHINOHARA Soshi (篠原 想詩)" userId="309c0b21-8b61-4cd5-9d32-07652c56306e" providerId="ADAL" clId="{60D42A6B-AE32-4A06-B461-AA9486421C3B}" dt="2026-09-18T06:10:46.655" v="2473" actId="21"/>
+          <ac:graphicFrameMkLst>
+            <pc:docMk/>
+            <pc:sldMk cId="0" sldId="259"/>
+            <ac:graphicFrameMk id="20515" creationId="{BF03AD17-F94C-3F17-1164-5D87486DAD35}"/>
+          </ac:graphicFrameMkLst>
+        </pc:graphicFrameChg>
+      </pc:sldChg>
+      <pc:sldChg chg="addSp delSp modSp add del mod ord">
+        <pc:chgData name="SHINOHARA Soshi (篠原 想詩)" userId="309c0b21-8b61-4cd5-9d32-07652c56306e" providerId="ADAL" clId="{60D42A6B-AE32-4A06-B461-AA9486421C3B}" dt="2026-09-18T06:11:40.624" v="2511" actId="20577"/>
+        <pc:sldMkLst>
+          <pc:docMk/>
+          <pc:sldMk cId="0" sldId="260"/>
+        </pc:sldMkLst>
+        <pc:spChg chg="add del mod">
+          <ac:chgData name="SHINOHARA Soshi (篠原 想詩)" userId="309c0b21-8b61-4cd5-9d32-07652c56306e" providerId="ADAL" clId="{60D42A6B-AE32-4A06-B461-AA9486421C3B}" dt="2026-09-18T05:20:53.246" v="189" actId="478"/>
+          <ac:spMkLst>
+            <pc:docMk/>
+            <pc:sldMk cId="0" sldId="260"/>
+            <ac:spMk id="3" creationId="{4F55B57D-F8B6-6C1D-4BEA-FDF1012D8018}"/>
+          </ac:spMkLst>
+        </pc:spChg>
+        <pc:spChg chg="add del">
+          <ac:chgData name="SHINOHARA Soshi (篠原 想詩)" userId="309c0b21-8b61-4cd5-9d32-07652c56306e" providerId="ADAL" clId="{60D42A6B-AE32-4A06-B461-AA9486421C3B}" dt="2026-09-18T06:08:16.468" v="2383" actId="478"/>
+          <ac:spMkLst>
+            <pc:docMk/>
+            <pc:sldMk cId="0" sldId="260"/>
+            <ac:spMk id="5" creationId="{431B13A8-3DD4-DFA4-DE7E-C5BF855B41E7}"/>
+          </ac:spMkLst>
+        </pc:spChg>
+        <pc:spChg chg="add del">
+          <ac:chgData name="SHINOHARA Soshi (篠原 想詩)" userId="309c0b21-8b61-4cd5-9d32-07652c56306e" providerId="ADAL" clId="{60D42A6B-AE32-4A06-B461-AA9486421C3B}" dt="2026-09-18T05:37:16.287" v="719" actId="478"/>
+          <ac:spMkLst>
+            <pc:docMk/>
+            <pc:sldMk cId="0" sldId="260"/>
+            <ac:spMk id="7" creationId="{ABD3EDD7-62E8-46C9-CEEB-FFED12304482}"/>
+          </ac:spMkLst>
+        </pc:spChg>
+        <pc:spChg chg="add mod">
+          <ac:chgData name="SHINOHARA Soshi (篠原 想詩)" userId="309c0b21-8b61-4cd5-9d32-07652c56306e" providerId="ADAL" clId="{60D42A6B-AE32-4A06-B461-AA9486421C3B}" dt="2026-09-18T05:53:03.442" v="1652" actId="20577"/>
+          <ac:spMkLst>
+            <pc:docMk/>
+            <pc:sldMk cId="0" sldId="260"/>
+            <ac:spMk id="9" creationId="{286AF094-EB23-DE59-C364-CE66702F5820}"/>
+          </ac:spMkLst>
+        </pc:spChg>
+        <pc:spChg chg="add mod">
+          <ac:chgData name="SHINOHARA Soshi (篠原 想詩)" userId="309c0b21-8b61-4cd5-9d32-07652c56306e" providerId="ADAL" clId="{60D42A6B-AE32-4A06-B461-AA9486421C3B}" dt="2026-09-18T06:11:40.624" v="2511" actId="20577"/>
+          <ac:spMkLst>
+            <pc:docMk/>
+            <pc:sldMk cId="0" sldId="260"/>
+            <ac:spMk id="11" creationId="{9062C9EA-A562-CB3D-30B1-0D2FE45C706F}"/>
+          </ac:spMkLst>
+        </pc:spChg>
+        <pc:spChg chg="add del mod">
+          <ac:chgData name="SHINOHARA Soshi (篠原 想詩)" userId="309c0b21-8b61-4cd5-9d32-07652c56306e" providerId="ADAL" clId="{60D42A6B-AE32-4A06-B461-AA9486421C3B}" dt="2026-09-18T05:26:57.954" v="316" actId="478"/>
+          <ac:spMkLst>
+            <pc:docMk/>
+            <pc:sldMk cId="0" sldId="260"/>
+            <ac:spMk id="13" creationId="{3932B18D-C369-43F3-4CDD-B87A63732FDB}"/>
+          </ac:spMkLst>
+        </pc:spChg>
+        <pc:spChg chg="add del mod">
+          <ac:chgData name="SHINOHARA Soshi (篠原 想詩)" userId="309c0b21-8b61-4cd5-9d32-07652c56306e" providerId="ADAL" clId="{60D42A6B-AE32-4A06-B461-AA9486421C3B}" dt="2026-09-18T05:27:00.072" v="317" actId="478"/>
+          <ac:spMkLst>
+            <pc:docMk/>
+            <pc:sldMk cId="0" sldId="260"/>
+            <ac:spMk id="15" creationId="{89E8F5CB-8474-8F3C-1087-5370B299E16C}"/>
+          </ac:spMkLst>
+        </pc:spChg>
+        <pc:spChg chg="add del mod">
+          <ac:chgData name="SHINOHARA Soshi (篠原 想詩)" userId="309c0b21-8b61-4cd5-9d32-07652c56306e" providerId="ADAL" clId="{60D42A6B-AE32-4A06-B461-AA9486421C3B}" dt="2026-09-18T05:26:57.954" v="316" actId="478"/>
+          <ac:spMkLst>
+            <pc:docMk/>
+            <pc:sldMk cId="0" sldId="260"/>
+            <ac:spMk id="17" creationId="{5F4B4C21-10CC-7BB4-8886-097CC3FBD6A2}"/>
+          </ac:spMkLst>
+        </pc:spChg>
+        <pc:spChg chg="add del mod">
+          <ac:chgData name="SHINOHARA Soshi (篠原 想詩)" userId="309c0b21-8b61-4cd5-9d32-07652c56306e" providerId="ADAL" clId="{60D42A6B-AE32-4A06-B461-AA9486421C3B}" dt="2026-09-18T05:27:00.072" v="317" actId="478"/>
+          <ac:spMkLst>
+            <pc:docMk/>
+            <pc:sldMk cId="0" sldId="260"/>
+            <ac:spMk id="19" creationId="{6566FDEC-E851-4FD8-440B-9AB7B75D8615}"/>
+          </ac:spMkLst>
+        </pc:spChg>
+        <pc:spChg chg="del mod">
+          <ac:chgData name="SHINOHARA Soshi (篠原 想詩)" userId="309c0b21-8b61-4cd5-9d32-07652c56306e" providerId="ADAL" clId="{60D42A6B-AE32-4A06-B461-AA9486421C3B}" dt="2026-09-18T05:26:57.954" v="316" actId="478"/>
+          <ac:spMkLst>
+            <pc:docMk/>
+            <pc:sldMk cId="0" sldId="260"/>
+            <ac:spMk id="21" creationId="{59F512A8-F464-D0D0-9A1A-D5A3570BFD77}"/>
+          </ac:spMkLst>
+        </pc:spChg>
+        <pc:spChg chg="add del mod">
+          <ac:chgData name="SHINOHARA Soshi (篠原 想詩)" userId="309c0b21-8b61-4cd5-9d32-07652c56306e" providerId="ADAL" clId="{60D42A6B-AE32-4A06-B461-AA9486421C3B}" dt="2026-09-18T05:27:00.072" v="317" actId="478"/>
+          <ac:spMkLst>
+            <pc:docMk/>
+            <pc:sldMk cId="0" sldId="260"/>
+            <ac:spMk id="23" creationId="{0790BCF8-C3A8-E5A4-D36A-2A9AED582F98}"/>
+          </ac:spMkLst>
+        </pc:spChg>
+        <pc:spChg chg="add">
+          <ac:chgData name="SHINOHARA Soshi (篠原 想詩)" userId="309c0b21-8b61-4cd5-9d32-07652c56306e" providerId="ADAL" clId="{60D42A6B-AE32-4A06-B461-AA9486421C3B}" dt="2026-09-18T06:08:16.898" v="2384" actId="22"/>
+          <ac:spMkLst>
+            <pc:docMk/>
+            <pc:sldMk cId="0" sldId="260"/>
+            <ac:spMk id="29" creationId="{99BBA5A8-AC1B-3C0B-F774-2765F922C93F}"/>
+          </ac:spMkLst>
+        </pc:spChg>
+        <pc:spChg chg="add del">
+          <ac:chgData name="SHINOHARA Soshi (篠原 想詩)" userId="309c0b21-8b61-4cd5-9d32-07652c56306e" providerId="ADAL" clId="{60D42A6B-AE32-4A06-B461-AA9486421C3B}" dt="2026-09-18T06:08:18.731" v="2385" actId="478"/>
+          <ac:spMkLst>
+            <pc:docMk/>
+            <pc:sldMk cId="0" sldId="260"/>
+            <ac:spMk id="31" creationId="{FA40E3C3-CB5B-5524-9202-BA4ECA6CB4A9}"/>
+          </ac:spMkLst>
+        </pc:spChg>
+        <pc:spChg chg="mod">
+          <ac:chgData name="SHINOHARA Soshi (篠原 想詩)" userId="309c0b21-8b61-4cd5-9d32-07652c56306e" providerId="ADAL" clId="{60D42A6B-AE32-4A06-B461-AA9486421C3B}" dt="2026-09-18T05:53:44.989" v="1660" actId="20577"/>
+          <ac:spMkLst>
+            <pc:docMk/>
+            <pc:sldMk cId="0" sldId="260"/>
+            <ac:spMk id="21506" creationId="{F73DBF07-353A-1DAE-881E-450898FCC584}"/>
+          </ac:spMkLst>
+        </pc:spChg>
+        <pc:spChg chg="del">
+          <ac:chgData name="SHINOHARA Soshi (篠原 想詩)" userId="309c0b21-8b61-4cd5-9d32-07652c56306e" providerId="ADAL" clId="{60D42A6B-AE32-4A06-B461-AA9486421C3B}" dt="2026-09-18T05:18:05.097" v="175" actId="478"/>
+          <ac:spMkLst>
+            <pc:docMk/>
+            <pc:sldMk cId="0" sldId="260"/>
+            <ac:spMk id="21507" creationId="{A317CE7C-B655-40C7-01E2-46D229D3A532}"/>
+          </ac:spMkLst>
+        </pc:spChg>
+        <pc:picChg chg="add del mod">
+          <ac:chgData name="SHINOHARA Soshi (篠原 想詩)" userId="309c0b21-8b61-4cd5-9d32-07652c56306e" providerId="ADAL" clId="{60D42A6B-AE32-4A06-B461-AA9486421C3B}" dt="2026-09-18T05:33:08.130" v="603" actId="478"/>
+          <ac:picMkLst>
+            <pc:docMk/>
+            <pc:sldMk cId="0" sldId="260"/>
+            <ac:picMk id="25" creationId="{FD94B394-67AA-AAF2-7110-7A9DA3C55AB5}"/>
+          </ac:picMkLst>
+        </pc:picChg>
+        <pc:picChg chg="add mod">
+          <ac:chgData name="SHINOHARA Soshi (篠原 想詩)" userId="309c0b21-8b61-4cd5-9d32-07652c56306e" providerId="ADAL" clId="{60D42A6B-AE32-4A06-B461-AA9486421C3B}" dt="2026-09-18T05:54:06.120" v="1663" actId="1076"/>
+          <ac:picMkLst>
+            <pc:docMk/>
+            <pc:sldMk cId="0" sldId="260"/>
+            <ac:picMk id="27" creationId="{9FFAB5E6-B58F-408D-66BD-F06FEFD51917}"/>
+          </ac:picMkLst>
+        </pc:picChg>
+      </pc:sldChg>
+      <pc:sldChg chg="addSp delSp modSp add mod">
+        <pc:chgData name="SHINOHARA Soshi (篠原 想詩)" userId="309c0b21-8b61-4cd5-9d32-07652c56306e" providerId="ADAL" clId="{60D42A6B-AE32-4A06-B461-AA9486421C3B}" dt="2026-09-18T07:24:11.208" v="2544" actId="207"/>
+        <pc:sldMkLst>
+          <pc:docMk/>
+          <pc:sldMk cId="2460916238" sldId="261"/>
+        </pc:sldMkLst>
+        <pc:spChg chg="add del mod">
+          <ac:chgData name="SHINOHARA Soshi (篠原 想詩)" userId="309c0b21-8b61-4cd5-9d32-07652c56306e" providerId="ADAL" clId="{60D42A6B-AE32-4A06-B461-AA9486421C3B}" dt="2026-09-18T05:25:08.832" v="262" actId="478"/>
+          <ac:spMkLst>
+            <pc:docMk/>
+            <pc:sldMk cId="2460916238" sldId="261"/>
+            <ac:spMk id="3" creationId="{CA4D1F53-A14A-7162-186C-AA71923C274E}"/>
+          </ac:spMkLst>
+        </pc:spChg>
+        <pc:spChg chg="add del mod">
+          <ac:chgData name="SHINOHARA Soshi (篠原 想詩)" userId="309c0b21-8b61-4cd5-9d32-07652c56306e" providerId="ADAL" clId="{60D42A6B-AE32-4A06-B461-AA9486421C3B}" dt="2026-09-18T06:07:30.410" v="2336" actId="478"/>
+          <ac:spMkLst>
+            <pc:docMk/>
+            <pc:sldMk cId="2460916238" sldId="261"/>
+            <ac:spMk id="5" creationId="{BE7B8D1F-E32B-7814-B7DE-5AAAAD2D4181}"/>
+          </ac:spMkLst>
+        </pc:spChg>
+        <pc:spChg chg="del">
+          <ac:chgData name="SHINOHARA Soshi (篠原 想詩)" userId="309c0b21-8b61-4cd5-9d32-07652c56306e" providerId="ADAL" clId="{60D42A6B-AE32-4A06-B461-AA9486421C3B}" dt="2026-09-18T06:07:26.110" v="2333" actId="478"/>
+          <ac:spMkLst>
+            <pc:docMk/>
+            <pc:sldMk cId="2460916238" sldId="261"/>
+            <ac:spMk id="6" creationId="{7F4E5446-F46C-48CC-6E65-7B7B2E9503FE}"/>
+          </ac:spMkLst>
+        </pc:spChg>
+        <pc:spChg chg="add del">
+          <ac:chgData name="SHINOHARA Soshi (篠原 想詩)" userId="309c0b21-8b61-4cd5-9d32-07652c56306e" providerId="ADAL" clId="{60D42A6B-AE32-4A06-B461-AA9486421C3B}" dt="2026-09-18T05:24:54.695" v="257" actId="478"/>
+          <ac:spMkLst>
+            <pc:docMk/>
+            <pc:sldMk cId="2460916238" sldId="261"/>
+            <ac:spMk id="7" creationId="{01CE3EA1-F0A8-7424-66A3-DBA858822732}"/>
+          </ac:spMkLst>
+        </pc:spChg>
+        <pc:spChg chg="add del">
+          <ac:chgData name="SHINOHARA Soshi (篠原 想詩)" userId="309c0b21-8b61-4cd5-9d32-07652c56306e" providerId="ADAL" clId="{60D42A6B-AE32-4A06-B461-AA9486421C3B}" dt="2026-09-18T05:24:54.695" v="257" actId="478"/>
+          <ac:spMkLst>
+            <pc:docMk/>
+            <pc:sldMk cId="2460916238" sldId="261"/>
+            <ac:spMk id="9" creationId="{8D09A15F-04FF-CD0E-4017-A04FA5ABA722}"/>
+          </ac:spMkLst>
+        </pc:spChg>
+        <pc:spChg chg="mod">
+          <ac:chgData name="SHINOHARA Soshi (篠原 想詩)" userId="309c0b21-8b61-4cd5-9d32-07652c56306e" providerId="ADAL" clId="{60D42A6B-AE32-4A06-B461-AA9486421C3B}" dt="2026-09-18T06:10:12.703" v="2455" actId="20577"/>
+          <ac:spMkLst>
+            <pc:docMk/>
+            <pc:sldMk cId="2460916238" sldId="261"/>
+            <ac:spMk id="10" creationId="{3ED9BB57-B053-F70B-D524-9A419F78B21D}"/>
+          </ac:spMkLst>
+        </pc:spChg>
+        <pc:spChg chg="add del">
+          <ac:chgData name="SHINOHARA Soshi (篠原 想詩)" userId="309c0b21-8b61-4cd5-9d32-07652c56306e" providerId="ADAL" clId="{60D42A6B-AE32-4A06-B461-AA9486421C3B}" dt="2026-09-18T05:24:54.695" v="257" actId="478"/>
+          <ac:spMkLst>
+            <pc:docMk/>
+            <pc:sldMk cId="2460916238" sldId="261"/>
+            <ac:spMk id="11" creationId="{21434601-AF06-911A-86DB-6D766E08ACF6}"/>
+          </ac:spMkLst>
+        </pc:spChg>
+        <pc:spChg chg="add del">
+          <ac:chgData name="SHINOHARA Soshi (篠原 想詩)" userId="309c0b21-8b61-4cd5-9d32-07652c56306e" providerId="ADAL" clId="{60D42A6B-AE32-4A06-B461-AA9486421C3B}" dt="2026-09-18T05:24:54.695" v="257" actId="478"/>
+          <ac:spMkLst>
+            <pc:docMk/>
+            <pc:sldMk cId="2460916238" sldId="261"/>
+            <ac:spMk id="13" creationId="{0A844F94-308C-40E7-389C-C85C23048104}"/>
+          </ac:spMkLst>
+        </pc:spChg>
+        <pc:spChg chg="mod">
+          <ac:chgData name="SHINOHARA Soshi (篠原 想詩)" userId="309c0b21-8b61-4cd5-9d32-07652c56306e" providerId="ADAL" clId="{60D42A6B-AE32-4A06-B461-AA9486421C3B}" dt="2026-09-18T05:47:59.610" v="1393" actId="1076"/>
+          <ac:spMkLst>
+            <pc:docMk/>
+            <pc:sldMk cId="2460916238" sldId="261"/>
+            <ac:spMk id="14" creationId="{5B0E15B8-93C6-B5DC-8BC8-AE4DFDADDF16}"/>
+          </ac:spMkLst>
+        </pc:spChg>
+        <pc:spChg chg="add del mod">
+          <ac:chgData name="SHINOHARA Soshi (篠原 想詩)" userId="309c0b21-8b61-4cd5-9d32-07652c56306e" providerId="ADAL" clId="{60D42A6B-AE32-4A06-B461-AA9486421C3B}" dt="2026-09-18T05:24:54.695" v="257" actId="478"/>
+          <ac:spMkLst>
+            <pc:docMk/>
+            <pc:sldMk cId="2460916238" sldId="261"/>
+            <ac:spMk id="15" creationId="{95656763-70B1-A3A4-369F-7EF7B623D55F}"/>
+          </ac:spMkLst>
+        </pc:spChg>
+        <pc:spChg chg="add del">
+          <ac:chgData name="SHINOHARA Soshi (篠原 想詩)" userId="309c0b21-8b61-4cd5-9d32-07652c56306e" providerId="ADAL" clId="{60D42A6B-AE32-4A06-B461-AA9486421C3B}" dt="2026-09-18T05:24:54.695" v="257" actId="478"/>
+          <ac:spMkLst>
+            <pc:docMk/>
+            <pc:sldMk cId="2460916238" sldId="261"/>
+            <ac:spMk id="17" creationId="{0F5239F4-8C8C-B0DF-B4B5-A862F57DEB1C}"/>
+          </ac:spMkLst>
+        </pc:spChg>
+        <pc:spChg chg="mod">
+          <ac:chgData name="SHINOHARA Soshi (篠原 想詩)" userId="309c0b21-8b61-4cd5-9d32-07652c56306e" providerId="ADAL" clId="{60D42A6B-AE32-4A06-B461-AA9486421C3B}" dt="2026-09-18T05:47:59.610" v="1393" actId="1076"/>
+          <ac:spMkLst>
+            <pc:docMk/>
+            <pc:sldMk cId="2460916238" sldId="261"/>
+            <ac:spMk id="18" creationId="{497756DF-3408-5C63-2891-8CB7EF569B47}"/>
+          </ac:spMkLst>
+        </pc:spChg>
+        <pc:spChg chg="add del">
+          <ac:chgData name="SHINOHARA Soshi (篠原 想詩)" userId="309c0b21-8b61-4cd5-9d32-07652c56306e" providerId="ADAL" clId="{60D42A6B-AE32-4A06-B461-AA9486421C3B}" dt="2026-09-18T05:24:54.695" v="257" actId="478"/>
+          <ac:spMkLst>
+            <pc:docMk/>
+            <pc:sldMk cId="2460916238" sldId="261"/>
+            <ac:spMk id="19" creationId="{7826C402-562F-4BD5-7C6B-D0FDFEAA603D}"/>
+          </ac:spMkLst>
+        </pc:spChg>
+        <pc:spChg chg="add del">
+          <ac:chgData name="SHINOHARA Soshi (篠原 想詩)" userId="309c0b21-8b61-4cd5-9d32-07652c56306e" providerId="ADAL" clId="{60D42A6B-AE32-4A06-B461-AA9486421C3B}" dt="2026-09-18T05:24:54.695" v="257" actId="478"/>
+          <ac:spMkLst>
+            <pc:docMk/>
+            <pc:sldMk cId="2460916238" sldId="261"/>
+            <ac:spMk id="21" creationId="{6F4993EC-9588-F220-45D8-1A365416A0CA}"/>
+          </ac:spMkLst>
+        </pc:spChg>
+        <pc:spChg chg="mod">
+          <ac:chgData name="SHINOHARA Soshi (篠原 想詩)" userId="309c0b21-8b61-4cd5-9d32-07652c56306e" providerId="ADAL" clId="{60D42A6B-AE32-4A06-B461-AA9486421C3B}" dt="2026-09-18T05:50:02.179" v="1414" actId="1076"/>
+          <ac:spMkLst>
+            <pc:docMk/>
+            <pc:sldMk cId="2460916238" sldId="261"/>
+            <ac:spMk id="22" creationId="{1ED71925-19F6-F7EB-DF01-3604792C541E}"/>
+          </ac:spMkLst>
+        </pc:spChg>
+        <pc:spChg chg="add del">
+          <ac:chgData name="SHINOHARA Soshi (篠原 想詩)" userId="309c0b21-8b61-4cd5-9d32-07652c56306e" providerId="ADAL" clId="{60D42A6B-AE32-4A06-B461-AA9486421C3B}" dt="2026-09-18T05:24:54.695" v="257" actId="478"/>
+          <ac:spMkLst>
+            <pc:docMk/>
+            <pc:sldMk cId="2460916238" sldId="261"/>
+            <ac:spMk id="23" creationId="{9958C36B-2683-47BF-00EE-254029DB53E4}"/>
+          </ac:spMkLst>
+        </pc:spChg>
+        <pc:spChg chg="add mod">
+          <ac:chgData name="SHINOHARA Soshi (篠原 想詩)" userId="309c0b21-8b61-4cd5-9d32-07652c56306e" providerId="ADAL" clId="{60D42A6B-AE32-4A06-B461-AA9486421C3B}" dt="2026-09-18T05:50:02.179" v="1414" actId="1076"/>
+          <ac:spMkLst>
+            <pc:docMk/>
+            <pc:sldMk cId="2460916238" sldId="261"/>
+            <ac:spMk id="25" creationId="{9AA1D80A-7EAB-E5E8-2EB1-FC55B36AF4FB}"/>
+          </ac:spMkLst>
+        </pc:spChg>
+        <pc:spChg chg="add mod">
+          <ac:chgData name="SHINOHARA Soshi (篠原 想詩)" userId="309c0b21-8b61-4cd5-9d32-07652c56306e" providerId="ADAL" clId="{60D42A6B-AE32-4A06-B461-AA9486421C3B}" dt="2026-09-18T05:50:02.179" v="1414" actId="1076"/>
+          <ac:spMkLst>
+            <pc:docMk/>
+            <pc:sldMk cId="2460916238" sldId="261"/>
+            <ac:spMk id="29" creationId="{A3A85E53-59E3-14F1-A43D-43A5D5555EB0}"/>
+          </ac:spMkLst>
+        </pc:spChg>
+        <pc:spChg chg="add mod">
+          <ac:chgData name="SHINOHARA Soshi (篠原 想詩)" userId="309c0b21-8b61-4cd5-9d32-07652c56306e" providerId="ADAL" clId="{60D42A6B-AE32-4A06-B461-AA9486421C3B}" dt="2026-09-18T05:50:02.179" v="1414" actId="1076"/>
+          <ac:spMkLst>
+            <pc:docMk/>
+            <pc:sldMk cId="2460916238" sldId="261"/>
+            <ac:spMk id="31" creationId="{4360A1D8-3337-5B5F-A527-4558554291F7}"/>
+          </ac:spMkLst>
+        </pc:spChg>
+        <pc:spChg chg="add mod">
+          <ac:chgData name="SHINOHARA Soshi (篠原 想詩)" userId="309c0b21-8b61-4cd5-9d32-07652c56306e" providerId="ADAL" clId="{60D42A6B-AE32-4A06-B461-AA9486421C3B}" dt="2026-09-18T05:50:02.179" v="1414" actId="1076"/>
+          <ac:spMkLst>
+            <pc:docMk/>
+            <pc:sldMk cId="2460916238" sldId="261"/>
+            <ac:spMk id="21505" creationId="{927C2915-20BF-81E6-ADAB-0B263E213E91}"/>
+          </ac:spMkLst>
+        </pc:spChg>
+        <pc:spChg chg="mod">
+          <ac:chgData name="SHINOHARA Soshi (篠原 想詩)" userId="309c0b21-8b61-4cd5-9d32-07652c56306e" providerId="ADAL" clId="{60D42A6B-AE32-4A06-B461-AA9486421C3B}" dt="2026-09-18T05:46:55.708" v="1359" actId="403"/>
+          <ac:spMkLst>
+            <pc:docMk/>
+            <pc:sldMk cId="2460916238" sldId="261"/>
+            <ac:spMk id="21506" creationId="{8B5E1CCB-E003-0B0A-94DD-5D464AE71E1F}"/>
+          </ac:spMkLst>
+        </pc:spChg>
+        <pc:spChg chg="add mod">
+          <ac:chgData name="SHINOHARA Soshi (篠原 想詩)" userId="309c0b21-8b61-4cd5-9d32-07652c56306e" providerId="ADAL" clId="{60D42A6B-AE32-4A06-B461-AA9486421C3B}" dt="2026-09-18T06:10:16.367" v="2466" actId="20577"/>
+          <ac:spMkLst>
+            <pc:docMk/>
+            <pc:sldMk cId="2460916238" sldId="261"/>
+            <ac:spMk id="21508" creationId="{2292334C-0E0C-4611-CBB3-F1ED8685F0EE}"/>
+          </ac:spMkLst>
+        </pc:spChg>
+        <pc:spChg chg="mod">
+          <ac:chgData name="SHINOHARA Soshi (篠原 想詩)" userId="309c0b21-8b61-4cd5-9d32-07652c56306e" providerId="ADAL" clId="{60D42A6B-AE32-4A06-B461-AA9486421C3B}" dt="2026-09-18T05:47:59.610" v="1393" actId="1076"/>
+          <ac:spMkLst>
+            <pc:docMk/>
+            <pc:sldMk cId="2460916238" sldId="261"/>
+            <ac:spMk id="21510" creationId="{43FF9372-D4F3-024E-F5FB-EEBCEE3D6C53}"/>
+          </ac:spMkLst>
+        </pc:spChg>
+        <pc:spChg chg="mod">
+          <ac:chgData name="SHINOHARA Soshi (篠原 想詩)" userId="309c0b21-8b61-4cd5-9d32-07652c56306e" providerId="ADAL" clId="{60D42A6B-AE32-4A06-B461-AA9486421C3B}" dt="2026-09-18T05:47:59.610" v="1393" actId="1076"/>
+          <ac:spMkLst>
+            <pc:docMk/>
+            <pc:sldMk cId="2460916238" sldId="261"/>
+            <ac:spMk id="21512" creationId="{89D92C62-0182-0465-1688-F4417EC2F72B}"/>
+          </ac:spMkLst>
+        </pc:spChg>
+        <pc:spChg chg="mod">
+          <ac:chgData name="SHINOHARA Soshi (篠原 想詩)" userId="309c0b21-8b61-4cd5-9d32-07652c56306e" providerId="ADAL" clId="{60D42A6B-AE32-4A06-B461-AA9486421C3B}" dt="2026-09-18T05:50:02.179" v="1414" actId="1076"/>
+          <ac:spMkLst>
+            <pc:docMk/>
+            <pc:sldMk cId="2460916238" sldId="261"/>
+            <ac:spMk id="21514" creationId="{D0A4DD7B-04A4-164A-EDDF-A00AC17F588E}"/>
+          </ac:spMkLst>
+        </pc:spChg>
+        <pc:spChg chg="add mod">
+          <ac:chgData name="SHINOHARA Soshi (篠原 想詩)" userId="309c0b21-8b61-4cd5-9d32-07652c56306e" providerId="ADAL" clId="{60D42A6B-AE32-4A06-B461-AA9486421C3B}" dt="2026-09-18T05:50:02.179" v="1414" actId="1076"/>
+          <ac:spMkLst>
+            <pc:docMk/>
+            <pc:sldMk cId="2460916238" sldId="261"/>
+            <ac:spMk id="21516" creationId="{CE12C862-B8D7-8680-F5A6-9D5626C05174}"/>
+          </ac:spMkLst>
+        </pc:spChg>
+        <pc:spChg chg="add mod">
+          <ac:chgData name="SHINOHARA Soshi (篠原 想詩)" userId="309c0b21-8b61-4cd5-9d32-07652c56306e" providerId="ADAL" clId="{60D42A6B-AE32-4A06-B461-AA9486421C3B}" dt="2026-09-18T05:50:02.179" v="1414" actId="1076"/>
+          <ac:spMkLst>
+            <pc:docMk/>
+            <pc:sldMk cId="2460916238" sldId="261"/>
+            <ac:spMk id="21518" creationId="{0B1D0BFE-19E5-BEBB-29BF-6206205D297A}"/>
+          </ac:spMkLst>
+        </pc:spChg>
+        <pc:spChg chg="add mod">
+          <ac:chgData name="SHINOHARA Soshi (篠原 想詩)" userId="309c0b21-8b61-4cd5-9d32-07652c56306e" providerId="ADAL" clId="{60D42A6B-AE32-4A06-B461-AA9486421C3B}" dt="2026-09-18T07:24:11.208" v="2544" actId="207"/>
+          <ac:spMkLst>
+            <pc:docMk/>
+            <pc:sldMk cId="2460916238" sldId="261"/>
+            <ac:spMk id="21522" creationId="{23394E18-7729-EF9C-1A57-D32D35698E0B}"/>
+          </ac:spMkLst>
+        </pc:spChg>
+        <pc:spChg chg="add del mod">
+          <ac:chgData name="SHINOHARA Soshi (篠原 想詩)" userId="309c0b21-8b61-4cd5-9d32-07652c56306e" providerId="ADAL" clId="{60D42A6B-AE32-4A06-B461-AA9486421C3B}" dt="2026-09-18T05:47:51.381" v="1392" actId="478"/>
+          <ac:spMkLst>
+            <pc:docMk/>
+            <pc:sldMk cId="2460916238" sldId="261"/>
+            <ac:spMk id="21524" creationId="{B2F10FD7-6ED5-4E6F-4153-33B85EE2B03E}"/>
+          </ac:spMkLst>
+        </pc:spChg>
+        <pc:spChg chg="del mod">
+          <ac:chgData name="SHINOHARA Soshi (篠原 想詩)" userId="309c0b21-8b61-4cd5-9d32-07652c56306e" providerId="ADAL" clId="{60D42A6B-AE32-4A06-B461-AA9486421C3B}" dt="2026-09-18T05:47:49.117" v="1391" actId="478"/>
+          <ac:spMkLst>
+            <pc:docMk/>
+            <pc:sldMk cId="2460916238" sldId="261"/>
+            <ac:spMk id="21526" creationId="{720EA9A5-F780-985C-4940-3F9A5D2FEC2F}"/>
+          </ac:spMkLst>
+        </pc:spChg>
+        <pc:spChg chg="add mod">
+          <ac:chgData name="SHINOHARA Soshi (篠原 想詩)" userId="309c0b21-8b61-4cd5-9d32-07652c56306e" providerId="ADAL" clId="{60D42A6B-AE32-4A06-B461-AA9486421C3B}" dt="2026-09-18T06:03:14.359" v="2304" actId="1582"/>
+          <ac:spMkLst>
+            <pc:docMk/>
+            <pc:sldMk cId="2460916238" sldId="261"/>
+            <ac:spMk id="21527" creationId="{231EE372-2D83-A895-742F-441F2D69583B}"/>
+          </ac:spMkLst>
+        </pc:spChg>
+        <pc:spChg chg="add mod">
+          <ac:chgData name="SHINOHARA Soshi (篠原 想詩)" userId="309c0b21-8b61-4cd5-9d32-07652c56306e" providerId="ADAL" clId="{60D42A6B-AE32-4A06-B461-AA9486421C3B}" dt="2026-09-18T05:49:47.348" v="1412" actId="1076"/>
+          <ac:spMkLst>
+            <pc:docMk/>
+            <pc:sldMk cId="2460916238" sldId="261"/>
+            <ac:spMk id="21529" creationId="{08D3BE1E-A7CA-BEB2-ADB6-594EF66852D4}"/>
+          </ac:spMkLst>
+        </pc:spChg>
+        <pc:spChg chg="add mod">
+          <ac:chgData name="SHINOHARA Soshi (篠原 想詩)" userId="309c0b21-8b61-4cd5-9d32-07652c56306e" providerId="ADAL" clId="{60D42A6B-AE32-4A06-B461-AA9486421C3B}" dt="2026-09-18T06:09:45.821" v="2404" actId="20577"/>
+          <ac:spMkLst>
+            <pc:docMk/>
+            <pc:sldMk cId="2460916238" sldId="261"/>
+            <ac:spMk id="21531" creationId="{0E081BA2-CF81-69EE-3F51-8B71713AA293}"/>
+          </ac:spMkLst>
+        </pc:spChg>
+        <pc:spChg chg="add mod">
+          <ac:chgData name="SHINOHARA Soshi (篠原 想詩)" userId="309c0b21-8b61-4cd5-9d32-07652c56306e" providerId="ADAL" clId="{60D42A6B-AE32-4A06-B461-AA9486421C3B}" dt="2026-09-18T06:03:40.075" v="2308" actId="1076"/>
+          <ac:spMkLst>
+            <pc:docMk/>
+            <pc:sldMk cId="2460916238" sldId="261"/>
+            <ac:spMk id="21533" creationId="{B85F4D50-9C37-7186-F9DF-DF2611B8DAE4}"/>
+          </ac:spMkLst>
+        </pc:spChg>
+        <pc:spChg chg="add">
+          <ac:chgData name="SHINOHARA Soshi (篠原 想詩)" userId="309c0b21-8b61-4cd5-9d32-07652c56306e" providerId="ADAL" clId="{60D42A6B-AE32-4A06-B461-AA9486421C3B}" dt="2026-09-18T06:07:26.395" v="2334" actId="22"/>
+          <ac:spMkLst>
+            <pc:docMk/>
+            <pc:sldMk cId="2460916238" sldId="261"/>
+            <ac:spMk id="21535" creationId="{2E47C8EF-6705-D95C-B05D-E243520E31E0}"/>
+          </ac:spMkLst>
+        </pc:spChg>
+        <pc:spChg chg="add del">
+          <ac:chgData name="SHINOHARA Soshi (篠原 想詩)" userId="309c0b21-8b61-4cd5-9d32-07652c56306e" providerId="ADAL" clId="{60D42A6B-AE32-4A06-B461-AA9486421C3B}" dt="2026-09-18T06:07:28.184" v="2335" actId="478"/>
+          <ac:spMkLst>
+            <pc:docMk/>
+            <pc:sldMk cId="2460916238" sldId="261"/>
+            <ac:spMk id="21537" creationId="{24243219-7C45-AC1E-0C8D-E3B5C1DED6B2}"/>
+          </ac:spMkLst>
+        </pc:spChg>
+      </pc:sldChg>
+      <pc:sldChg chg="add del">
+        <pc:chgData name="SHINOHARA Soshi (篠原 想詩)" userId="309c0b21-8b61-4cd5-9d32-07652c56306e" providerId="ADAL" clId="{60D42A6B-AE32-4A06-B461-AA9486421C3B}" dt="2026-09-18T05:26:41.898" v="310"/>
+        <pc:sldMkLst>
+          <pc:docMk/>
+          <pc:sldMk cId="986264629" sldId="262"/>
+        </pc:sldMkLst>
+      </pc:sldChg>
+      <pc:sldChg chg="add del">
+        <pc:chgData name="SHINOHARA Soshi (篠原 想詩)" userId="309c0b21-8b61-4cd5-9d32-07652c56306e" providerId="ADAL" clId="{60D42A6B-AE32-4A06-B461-AA9486421C3B}" dt="2026-09-18T05:26:52.924" v="315" actId="47"/>
+        <pc:sldMkLst>
+          <pc:docMk/>
+          <pc:sldMk cId="3842469057" sldId="262"/>
+        </pc:sldMkLst>
+      </pc:sldChg>
+      <pc:sldChg chg="delSp modSp add mod">
+        <pc:chgData name="SHINOHARA Soshi (篠原 想詩)" userId="309c0b21-8b61-4cd5-9d32-07652c56306e" providerId="ADAL" clId="{60D42A6B-AE32-4A06-B461-AA9486421C3B}" dt="2026-09-18T07:18:17.875" v="2543" actId="1076"/>
+        <pc:sldMkLst>
+          <pc:docMk/>
+          <pc:sldMk cId="2416652295" sldId="263"/>
+        </pc:sldMkLst>
+        <pc:spChg chg="mod">
+          <ac:chgData name="SHINOHARA Soshi (篠原 想詩)" userId="309c0b21-8b61-4cd5-9d32-07652c56306e" providerId="ADAL" clId="{60D42A6B-AE32-4A06-B461-AA9486421C3B}" dt="2026-09-18T06:06:58.138" v="2327" actId="14100"/>
+          <ac:spMkLst>
+            <pc:docMk/>
+            <pc:sldMk cId="2416652295" sldId="263"/>
+            <ac:spMk id="5" creationId="{03ADD616-96E1-C816-722E-D432D1B1434B}"/>
+          </ac:spMkLst>
+        </pc:spChg>
+        <pc:spChg chg="mod">
+          <ac:chgData name="SHINOHARA Soshi (篠原 想詩)" userId="309c0b21-8b61-4cd5-9d32-07652c56306e" providerId="ADAL" clId="{60D42A6B-AE32-4A06-B461-AA9486421C3B}" dt="2026-09-18T06:07:20.645" v="2332" actId="14100"/>
+          <ac:spMkLst>
+            <pc:docMk/>
+            <pc:sldMk cId="2416652295" sldId="263"/>
+            <ac:spMk id="7" creationId="{9D8E4493-09ED-D66D-BB69-F4E17FDDAAE5}"/>
+          </ac:spMkLst>
+        </pc:spChg>
+        <pc:spChg chg="mod">
+          <ac:chgData name="SHINOHARA Soshi (篠原 想詩)" userId="309c0b21-8b61-4cd5-9d32-07652c56306e" providerId="ADAL" clId="{60D42A6B-AE32-4A06-B461-AA9486421C3B}" dt="2026-09-18T05:50:15.383" v="1415" actId="1076"/>
+          <ac:spMkLst>
+            <pc:docMk/>
+            <pc:sldMk cId="2416652295" sldId="263"/>
+            <ac:spMk id="9" creationId="{A76CBF8E-780A-F613-552A-79DF92A79B34}"/>
+          </ac:spMkLst>
+        </pc:spChg>
+        <pc:spChg chg="mod">
+          <ac:chgData name="SHINOHARA Soshi (篠原 想詩)" userId="309c0b21-8b61-4cd5-9d32-07652c56306e" providerId="ADAL" clId="{60D42A6B-AE32-4A06-B461-AA9486421C3B}" dt="2026-09-18T07:18:08.613" v="2541" actId="14100"/>
+          <ac:spMkLst>
+            <pc:docMk/>
+            <pc:sldMk cId="2416652295" sldId="263"/>
+            <ac:spMk id="11" creationId="{334C37F2-BE3E-BFC0-CAB9-D3917FDC0606}"/>
+          </ac:spMkLst>
+        </pc:spChg>
+        <pc:spChg chg="mod">
+          <ac:chgData name="SHINOHARA Soshi (篠原 想詩)" userId="309c0b21-8b61-4cd5-9d32-07652c56306e" providerId="ADAL" clId="{60D42A6B-AE32-4A06-B461-AA9486421C3B}" dt="2026-09-18T06:09:13.314" v="2397" actId="1076"/>
+          <ac:spMkLst>
+            <pc:docMk/>
+            <pc:sldMk cId="2416652295" sldId="263"/>
+            <ac:spMk id="13" creationId="{CFA581EB-E5DD-E949-61AD-F14177A9CC17}"/>
+          </ac:spMkLst>
+        </pc:spChg>
+        <pc:spChg chg="mod">
+          <ac:chgData name="SHINOHARA Soshi (篠原 想詩)" userId="309c0b21-8b61-4cd5-9d32-07652c56306e" providerId="ADAL" clId="{60D42A6B-AE32-4A06-B461-AA9486421C3B}" dt="2026-09-18T06:09:13.314" v="2397" actId="1076"/>
+          <ac:spMkLst>
+            <pc:docMk/>
+            <pc:sldMk cId="2416652295" sldId="263"/>
+            <ac:spMk id="15" creationId="{CBB4D034-4453-9918-E427-6F3BF26F1E67}"/>
+          </ac:spMkLst>
+        </pc:spChg>
+        <pc:spChg chg="mod">
+          <ac:chgData name="SHINOHARA Soshi (篠原 想詩)" userId="309c0b21-8b61-4cd5-9d32-07652c56306e" providerId="ADAL" clId="{60D42A6B-AE32-4A06-B461-AA9486421C3B}" dt="2026-09-18T06:09:17.823" v="2398" actId="1076"/>
+          <ac:spMkLst>
+            <pc:docMk/>
+            <pc:sldMk cId="2416652295" sldId="263"/>
+            <ac:spMk id="17" creationId="{9EA7CA49-8438-F8C9-4C30-426972466047}"/>
+          </ac:spMkLst>
+        </pc:spChg>
+        <pc:spChg chg="mod">
+          <ac:chgData name="SHINOHARA Soshi (篠原 想詩)" userId="309c0b21-8b61-4cd5-9d32-07652c56306e" providerId="ADAL" clId="{60D42A6B-AE32-4A06-B461-AA9486421C3B}" dt="2026-09-18T07:18:17.875" v="2543" actId="1076"/>
+          <ac:spMkLst>
+            <pc:docMk/>
+            <pc:sldMk cId="2416652295" sldId="263"/>
+            <ac:spMk id="19" creationId="{0E391B8E-AB01-AC75-D1D9-4BA5617A534F}"/>
+          </ac:spMkLst>
+        </pc:spChg>
+        <pc:spChg chg="del mod">
+          <ac:chgData name="SHINOHARA Soshi (篠原 想詩)" userId="309c0b21-8b61-4cd5-9d32-07652c56306e" providerId="ADAL" clId="{60D42A6B-AE32-4A06-B461-AA9486421C3B}" dt="2026-09-18T05:49:37.448" v="1407" actId="21"/>
+          <ac:spMkLst>
+            <pc:docMk/>
+            <pc:sldMk cId="2416652295" sldId="263"/>
+            <ac:spMk id="21" creationId="{0A34CEB6-CCB9-988E-2DFF-1ECD24F42D9F}"/>
+          </ac:spMkLst>
+        </pc:spChg>
+        <pc:spChg chg="del mod">
+          <ac:chgData name="SHINOHARA Soshi (篠原 想詩)" userId="309c0b21-8b61-4cd5-9d32-07652c56306e" providerId="ADAL" clId="{60D42A6B-AE32-4A06-B461-AA9486421C3B}" dt="2026-09-18T05:49:37.448" v="1407" actId="21"/>
+          <ac:spMkLst>
+            <pc:docMk/>
+            <pc:sldMk cId="2416652295" sldId="263"/>
+            <ac:spMk id="23" creationId="{00857F23-C44E-A666-426E-21F27FF95978}"/>
+          </ac:spMkLst>
+        </pc:spChg>
+        <pc:spChg chg="mod">
+          <ac:chgData name="SHINOHARA Soshi (篠原 想詩)" userId="309c0b21-8b61-4cd5-9d32-07652c56306e" providerId="ADAL" clId="{60D42A6B-AE32-4A06-B461-AA9486421C3B}" dt="2026-09-18T05:46:41.920" v="1358" actId="1076"/>
+          <ac:spMkLst>
+            <pc:docMk/>
+            <pc:sldMk cId="2416652295" sldId="263"/>
+            <ac:spMk id="21506" creationId="{BBF3B7B6-7F4A-254F-EB33-2638E125F1E0}"/>
+          </ac:spMkLst>
+        </pc:spChg>
+      </pc:sldChg>
+      <pc:sldChg chg="addSp delSp modSp add mod ord">
+        <pc:chgData name="SHINOHARA Soshi (篠原 想詩)" userId="309c0b21-8b61-4cd5-9d32-07652c56306e" providerId="ADAL" clId="{60D42A6B-AE32-4A06-B461-AA9486421C3B}" dt="2026-09-18T07:27:41.343" v="2583" actId="20577"/>
+        <pc:sldMkLst>
+          <pc:docMk/>
+          <pc:sldMk cId="147431364" sldId="264"/>
+        </pc:sldMkLst>
+        <pc:spChg chg="add del mod">
+          <ac:chgData name="SHINOHARA Soshi (篠原 想詩)" userId="309c0b21-8b61-4cd5-9d32-07652c56306e" providerId="ADAL" clId="{60D42A6B-AE32-4A06-B461-AA9486421C3B}" dt="2026-09-18T06:07:39.375" v="2340" actId="478"/>
+          <ac:spMkLst>
+            <pc:docMk/>
+            <pc:sldMk cId="147431364" sldId="264"/>
+            <ac:spMk id="3" creationId="{307B1FFF-4372-E844-97E8-30ADF086F187}"/>
+          </ac:spMkLst>
+        </pc:spChg>
+        <pc:spChg chg="del">
+          <ac:chgData name="SHINOHARA Soshi (篠原 想詩)" userId="309c0b21-8b61-4cd5-9d32-07652c56306e" providerId="ADAL" clId="{60D42A6B-AE32-4A06-B461-AA9486421C3B}" dt="2026-09-18T06:07:36.040" v="2337" actId="478"/>
+          <ac:spMkLst>
+            <pc:docMk/>
+            <pc:sldMk cId="147431364" sldId="264"/>
+            <ac:spMk id="5" creationId="{05EB874F-BED0-70CE-2524-0004B0E0A7AB}"/>
+          </ac:spMkLst>
+        </pc:spChg>
+        <pc:spChg chg="add mod">
+          <ac:chgData name="SHINOHARA Soshi (篠原 想詩)" userId="309c0b21-8b61-4cd5-9d32-07652c56306e" providerId="ADAL" clId="{60D42A6B-AE32-4A06-B461-AA9486421C3B}" dt="2026-09-18T05:55:29.688" v="1687" actId="1076"/>
+          <ac:spMkLst>
+            <pc:docMk/>
+            <pc:sldMk cId="147431364" sldId="264"/>
+            <ac:spMk id="6" creationId="{9F0FB3CC-52F3-1B56-A3C9-4771819CFED5}"/>
+          </ac:spMkLst>
+        </pc:spChg>
+        <pc:spChg chg="del">
+          <ac:chgData name="SHINOHARA Soshi (篠原 想詩)" userId="309c0b21-8b61-4cd5-9d32-07652c56306e" providerId="ADAL" clId="{60D42A6B-AE32-4A06-B461-AA9486421C3B}" dt="2026-09-18T05:54:43.421" v="1669" actId="478"/>
+          <ac:spMkLst>
+            <pc:docMk/>
+            <pc:sldMk cId="147431364" sldId="264"/>
+            <ac:spMk id="7" creationId="{32051751-D992-8D98-D7B3-5B3E77D972D0}"/>
+          </ac:spMkLst>
+        </pc:spChg>
+        <pc:spChg chg="del">
+          <ac:chgData name="SHINOHARA Soshi (篠原 想詩)" userId="309c0b21-8b61-4cd5-9d32-07652c56306e" providerId="ADAL" clId="{60D42A6B-AE32-4A06-B461-AA9486421C3B}" dt="2026-09-18T05:54:42.710" v="1668" actId="478"/>
+          <ac:spMkLst>
+            <pc:docMk/>
+            <pc:sldMk cId="147431364" sldId="264"/>
+            <ac:spMk id="9" creationId="{40DA71E2-5169-C226-9716-1D29245292DA}"/>
+          </ac:spMkLst>
+        </pc:spChg>
+        <pc:spChg chg="add mod">
+          <ac:chgData name="SHINOHARA Soshi (篠原 想詩)" userId="309c0b21-8b61-4cd5-9d32-07652c56306e" providerId="ADAL" clId="{60D42A6B-AE32-4A06-B461-AA9486421C3B}" dt="2026-09-18T05:57:01.641" v="1782" actId="20577"/>
+          <ac:spMkLst>
+            <pc:docMk/>
+            <pc:sldMk cId="147431364" sldId="264"/>
+            <ac:spMk id="10" creationId="{A99D0592-4AAB-EE9D-86AD-508AC56407B7}"/>
+          </ac:spMkLst>
+        </pc:spChg>
+        <pc:spChg chg="del">
+          <ac:chgData name="SHINOHARA Soshi (篠原 想詩)" userId="309c0b21-8b61-4cd5-9d32-07652c56306e" providerId="ADAL" clId="{60D42A6B-AE32-4A06-B461-AA9486421C3B}" dt="2026-09-18T05:54:42.710" v="1668" actId="478"/>
+          <ac:spMkLst>
+            <pc:docMk/>
+            <pc:sldMk cId="147431364" sldId="264"/>
+            <ac:spMk id="11" creationId="{5A0F1061-0D3B-DF52-4C20-A9727B3AD83E}"/>
+          </ac:spMkLst>
+        </pc:spChg>
+        <pc:spChg chg="del">
+          <ac:chgData name="SHINOHARA Soshi (篠原 想詩)" userId="309c0b21-8b61-4cd5-9d32-07652c56306e" providerId="ADAL" clId="{60D42A6B-AE32-4A06-B461-AA9486421C3B}" dt="2026-09-18T05:54:42.710" v="1668" actId="478"/>
+          <ac:spMkLst>
+            <pc:docMk/>
+            <pc:sldMk cId="147431364" sldId="264"/>
+            <ac:spMk id="13" creationId="{F83BA511-67DA-15B1-A537-77506D5113E2}"/>
+          </ac:spMkLst>
+        </pc:spChg>
+        <pc:spChg chg="add mod">
+          <ac:chgData name="SHINOHARA Soshi (篠原 想詩)" userId="309c0b21-8b61-4cd5-9d32-07652c56306e" providerId="ADAL" clId="{60D42A6B-AE32-4A06-B461-AA9486421C3B}" dt="2026-09-18T06:08:39.880" v="2390" actId="1076"/>
+          <ac:spMkLst>
+            <pc:docMk/>
+            <pc:sldMk cId="147431364" sldId="264"/>
+            <ac:spMk id="14" creationId="{E01BB2FC-B37F-D766-FE9D-4C8FAD15E35A}"/>
+          </ac:spMkLst>
+        </pc:spChg>
+        <pc:spChg chg="del">
+          <ac:chgData name="SHINOHARA Soshi (篠原 想詩)" userId="309c0b21-8b61-4cd5-9d32-07652c56306e" providerId="ADAL" clId="{60D42A6B-AE32-4A06-B461-AA9486421C3B}" dt="2026-09-18T05:54:42.710" v="1668" actId="478"/>
+          <ac:spMkLst>
+            <pc:docMk/>
+            <pc:sldMk cId="147431364" sldId="264"/>
+            <ac:spMk id="15" creationId="{17E3DE3F-0A9D-878D-5147-69C69CDCFAB7}"/>
+          </ac:spMkLst>
+        </pc:spChg>
+        <pc:spChg chg="del">
+          <ac:chgData name="SHINOHARA Soshi (篠原 想詩)" userId="309c0b21-8b61-4cd5-9d32-07652c56306e" providerId="ADAL" clId="{60D42A6B-AE32-4A06-B461-AA9486421C3B}" dt="2026-09-18T05:54:42.710" v="1668" actId="478"/>
+          <ac:spMkLst>
+            <pc:docMk/>
+            <pc:sldMk cId="147431364" sldId="264"/>
+            <ac:spMk id="17" creationId="{F414B563-D382-0346-6704-8887DDD4FEDF}"/>
+          </ac:spMkLst>
+        </pc:spChg>
+        <pc:spChg chg="add mod">
+          <ac:chgData name="SHINOHARA Soshi (篠原 想詩)" userId="309c0b21-8b61-4cd5-9d32-07652c56306e" providerId="ADAL" clId="{60D42A6B-AE32-4A06-B461-AA9486421C3B}" dt="2026-09-18T07:27:41.343" v="2583" actId="20577"/>
+          <ac:spMkLst>
+            <pc:docMk/>
+            <pc:sldMk cId="147431364" sldId="264"/>
+            <ac:spMk id="18" creationId="{65F3A6C4-9A81-1EF9-8F56-E2D36B994E0B}"/>
+          </ac:spMkLst>
+        </pc:spChg>
+        <pc:spChg chg="del">
+          <ac:chgData name="SHINOHARA Soshi (篠原 想詩)" userId="309c0b21-8b61-4cd5-9d32-07652c56306e" providerId="ADAL" clId="{60D42A6B-AE32-4A06-B461-AA9486421C3B}" dt="2026-09-18T05:54:42.710" v="1668" actId="478"/>
+          <ac:spMkLst>
+            <pc:docMk/>
+            <pc:sldMk cId="147431364" sldId="264"/>
+            <ac:spMk id="19" creationId="{3CA7ABDB-9CF4-7419-A3F0-372837F4CA68}"/>
+          </ac:spMkLst>
+        </pc:spChg>
+        <pc:spChg chg="add mod">
+          <ac:chgData name="SHINOHARA Soshi (篠原 想詩)" userId="309c0b21-8b61-4cd5-9d32-07652c56306e" providerId="ADAL" clId="{60D42A6B-AE32-4A06-B461-AA9486421C3B}" dt="2026-09-18T06:08:39.880" v="2390" actId="1076"/>
+          <ac:spMkLst>
+            <pc:docMk/>
+            <pc:sldMk cId="147431364" sldId="264"/>
+            <ac:spMk id="21" creationId="{51637B88-5226-9238-B14D-891D3D348264}"/>
+          </ac:spMkLst>
+        </pc:spChg>
+        <pc:spChg chg="add mod">
+          <ac:chgData name="SHINOHARA Soshi (篠原 想詩)" userId="309c0b21-8b61-4cd5-9d32-07652c56306e" providerId="ADAL" clId="{60D42A6B-AE32-4A06-B461-AA9486421C3B}" dt="2026-09-18T06:08:34.632" v="2389" actId="1076"/>
+          <ac:spMkLst>
+            <pc:docMk/>
+            <pc:sldMk cId="147431364" sldId="264"/>
+            <ac:spMk id="25" creationId="{90B734DB-F072-0773-4A91-F2D0428DC85B}"/>
+          </ac:spMkLst>
+        </pc:spChg>
+        <pc:spChg chg="add">
+          <ac:chgData name="SHINOHARA Soshi (篠原 想詩)" userId="309c0b21-8b61-4cd5-9d32-07652c56306e" providerId="ADAL" clId="{60D42A6B-AE32-4A06-B461-AA9486421C3B}" dt="2026-09-18T06:07:36.711" v="2338" actId="22"/>
+          <ac:spMkLst>
+            <pc:docMk/>
+            <pc:sldMk cId="147431364" sldId="264"/>
+            <ac:spMk id="27" creationId="{4196054C-6AD3-7A06-15DA-5D1815E3D737}"/>
+          </ac:spMkLst>
+        </pc:spChg>
+        <pc:spChg chg="add mod">
+          <ac:chgData name="SHINOHARA Soshi (篠原 想詩)" userId="309c0b21-8b61-4cd5-9d32-07652c56306e" providerId="ADAL" clId="{60D42A6B-AE32-4A06-B461-AA9486421C3B}" dt="2026-09-18T06:08:55.477" v="2393" actId="14100"/>
+          <ac:spMkLst>
+            <pc:docMk/>
+            <pc:sldMk cId="147431364" sldId="264"/>
+            <ac:spMk id="29" creationId="{0E469F14-DE54-B50C-65FD-4EF61E57F230}"/>
+          </ac:spMkLst>
+        </pc:spChg>
+        <pc:spChg chg="mod">
+          <ac:chgData name="SHINOHARA Soshi (篠原 想詩)" userId="309c0b21-8b61-4cd5-9d32-07652c56306e" providerId="ADAL" clId="{60D42A6B-AE32-4A06-B461-AA9486421C3B}" dt="2026-09-18T06:01:54.966" v="2261" actId="207"/>
+          <ac:spMkLst>
+            <pc:docMk/>
+            <pc:sldMk cId="147431364" sldId="264"/>
+            <ac:spMk id="21506" creationId="{64226943-6F0D-9B1F-EB98-B1CB9F46A659}"/>
+          </ac:spMkLst>
+        </pc:spChg>
+        <pc:graphicFrameChg chg="add mod modGraphic">
+          <ac:chgData name="SHINOHARA Soshi (篠原 想詩)" userId="309c0b21-8b61-4cd5-9d32-07652c56306e" providerId="ADAL" clId="{60D42A6B-AE32-4A06-B461-AA9486421C3B}" dt="2026-09-18T06:11:57.996" v="2515" actId="20577"/>
+          <ac:graphicFrameMkLst>
+            <pc:docMk/>
+            <pc:sldMk cId="147431364" sldId="264"/>
+            <ac:graphicFrameMk id="23" creationId="{A1CE0432-81FE-9A98-8528-48DD5FFDE362}"/>
+          </ac:graphicFrameMkLst>
+        </pc:graphicFrameChg>
+      </pc:sldChg>
+      <pc:sldChg chg="addSp delSp add del mod">
+        <pc:chgData name="SHINOHARA Soshi (篠原 想詩)" userId="309c0b21-8b61-4cd5-9d32-07652c56306e" providerId="ADAL" clId="{60D42A6B-AE32-4A06-B461-AA9486421C3B}" dt="2026-09-18T06:08:57.444" v="2394" actId="47"/>
+        <pc:sldMkLst>
+          <pc:docMk/>
+          <pc:sldMk cId="1314201938" sldId="265"/>
+        </pc:sldMkLst>
+        <pc:spChg chg="del">
+          <ac:chgData name="SHINOHARA Soshi (篠原 想詩)" userId="309c0b21-8b61-4cd5-9d32-07652c56306e" providerId="ADAL" clId="{60D42A6B-AE32-4A06-B461-AA9486421C3B}" dt="2026-09-18T06:05:23.662" v="2314" actId="478"/>
+          <ac:spMkLst>
+            <pc:docMk/>
+            <pc:sldMk cId="1314201938" sldId="265"/>
+            <ac:spMk id="3" creationId="{E7EF5306-233C-D888-C4F9-869857861AC2}"/>
+          </ac:spMkLst>
+        </pc:spChg>
+        <pc:spChg chg="add del">
+          <ac:chgData name="SHINOHARA Soshi (篠原 想詩)" userId="309c0b21-8b61-4cd5-9d32-07652c56306e" providerId="ADAL" clId="{60D42A6B-AE32-4A06-B461-AA9486421C3B}" dt="2026-09-18T06:08:07.935" v="2381" actId="478"/>
+          <ac:spMkLst>
+            <pc:docMk/>
+            <pc:sldMk cId="1314201938" sldId="265"/>
+            <ac:spMk id="5" creationId="{2FA5BB3F-AB34-D2DF-4D36-1FCD30EAFEBF}"/>
+          </ac:spMkLst>
+        </pc:spChg>
+        <pc:spChg chg="del">
+          <ac:chgData name="SHINOHARA Soshi (篠原 想詩)" userId="309c0b21-8b61-4cd5-9d32-07652c56306e" providerId="ADAL" clId="{60D42A6B-AE32-4A06-B461-AA9486421C3B}" dt="2026-09-18T06:05:19.005" v="2313" actId="478"/>
+          <ac:spMkLst>
+            <pc:docMk/>
+            <pc:sldMk cId="1314201938" sldId="265"/>
+            <ac:spMk id="6" creationId="{5A1063EE-9E6D-631E-F8F0-44B6D334FDDF}"/>
+          </ac:spMkLst>
+        </pc:spChg>
+        <pc:spChg chg="del">
+          <ac:chgData name="SHINOHARA Soshi (篠原 想詩)" userId="309c0b21-8b61-4cd5-9d32-07652c56306e" providerId="ADAL" clId="{60D42A6B-AE32-4A06-B461-AA9486421C3B}" dt="2026-09-18T06:05:19.005" v="2313" actId="478"/>
+          <ac:spMkLst>
+            <pc:docMk/>
+            <pc:sldMk cId="1314201938" sldId="265"/>
+            <ac:spMk id="10" creationId="{36257D8E-473D-A3A2-03E5-7CA4F72923D1}"/>
+          </ac:spMkLst>
+        </pc:spChg>
+        <pc:spChg chg="del">
+          <ac:chgData name="SHINOHARA Soshi (篠原 想詩)" userId="309c0b21-8b61-4cd5-9d32-07652c56306e" providerId="ADAL" clId="{60D42A6B-AE32-4A06-B461-AA9486421C3B}" dt="2026-09-18T06:05:19.005" v="2313" actId="478"/>
+          <ac:spMkLst>
+            <pc:docMk/>
+            <pc:sldMk cId="1314201938" sldId="265"/>
+            <ac:spMk id="14" creationId="{97ED53A4-D1E1-F356-C32D-C4DF01E9D78A}"/>
+          </ac:spMkLst>
+        </pc:spChg>
+        <pc:spChg chg="del">
+          <ac:chgData name="SHINOHARA Soshi (篠原 想詩)" userId="309c0b21-8b61-4cd5-9d32-07652c56306e" providerId="ADAL" clId="{60D42A6B-AE32-4A06-B461-AA9486421C3B}" dt="2026-09-18T06:05:19.005" v="2313" actId="478"/>
+          <ac:spMkLst>
+            <pc:docMk/>
+            <pc:sldMk cId="1314201938" sldId="265"/>
+            <ac:spMk id="18" creationId="{C7C043CB-6ECC-E00B-D998-006A6A1A1EE3}"/>
+          </ac:spMkLst>
+        </pc:spChg>
+        <pc:spChg chg="del">
+          <ac:chgData name="SHINOHARA Soshi (篠原 想詩)" userId="309c0b21-8b61-4cd5-9d32-07652c56306e" providerId="ADAL" clId="{60D42A6B-AE32-4A06-B461-AA9486421C3B}" dt="2026-09-18T06:05:19.005" v="2313" actId="478"/>
+          <ac:spMkLst>
+            <pc:docMk/>
+            <pc:sldMk cId="1314201938" sldId="265"/>
+            <ac:spMk id="21" creationId="{01BC4F24-814E-B738-E9F9-62CD2ECE9CD4}"/>
+          </ac:spMkLst>
+        </pc:spChg>
+        <pc:spChg chg="del">
+          <ac:chgData name="SHINOHARA Soshi (篠原 想詩)" userId="309c0b21-8b61-4cd5-9d32-07652c56306e" providerId="ADAL" clId="{60D42A6B-AE32-4A06-B461-AA9486421C3B}" dt="2026-09-18T06:05:30.240" v="2316" actId="478"/>
+          <ac:spMkLst>
+            <pc:docMk/>
+            <pc:sldMk cId="1314201938" sldId="265"/>
+            <ac:spMk id="25" creationId="{5E0BD695-208B-8E25-EE99-545B14AAEDDD}"/>
+          </ac:spMkLst>
+        </pc:spChg>
+        <pc:graphicFrameChg chg="del">
+          <ac:chgData name="SHINOHARA Soshi (篠原 想詩)" userId="309c0b21-8b61-4cd5-9d32-07652c56306e" providerId="ADAL" clId="{60D42A6B-AE32-4A06-B461-AA9486421C3B}" dt="2026-09-18T06:05:27.563" v="2315" actId="478"/>
+          <ac:graphicFrameMkLst>
+            <pc:docMk/>
+            <pc:sldMk cId="1314201938" sldId="265"/>
+            <ac:graphicFrameMk id="23" creationId="{1EE2691D-2C68-50A1-72EA-5FC142209032}"/>
+          </ac:graphicFrameMkLst>
+        </pc:graphicFrameChg>
+      </pc:sldChg>
+      <pc:sldChg chg="addSp delSp modSp add mod">
+        <pc:chgData name="SHINOHARA Soshi (篠原 想詩)" userId="309c0b21-8b61-4cd5-9d32-07652c56306e" providerId="ADAL" clId="{60D42A6B-AE32-4A06-B461-AA9486421C3B}" dt="2026-09-18T06:15:35.154" v="2535" actId="1076"/>
+        <pc:sldMkLst>
+          <pc:docMk/>
+          <pc:sldMk cId="3249971736" sldId="265"/>
+        </pc:sldMkLst>
+        <pc:spChg chg="add del">
+          <ac:chgData name="SHINOHARA Soshi (篠原 想詩)" userId="309c0b21-8b61-4cd5-9d32-07652c56306e" providerId="ADAL" clId="{60D42A6B-AE32-4A06-B461-AA9486421C3B}" dt="2026-09-18T06:10:53.489" v="2476" actId="478"/>
+          <ac:spMkLst>
+            <pc:docMk/>
+            <pc:sldMk cId="3249971736" sldId="265"/>
+            <ac:spMk id="3" creationId="{6455A74A-3145-43E9-0FEA-96984B6C3345}"/>
+          </ac:spMkLst>
+        </pc:spChg>
+        <pc:spChg chg="add del">
+          <ac:chgData name="SHINOHARA Soshi (篠原 想詩)" userId="309c0b21-8b61-4cd5-9d32-07652c56306e" providerId="ADAL" clId="{60D42A6B-AE32-4A06-B461-AA9486421C3B}" dt="2026-09-18T06:10:55.834" v="2477" actId="478"/>
+          <ac:spMkLst>
+            <pc:docMk/>
+            <pc:sldMk cId="3249971736" sldId="265"/>
+            <ac:spMk id="5" creationId="{A951B59B-374D-286A-33A5-2D7F49AA888B}"/>
+          </ac:spMkLst>
+        </pc:spChg>
+        <pc:spChg chg="del">
+          <ac:chgData name="SHINOHARA Soshi (篠原 想詩)" userId="309c0b21-8b61-4cd5-9d32-07652c56306e" providerId="ADAL" clId="{60D42A6B-AE32-4A06-B461-AA9486421C3B}" dt="2026-09-18T06:10:42.448" v="2472" actId="478"/>
+          <ac:spMkLst>
+            <pc:docMk/>
+            <pc:sldMk cId="3249971736" sldId="265"/>
+            <ac:spMk id="6" creationId="{1CF1F0CB-11DA-7A96-97F4-CD39540D3032}"/>
+          </ac:spMkLst>
+        </pc:spChg>
+        <pc:spChg chg="del">
+          <ac:chgData name="SHINOHARA Soshi (篠原 想詩)" userId="309c0b21-8b61-4cd5-9d32-07652c56306e" providerId="ADAL" clId="{60D42A6B-AE32-4A06-B461-AA9486421C3B}" dt="2026-09-18T06:10:42.448" v="2472" actId="478"/>
+          <ac:spMkLst>
+            <pc:docMk/>
+            <pc:sldMk cId="3249971736" sldId="265"/>
+            <ac:spMk id="10" creationId="{9D0F0D21-0F87-47E7-8D1D-9E026C31F900}"/>
+          </ac:spMkLst>
+        </pc:spChg>
+        <pc:spChg chg="del">
+          <ac:chgData name="SHINOHARA Soshi (篠原 想詩)" userId="309c0b21-8b61-4cd5-9d32-07652c56306e" providerId="ADAL" clId="{60D42A6B-AE32-4A06-B461-AA9486421C3B}" dt="2026-09-18T06:10:42.448" v="2472" actId="478"/>
+          <ac:spMkLst>
+            <pc:docMk/>
+            <pc:sldMk cId="3249971736" sldId="265"/>
+            <ac:spMk id="14" creationId="{84292A5C-EF93-1D6D-D96F-63339C36B5DA}"/>
+          </ac:spMkLst>
+        </pc:spChg>
+        <pc:spChg chg="del">
+          <ac:chgData name="SHINOHARA Soshi (篠原 想詩)" userId="309c0b21-8b61-4cd5-9d32-07652c56306e" providerId="ADAL" clId="{60D42A6B-AE32-4A06-B461-AA9486421C3B}" dt="2026-09-18T06:10:42.448" v="2472" actId="478"/>
+          <ac:spMkLst>
+            <pc:docMk/>
+            <pc:sldMk cId="3249971736" sldId="265"/>
+            <ac:spMk id="18" creationId="{000861EA-2373-894B-6A08-36763DE3141E}"/>
+          </ac:spMkLst>
+        </pc:spChg>
+        <pc:spChg chg="del">
+          <ac:chgData name="SHINOHARA Soshi (篠原 想詩)" userId="309c0b21-8b61-4cd5-9d32-07652c56306e" providerId="ADAL" clId="{60D42A6B-AE32-4A06-B461-AA9486421C3B}" dt="2026-09-18T06:10:42.448" v="2472" actId="478"/>
+          <ac:spMkLst>
+            <pc:docMk/>
+            <pc:sldMk cId="3249971736" sldId="265"/>
+            <ac:spMk id="21" creationId="{70FA87B6-0C29-4AC4-3931-2C2B3D9862AC}"/>
+          </ac:spMkLst>
+        </pc:spChg>
+        <pc:spChg chg="del">
+          <ac:chgData name="SHINOHARA Soshi (篠原 想詩)" userId="309c0b21-8b61-4cd5-9d32-07652c56306e" providerId="ADAL" clId="{60D42A6B-AE32-4A06-B461-AA9486421C3B}" dt="2026-09-18T06:10:42.448" v="2472" actId="478"/>
+          <ac:spMkLst>
+            <pc:docMk/>
+            <pc:sldMk cId="3249971736" sldId="265"/>
+            <ac:spMk id="25" creationId="{892490C8-31AD-E3FF-0ABF-416A7E172DAD}"/>
+          </ac:spMkLst>
+        </pc:spChg>
+        <pc:spChg chg="del mod">
+          <ac:chgData name="SHINOHARA Soshi (篠原 想詩)" userId="309c0b21-8b61-4cd5-9d32-07652c56306e" providerId="ADAL" clId="{60D42A6B-AE32-4A06-B461-AA9486421C3B}" dt="2026-09-18T06:10:40.390" v="2471" actId="478"/>
+          <ac:spMkLst>
+            <pc:docMk/>
+            <pc:sldMk cId="3249971736" sldId="265"/>
+            <ac:spMk id="29" creationId="{B46D97C3-DBD4-B9B1-258F-034692CBEEA3}"/>
+          </ac:spMkLst>
+        </pc:spChg>
+        <pc:spChg chg="mod">
+          <ac:chgData name="SHINOHARA Soshi (篠原 想詩)" userId="309c0b21-8b61-4cd5-9d32-07652c56306e" providerId="ADAL" clId="{60D42A6B-AE32-4A06-B461-AA9486421C3B}" dt="2026-09-18T06:11:01.130" v="2507" actId="20577"/>
+          <ac:spMkLst>
+            <pc:docMk/>
+            <pc:sldMk cId="3249971736" sldId="265"/>
+            <ac:spMk id="21506" creationId="{EE83C36C-337B-3CAA-0B83-0A1517A40289}"/>
+          </ac:spMkLst>
+        </pc:spChg>
+        <pc:graphicFrameChg chg="add mod modGraphic">
+          <ac:chgData name="SHINOHARA Soshi (篠原 想詩)" userId="309c0b21-8b61-4cd5-9d32-07652c56306e" providerId="ADAL" clId="{60D42A6B-AE32-4A06-B461-AA9486421C3B}" dt="2026-09-18T06:15:35.154" v="2535" actId="1076"/>
+          <ac:graphicFrameMkLst>
+            <pc:docMk/>
+            <pc:sldMk cId="3249971736" sldId="265"/>
+            <ac:graphicFrameMk id="8" creationId="{58D35AA5-77A7-64BC-8911-FEFE11A99615}"/>
+          </ac:graphicFrameMkLst>
+        </pc:graphicFrameChg>
+        <pc:graphicFrameChg chg="del">
+          <ac:chgData name="SHINOHARA Soshi (篠原 想詩)" userId="309c0b21-8b61-4cd5-9d32-07652c56306e" providerId="ADAL" clId="{60D42A6B-AE32-4A06-B461-AA9486421C3B}" dt="2026-09-18T06:10:42.448" v="2472" actId="478"/>
+          <ac:graphicFrameMkLst>
+            <pc:docMk/>
+            <pc:sldMk cId="3249971736" sldId="265"/>
+            <ac:graphicFrameMk id="23" creationId="{CA1BBA50-64D8-27C8-734A-9DB62746C46C}"/>
+          </ac:graphicFrameMkLst>
+        </pc:graphicFrameChg>
+      </pc:sldChg>
+      <pc:sldMasterChg chg="del delSldLayout">
+        <pc:chgData name="SHINOHARA Soshi (篠原 想詩)" userId="309c0b21-8b61-4cd5-9d32-07652c56306e" providerId="ADAL" clId="{60D42A6B-AE32-4A06-B461-AA9486421C3B}" dt="2026-09-18T06:09:01.320" v="2396" actId="47"/>
+        <pc:sldMasterMkLst>
+          <pc:docMk/>
+          <pc:sldMasterMk cId="3019807980" sldId="2147483648"/>
+        </pc:sldMasterMkLst>
+        <pc:sldLayoutChg chg="del">
+          <pc:chgData name="SHINOHARA Soshi (篠原 想詩)" userId="309c0b21-8b61-4cd5-9d32-07652c56306e" providerId="ADAL" clId="{60D42A6B-AE32-4A06-B461-AA9486421C3B}" dt="2026-09-18T06:09:01.320" v="2396" actId="47"/>
+          <pc:sldLayoutMkLst>
+            <pc:docMk/>
+            <pc:sldMasterMk cId="3019807980" sldId="2147483648"/>
+            <pc:sldLayoutMk cId="181740245" sldId="2147483649"/>
+          </pc:sldLayoutMkLst>
+        </pc:sldLayoutChg>
+        <pc:sldLayoutChg chg="del">
+          <pc:chgData name="SHINOHARA Soshi (篠原 想詩)" userId="309c0b21-8b61-4cd5-9d32-07652c56306e" providerId="ADAL" clId="{60D42A6B-AE32-4A06-B461-AA9486421C3B}" dt="2026-09-18T06:09:01.320" v="2396" actId="47"/>
+          <pc:sldLayoutMkLst>
+            <pc:docMk/>
+            <pc:sldMasterMk cId="3019807980" sldId="2147483648"/>
+            <pc:sldLayoutMk cId="1262986352" sldId="2147483650"/>
+          </pc:sldLayoutMkLst>
+        </pc:sldLayoutChg>
+        <pc:sldLayoutChg chg="del">
+          <pc:chgData name="SHINOHARA Soshi (篠原 想詩)" userId="309c0b21-8b61-4cd5-9d32-07652c56306e" providerId="ADAL" clId="{60D42A6B-AE32-4A06-B461-AA9486421C3B}" dt="2026-09-18T06:09:01.320" v="2396" actId="47"/>
+          <pc:sldLayoutMkLst>
+            <pc:docMk/>
+            <pc:sldMasterMk cId="3019807980" sldId="2147483648"/>
+            <pc:sldLayoutMk cId="1801365498" sldId="2147483651"/>
+          </pc:sldLayoutMkLst>
+        </pc:sldLayoutChg>
+        <pc:sldLayoutChg chg="del">
+          <pc:chgData name="SHINOHARA Soshi (篠原 想詩)" userId="309c0b21-8b61-4cd5-9d32-07652c56306e" providerId="ADAL" clId="{60D42A6B-AE32-4A06-B461-AA9486421C3B}" dt="2026-09-18T06:09:01.320" v="2396" actId="47"/>
+          <pc:sldLayoutMkLst>
+            <pc:docMk/>
+            <pc:sldMasterMk cId="3019807980" sldId="2147483648"/>
+            <pc:sldLayoutMk cId="1707429675" sldId="2147483652"/>
+          </pc:sldLayoutMkLst>
+        </pc:sldLayoutChg>
+        <pc:sldLayoutChg chg="del">
+          <pc:chgData name="SHINOHARA Soshi (篠原 想詩)" userId="309c0b21-8b61-4cd5-9d32-07652c56306e" providerId="ADAL" clId="{60D42A6B-AE32-4A06-B461-AA9486421C3B}" dt="2026-09-18T06:09:01.320" v="2396" actId="47"/>
+          <pc:sldLayoutMkLst>
+            <pc:docMk/>
+            <pc:sldMasterMk cId="3019807980" sldId="2147483648"/>
+            <pc:sldLayoutMk cId="3447607662" sldId="2147483653"/>
+          </pc:sldLayoutMkLst>
+        </pc:sldLayoutChg>
+        <pc:sldLayoutChg chg="del">
+          <pc:chgData name="SHINOHARA Soshi (篠原 想詩)" userId="309c0b21-8b61-4cd5-9d32-07652c56306e" providerId="ADAL" clId="{60D42A6B-AE32-4A06-B461-AA9486421C3B}" dt="2026-09-18T06:09:01.320" v="2396" actId="47"/>
+          <pc:sldLayoutMkLst>
+            <pc:docMk/>
+            <pc:sldMasterMk cId="3019807980" sldId="2147483648"/>
+            <pc:sldLayoutMk cId="3774007086" sldId="2147483654"/>
+          </pc:sldLayoutMkLst>
+        </pc:sldLayoutChg>
+        <pc:sldLayoutChg chg="del">
+          <pc:chgData name="SHINOHARA Soshi (篠原 想詩)" userId="309c0b21-8b61-4cd5-9d32-07652c56306e" providerId="ADAL" clId="{60D42A6B-AE32-4A06-B461-AA9486421C3B}" dt="2026-09-18T06:09:01.320" v="2396" actId="47"/>
+          <pc:sldLayoutMkLst>
+            <pc:docMk/>
+            <pc:sldMasterMk cId="3019807980" sldId="2147483648"/>
+            <pc:sldLayoutMk cId="2525697723" sldId="2147483655"/>
+          </pc:sldLayoutMkLst>
+        </pc:sldLayoutChg>
+        <pc:sldLayoutChg chg="del">
+          <pc:chgData name="SHINOHARA Soshi (篠原 想詩)" userId="309c0b21-8b61-4cd5-9d32-07652c56306e" providerId="ADAL" clId="{60D42A6B-AE32-4A06-B461-AA9486421C3B}" dt="2026-09-18T06:09:01.320" v="2396" actId="47"/>
+          <pc:sldLayoutMkLst>
+            <pc:docMk/>
+            <pc:sldMasterMk cId="3019807980" sldId="2147483648"/>
+            <pc:sldLayoutMk cId="1592917292" sldId="2147483656"/>
+          </pc:sldLayoutMkLst>
+        </pc:sldLayoutChg>
+        <pc:sldLayoutChg chg="del">
+          <pc:chgData name="SHINOHARA Soshi (篠原 想詩)" userId="309c0b21-8b61-4cd5-9d32-07652c56306e" providerId="ADAL" clId="{60D42A6B-AE32-4A06-B461-AA9486421C3B}" dt="2026-09-18T06:09:01.320" v="2396" actId="47"/>
+          <pc:sldLayoutMkLst>
+            <pc:docMk/>
+            <pc:sldMasterMk cId="3019807980" sldId="2147483648"/>
+            <pc:sldLayoutMk cId="2073493225" sldId="2147483657"/>
+          </pc:sldLayoutMkLst>
+        </pc:sldLayoutChg>
+        <pc:sldLayoutChg chg="del">
+          <pc:chgData name="SHINOHARA Soshi (篠原 想詩)" userId="309c0b21-8b61-4cd5-9d32-07652c56306e" providerId="ADAL" clId="{60D42A6B-AE32-4A06-B461-AA9486421C3B}" dt="2026-09-18T06:09:01.320" v="2396" actId="47"/>
+          <pc:sldLayoutMkLst>
+            <pc:docMk/>
+            <pc:sldMasterMk cId="3019807980" sldId="2147483648"/>
+            <pc:sldLayoutMk cId="468604226" sldId="2147483658"/>
+          </pc:sldLayoutMkLst>
+        </pc:sldLayoutChg>
+        <pc:sldLayoutChg chg="del">
+          <pc:chgData name="SHINOHARA Soshi (篠原 想詩)" userId="309c0b21-8b61-4cd5-9d32-07652c56306e" providerId="ADAL" clId="{60D42A6B-AE32-4A06-B461-AA9486421C3B}" dt="2026-09-18T06:09:01.320" v="2396" actId="47"/>
+          <pc:sldLayoutMkLst>
+            <pc:docMk/>
+            <pc:sldMasterMk cId="3019807980" sldId="2147483648"/>
+            <pc:sldLayoutMk cId="1426030442" sldId="2147483659"/>
+          </pc:sldLayoutMkLst>
+        </pc:sldLayoutChg>
+      </pc:sldMasterChg>
     </pc:docChg>
   </pc:docChgLst>
 </pc:chgInfo>
@@ -4427,7 +5695,7 @@
                   </a:schemeClr>
                 </a:solidFill>
               </a:rPr>
-              <a:t>9</a:t>
+              <a:t>10</a:t>
             </a:r>
             <a:r>
               <a:rPr lang="ja-JP" altLang="en-US" sz="5400" kern="0" dirty="0">
@@ -6458,7 +7726,7 @@
           </a:solidFill>
           <a:ln w="9525">
             <a:solidFill>
-              <a:srgbClr val="9B9B9B"/>
+              <a:srgbClr val="C00000"/>
             </a:solidFill>
           </a:ln>
         </p:spPr>
@@ -6476,12 +7744,12 @@
             <a:r>
               <a:rPr lang="ja-JP" altLang="en-US" sz="1600" b="0" dirty="0">
                 <a:solidFill>
-                  <a:srgbClr val="000000"/>
+                  <a:srgbClr val="C00000"/>
                 </a:solidFill>
                 <a:latin typeface="Meiryo"/>
                 <a:ea typeface="Meiryo"/>
               </a:rPr>
-              <a:t>誤って流すと生産停止</a:t>
+              <a:t>誤実行で生産停止</a:t>
             </a:r>
           </a:p>
         </p:txBody>
@@ -6530,7 +7798,7 @@
                 <a:latin typeface="Meiryo"/>
                 <a:ea typeface="Meiryo"/>
               </a:rPr>
-              <a:t>→ 異常時の手順は「全ラインの生産と作業を停止」から始まり、月次と区別できる整理が必要だった</a:t>
+              <a:t>→ 異常時の手順は冒頭が「全ラインの生産と作業を停止」</a:t>
             </a:r>
           </a:p>
         </p:txBody>
@@ -6632,7 +7900,24 @@
                 <a:latin typeface="Meiryo"/>
                 <a:ea typeface="Meiryo"/>
               </a:rPr>
-              <a:t>公式資料から本文を反映</a:t>
+              <a:t>公式資料の</a:t>
+            </a:r>
+          </a:p>
+          <a:p>
+            <a:pPr algn="ctr">
+              <a:lnSpc>
+                <a:spcPct val="105000"/>
+              </a:lnSpc>
+            </a:pPr>
+            <a:r>
+              <a:rPr lang="ja-JP" altLang="en-US" sz="1600" b="0" dirty="0">
+                <a:solidFill>
+                  <a:srgbClr val="000000"/>
+                </a:solidFill>
+                <a:latin typeface="Meiryo"/>
+                <a:ea typeface="Meiryo"/>
+              </a:rPr>
+              <a:t>本文を反映</a:t>
             </a:r>
           </a:p>
         </p:txBody>
@@ -6919,7 +8204,7 @@
                 <a:latin typeface="Meiryo"/>
                 <a:ea typeface="Meiryo"/>
               </a:rPr>
-              <a:t>管理手順書案2冊を作成</a:t>
+              <a:t>管理手順書案2冊作成</a:t>
             </a:r>
           </a:p>
         </p:txBody>
@@ -7095,7 +8380,7 @@
                 <a:latin typeface="Meiryo"/>
                 <a:ea typeface="Meiryo"/>
               </a:rPr>
-              <a:t>・10/14の会議で再起動手順の統合掲載を決定。停止1〜6/起動7〜14に分割し、月次と異常時を分けた。</a:t>
+              <a:t>・会議で決定した方針に基づき、再起動手順の掲載を統合した。</a:t>
             </a:r>
             <a:endParaRPr lang="en-US" altLang="ja-JP" b="0" dirty="0">
               <a:solidFill>
@@ -7529,6 +8814,13 @@
               </a:rPr>
               <a:t>・改良点だけをver.2本体へ統合(設定読み込み1回化・空欄スキップ・送信漏れで中断)。</a:t>
             </a:r>
+            <a:endParaRPr lang="ja-JP" altLang="en-US" sz="1600" b="0" dirty="0">
+              <a:solidFill>
+                <a:srgbClr val="000000"/>
+              </a:solidFill>
+              <a:latin typeface="Meiryo"/>
+              <a:ea typeface="Meiryo"/>
+            </a:endParaRPr>
           </a:p>
           <a:p>
             <a:pPr algn="l">
@@ -7549,6 +8841,13 @@
               </a:rPr>
               <a:t>・旧版の実績を尊重し、勝手な書き換えはしない方針で改修。</a:t>
             </a:r>
+            <a:endParaRPr lang="ja-JP" altLang="en-US" sz="1600" b="0" dirty="0">
+              <a:solidFill>
+                <a:srgbClr val="000000"/>
+              </a:solidFill>
+              <a:latin typeface="Meiryo"/>
+              <a:ea typeface="Meiryo"/>
+            </a:endParaRPr>
           </a:p>
           <a:p>
             <a:pPr algn="l">
@@ -7569,6 +8868,13 @@
               </a:rPr>
               <a:t>・テストケース47件を作成し、コンパイル→試し実行10件→本番1件→10件の段階で検証する。</a:t>
             </a:r>
+            <a:endParaRPr lang="ja-JP" altLang="en-US" sz="1600" b="0" dirty="0">
+              <a:solidFill>
+                <a:srgbClr val="000000"/>
+              </a:solidFill>
+              <a:latin typeface="Meiryo"/>
+              <a:ea typeface="Meiryo"/>
+            </a:endParaRPr>
           </a:p>
         </p:txBody>
       </p:sp>
@@ -8643,6 +9949,13 @@
               </a:rPr>
               <a:t>実施時期：10月末 本番(予定)</a:t>
             </a:r>
+            <a:endParaRPr lang="ja-JP" altLang="en-US" sz="1400" b="0" dirty="0">
+              <a:solidFill>
+                <a:srgbClr val="666666"/>
+              </a:solidFill>
+              <a:latin typeface="Meiryo"/>
+              <a:ea typeface="Meiryo"/>
+            </a:endParaRPr>
           </a:p>
         </p:txBody>
       </p:sp>
@@ -9652,7 +10965,7 @@
                 </a:tc>
                 <a:extLst>
                   <a:ext uri="{0D108BD9-81ED-4DB2-BD59-A6C34878D82A}">
-                    <a16:rowId xmlns:a16="http://schemas.microsoft.com/office/drawing/2014/main" val="3817583905"/>
+                    <a16:rowId xmlns:a16="http://schemas.microsoft.com/office/drawing/2014/main" val="10004"/>
                   </a:ext>
                 </a:extLst>
               </a:tr>
@@ -9791,7 +11104,7 @@
                 </a:tc>
                 <a:extLst>
                   <a:ext uri="{0D108BD9-81ED-4DB2-BD59-A6C34878D82A}">
-                    <a16:rowId xmlns:a16="http://schemas.microsoft.com/office/drawing/2014/main" val="2954010635"/>
+                    <a16:rowId xmlns:a16="http://schemas.microsoft.com/office/drawing/2014/main" val="10004"/>
                   </a:ext>
                 </a:extLst>
               </a:tr>
@@ -9930,7 +11243,7 @@
                 </a:tc>
                 <a:extLst>
                   <a:ext uri="{0D108BD9-81ED-4DB2-BD59-A6C34878D82A}">
-                    <a16:rowId xmlns:a16="http://schemas.microsoft.com/office/drawing/2014/main" val="1548618165"/>
+                    <a16:rowId xmlns:a16="http://schemas.microsoft.com/office/drawing/2014/main" val="10004"/>
                   </a:ext>
                 </a:extLst>
               </a:tr>
@@ -10069,7 +11382,7 @@
                 </a:tc>
                 <a:extLst>
                   <a:ext uri="{0D108BD9-81ED-4DB2-BD59-A6C34878D82A}">
-                    <a16:rowId xmlns:a16="http://schemas.microsoft.com/office/drawing/2014/main" val="230949805"/>
+                    <a16:rowId xmlns:a16="http://schemas.microsoft.com/office/drawing/2014/main" val="10004"/>
                   </a:ext>
                 </a:extLst>
               </a:tr>

</xml_diff>